<commit_message>
Simplify co-creations into original art and brand collaboration
</commit_message>
<xml_diff>
--- a/GIUMS-MediaKit-EN.pptx
+++ b/GIUMS-MediaKit-EN.pptx
@@ -2,22 +2,22 @@
 <file path=ppt/presentation.xml><?xml version="1.0" encoding="utf-8"?>
 <p:presentation xmlns:p="http://schemas.openxmlformats.org/presentationml/2006/main">
   <p:sldMasterIdLst>
-    <p:sldMasterId xmlns:r="http://schemas.openxmlformats.org/officeDocument/2006/relationships" id="2147483648" r:id="R10dd6019c1a54a75"/>
+    <p:sldMasterId xmlns:r="http://schemas.openxmlformats.org/officeDocument/2006/relationships" id="2147483648" r:id="R57e40e531e424442"/>
   </p:sldMasterIdLst>
   <p:notesMasterIdLst>
-    <p:notesMasterId xmlns:r="http://schemas.openxmlformats.org/officeDocument/2006/relationships" r:id="R543d348a66d747e7"/>
+    <p:notesMasterId xmlns:r="http://schemas.openxmlformats.org/officeDocument/2006/relationships" r:id="R20316c43ebf94eed"/>
   </p:notesMasterIdLst>
   <p:sldIdLst>
-    <p:sldId xmlns:r="http://schemas.openxmlformats.org/officeDocument/2006/relationships" id="256" r:id="R92bbc1590cd24596"/>
-    <p:sldId xmlns:r="http://schemas.openxmlformats.org/officeDocument/2006/relationships" id="257" r:id="R7b488a8dc1404ad5"/>
-    <p:sldId xmlns:r="http://schemas.openxmlformats.org/officeDocument/2006/relationships" id="258" r:id="R8e4404e989404418"/>
-    <p:sldId xmlns:r="http://schemas.openxmlformats.org/officeDocument/2006/relationships" id="259" r:id="R0978ee147eb14735"/>
-    <p:sldId xmlns:r="http://schemas.openxmlformats.org/officeDocument/2006/relationships" id="260" r:id="R3aad700798ca4a08"/>
-    <p:sldId xmlns:r="http://schemas.openxmlformats.org/officeDocument/2006/relationships" id="261" r:id="R890d1b9848ec4b24"/>
-    <p:sldId xmlns:r="http://schemas.openxmlformats.org/officeDocument/2006/relationships" id="262" r:id="Re12ffbd8a14d4d7c"/>
-    <p:sldId xmlns:r="http://schemas.openxmlformats.org/officeDocument/2006/relationships" id="263" r:id="R163bf11d9e644a22"/>
-    <p:sldId xmlns:r="http://schemas.openxmlformats.org/officeDocument/2006/relationships" id="264" r:id="R2b5ea8c7066a4501"/>
-    <p:sldId xmlns:r="http://schemas.openxmlformats.org/officeDocument/2006/relationships" id="265" r:id="R935c83ebe18242c3"/>
+    <p:sldId xmlns:r="http://schemas.openxmlformats.org/officeDocument/2006/relationships" id="256" r:id="R4c40485d89134a70"/>
+    <p:sldId xmlns:r="http://schemas.openxmlformats.org/officeDocument/2006/relationships" id="257" r:id="R74d519955ba645dc"/>
+    <p:sldId xmlns:r="http://schemas.openxmlformats.org/officeDocument/2006/relationships" id="258" r:id="R286effb04f5b4b88"/>
+    <p:sldId xmlns:r="http://schemas.openxmlformats.org/officeDocument/2006/relationships" id="259" r:id="R4126a5ff220d4e74"/>
+    <p:sldId xmlns:r="http://schemas.openxmlformats.org/officeDocument/2006/relationships" id="260" r:id="Rd0af78352d2c4933"/>
+    <p:sldId xmlns:r="http://schemas.openxmlformats.org/officeDocument/2006/relationships" id="261" r:id="R61b42446034342e0"/>
+    <p:sldId xmlns:r="http://schemas.openxmlformats.org/officeDocument/2006/relationships" id="262" r:id="R5853756a9c8a421c"/>
+    <p:sldId xmlns:r="http://schemas.openxmlformats.org/officeDocument/2006/relationships" id="263" r:id="Rf133ccb041684c45"/>
+    <p:sldId xmlns:r="http://schemas.openxmlformats.org/officeDocument/2006/relationships" id="264" r:id="Rfcfe2899185946e4"/>
+    <p:sldId xmlns:r="http://schemas.openxmlformats.org/officeDocument/2006/relationships" id="265" r:id="R15b0868535ca428c"/>
   </p:sldIdLst>
   <p:sldSz cx="12192000" cy="6858000"/>
   <p:notesSz cx="6858000" cy="9144000"/>
@@ -1128,7 +1128,7 @@
           <p:cNvPr id="3" name="Title">
             <a:extLst xmlns:a="http://schemas.openxmlformats.org/drawingml/2006/main">
               <a:ext uri="{FF2B5EF4-FFF2-40B4-BE49-F238E27FC236}">
-                <a16:creationId xmlns:a16="http://schemas.microsoft.com/office/drawing/2014/main" id="{4AD7CC6E-B56D-48C0-8119-41063DB932BD}"/>
+                <a16:creationId xmlns:a16="http://schemas.microsoft.com/office/drawing/2014/main" id="{7F074A18-28F4-4AC9-9944-CCAFDBA283EA}"/>
               </a:ext>
             </a:extLst>
           </p:cNvPr>
@@ -1357,7 +1357,7 @@
           <p:cNvPr id="2" name="Subtitle">
             <a:extLst xmlns:a="http://schemas.openxmlformats.org/drawingml/2006/main">
               <a:ext uri="{FF2B5EF4-FFF2-40B4-BE49-F238E27FC236}">
-                <a16:creationId xmlns:a16="http://schemas.microsoft.com/office/drawing/2014/main" id="{0B42C473-9E6C-409B-BD1E-38F84BB5B470}"/>
+                <a16:creationId xmlns:a16="http://schemas.microsoft.com/office/drawing/2014/main" id="{6F10948E-B82C-4DB3-9548-80E7964CAA4B}"/>
               </a:ext>
             </a:extLst>
           </p:cNvPr>
@@ -1603,7 +1603,7 @@
           <p:cNvPr id="2" name="Section title">
             <a:extLst xmlns:a="http://schemas.openxmlformats.org/drawingml/2006/main">
               <a:ext uri="{FF2B5EF4-FFF2-40B4-BE49-F238E27FC236}">
-                <a16:creationId xmlns:a16="http://schemas.microsoft.com/office/drawing/2014/main" id="{6B9ED9B9-DBB5-4D1B-A328-EDD85445938C}"/>
+                <a16:creationId xmlns:a16="http://schemas.microsoft.com/office/drawing/2014/main" id="{67A1B9B7-83AB-41E8-8C58-7AAD99DC38CD}"/>
               </a:ext>
             </a:extLst>
           </p:cNvPr>
@@ -1849,7 +1849,7 @@
           <p:cNvPr id="3" name="Title">
             <a:extLst xmlns:a="http://schemas.openxmlformats.org/drawingml/2006/main">
               <a:ext uri="{FF2B5EF4-FFF2-40B4-BE49-F238E27FC236}">
-                <a16:creationId xmlns:a16="http://schemas.microsoft.com/office/drawing/2014/main" id="{B0BA27B5-34FE-4215-8944-3CEFEF252058}"/>
+                <a16:creationId xmlns:a16="http://schemas.microsoft.com/office/drawing/2014/main" id="{AAE22794-D2E4-42BF-AF4B-8058EFFEC19A}"/>
               </a:ext>
             </a:extLst>
           </p:cNvPr>
@@ -2078,7 +2078,7 @@
           <p:cNvPr id="2" name="Body">
             <a:extLst xmlns:a="http://schemas.openxmlformats.org/drawingml/2006/main">
               <a:ext uri="{FF2B5EF4-FFF2-40B4-BE49-F238E27FC236}">
-                <a16:creationId xmlns:a16="http://schemas.microsoft.com/office/drawing/2014/main" id="{2D6118D4-50FB-4BB0-8490-A9DA4AD23101}"/>
+                <a16:creationId xmlns:a16="http://schemas.microsoft.com/office/drawing/2014/main" id="{DB2424B2-A7F8-46A4-902C-72BDF8638997}"/>
               </a:ext>
             </a:extLst>
           </p:cNvPr>
@@ -2324,7 +2324,7 @@
           <p:cNvPr id="4" name="Title">
             <a:extLst xmlns:a="http://schemas.openxmlformats.org/drawingml/2006/main">
               <a:ext uri="{FF2B5EF4-FFF2-40B4-BE49-F238E27FC236}">
-                <a16:creationId xmlns:a16="http://schemas.microsoft.com/office/drawing/2014/main" id="{0AF59BE2-AED5-41E8-A799-A9D81637DAE1}"/>
+                <a16:creationId xmlns:a16="http://schemas.microsoft.com/office/drawing/2014/main" id="{60083569-92C5-4136-9E0C-F32F6EFD96BA}"/>
               </a:ext>
             </a:extLst>
           </p:cNvPr>
@@ -2553,7 +2553,7 @@
           <p:cNvPr id="2" name="Left column">
             <a:extLst xmlns:a="http://schemas.openxmlformats.org/drawingml/2006/main">
               <a:ext uri="{FF2B5EF4-FFF2-40B4-BE49-F238E27FC236}">
-                <a16:creationId xmlns:a16="http://schemas.microsoft.com/office/drawing/2014/main" id="{D07351BE-17D3-429D-8D64-10007327F48A}"/>
+                <a16:creationId xmlns:a16="http://schemas.microsoft.com/office/drawing/2014/main" id="{1FB3A928-3CCC-4835-812F-D6064ADA1851}"/>
               </a:ext>
             </a:extLst>
           </p:cNvPr>
@@ -2782,7 +2782,7 @@
           <p:cNvPr id="3" name="Right column">
             <a:extLst xmlns:a="http://schemas.openxmlformats.org/drawingml/2006/main">
               <a:ext uri="{FF2B5EF4-FFF2-40B4-BE49-F238E27FC236}">
-                <a16:creationId xmlns:a16="http://schemas.microsoft.com/office/drawing/2014/main" id="{B198CF31-3C3B-41F0-B9A4-1CDFC3B32141}"/>
+                <a16:creationId xmlns:a16="http://schemas.microsoft.com/office/drawing/2014/main" id="{5A10B98E-0A76-4446-8C39-9BA988A9052C}"/>
               </a:ext>
             </a:extLst>
           </p:cNvPr>
@@ -3028,7 +3028,7 @@
           <p:cNvPr id="3" name="Title">
             <a:extLst xmlns:a="http://schemas.openxmlformats.org/drawingml/2006/main">
               <a:ext uri="{FF2B5EF4-FFF2-40B4-BE49-F238E27FC236}">
-                <a16:creationId xmlns:a16="http://schemas.microsoft.com/office/drawing/2014/main" id="{79D35F6A-F2B5-427F-8222-3C090927A981}"/>
+                <a16:creationId xmlns:a16="http://schemas.microsoft.com/office/drawing/2014/main" id="{135DD4B0-4AB7-4E48-9628-5BFAA86B4BDF}"/>
               </a:ext>
             </a:extLst>
           </p:cNvPr>
@@ -3257,7 +3257,7 @@
           <p:cNvPr id="2" name="Left column">
             <a:extLst xmlns:a="http://schemas.openxmlformats.org/drawingml/2006/main">
               <a:ext uri="{FF2B5EF4-FFF2-40B4-BE49-F238E27FC236}">
-                <a16:creationId xmlns:a16="http://schemas.microsoft.com/office/drawing/2014/main" id="{92ECE92C-F2C9-4E5C-AAF5-805A9F7839B2}"/>
+                <a16:creationId xmlns:a16="http://schemas.microsoft.com/office/drawing/2014/main" id="{3E75BA9C-794F-4220-9C68-FC3AE4EDFC1D}"/>
               </a:ext>
             </a:extLst>
           </p:cNvPr>
@@ -3524,12 +3524,12 @@
   </p:cSld>
   <p:clrMap bg1="lt1" tx1="dk1" bg2="lt2" tx2="dk2" accent1="accent1" accent2="accent2" accent3="accent3" accent4="accent4" accent5="accent5" accent6="accent6" hlink="hlink" folHlink="folHlink"/>
   <p:sldLayoutIdLst>
-    <p:sldLayoutId xmlns:r="http://schemas.openxmlformats.org/officeDocument/2006/relationships" id="2147483649" r:id="Rb625ced5555d4b9f"/>
-    <p:sldLayoutId xmlns:r="http://schemas.openxmlformats.org/officeDocument/2006/relationships" id="2147483650" r:id="R451a2ae056e947f2"/>
-    <p:sldLayoutId xmlns:r="http://schemas.openxmlformats.org/officeDocument/2006/relationships" id="2147483651" r:id="R1db7398b20254526"/>
-    <p:sldLayoutId xmlns:r="http://schemas.openxmlformats.org/officeDocument/2006/relationships" id="2147483652" r:id="R532169a538f54e69"/>
-    <p:sldLayoutId xmlns:r="http://schemas.openxmlformats.org/officeDocument/2006/relationships" id="2147483653" r:id="R656ea340b58e4ffa"/>
-    <p:sldLayoutId xmlns:r="http://schemas.openxmlformats.org/officeDocument/2006/relationships" id="2147483654" r:id="Rdd59f93ce91b4e63"/>
+    <p:sldLayoutId xmlns:r="http://schemas.openxmlformats.org/officeDocument/2006/relationships" id="2147483649" r:id="R9077d778cad64cb6"/>
+    <p:sldLayoutId xmlns:r="http://schemas.openxmlformats.org/officeDocument/2006/relationships" id="2147483650" r:id="Rfe117b49ce954f93"/>
+    <p:sldLayoutId xmlns:r="http://schemas.openxmlformats.org/officeDocument/2006/relationships" id="2147483651" r:id="R1aea2f2b24054722"/>
+    <p:sldLayoutId xmlns:r="http://schemas.openxmlformats.org/officeDocument/2006/relationships" id="2147483652" r:id="R6e6f705b6b0740db"/>
+    <p:sldLayoutId xmlns:r="http://schemas.openxmlformats.org/officeDocument/2006/relationships" id="2147483653" r:id="R1a7f1bbfa7cb4acf"/>
+    <p:sldLayoutId xmlns:r="http://schemas.openxmlformats.org/officeDocument/2006/relationships" id="2147483654" r:id="Rea2b4656b16b45e3"/>
   </p:sldLayoutIdLst>
   <p:txStyles>
     <p:titleStyle>
@@ -4080,7 +4080,7 @@
           <p:cNvPr id="2" name="">
             <a:extLst xmlns:a="http://schemas.openxmlformats.org/drawingml/2006/main">
               <a:ext uri="{FF2B5EF4-FFF2-40B4-BE49-F238E27FC236}">
-                <a16:creationId xmlns:a16="http://schemas.microsoft.com/office/drawing/2014/main" id="{B7AB382A-4435-42FB-8D41-8C23B356B977}"/>
+                <a16:creationId xmlns:a16="http://schemas.microsoft.com/office/drawing/2014/main" id="{0E12A183-C556-4FF5-BD66-B1131A0A60EC}"/>
               </a:ext>
             </a:extLst>
           </p:cNvPr>
@@ -4090,7 +4090,7 @@
           <p:nvPr/>
         </p:nvPicPr>
         <p:blipFill>
-          <a:blip xmlns:r="http://schemas.openxmlformats.org/officeDocument/2006/relationships" xmlns:a="http://schemas.openxmlformats.org/drawingml/2006/main" r:embed="Rd628f1b6255141f4"/>
+          <a:blip xmlns:r="http://schemas.openxmlformats.org/officeDocument/2006/relationships" xmlns:a="http://schemas.openxmlformats.org/drawingml/2006/main" r:embed="Rc578ae5d42384483"/>
           <a:stretch xmlns:a="http://schemas.openxmlformats.org/drawingml/2006/main"/>
         </p:blipFill>
         <p:spPr>
@@ -4106,7 +4106,7 @@
     </p:spTree>
     <p:extLst>
       <p:ext uri="{BB962C8B-B14F-4D97-AF65-F5344CB8AC3E}">
-        <p14:creationId xmlns:p14="http://schemas.microsoft.com/office/powerpoint/2010/main" val="1371823393"/>
+        <p14:creationId xmlns:p14="http://schemas.microsoft.com/office/powerpoint/2010/main" val="1337559658"/>
       </p:ext>
     </p:extLst>
   </p:cSld>
@@ -4134,10 +4134,10 @@
       </p:grpSpPr>
       <p:sp>
         <p:nvSpPr>
-          <p:cNvPr id="17" name="text-124">
+          <p:cNvPr id="17" name="text-116">
             <a:extLst xmlns:a="http://schemas.openxmlformats.org/drawingml/2006/main">
               <a:ext uri="{FF2B5EF4-FFF2-40B4-BE49-F238E27FC236}">
-                <a16:creationId xmlns:a16="http://schemas.microsoft.com/office/drawing/2014/main" id="{E21DF932-AC0D-4061-8C97-832F4B4B1115}"/>
+                <a16:creationId xmlns:a16="http://schemas.microsoft.com/office/drawing/2014/main" id="{B4991C50-1520-4238-A6BE-32BB503C0F44}"/>
               </a:ext>
             </a:extLst>
           </p:cNvPr>
@@ -4292,10 +4292,10 @@
       </p:sp>
       <p:sp>
         <p:nvSpPr>
-          <p:cNvPr id="2" name="text-125">
+          <p:cNvPr id="2" name="text-117">
             <a:extLst xmlns:a="http://schemas.openxmlformats.org/drawingml/2006/main">
               <a:ext uri="{FF2B5EF4-FFF2-40B4-BE49-F238E27FC236}">
-                <a16:creationId xmlns:a16="http://schemas.microsoft.com/office/drawing/2014/main" id="{B7C04C55-849E-443A-8A1C-987F5C173033}"/>
+                <a16:creationId xmlns:a16="http://schemas.microsoft.com/office/drawing/2014/main" id="{A013D35C-133C-49EC-8FDA-EF6B86735134}"/>
               </a:ext>
             </a:extLst>
           </p:cNvPr>
@@ -4450,10 +4450,10 @@
       </p:sp>
       <p:sp>
         <p:nvSpPr>
-          <p:cNvPr id="3" name="text-126">
+          <p:cNvPr id="3" name="text-118">
             <a:extLst xmlns:a="http://schemas.openxmlformats.org/drawingml/2006/main">
               <a:ext uri="{FF2B5EF4-FFF2-40B4-BE49-F238E27FC236}">
-                <a16:creationId xmlns:a16="http://schemas.microsoft.com/office/drawing/2014/main" id="{EE22D49E-38BC-4C89-AC4F-3B91D8B2BDCE}"/>
+                <a16:creationId xmlns:a16="http://schemas.microsoft.com/office/drawing/2014/main" id="{B4D9A2C5-2D93-44C1-99C4-AE28D43B4515}"/>
               </a:ext>
             </a:extLst>
           </p:cNvPr>
@@ -4608,10 +4608,10 @@
       </p:sp>
       <p:sp>
         <p:nvSpPr>
-          <p:cNvPr id="4" name="text-127">
+          <p:cNvPr id="4" name="text-119">
             <a:extLst xmlns:a="http://schemas.openxmlformats.org/drawingml/2006/main">
               <a:ext uri="{FF2B5EF4-FFF2-40B4-BE49-F238E27FC236}">
-                <a16:creationId xmlns:a16="http://schemas.microsoft.com/office/drawing/2014/main" id="{94449977-98E4-4DC0-926D-5F525595BCB3}"/>
+                <a16:creationId xmlns:a16="http://schemas.microsoft.com/office/drawing/2014/main" id="{3FFF99AA-B1EC-46CE-B223-57EBEC161F83}"/>
               </a:ext>
             </a:extLst>
           </p:cNvPr>
@@ -4766,10 +4766,10 @@
       </p:sp>
       <p:sp>
         <p:nvSpPr>
-          <p:cNvPr id="5" name="text-128">
+          <p:cNvPr id="5" name="text-120">
             <a:extLst xmlns:a="http://schemas.openxmlformats.org/drawingml/2006/main">
               <a:ext uri="{FF2B5EF4-FFF2-40B4-BE49-F238E27FC236}">
-                <a16:creationId xmlns:a16="http://schemas.microsoft.com/office/drawing/2014/main" id="{44B019AA-255B-448A-9BA0-225BC995207F}"/>
+                <a16:creationId xmlns:a16="http://schemas.microsoft.com/office/drawing/2014/main" id="{F1220BAB-9D5F-44C8-93BE-BC63696431FF}"/>
               </a:ext>
             </a:extLst>
           </p:cNvPr>
@@ -4924,10 +4924,10 @@
       </p:sp>
       <p:sp>
         <p:nvSpPr>
-          <p:cNvPr id="6" name="text-129">
+          <p:cNvPr id="6" name="text-121">
             <a:extLst xmlns:a="http://schemas.openxmlformats.org/drawingml/2006/main">
               <a:ext uri="{FF2B5EF4-FFF2-40B4-BE49-F238E27FC236}">
-                <a16:creationId xmlns:a16="http://schemas.microsoft.com/office/drawing/2014/main" id="{76342ACF-1DC3-494B-80D3-7A6533901905}"/>
+                <a16:creationId xmlns:a16="http://schemas.microsoft.com/office/drawing/2014/main" id="{AADDC635-A4A5-497B-9DDA-E114952D89CD}"/>
               </a:ext>
             </a:extLst>
           </p:cNvPr>
@@ -5082,10 +5082,10 @@
       </p:sp>
       <p:sp>
         <p:nvSpPr>
-          <p:cNvPr id="7" name="text-130">
+          <p:cNvPr id="7" name="text-122">
             <a:extLst xmlns:a="http://schemas.openxmlformats.org/drawingml/2006/main">
               <a:ext uri="{FF2B5EF4-FFF2-40B4-BE49-F238E27FC236}">
-                <a16:creationId xmlns:a16="http://schemas.microsoft.com/office/drawing/2014/main" id="{886CBE18-4560-421E-ABBF-86A42A6B46FE}"/>
+                <a16:creationId xmlns:a16="http://schemas.microsoft.com/office/drawing/2014/main" id="{DC10BBD7-DCB8-447F-8428-A6263A2881DA}"/>
               </a:ext>
             </a:extLst>
           </p:cNvPr>
@@ -5232,7 +5232,7 @@
                 <a:latin typeface="Arial"/>
                 <a:ea typeface="Arial"/>
                 <a:cs typeface="Arial"/>
-                <a:hlinkClick xmlns:r="http://schemas.openxmlformats.org/officeDocument/2006/relationships" r:id="R48e7aa9757b14cb3"/>
+                <a:hlinkClick xmlns:r="http://schemas.openxmlformats.org/officeDocument/2006/relationships" r:id="Ra85f08dd3b6746b1"/>
               </a:rPr>
               <a:t>giumsart@gmail.com</a:t>
             </a:r>
@@ -5241,10 +5241,10 @@
       </p:sp>
       <p:sp>
         <p:nvSpPr>
-          <p:cNvPr id="8" name="text-131">
+          <p:cNvPr id="8" name="text-123">
             <a:extLst xmlns:a="http://schemas.openxmlformats.org/drawingml/2006/main">
               <a:ext uri="{FF2B5EF4-FFF2-40B4-BE49-F238E27FC236}">
-                <a16:creationId xmlns:a16="http://schemas.microsoft.com/office/drawing/2014/main" id="{17C3EEB3-B5CA-498F-83CA-1D272BF3D108}"/>
+                <a16:creationId xmlns:a16="http://schemas.microsoft.com/office/drawing/2014/main" id="{D6C3F91B-376B-47C0-861A-0C0934AD0F2D}"/>
               </a:ext>
             </a:extLst>
           </p:cNvPr>
@@ -5391,7 +5391,7 @@
                 <a:latin typeface="Arial"/>
                 <a:ea typeface="Arial"/>
                 <a:cs typeface="Arial"/>
-                <a:hlinkClick xmlns:r="http://schemas.openxmlformats.org/officeDocument/2006/relationships" r:id="R4581c3307ac246eb"/>
+                <a:hlinkClick xmlns:r="http://schemas.openxmlformats.org/officeDocument/2006/relationships" r:id="R2a408c1b3efa4413"/>
               </a:rPr>
               <a:t>giums.onrender.com</a:t>
             </a:r>
@@ -5400,10 +5400,10 @@
       </p:sp>
       <p:sp>
         <p:nvSpPr>
-          <p:cNvPr id="9" name="text-132">
+          <p:cNvPr id="9" name="text-124">
             <a:extLst xmlns:a="http://schemas.openxmlformats.org/drawingml/2006/main">
               <a:ext uri="{FF2B5EF4-FFF2-40B4-BE49-F238E27FC236}">
-                <a16:creationId xmlns:a16="http://schemas.microsoft.com/office/drawing/2014/main" id="{3ABA1BDA-C22D-4C5F-92C7-0213F48EC358}"/>
+                <a16:creationId xmlns:a16="http://schemas.microsoft.com/office/drawing/2014/main" id="{CD23D840-C643-460A-A5DF-526FD2CD1102}"/>
               </a:ext>
             </a:extLst>
           </p:cNvPr>
@@ -5550,7 +5550,7 @@
                 <a:latin typeface="Arial"/>
                 <a:ea typeface="Arial"/>
                 <a:cs typeface="Arial"/>
-                <a:hlinkClick xmlns:r="http://schemas.openxmlformats.org/officeDocument/2006/relationships" r:id="R6dd87dea09d645ab"/>
+                <a:hlinkClick xmlns:r="http://schemas.openxmlformats.org/officeDocument/2006/relationships" r:id="R28717030f470431e"/>
               </a:rPr>
               <a:t>@giums</a:t>
             </a:r>
@@ -5559,10 +5559,10 @@
       </p:sp>
       <p:sp>
         <p:nvSpPr>
-          <p:cNvPr id="10" name="text-133">
+          <p:cNvPr id="10" name="text-125">
             <a:extLst xmlns:a="http://schemas.openxmlformats.org/drawingml/2006/main">
               <a:ext uri="{FF2B5EF4-FFF2-40B4-BE49-F238E27FC236}">
-                <a16:creationId xmlns:a16="http://schemas.microsoft.com/office/drawing/2014/main" id="{031CC63F-BEAD-4721-950E-28235CF42774}"/>
+                <a16:creationId xmlns:a16="http://schemas.microsoft.com/office/drawing/2014/main" id="{F2F97C36-A584-4FA3-9D8A-C8B0460CD61C}"/>
               </a:ext>
             </a:extLst>
           </p:cNvPr>
@@ -5709,7 +5709,7 @@
                 <a:latin typeface="Arial"/>
                 <a:ea typeface="Arial"/>
                 <a:cs typeface="Arial"/>
-                <a:hlinkClick xmlns:r="http://schemas.openxmlformats.org/officeDocument/2006/relationships" r:id="Rfe62dc73579944d3"/>
+                <a:hlinkClick xmlns:r="http://schemas.openxmlformats.org/officeDocument/2006/relationships" r:id="R28c826b9450a4f4b"/>
               </a:rPr>
               <a:t>@giums.bsky.social</a:t>
             </a:r>
@@ -5718,10 +5718,10 @@
       </p:sp>
       <p:sp>
         <p:nvSpPr>
-          <p:cNvPr id="11" name="text-134">
+          <p:cNvPr id="11" name="text-126">
             <a:extLst xmlns:a="http://schemas.openxmlformats.org/drawingml/2006/main">
               <a:ext uri="{FF2B5EF4-FFF2-40B4-BE49-F238E27FC236}">
-                <a16:creationId xmlns:a16="http://schemas.microsoft.com/office/drawing/2014/main" id="{B0342F76-8E4F-4B1D-93C5-64ED0DDAF6F0}"/>
+                <a16:creationId xmlns:a16="http://schemas.microsoft.com/office/drawing/2014/main" id="{F9AB733A-04C2-4964-AC4A-BE2F74B1D189}"/>
               </a:ext>
             </a:extLst>
           </p:cNvPr>
@@ -5868,7 +5868,7 @@
                 <a:latin typeface="Arial"/>
                 <a:ea typeface="Arial"/>
                 <a:cs typeface="Arial"/>
-                <a:hlinkClick xmlns:r="http://schemas.openxmlformats.org/officeDocument/2006/relationships" r:id="Rf388347cf3b547c9"/>
+                <a:hlinkClick xmlns:r="http://schemas.openxmlformats.org/officeDocument/2006/relationships" r:id="R708dfc3bc70c4a8b"/>
               </a:rPr>
               <a:t>@GIUMSyt</a:t>
             </a:r>
@@ -5877,10 +5877,10 @@
       </p:sp>
       <p:sp>
         <p:nvSpPr>
-          <p:cNvPr id="12" name="text-135">
+          <p:cNvPr id="12" name="text-127">
             <a:extLst xmlns:a="http://schemas.openxmlformats.org/drawingml/2006/main">
               <a:ext uri="{FF2B5EF4-FFF2-40B4-BE49-F238E27FC236}">
-                <a16:creationId xmlns:a16="http://schemas.microsoft.com/office/drawing/2014/main" id="{E220566E-AE9B-4A52-81AF-1C2685222564}"/>
+                <a16:creationId xmlns:a16="http://schemas.microsoft.com/office/drawing/2014/main" id="{549D11F4-6BC2-4A45-8BE2-26C35895587F}"/>
               </a:ext>
             </a:extLst>
           </p:cNvPr>
@@ -6027,7 +6027,7 @@
                 <a:latin typeface="Arial"/>
                 <a:ea typeface="Arial"/>
                 <a:cs typeface="Arial"/>
-                <a:hlinkClick xmlns:r="http://schemas.openxmlformats.org/officeDocument/2006/relationships" r:id="R59e24c0143b64e43"/>
+                <a:hlinkClick xmlns:r="http://schemas.openxmlformats.org/officeDocument/2006/relationships" r:id="Rb86a8c227fd54559"/>
               </a:rPr>
               <a:t>twitch.tv/giums</a:t>
             </a:r>
@@ -6036,10 +6036,10 @@
       </p:sp>
       <p:sp>
         <p:nvSpPr>
-          <p:cNvPr id="13" name="text-136">
+          <p:cNvPr id="13" name="text-128">
             <a:extLst xmlns:a="http://schemas.openxmlformats.org/drawingml/2006/main">
               <a:ext uri="{FF2B5EF4-FFF2-40B4-BE49-F238E27FC236}">
-                <a16:creationId xmlns:a16="http://schemas.microsoft.com/office/drawing/2014/main" id="{427603CE-52CC-4D67-8D03-75E66B3BDA20}"/>
+                <a16:creationId xmlns:a16="http://schemas.microsoft.com/office/drawing/2014/main" id="{05F3515B-C348-43AB-87A4-9AF2698E86C3}"/>
               </a:ext>
             </a:extLst>
           </p:cNvPr>
@@ -6186,7 +6186,7 @@
                 <a:latin typeface="Arial"/>
                 <a:ea typeface="Arial"/>
                 <a:cs typeface="Arial"/>
-                <a:hlinkClick xmlns:r="http://schemas.openxmlformats.org/officeDocument/2006/relationships" r:id="R82095f61abcd4f05"/>
+                <a:hlinkClick xmlns:r="http://schemas.openxmlformats.org/officeDocument/2006/relationships" r:id="R00285faa0eae42ad"/>
               </a:rPr>
               <a:t>patreon.com/giums</a:t>
             </a:r>
@@ -6195,10 +6195,10 @@
       </p:sp>
       <p:sp>
         <p:nvSpPr>
-          <p:cNvPr id="14" name="text-137">
+          <p:cNvPr id="14" name="text-129">
             <a:extLst xmlns:a="http://schemas.openxmlformats.org/drawingml/2006/main">
               <a:ext uri="{FF2B5EF4-FFF2-40B4-BE49-F238E27FC236}">
-                <a16:creationId xmlns:a16="http://schemas.microsoft.com/office/drawing/2014/main" id="{89F17BC6-E892-4149-80FF-8341945ACAE9}"/>
+                <a16:creationId xmlns:a16="http://schemas.microsoft.com/office/drawing/2014/main" id="{F0714B89-B66E-44DA-92FF-5D8262690B80}"/>
               </a:ext>
             </a:extLst>
           </p:cNvPr>
@@ -6353,10 +6353,10 @@
       </p:sp>
       <p:sp>
         <p:nvSpPr>
-          <p:cNvPr id="15" name="text-138">
+          <p:cNvPr id="15" name="text-130">
             <a:extLst xmlns:a="http://schemas.openxmlformats.org/drawingml/2006/main">
               <a:ext uri="{FF2B5EF4-FFF2-40B4-BE49-F238E27FC236}">
-                <a16:creationId xmlns:a16="http://schemas.microsoft.com/office/drawing/2014/main" id="{772B7199-8D1A-4181-AA28-13A757E879E1}"/>
+                <a16:creationId xmlns:a16="http://schemas.microsoft.com/office/drawing/2014/main" id="{F60093C1-225A-4DB6-A3BA-705A3BC5BE7A}"/>
               </a:ext>
             </a:extLst>
           </p:cNvPr>
@@ -6511,10 +6511,10 @@
       </p:sp>
       <p:sp>
         <p:nvSpPr>
-          <p:cNvPr id="16" name="text-139">
+          <p:cNvPr id="16" name="text-131">
             <a:extLst xmlns:a="http://schemas.openxmlformats.org/drawingml/2006/main">
               <a:ext uri="{FF2B5EF4-FFF2-40B4-BE49-F238E27FC236}">
-                <a16:creationId xmlns:a16="http://schemas.microsoft.com/office/drawing/2014/main" id="{B4469BFF-8CF5-4A36-9C38-0C5A317F0D15}"/>
+                <a16:creationId xmlns:a16="http://schemas.microsoft.com/office/drawing/2014/main" id="{A875FBEF-8F56-4D39-A183-15F971F98C89}"/>
               </a:ext>
             </a:extLst>
           </p:cNvPr>
@@ -6670,7 +6670,7 @@
     </p:spTree>
     <p:extLst>
       <p:ext uri="{BB962C8B-B14F-4D97-AF65-F5344CB8AC3E}">
-        <p14:creationId xmlns:p14="http://schemas.microsoft.com/office/powerpoint/2010/main" val="2000653163"/>
+        <p14:creationId xmlns:p14="http://schemas.microsoft.com/office/powerpoint/2010/main" val="259899972"/>
       </p:ext>
     </p:extLst>
   </p:cSld>
@@ -6701,7 +6701,7 @@
           <p:cNvPr id="10" name="text-1">
             <a:extLst xmlns:a="http://schemas.openxmlformats.org/drawingml/2006/main">
               <a:ext uri="{FF2B5EF4-FFF2-40B4-BE49-F238E27FC236}">
-                <a16:creationId xmlns:a16="http://schemas.microsoft.com/office/drawing/2014/main" id="{426D3649-FA41-4145-9965-11B1FC940DA5}"/>
+                <a16:creationId xmlns:a16="http://schemas.microsoft.com/office/drawing/2014/main" id="{D0A74FA6-68AF-404D-86DA-212C548CE33C}"/>
               </a:ext>
             </a:extLst>
           </p:cNvPr>
@@ -6859,7 +6859,7 @@
           <p:cNvPr id="2" name="text-2">
             <a:extLst xmlns:a="http://schemas.openxmlformats.org/drawingml/2006/main">
               <a:ext uri="{FF2B5EF4-FFF2-40B4-BE49-F238E27FC236}">
-                <a16:creationId xmlns:a16="http://schemas.microsoft.com/office/drawing/2014/main" id="{9ACCC0E4-45ED-4A6A-A7B9-39CE7376AD25}"/>
+                <a16:creationId xmlns:a16="http://schemas.microsoft.com/office/drawing/2014/main" id="{F21B263D-175F-4A6D-ABAC-CD2C32E07403}"/>
               </a:ext>
             </a:extLst>
           </p:cNvPr>
@@ -7017,7 +7017,7 @@
           <p:cNvPr id="3" name="text-3">
             <a:extLst xmlns:a="http://schemas.openxmlformats.org/drawingml/2006/main">
               <a:ext uri="{FF2B5EF4-FFF2-40B4-BE49-F238E27FC236}">
-                <a16:creationId xmlns:a16="http://schemas.microsoft.com/office/drawing/2014/main" id="{4FFC7401-D5D1-462A-B73F-6BDCF3868C9F}"/>
+                <a16:creationId xmlns:a16="http://schemas.microsoft.com/office/drawing/2014/main" id="{0D5B0EF1-2CFF-4D86-9F5B-2E46EDC9C5F9}"/>
               </a:ext>
             </a:extLst>
           </p:cNvPr>
@@ -7175,7 +7175,7 @@
           <p:cNvPr id="4" name="text-4">
             <a:extLst xmlns:a="http://schemas.openxmlformats.org/drawingml/2006/main">
               <a:ext uri="{FF2B5EF4-FFF2-40B4-BE49-F238E27FC236}">
-                <a16:creationId xmlns:a16="http://schemas.microsoft.com/office/drawing/2014/main" id="{E080647E-2CF2-499E-A44D-4F3011906EC1}"/>
+                <a16:creationId xmlns:a16="http://schemas.microsoft.com/office/drawing/2014/main" id="{F79BD9FF-C9CE-4CA0-A608-57C98E9AE8F3}"/>
               </a:ext>
             </a:extLst>
           </p:cNvPr>
@@ -7333,7 +7333,7 @@
           <p:cNvPr id="5" name="">
             <a:extLst xmlns:a="http://schemas.openxmlformats.org/drawingml/2006/main">
               <a:ext uri="{FF2B5EF4-FFF2-40B4-BE49-F238E27FC236}">
-                <a16:creationId xmlns:a16="http://schemas.microsoft.com/office/drawing/2014/main" id="{C694F387-FC8C-4514-AE22-21BE1CE365D0}"/>
+                <a16:creationId xmlns:a16="http://schemas.microsoft.com/office/drawing/2014/main" id="{C08F961C-B959-4B20-8DE1-0D28A9E6AA1D}"/>
               </a:ext>
             </a:extLst>
           </p:cNvPr>
@@ -7343,7 +7343,7 @@
           <p:nvPr/>
         </p:nvPicPr>
         <p:blipFill>
-          <a:blip xmlns:r="http://schemas.openxmlformats.org/officeDocument/2006/relationships" xmlns:a="http://schemas.openxmlformats.org/drawingml/2006/main" r:embed="R22bd407601714789"/>
+          <a:blip xmlns:r="http://schemas.openxmlformats.org/officeDocument/2006/relationships" xmlns:a="http://schemas.openxmlformats.org/drawingml/2006/main" r:embed="R2df65e1c98324e83"/>
           <a:srcRect xmlns:a="http://schemas.openxmlformats.org/drawingml/2006/main" l="0" t="4591" r="0" b="4591"/>
           <a:stretch xmlns:a="http://schemas.openxmlformats.org/drawingml/2006/main">
             <a:fillRect l="0" t="0" r="0" b="0"/>
@@ -7364,7 +7364,7 @@
           <p:cNvPr id="6" name="text-5">
             <a:extLst xmlns:a="http://schemas.openxmlformats.org/drawingml/2006/main">
               <a:ext uri="{FF2B5EF4-FFF2-40B4-BE49-F238E27FC236}">
-                <a16:creationId xmlns:a16="http://schemas.microsoft.com/office/drawing/2014/main" id="{47099D34-FB29-4FFE-9D80-DB21EE0ADC93}"/>
+                <a16:creationId xmlns:a16="http://schemas.microsoft.com/office/drawing/2014/main" id="{E2C03E35-57DE-494D-8E69-2EA451DF78AD}"/>
               </a:ext>
             </a:extLst>
           </p:cNvPr>
@@ -7522,7 +7522,7 @@
           <p:cNvPr id="7" name="text-6">
             <a:extLst xmlns:a="http://schemas.openxmlformats.org/drawingml/2006/main">
               <a:ext uri="{FF2B5EF4-FFF2-40B4-BE49-F238E27FC236}">
-                <a16:creationId xmlns:a16="http://schemas.microsoft.com/office/drawing/2014/main" id="{3310B48F-6757-49E6-B415-41A10672BD74}"/>
+                <a16:creationId xmlns:a16="http://schemas.microsoft.com/office/drawing/2014/main" id="{D20CCBE6-0639-4BBE-BD54-35D829ABE29C}"/>
               </a:ext>
             </a:extLst>
           </p:cNvPr>
@@ -7680,7 +7680,7 @@
           <p:cNvPr id="8" name="text-7">
             <a:extLst xmlns:a="http://schemas.openxmlformats.org/drawingml/2006/main">
               <a:ext uri="{FF2B5EF4-FFF2-40B4-BE49-F238E27FC236}">
-                <a16:creationId xmlns:a16="http://schemas.microsoft.com/office/drawing/2014/main" id="{EDFD7A17-F300-408F-B9FA-39EE0CDB5667}"/>
+                <a16:creationId xmlns:a16="http://schemas.microsoft.com/office/drawing/2014/main" id="{DA73A4A1-6A3C-4DD5-9041-90EF5421D9E9}"/>
               </a:ext>
             </a:extLst>
           </p:cNvPr>
@@ -7838,7 +7838,7 @@
           <p:cNvPr id="9" name="text-8">
             <a:extLst xmlns:a="http://schemas.openxmlformats.org/drawingml/2006/main">
               <a:ext uri="{FF2B5EF4-FFF2-40B4-BE49-F238E27FC236}">
-                <a16:creationId xmlns:a16="http://schemas.microsoft.com/office/drawing/2014/main" id="{F3BB6555-D043-41D1-82C3-4E7BFCB35366}"/>
+                <a16:creationId xmlns:a16="http://schemas.microsoft.com/office/drawing/2014/main" id="{7E68F585-AB5D-4DCA-AD7E-37103410259E}"/>
               </a:ext>
             </a:extLst>
           </p:cNvPr>
@@ -7994,7 +7994,7 @@
     </p:spTree>
     <p:extLst>
       <p:ext uri="{BB962C8B-B14F-4D97-AF65-F5344CB8AC3E}">
-        <p14:creationId xmlns:p14="http://schemas.microsoft.com/office/powerpoint/2010/main" val="1196414749"/>
+        <p14:creationId xmlns:p14="http://schemas.microsoft.com/office/powerpoint/2010/main" val="769847329"/>
       </p:ext>
     </p:extLst>
   </p:cSld>
@@ -8022,10 +8022,10 @@
       </p:grpSpPr>
       <p:sp>
         <p:nvSpPr>
-          <p:cNvPr id="17" name="text-9">
+          <p:cNvPr id="9" name="text-9">
             <a:extLst xmlns:a="http://schemas.openxmlformats.org/drawingml/2006/main">
               <a:ext uri="{FF2B5EF4-FFF2-40B4-BE49-F238E27FC236}">
-                <a16:creationId xmlns:a16="http://schemas.microsoft.com/office/drawing/2014/main" id="{CFA759C8-1B7F-40DA-B31F-7E4BD2D7D669}"/>
+                <a16:creationId xmlns:a16="http://schemas.microsoft.com/office/drawing/2014/main" id="{F1D4B3A9-B846-444F-BF4E-DBE7A0729F7C}"/>
               </a:ext>
             </a:extLst>
           </p:cNvPr>
@@ -8183,7 +8183,7 @@
           <p:cNvPr id="2" name="text-10">
             <a:extLst xmlns:a="http://schemas.openxmlformats.org/drawingml/2006/main">
               <a:ext uri="{FF2B5EF4-FFF2-40B4-BE49-F238E27FC236}">
-                <a16:creationId xmlns:a16="http://schemas.microsoft.com/office/drawing/2014/main" id="{5D506F7F-7205-424F-9EFE-EC985F2C448F}"/>
+                <a16:creationId xmlns:a16="http://schemas.microsoft.com/office/drawing/2014/main" id="{FB16C527-7E03-485A-83A4-FA21028D5D2F}"/>
               </a:ext>
             </a:extLst>
           </p:cNvPr>
@@ -8341,7 +8341,7 @@
           <p:cNvPr id="3" name="text-11">
             <a:extLst xmlns:a="http://schemas.openxmlformats.org/drawingml/2006/main">
               <a:ext uri="{FF2B5EF4-FFF2-40B4-BE49-F238E27FC236}">
-                <a16:creationId xmlns:a16="http://schemas.microsoft.com/office/drawing/2014/main" id="{4201BDFB-CB59-4E58-B300-75AA275F13BB}"/>
+                <a16:creationId xmlns:a16="http://schemas.microsoft.com/office/drawing/2014/main" id="{14EF2C13-790C-4F2F-909B-0B2227F022CA}"/>
               </a:ext>
             </a:extLst>
           </p:cNvPr>
@@ -8499,7 +8499,7 @@
           <p:cNvPr id="4" name="text-12">
             <a:extLst xmlns:a="http://schemas.openxmlformats.org/drawingml/2006/main">
               <a:ext uri="{FF2B5EF4-FFF2-40B4-BE49-F238E27FC236}">
-                <a16:creationId xmlns:a16="http://schemas.microsoft.com/office/drawing/2014/main" id="{EEA42201-A728-4F13-9C5F-50903090F31F}"/>
+                <a16:creationId xmlns:a16="http://schemas.microsoft.com/office/drawing/2014/main" id="{AEC927A9-AB14-4A79-BDD4-92E5D8F516F3}"/>
               </a:ext>
             </a:extLst>
           </p:cNvPr>
@@ -8657,7 +8657,7 @@
           <p:cNvPr id="5" name="text-13">
             <a:extLst xmlns:a="http://schemas.openxmlformats.org/drawingml/2006/main">
               <a:ext uri="{FF2B5EF4-FFF2-40B4-BE49-F238E27FC236}">
-                <a16:creationId xmlns:a16="http://schemas.microsoft.com/office/drawing/2014/main" id="{89F1F537-3696-4E6C-861C-DBF7BCEECF30}"/>
+                <a16:creationId xmlns:a16="http://schemas.microsoft.com/office/drawing/2014/main" id="{9E202F7D-F45C-4A06-81F7-42BD99EDF121}"/>
               </a:ext>
             </a:extLst>
           </p:cNvPr>
@@ -8668,8 +8668,8 @@
         </p:nvSpPr>
         <p:spPr>
           <a:xfrm xmlns:a="http://schemas.openxmlformats.org/drawingml/2006/main">
-            <a:off x="609600" y="1752600"/>
-            <a:ext cx="5238750" cy="523875"/>
+            <a:off x="609600" y="1885950"/>
+            <a:ext cx="5238750" cy="952500"/>
           </a:xfrm>
           <a:prstGeom xmlns:a="http://schemas.openxmlformats.org/drawingml/2006/main" prst="rect">
             <a:avLst/>
@@ -8685,7 +8685,7 @@
           </a:bodyPr>
           <a:lstStyle xmlns:a="http://schemas.openxmlformats.org/drawingml/2006/main">
             <a:defPPr>
-              <a:defRPr sz="2250" b="0">
+              <a:defRPr sz="2400" b="0">
                 <a:solidFill>
                   <a:srgbClr val="C2142F"/>
                 </a:solidFill>
@@ -8695,7 +8695,7 @@
               </a:defRPr>
             </a:defPPr>
             <a:lvl1pPr>
-              <a:defRPr sz="2250" b="0">
+              <a:defRPr sz="2400" b="0">
                 <a:solidFill>
                   <a:srgbClr val="C2142F"/>
                 </a:solidFill>
@@ -8705,7 +8705,7 @@
               </a:defRPr>
             </a:lvl1pPr>
             <a:lvl2pPr>
-              <a:defRPr sz="2250" b="0">
+              <a:defRPr sz="2400" b="0">
                 <a:solidFill>
                   <a:srgbClr val="C2142F"/>
                 </a:solidFill>
@@ -8715,7 +8715,7 @@
               </a:defRPr>
             </a:lvl2pPr>
             <a:lvl3pPr>
-              <a:defRPr sz="2250" b="0">
+              <a:defRPr sz="2400" b="0">
                 <a:solidFill>
                   <a:srgbClr val="C2142F"/>
                 </a:solidFill>
@@ -8725,7 +8725,7 @@
               </a:defRPr>
             </a:lvl3pPr>
             <a:lvl4pPr>
-              <a:defRPr sz="2250" b="0">
+              <a:defRPr sz="2400" b="0">
                 <a:solidFill>
                   <a:srgbClr val="C2142F"/>
                 </a:solidFill>
@@ -8735,7 +8735,7 @@
               </a:defRPr>
             </a:lvl4pPr>
             <a:lvl5pPr>
-              <a:defRPr sz="2250" b="0">
+              <a:defRPr sz="2400" b="0">
                 <a:solidFill>
                   <a:srgbClr val="C2142F"/>
                 </a:solidFill>
@@ -8745,7 +8745,7 @@
               </a:defRPr>
             </a:lvl5pPr>
             <a:lvl6pPr>
-              <a:defRPr sz="2250" b="0">
+              <a:defRPr sz="2400" b="0">
                 <a:solidFill>
                   <a:srgbClr val="C2142F"/>
                 </a:solidFill>
@@ -8755,7 +8755,7 @@
               </a:defRPr>
             </a:lvl6pPr>
             <a:lvl7pPr>
-              <a:defRPr sz="2250" b="0">
+              <a:defRPr sz="2400" b="0">
                 <a:solidFill>
                   <a:srgbClr val="C2142F"/>
                 </a:solidFill>
@@ -8765,7 +8765,7 @@
               </a:defRPr>
             </a:lvl7pPr>
             <a:lvl8pPr>
-              <a:defRPr sz="2250" b="0">
+              <a:defRPr sz="2400" b="0">
                 <a:solidFill>
                   <a:srgbClr val="C2142F"/>
                 </a:solidFill>
@@ -8775,7 +8775,7 @@
               </a:defRPr>
             </a:lvl8pPr>
             <a:lvl9pPr>
-              <a:defRPr sz="2250" b="0">
+              <a:defRPr sz="2400" b="0">
                 <a:solidFill>
                   <a:srgbClr val="C2142F"/>
                 </a:solidFill>
@@ -8787,7 +8787,7 @@
           </a:lstStyle>
           <a:p xmlns:a="http://schemas.openxmlformats.org/drawingml/2006/main">
             <a:pPr>
-              <a:defRPr sz="2250" b="0">
+              <a:defRPr sz="2400" b="0">
                 <a:solidFill>
                   <a:srgbClr val="C2142F"/>
                 </a:solidFill>
@@ -8797,7 +8797,7 @@
               </a:defRPr>
             </a:pPr>
             <a:r>
-              <a:rPr sz="2250" b="0">
+              <a:rPr sz="2400" b="0">
                 <a:solidFill>
                   <a:srgbClr val="C2142F"/>
                 </a:solidFill>
@@ -8805,7 +8805,7 @@
                 <a:ea typeface="Georgia"/>
                 <a:cs typeface="Georgia"/>
               </a:rPr>
-              <a:t>Tabletop RPG &amp; games</a:t>
+              <a:t>Original Artwork Development</a:t>
             </a:r>
           </a:p>
         </p:txBody>
@@ -8815,7 +8815,7 @@
           <p:cNvPr id="6" name="text-14">
             <a:extLst xmlns:a="http://schemas.openxmlformats.org/drawingml/2006/main">
               <a:ext uri="{FF2B5EF4-FFF2-40B4-BE49-F238E27FC236}">
-                <a16:creationId xmlns:a16="http://schemas.microsoft.com/office/drawing/2014/main" id="{EF6BEBA0-68E0-4A1D-80D7-B81CD9AD6368}"/>
+                <a16:creationId xmlns:a16="http://schemas.microsoft.com/office/drawing/2014/main" id="{2261BEF9-8963-4FED-AD1A-0C3C30C34C23}"/>
               </a:ext>
             </a:extLst>
           </p:cNvPr>
@@ -8826,8 +8826,8 @@
         </p:nvSpPr>
         <p:spPr>
           <a:xfrm xmlns:a="http://schemas.openxmlformats.org/drawingml/2006/main">
-            <a:off x="609600" y="2419350"/>
-            <a:ext cx="5238750" cy="1390650"/>
+            <a:off x="609600" y="3057525"/>
+            <a:ext cx="5238750" cy="2857500"/>
           </a:xfrm>
           <a:prstGeom xmlns:a="http://schemas.openxmlformats.org/drawingml/2006/main" prst="rect">
             <a:avLst/>
@@ -8843,7 +8843,7 @@
           </a:bodyPr>
           <a:lstStyle xmlns:a="http://schemas.openxmlformats.org/drawingml/2006/main">
             <a:defPPr>
-              <a:defRPr sz="1800" b="0">
+              <a:defRPr sz="2100" b="0">
                 <a:solidFill>
                   <a:srgbClr val="111015"/>
                 </a:solidFill>
@@ -8853,7 +8853,7 @@
               </a:defRPr>
             </a:defPPr>
             <a:lvl1pPr>
-              <a:defRPr sz="1800" b="0">
+              <a:defRPr sz="2100" b="0">
                 <a:solidFill>
                   <a:srgbClr val="111015"/>
                 </a:solidFill>
@@ -8863,7 +8863,7 @@
               </a:defRPr>
             </a:lvl1pPr>
             <a:lvl2pPr>
-              <a:defRPr sz="1800" b="0">
+              <a:defRPr sz="2100" b="0">
                 <a:solidFill>
                   <a:srgbClr val="111015"/>
                 </a:solidFill>
@@ -8873,7 +8873,7 @@
               </a:defRPr>
             </a:lvl2pPr>
             <a:lvl3pPr>
-              <a:defRPr sz="1800" b="0">
+              <a:defRPr sz="2100" b="0">
                 <a:solidFill>
                   <a:srgbClr val="111015"/>
                 </a:solidFill>
@@ -8883,7 +8883,7 @@
               </a:defRPr>
             </a:lvl3pPr>
             <a:lvl4pPr>
-              <a:defRPr sz="1800" b="0">
+              <a:defRPr sz="2100" b="0">
                 <a:solidFill>
                   <a:srgbClr val="111015"/>
                 </a:solidFill>
@@ -8893,7 +8893,7 @@
               </a:defRPr>
             </a:lvl4pPr>
             <a:lvl5pPr>
-              <a:defRPr sz="1800" b="0">
+              <a:defRPr sz="2100" b="0">
                 <a:solidFill>
                   <a:srgbClr val="111015"/>
                 </a:solidFill>
@@ -8903,7 +8903,7 @@
               </a:defRPr>
             </a:lvl5pPr>
             <a:lvl6pPr>
-              <a:defRPr sz="1800" b="0">
+              <a:defRPr sz="2100" b="0">
                 <a:solidFill>
                   <a:srgbClr val="111015"/>
                 </a:solidFill>
@@ -8913,7 +8913,7 @@
               </a:defRPr>
             </a:lvl6pPr>
             <a:lvl7pPr>
-              <a:defRPr sz="1800" b="0">
+              <a:defRPr sz="2100" b="0">
                 <a:solidFill>
                   <a:srgbClr val="111015"/>
                 </a:solidFill>
@@ -8923,7 +8923,7 @@
               </a:defRPr>
             </a:lvl7pPr>
             <a:lvl8pPr>
-              <a:defRPr sz="1800" b="0">
+              <a:defRPr sz="2100" b="0">
                 <a:solidFill>
                   <a:srgbClr val="111015"/>
                 </a:solidFill>
@@ -8933,7 +8933,7 @@
               </a:defRPr>
             </a:lvl8pPr>
             <a:lvl9pPr>
-              <a:defRPr sz="1800" b="0">
+              <a:defRPr sz="2100" b="0">
                 <a:solidFill>
                   <a:srgbClr val="111015"/>
                 </a:solidFill>
@@ -8945,7 +8945,7 @@
           </a:lstStyle>
           <a:p xmlns:a="http://schemas.openxmlformats.org/drawingml/2006/main">
             <a:pPr>
-              <a:defRPr sz="1800" b="0">
+              <a:defRPr sz="2100" b="0">
                 <a:solidFill>
                   <a:srgbClr val="111015"/>
                 </a:solidFill>
@@ -8955,7 +8955,7 @@
               </a:defRPr>
             </a:pPr>
             <a:r>
-              <a:rPr sz="1800" b="0">
+              <a:rPr sz="2100" b="0">
                 <a:solidFill>
                   <a:srgbClr val="111015"/>
                 </a:solidFill>
@@ -8963,7 +8963,7 @@
                 <a:ea typeface="Arial"/>
                 <a:cs typeface="Arial"/>
               </a:rPr>
-              <a:t>Designed for your project: characters, creatures and settings with visual consistency, ready to publish, serving publishers, game studios, TCG creators and independent community projects.</a:t>
+              <a:t>Illustrations that help tell your story: characters, creatures and settings with visual consistency, ready to publish. Serving publishers, game studios, TCG creators and independent projects.</a:t>
             </a:r>
           </a:p>
         </p:txBody>
@@ -8973,7 +8973,7 @@
           <p:cNvPr id="7" name="text-15">
             <a:extLst xmlns:a="http://schemas.openxmlformats.org/drawingml/2006/main">
               <a:ext uri="{FF2B5EF4-FFF2-40B4-BE49-F238E27FC236}">
-                <a16:creationId xmlns:a16="http://schemas.microsoft.com/office/drawing/2014/main" id="{C0885768-54E4-41D7-A57E-D356F6B082A3}"/>
+                <a16:creationId xmlns:a16="http://schemas.microsoft.com/office/drawing/2014/main" id="{D621A279-E8C7-4E88-BA74-0132842E23DA}"/>
               </a:ext>
             </a:extLst>
           </p:cNvPr>
@@ -8984,8 +8984,8 @@
         </p:nvSpPr>
         <p:spPr>
           <a:xfrm xmlns:a="http://schemas.openxmlformats.org/drawingml/2006/main">
-            <a:off x="6286500" y="1752600"/>
-            <a:ext cx="5238750" cy="523875"/>
+            <a:off x="6286500" y="1885950"/>
+            <a:ext cx="5238750" cy="952500"/>
           </a:xfrm>
           <a:prstGeom xmlns:a="http://schemas.openxmlformats.org/drawingml/2006/main" prst="rect">
             <a:avLst/>
@@ -9001,7 +9001,7 @@
           </a:bodyPr>
           <a:lstStyle xmlns:a="http://schemas.openxmlformats.org/drawingml/2006/main">
             <a:defPPr>
-              <a:defRPr sz="2250" b="0">
+              <a:defRPr sz="2400" b="0">
                 <a:solidFill>
                   <a:srgbClr val="C2142F"/>
                 </a:solidFill>
@@ -9011,7 +9011,7 @@
               </a:defRPr>
             </a:defPPr>
             <a:lvl1pPr>
-              <a:defRPr sz="2250" b="0">
+              <a:defRPr sz="2400" b="0">
                 <a:solidFill>
                   <a:srgbClr val="C2142F"/>
                 </a:solidFill>
@@ -9021,7 +9021,7 @@
               </a:defRPr>
             </a:lvl1pPr>
             <a:lvl2pPr>
-              <a:defRPr sz="2250" b="0">
+              <a:defRPr sz="2400" b="0">
                 <a:solidFill>
                   <a:srgbClr val="C2142F"/>
                 </a:solidFill>
@@ -9031,7 +9031,7 @@
               </a:defRPr>
             </a:lvl2pPr>
             <a:lvl3pPr>
-              <a:defRPr sz="2250" b="0">
+              <a:defRPr sz="2400" b="0">
                 <a:solidFill>
                   <a:srgbClr val="C2142F"/>
                 </a:solidFill>
@@ -9041,7 +9041,7 @@
               </a:defRPr>
             </a:lvl3pPr>
             <a:lvl4pPr>
-              <a:defRPr sz="2250" b="0">
+              <a:defRPr sz="2400" b="0">
                 <a:solidFill>
                   <a:srgbClr val="C2142F"/>
                 </a:solidFill>
@@ -9051,7 +9051,7 @@
               </a:defRPr>
             </a:lvl4pPr>
             <a:lvl5pPr>
-              <a:defRPr sz="2250" b="0">
+              <a:defRPr sz="2400" b="0">
                 <a:solidFill>
                   <a:srgbClr val="C2142F"/>
                 </a:solidFill>
@@ -9061,7 +9061,7 @@
               </a:defRPr>
             </a:lvl5pPr>
             <a:lvl6pPr>
-              <a:defRPr sz="2250" b="0">
+              <a:defRPr sz="2400" b="0">
                 <a:solidFill>
                   <a:srgbClr val="C2142F"/>
                 </a:solidFill>
@@ -9071,7 +9071,7 @@
               </a:defRPr>
             </a:lvl6pPr>
             <a:lvl7pPr>
-              <a:defRPr sz="2250" b="0">
+              <a:defRPr sz="2400" b="0">
                 <a:solidFill>
                   <a:srgbClr val="C2142F"/>
                 </a:solidFill>
@@ -9081,7 +9081,7 @@
               </a:defRPr>
             </a:lvl7pPr>
             <a:lvl8pPr>
-              <a:defRPr sz="2250" b="0">
+              <a:defRPr sz="2400" b="0">
                 <a:solidFill>
                   <a:srgbClr val="C2142F"/>
                 </a:solidFill>
@@ -9091,7 +9091,7 @@
               </a:defRPr>
             </a:lvl8pPr>
             <a:lvl9pPr>
-              <a:defRPr sz="2250" b="0">
+              <a:defRPr sz="2400" b="0">
                 <a:solidFill>
                   <a:srgbClr val="C2142F"/>
                 </a:solidFill>
@@ -9103,7 +9103,7 @@
           </a:lstStyle>
           <a:p xmlns:a="http://schemas.openxmlformats.org/drawingml/2006/main">
             <a:pPr>
-              <a:defRPr sz="2250" b="0">
+              <a:defRPr sz="2400" b="0">
                 <a:solidFill>
                   <a:srgbClr val="C2142F"/>
                 </a:solidFill>
@@ -9113,7 +9113,7 @@
               </a:defRPr>
             </a:pPr>
             <a:r>
-              <a:rPr sz="2250" b="0">
+              <a:rPr sz="2400" b="0">
                 <a:solidFill>
                   <a:srgbClr val="C2142F"/>
                 </a:solidFill>
@@ -9121,7 +9121,7 @@
                 <a:ea typeface="Georgia"/>
                 <a:cs typeface="Georgia"/>
               </a:rPr>
-              <a:t>Content for brands</a:t>
+              <a:t>Co-creation with brands</a:t>
             </a:r>
           </a:p>
         </p:txBody>
@@ -9131,7 +9131,7 @@
           <p:cNvPr id="8" name="text-16">
             <a:extLst xmlns:a="http://schemas.openxmlformats.org/drawingml/2006/main">
               <a:ext uri="{FF2B5EF4-FFF2-40B4-BE49-F238E27FC236}">
-                <a16:creationId xmlns:a16="http://schemas.microsoft.com/office/drawing/2014/main" id="{6D27D6D4-A75F-46EE-8318-CF5EFAC83C53}"/>
+                <a16:creationId xmlns:a16="http://schemas.microsoft.com/office/drawing/2014/main" id="{4506F440-ECAF-463A-94EB-F1C409B84702}"/>
               </a:ext>
             </a:extLst>
           </p:cNvPr>
@@ -9142,8 +9142,8 @@
         </p:nvSpPr>
         <p:spPr>
           <a:xfrm xmlns:a="http://schemas.openxmlformats.org/drawingml/2006/main">
-            <a:off x="6286500" y="2419350"/>
-            <a:ext cx="5238750" cy="857250"/>
+            <a:off x="6286500" y="3057525"/>
+            <a:ext cx="5238750" cy="2857500"/>
           </a:xfrm>
           <a:prstGeom xmlns:a="http://schemas.openxmlformats.org/drawingml/2006/main" prst="rect">
             <a:avLst/>
@@ -9159,7 +9159,7 @@
           </a:bodyPr>
           <a:lstStyle xmlns:a="http://schemas.openxmlformats.org/drawingml/2006/main">
             <a:defPPr>
-              <a:defRPr sz="1800" b="0">
+              <a:defRPr sz="2100" b="0">
                 <a:solidFill>
                   <a:srgbClr val="111015"/>
                 </a:solidFill>
@@ -9169,7 +9169,7 @@
               </a:defRPr>
             </a:defPPr>
             <a:lvl1pPr>
-              <a:defRPr sz="1800" b="0">
+              <a:defRPr sz="2100" b="0">
                 <a:solidFill>
                   <a:srgbClr val="111015"/>
                 </a:solidFill>
@@ -9179,7 +9179,7 @@
               </a:defRPr>
             </a:lvl1pPr>
             <a:lvl2pPr>
-              <a:defRPr sz="1800" b="0">
+              <a:defRPr sz="2100" b="0">
                 <a:solidFill>
                   <a:srgbClr val="111015"/>
                 </a:solidFill>
@@ -9189,7 +9189,7 @@
               </a:defRPr>
             </a:lvl2pPr>
             <a:lvl3pPr>
-              <a:defRPr sz="1800" b="0">
+              <a:defRPr sz="2100" b="0">
                 <a:solidFill>
                   <a:srgbClr val="111015"/>
                 </a:solidFill>
@@ -9199,7 +9199,7 @@
               </a:defRPr>
             </a:lvl3pPr>
             <a:lvl4pPr>
-              <a:defRPr sz="1800" b="0">
+              <a:defRPr sz="2100" b="0">
                 <a:solidFill>
                   <a:srgbClr val="111015"/>
                 </a:solidFill>
@@ -9209,7 +9209,7 @@
               </a:defRPr>
             </a:lvl4pPr>
             <a:lvl5pPr>
-              <a:defRPr sz="1800" b="0">
+              <a:defRPr sz="2100" b="0">
                 <a:solidFill>
                   <a:srgbClr val="111015"/>
                 </a:solidFill>
@@ -9219,7 +9219,7 @@
               </a:defRPr>
             </a:lvl5pPr>
             <a:lvl6pPr>
-              <a:defRPr sz="1800" b="0">
+              <a:defRPr sz="2100" b="0">
                 <a:solidFill>
                   <a:srgbClr val="111015"/>
                 </a:solidFill>
@@ -9229,7 +9229,7 @@
               </a:defRPr>
             </a:lvl6pPr>
             <a:lvl7pPr>
-              <a:defRPr sz="1800" b="0">
+              <a:defRPr sz="2100" b="0">
                 <a:solidFill>
                   <a:srgbClr val="111015"/>
                 </a:solidFill>
@@ -9239,7 +9239,7 @@
               </a:defRPr>
             </a:lvl7pPr>
             <a:lvl8pPr>
-              <a:defRPr sz="1800" b="0">
+              <a:defRPr sz="2100" b="0">
                 <a:solidFill>
                   <a:srgbClr val="111015"/>
                 </a:solidFill>
@@ -9249,7 +9249,7 @@
               </a:defRPr>
             </a:lvl8pPr>
             <a:lvl9pPr>
-              <a:defRPr sz="1800" b="0">
+              <a:defRPr sz="2100" b="0">
                 <a:solidFill>
                   <a:srgbClr val="111015"/>
                 </a:solidFill>
@@ -9261,7 +9261,7 @@
           </a:lstStyle>
           <a:p xmlns:a="http://schemas.openxmlformats.org/drawingml/2006/main">
             <a:pPr>
-              <a:defRPr sz="1800" b="0">
+              <a:defRPr sz="2100" b="0">
                 <a:solidFill>
                   <a:srgbClr val="111015"/>
                 </a:solidFill>
@@ -9271,7 +9271,7 @@
               </a:defRPr>
             </a:pPr>
             <a:r>
-              <a:rPr sz="1800" b="0">
+              <a:rPr sz="2100" b="0">
                 <a:solidFill>
                   <a:srgbClr val="111015"/>
                 </a:solidFill>
@@ -9279,1271 +9279,7 @@
                 <a:ea typeface="Arial"/>
                 <a:cs typeface="Arial"/>
               </a:rPr>
-              <a:t>Specialized content on products and tools for artists, connecting brands to the audience.</a:t>
-            </a:r>
-          </a:p>
-        </p:txBody>
-      </p:sp>
-      <p:sp>
-        <p:nvSpPr>
-          <p:cNvPr id="9" name="text-17">
-            <a:extLst xmlns:a="http://schemas.openxmlformats.org/drawingml/2006/main">
-              <a:ext uri="{FF2B5EF4-FFF2-40B4-BE49-F238E27FC236}">
-                <a16:creationId xmlns:a16="http://schemas.microsoft.com/office/drawing/2014/main" id="{7F3A999F-7C77-494A-9DF6-6D46EF8BDB58}"/>
-              </a:ext>
-            </a:extLst>
-          </p:cNvPr>
-          <p:cNvSpPr>
-            <a:spLocks xmlns:a="http://schemas.openxmlformats.org/drawingml/2006/main" noGrp="1"/>
-          </p:cNvSpPr>
-          <p:nvPr/>
-        </p:nvSpPr>
-        <p:spPr>
-          <a:xfrm xmlns:a="http://schemas.openxmlformats.org/drawingml/2006/main">
-            <a:off x="609600" y="3981450"/>
-            <a:ext cx="5238750" cy="381000"/>
-          </a:xfrm>
-          <a:prstGeom xmlns:a="http://schemas.openxmlformats.org/drawingml/2006/main" prst="rect">
-            <a:avLst/>
-          </a:prstGeom>
-          <a:noFill xmlns:a="http://schemas.openxmlformats.org/drawingml/2006/main"/>
-          <a:ln xmlns:a="http://schemas.openxmlformats.org/drawingml/2006/main" w="0">
-            <a:noFill/>
-          </a:ln>
-        </p:spPr>
-        <p:txBody>
-          <a:bodyPr xmlns:a="http://schemas.openxmlformats.org/drawingml/2006/main" lIns="0" tIns="0" rIns="0" bIns="0" anchor="t">
-            <a:noAutofit/>
-          </a:bodyPr>
-          <a:lstStyle xmlns:a="http://schemas.openxmlformats.org/drawingml/2006/main">
-            <a:defPPr>
-              <a:defRPr sz="1800" b="1">
-                <a:solidFill>
-                  <a:srgbClr val="111015"/>
-                </a:solidFill>
-                <a:latin typeface="Georgia"/>
-                <a:ea typeface="Georgia"/>
-                <a:cs typeface="Georgia"/>
-              </a:defRPr>
-            </a:defPPr>
-            <a:lvl1pPr>
-              <a:defRPr sz="1800" b="1">
-                <a:solidFill>
-                  <a:srgbClr val="111015"/>
-                </a:solidFill>
-                <a:latin typeface="Georgia"/>
-                <a:ea typeface="Georgia"/>
-                <a:cs typeface="Georgia"/>
-              </a:defRPr>
-            </a:lvl1pPr>
-            <a:lvl2pPr>
-              <a:defRPr sz="1800" b="1">
-                <a:solidFill>
-                  <a:srgbClr val="111015"/>
-                </a:solidFill>
-                <a:latin typeface="Georgia"/>
-                <a:ea typeface="Georgia"/>
-                <a:cs typeface="Georgia"/>
-              </a:defRPr>
-            </a:lvl2pPr>
-            <a:lvl3pPr>
-              <a:defRPr sz="1800" b="1">
-                <a:solidFill>
-                  <a:srgbClr val="111015"/>
-                </a:solidFill>
-                <a:latin typeface="Georgia"/>
-                <a:ea typeface="Georgia"/>
-                <a:cs typeface="Georgia"/>
-              </a:defRPr>
-            </a:lvl3pPr>
-            <a:lvl4pPr>
-              <a:defRPr sz="1800" b="1">
-                <a:solidFill>
-                  <a:srgbClr val="111015"/>
-                </a:solidFill>
-                <a:latin typeface="Georgia"/>
-                <a:ea typeface="Georgia"/>
-                <a:cs typeface="Georgia"/>
-              </a:defRPr>
-            </a:lvl4pPr>
-            <a:lvl5pPr>
-              <a:defRPr sz="1800" b="1">
-                <a:solidFill>
-                  <a:srgbClr val="111015"/>
-                </a:solidFill>
-                <a:latin typeface="Georgia"/>
-                <a:ea typeface="Georgia"/>
-                <a:cs typeface="Georgia"/>
-              </a:defRPr>
-            </a:lvl5pPr>
-            <a:lvl6pPr>
-              <a:defRPr sz="1800" b="1">
-                <a:solidFill>
-                  <a:srgbClr val="111015"/>
-                </a:solidFill>
-                <a:latin typeface="Georgia"/>
-                <a:ea typeface="Georgia"/>
-                <a:cs typeface="Georgia"/>
-              </a:defRPr>
-            </a:lvl6pPr>
-            <a:lvl7pPr>
-              <a:defRPr sz="1800" b="1">
-                <a:solidFill>
-                  <a:srgbClr val="111015"/>
-                </a:solidFill>
-                <a:latin typeface="Georgia"/>
-                <a:ea typeface="Georgia"/>
-                <a:cs typeface="Georgia"/>
-              </a:defRPr>
-            </a:lvl7pPr>
-            <a:lvl8pPr>
-              <a:defRPr sz="1800" b="1">
-                <a:solidFill>
-                  <a:srgbClr val="111015"/>
-                </a:solidFill>
-                <a:latin typeface="Georgia"/>
-                <a:ea typeface="Georgia"/>
-                <a:cs typeface="Georgia"/>
-              </a:defRPr>
-            </a:lvl8pPr>
-            <a:lvl9pPr>
-              <a:defRPr sz="1800" b="1">
-                <a:solidFill>
-                  <a:srgbClr val="111015"/>
-                </a:solidFill>
-                <a:latin typeface="Georgia"/>
-                <a:ea typeface="Georgia"/>
-                <a:cs typeface="Georgia"/>
-              </a:defRPr>
-            </a:lvl9pPr>
-          </a:lstStyle>
-          <a:p xmlns:a="http://schemas.openxmlformats.org/drawingml/2006/main">
-            <a:pPr>
-              <a:defRPr sz="1800" b="1">
-                <a:solidFill>
-                  <a:srgbClr val="111015"/>
-                </a:solidFill>
-                <a:latin typeface="Georgia"/>
-                <a:ea typeface="Georgia"/>
-                <a:cs typeface="Georgia"/>
-              </a:defRPr>
-            </a:pPr>
-            <a:r>
-              <a:rPr sz="1800" b="1">
-                <a:solidFill>
-                  <a:srgbClr val="111015"/>
-                </a:solidFill>
-                <a:latin typeface="Georgia"/>
-                <a:ea typeface="Georgia"/>
-                <a:cs typeface="Georgia"/>
-              </a:rPr>
-              <a:t>Art for books and games</a:t>
-            </a:r>
-          </a:p>
-        </p:txBody>
-      </p:sp>
-      <p:sp>
-        <p:nvSpPr>
-          <p:cNvPr id="10" name="text-18">
-            <a:extLst xmlns:a="http://schemas.openxmlformats.org/drawingml/2006/main">
-              <a:ext uri="{FF2B5EF4-FFF2-40B4-BE49-F238E27FC236}">
-                <a16:creationId xmlns:a16="http://schemas.microsoft.com/office/drawing/2014/main" id="{2E6835CB-D8D6-416A-B54C-9EDF00ABED1C}"/>
-              </a:ext>
-            </a:extLst>
-          </p:cNvPr>
-          <p:cNvSpPr>
-            <a:spLocks xmlns:a="http://schemas.openxmlformats.org/drawingml/2006/main" noGrp="1"/>
-          </p:cNvSpPr>
-          <p:nvPr/>
-        </p:nvSpPr>
-        <p:spPr>
-          <a:xfrm xmlns:a="http://schemas.openxmlformats.org/drawingml/2006/main">
-            <a:off x="609600" y="4391025"/>
-            <a:ext cx="5238750" cy="857250"/>
-          </a:xfrm>
-          <a:prstGeom xmlns:a="http://schemas.openxmlformats.org/drawingml/2006/main" prst="rect">
-            <a:avLst/>
-          </a:prstGeom>
-          <a:noFill xmlns:a="http://schemas.openxmlformats.org/drawingml/2006/main"/>
-          <a:ln xmlns:a="http://schemas.openxmlformats.org/drawingml/2006/main" w="0">
-            <a:noFill/>
-          </a:ln>
-        </p:spPr>
-        <p:txBody>
-          <a:bodyPr xmlns:a="http://schemas.openxmlformats.org/drawingml/2006/main" lIns="0" tIns="0" rIns="0" bIns="0" anchor="t">
-            <a:noAutofit/>
-          </a:bodyPr>
-          <a:lstStyle xmlns:a="http://schemas.openxmlformats.org/drawingml/2006/main">
-            <a:defPPr>
-              <a:defRPr sz="1575" b="0">
-                <a:solidFill>
-                  <a:srgbClr val="5F5A63"/>
-                </a:solidFill>
-                <a:latin typeface="Arial"/>
-                <a:ea typeface="Arial"/>
-                <a:cs typeface="Arial"/>
-              </a:defRPr>
-            </a:defPPr>
-            <a:lvl1pPr>
-              <a:defRPr sz="1575" b="0">
-                <a:solidFill>
-                  <a:srgbClr val="5F5A63"/>
-                </a:solidFill>
-                <a:latin typeface="Arial"/>
-                <a:ea typeface="Arial"/>
-                <a:cs typeface="Arial"/>
-              </a:defRPr>
-            </a:lvl1pPr>
-            <a:lvl2pPr>
-              <a:defRPr sz="1575" b="0">
-                <a:solidFill>
-                  <a:srgbClr val="5F5A63"/>
-                </a:solidFill>
-                <a:latin typeface="Arial"/>
-                <a:ea typeface="Arial"/>
-                <a:cs typeface="Arial"/>
-              </a:defRPr>
-            </a:lvl2pPr>
-            <a:lvl3pPr>
-              <a:defRPr sz="1575" b="0">
-                <a:solidFill>
-                  <a:srgbClr val="5F5A63"/>
-                </a:solidFill>
-                <a:latin typeface="Arial"/>
-                <a:ea typeface="Arial"/>
-                <a:cs typeface="Arial"/>
-              </a:defRPr>
-            </a:lvl3pPr>
-            <a:lvl4pPr>
-              <a:defRPr sz="1575" b="0">
-                <a:solidFill>
-                  <a:srgbClr val="5F5A63"/>
-                </a:solidFill>
-                <a:latin typeface="Arial"/>
-                <a:ea typeface="Arial"/>
-                <a:cs typeface="Arial"/>
-              </a:defRPr>
-            </a:lvl4pPr>
-            <a:lvl5pPr>
-              <a:defRPr sz="1575" b="0">
-                <a:solidFill>
-                  <a:srgbClr val="5F5A63"/>
-                </a:solidFill>
-                <a:latin typeface="Arial"/>
-                <a:ea typeface="Arial"/>
-                <a:cs typeface="Arial"/>
-              </a:defRPr>
-            </a:lvl5pPr>
-            <a:lvl6pPr>
-              <a:defRPr sz="1575" b="0">
-                <a:solidFill>
-                  <a:srgbClr val="5F5A63"/>
-                </a:solidFill>
-                <a:latin typeface="Arial"/>
-                <a:ea typeface="Arial"/>
-                <a:cs typeface="Arial"/>
-              </a:defRPr>
-            </a:lvl6pPr>
-            <a:lvl7pPr>
-              <a:defRPr sz="1575" b="0">
-                <a:solidFill>
-                  <a:srgbClr val="5F5A63"/>
-                </a:solidFill>
-                <a:latin typeface="Arial"/>
-                <a:ea typeface="Arial"/>
-                <a:cs typeface="Arial"/>
-              </a:defRPr>
-            </a:lvl7pPr>
-            <a:lvl8pPr>
-              <a:defRPr sz="1575" b="0">
-                <a:solidFill>
-                  <a:srgbClr val="5F5A63"/>
-                </a:solidFill>
-                <a:latin typeface="Arial"/>
-                <a:ea typeface="Arial"/>
-                <a:cs typeface="Arial"/>
-              </a:defRPr>
-            </a:lvl8pPr>
-            <a:lvl9pPr>
-              <a:defRPr sz="1575" b="0">
-                <a:solidFill>
-                  <a:srgbClr val="5F5A63"/>
-                </a:solidFill>
-                <a:latin typeface="Arial"/>
-                <a:ea typeface="Arial"/>
-                <a:cs typeface="Arial"/>
-              </a:defRPr>
-            </a:lvl9pPr>
-          </a:lstStyle>
-          <a:p xmlns:a="http://schemas.openxmlformats.org/drawingml/2006/main">
-            <a:pPr>
-              <a:defRPr sz="1575" b="0">
-                <a:solidFill>
-                  <a:srgbClr val="5F5A63"/>
-                </a:solidFill>
-                <a:latin typeface="Arial"/>
-                <a:ea typeface="Arial"/>
-                <a:cs typeface="Arial"/>
-              </a:defRPr>
-            </a:pPr>
-            <a:r>
-              <a:rPr sz="1575" b="0">
-                <a:solidFill>
-                  <a:srgbClr val="5F5A63"/>
-                </a:solidFill>
-                <a:latin typeface="Arial"/>
-                <a:ea typeface="Arial"/>
-                <a:cs typeface="Arial"/>
-              </a:rPr>
-              <a:t>Illustrations that help tell your story: covers, interior pages, cards and environment art.</a:t>
-            </a:r>
-          </a:p>
-        </p:txBody>
-      </p:sp>
-      <p:sp>
-        <p:nvSpPr>
-          <p:cNvPr id="11" name="text-19">
-            <a:extLst xmlns:a="http://schemas.openxmlformats.org/drawingml/2006/main">
-              <a:ext uri="{FF2B5EF4-FFF2-40B4-BE49-F238E27FC236}">
-                <a16:creationId xmlns:a16="http://schemas.microsoft.com/office/drawing/2014/main" id="{B17AA82D-8CEB-4555-8123-09ACF76BD05F}"/>
-              </a:ext>
-            </a:extLst>
-          </p:cNvPr>
-          <p:cNvSpPr>
-            <a:spLocks xmlns:a="http://schemas.openxmlformats.org/drawingml/2006/main" noGrp="1"/>
-          </p:cNvSpPr>
-          <p:nvPr/>
-        </p:nvSpPr>
-        <p:spPr>
-          <a:xfrm xmlns:a="http://schemas.openxmlformats.org/drawingml/2006/main">
-            <a:off x="609600" y="5219700"/>
-            <a:ext cx="5238750" cy="381000"/>
-          </a:xfrm>
-          <a:prstGeom xmlns:a="http://schemas.openxmlformats.org/drawingml/2006/main" prst="rect">
-            <a:avLst/>
-          </a:prstGeom>
-          <a:noFill xmlns:a="http://schemas.openxmlformats.org/drawingml/2006/main"/>
-          <a:ln xmlns:a="http://schemas.openxmlformats.org/drawingml/2006/main" w="0">
-            <a:noFill/>
-          </a:ln>
-        </p:spPr>
-        <p:txBody>
-          <a:bodyPr xmlns:a="http://schemas.openxmlformats.org/drawingml/2006/main" lIns="0" tIns="0" rIns="0" bIns="0" anchor="t">
-            <a:noAutofit/>
-          </a:bodyPr>
-          <a:lstStyle xmlns:a="http://schemas.openxmlformats.org/drawingml/2006/main">
-            <a:defPPr>
-              <a:defRPr sz="1800" b="1">
-                <a:solidFill>
-                  <a:srgbClr val="111015"/>
-                </a:solidFill>
-                <a:latin typeface="Georgia"/>
-                <a:ea typeface="Georgia"/>
-                <a:cs typeface="Georgia"/>
-              </a:defRPr>
-            </a:defPPr>
-            <a:lvl1pPr>
-              <a:defRPr sz="1800" b="1">
-                <a:solidFill>
-                  <a:srgbClr val="111015"/>
-                </a:solidFill>
-                <a:latin typeface="Georgia"/>
-                <a:ea typeface="Georgia"/>
-                <a:cs typeface="Georgia"/>
-              </a:defRPr>
-            </a:lvl1pPr>
-            <a:lvl2pPr>
-              <a:defRPr sz="1800" b="1">
-                <a:solidFill>
-                  <a:srgbClr val="111015"/>
-                </a:solidFill>
-                <a:latin typeface="Georgia"/>
-                <a:ea typeface="Georgia"/>
-                <a:cs typeface="Georgia"/>
-              </a:defRPr>
-            </a:lvl2pPr>
-            <a:lvl3pPr>
-              <a:defRPr sz="1800" b="1">
-                <a:solidFill>
-                  <a:srgbClr val="111015"/>
-                </a:solidFill>
-                <a:latin typeface="Georgia"/>
-                <a:ea typeface="Georgia"/>
-                <a:cs typeface="Georgia"/>
-              </a:defRPr>
-            </a:lvl3pPr>
-            <a:lvl4pPr>
-              <a:defRPr sz="1800" b="1">
-                <a:solidFill>
-                  <a:srgbClr val="111015"/>
-                </a:solidFill>
-                <a:latin typeface="Georgia"/>
-                <a:ea typeface="Georgia"/>
-                <a:cs typeface="Georgia"/>
-              </a:defRPr>
-            </a:lvl4pPr>
-            <a:lvl5pPr>
-              <a:defRPr sz="1800" b="1">
-                <a:solidFill>
-                  <a:srgbClr val="111015"/>
-                </a:solidFill>
-                <a:latin typeface="Georgia"/>
-                <a:ea typeface="Georgia"/>
-                <a:cs typeface="Georgia"/>
-              </a:defRPr>
-            </a:lvl5pPr>
-            <a:lvl6pPr>
-              <a:defRPr sz="1800" b="1">
-                <a:solidFill>
-                  <a:srgbClr val="111015"/>
-                </a:solidFill>
-                <a:latin typeface="Georgia"/>
-                <a:ea typeface="Georgia"/>
-                <a:cs typeface="Georgia"/>
-              </a:defRPr>
-            </a:lvl6pPr>
-            <a:lvl7pPr>
-              <a:defRPr sz="1800" b="1">
-                <a:solidFill>
-                  <a:srgbClr val="111015"/>
-                </a:solidFill>
-                <a:latin typeface="Georgia"/>
-                <a:ea typeface="Georgia"/>
-                <a:cs typeface="Georgia"/>
-              </a:defRPr>
-            </a:lvl7pPr>
-            <a:lvl8pPr>
-              <a:defRPr sz="1800" b="1">
-                <a:solidFill>
-                  <a:srgbClr val="111015"/>
-                </a:solidFill>
-                <a:latin typeface="Georgia"/>
-                <a:ea typeface="Georgia"/>
-                <a:cs typeface="Georgia"/>
-              </a:defRPr>
-            </a:lvl8pPr>
-            <a:lvl9pPr>
-              <a:defRPr sz="1800" b="1">
-                <a:solidFill>
-                  <a:srgbClr val="111015"/>
-                </a:solidFill>
-                <a:latin typeface="Georgia"/>
-                <a:ea typeface="Georgia"/>
-                <a:cs typeface="Georgia"/>
-              </a:defRPr>
-            </a:lvl9pPr>
-          </a:lstStyle>
-          <a:p xmlns:a="http://schemas.openxmlformats.org/drawingml/2006/main">
-            <a:pPr>
-              <a:defRPr sz="1800" b="1">
-                <a:solidFill>
-                  <a:srgbClr val="111015"/>
-                </a:solidFill>
-                <a:latin typeface="Georgia"/>
-                <a:ea typeface="Georgia"/>
-                <a:cs typeface="Georgia"/>
-              </a:defRPr>
-            </a:pPr>
-            <a:r>
-              <a:rPr sz="1800" b="1">
-                <a:solidFill>
-                  <a:srgbClr val="111015"/>
-                </a:solidFill>
-                <a:latin typeface="Georgia"/>
-                <a:ea typeface="Georgia"/>
-                <a:cs typeface="Georgia"/>
-              </a:rPr>
-              <a:t>From brief to final art</a:t>
-            </a:r>
-          </a:p>
-        </p:txBody>
-      </p:sp>
-      <p:sp>
-        <p:nvSpPr>
-          <p:cNvPr id="12" name="text-20">
-            <a:extLst xmlns:a="http://schemas.openxmlformats.org/drawingml/2006/main">
-              <a:ext uri="{FF2B5EF4-FFF2-40B4-BE49-F238E27FC236}">
-                <a16:creationId xmlns:a16="http://schemas.microsoft.com/office/drawing/2014/main" id="{DC61DCA5-E6EF-4ACD-AF54-89CE60407A48}"/>
-              </a:ext>
-            </a:extLst>
-          </p:cNvPr>
-          <p:cNvSpPr>
-            <a:spLocks xmlns:a="http://schemas.openxmlformats.org/drawingml/2006/main" noGrp="1"/>
-          </p:cNvSpPr>
-          <p:nvPr/>
-        </p:nvSpPr>
-        <p:spPr>
-          <a:xfrm xmlns:a="http://schemas.openxmlformats.org/drawingml/2006/main">
-            <a:off x="609600" y="5629275"/>
-            <a:ext cx="5238750" cy="857250"/>
-          </a:xfrm>
-          <a:prstGeom xmlns:a="http://schemas.openxmlformats.org/drawingml/2006/main" prst="rect">
-            <a:avLst/>
-          </a:prstGeom>
-          <a:noFill xmlns:a="http://schemas.openxmlformats.org/drawingml/2006/main"/>
-          <a:ln xmlns:a="http://schemas.openxmlformats.org/drawingml/2006/main" w="0">
-            <a:noFill/>
-          </a:ln>
-        </p:spPr>
-        <p:txBody>
-          <a:bodyPr xmlns:a="http://schemas.openxmlformats.org/drawingml/2006/main" lIns="0" tIns="0" rIns="0" bIns="0" anchor="t">
-            <a:noAutofit/>
-          </a:bodyPr>
-          <a:lstStyle xmlns:a="http://schemas.openxmlformats.org/drawingml/2006/main">
-            <a:defPPr>
-              <a:defRPr sz="1575" b="0">
-                <a:solidFill>
-                  <a:srgbClr val="5F5A63"/>
-                </a:solidFill>
-                <a:latin typeface="Arial"/>
-                <a:ea typeface="Arial"/>
-                <a:cs typeface="Arial"/>
-              </a:defRPr>
-            </a:defPPr>
-            <a:lvl1pPr>
-              <a:defRPr sz="1575" b="0">
-                <a:solidFill>
-                  <a:srgbClr val="5F5A63"/>
-                </a:solidFill>
-                <a:latin typeface="Arial"/>
-                <a:ea typeface="Arial"/>
-                <a:cs typeface="Arial"/>
-              </a:defRPr>
-            </a:lvl1pPr>
-            <a:lvl2pPr>
-              <a:defRPr sz="1575" b="0">
-                <a:solidFill>
-                  <a:srgbClr val="5F5A63"/>
-                </a:solidFill>
-                <a:latin typeface="Arial"/>
-                <a:ea typeface="Arial"/>
-                <a:cs typeface="Arial"/>
-              </a:defRPr>
-            </a:lvl2pPr>
-            <a:lvl3pPr>
-              <a:defRPr sz="1575" b="0">
-                <a:solidFill>
-                  <a:srgbClr val="5F5A63"/>
-                </a:solidFill>
-                <a:latin typeface="Arial"/>
-                <a:ea typeface="Arial"/>
-                <a:cs typeface="Arial"/>
-              </a:defRPr>
-            </a:lvl3pPr>
-            <a:lvl4pPr>
-              <a:defRPr sz="1575" b="0">
-                <a:solidFill>
-                  <a:srgbClr val="5F5A63"/>
-                </a:solidFill>
-                <a:latin typeface="Arial"/>
-                <a:ea typeface="Arial"/>
-                <a:cs typeface="Arial"/>
-              </a:defRPr>
-            </a:lvl4pPr>
-            <a:lvl5pPr>
-              <a:defRPr sz="1575" b="0">
-                <a:solidFill>
-                  <a:srgbClr val="5F5A63"/>
-                </a:solidFill>
-                <a:latin typeface="Arial"/>
-                <a:ea typeface="Arial"/>
-                <a:cs typeface="Arial"/>
-              </a:defRPr>
-            </a:lvl5pPr>
-            <a:lvl6pPr>
-              <a:defRPr sz="1575" b="0">
-                <a:solidFill>
-                  <a:srgbClr val="5F5A63"/>
-                </a:solidFill>
-                <a:latin typeface="Arial"/>
-                <a:ea typeface="Arial"/>
-                <a:cs typeface="Arial"/>
-              </a:defRPr>
-            </a:lvl6pPr>
-            <a:lvl7pPr>
-              <a:defRPr sz="1575" b="0">
-                <a:solidFill>
-                  <a:srgbClr val="5F5A63"/>
-                </a:solidFill>
-                <a:latin typeface="Arial"/>
-                <a:ea typeface="Arial"/>
-                <a:cs typeface="Arial"/>
-              </a:defRPr>
-            </a:lvl7pPr>
-            <a:lvl8pPr>
-              <a:defRPr sz="1575" b="0">
-                <a:solidFill>
-                  <a:srgbClr val="5F5A63"/>
-                </a:solidFill>
-                <a:latin typeface="Arial"/>
-                <a:ea typeface="Arial"/>
-                <a:cs typeface="Arial"/>
-              </a:defRPr>
-            </a:lvl8pPr>
-            <a:lvl9pPr>
-              <a:defRPr sz="1575" b="0">
-                <a:solidFill>
-                  <a:srgbClr val="5F5A63"/>
-                </a:solidFill>
-                <a:latin typeface="Arial"/>
-                <a:ea typeface="Arial"/>
-                <a:cs typeface="Arial"/>
-              </a:defRPr>
-            </a:lvl9pPr>
-          </a:lstStyle>
-          <a:p xmlns:a="http://schemas.openxmlformats.org/drawingml/2006/main">
-            <a:pPr>
-              <a:defRPr sz="1575" b="0">
-                <a:solidFill>
-                  <a:srgbClr val="5F5A63"/>
-                </a:solidFill>
-                <a:latin typeface="Arial"/>
-                <a:ea typeface="Arial"/>
-                <a:cs typeface="Arial"/>
-              </a:defRPr>
-            </a:pPr>
-            <a:r>
-              <a:rPr sz="1575" b="0">
-                <a:solidFill>
-                  <a:srgbClr val="5F5A63"/>
-                </a:solidFill>
-                <a:latin typeface="Arial"/>
-                <a:ea typeface="Arial"/>
-                <a:cs typeface="Arial"/>
-              </a:rPr>
-              <a:t>Original characters, creatures and complete reference sheets, with different angles, expressions, color palette, clothing and item details.</a:t>
-            </a:r>
-          </a:p>
-        </p:txBody>
-      </p:sp>
-      <p:sp>
-        <p:nvSpPr>
-          <p:cNvPr id="13" name="text-21">
-            <a:extLst xmlns:a="http://schemas.openxmlformats.org/drawingml/2006/main">
-              <a:ext uri="{FF2B5EF4-FFF2-40B4-BE49-F238E27FC236}">
-                <a16:creationId xmlns:a16="http://schemas.microsoft.com/office/drawing/2014/main" id="{2974D926-6274-45C3-8C38-6B8D564D12A1}"/>
-              </a:ext>
-            </a:extLst>
-          </p:cNvPr>
-          <p:cNvSpPr>
-            <a:spLocks xmlns:a="http://schemas.openxmlformats.org/drawingml/2006/main" noGrp="1"/>
-          </p:cNvSpPr>
-          <p:nvPr/>
-        </p:nvSpPr>
-        <p:spPr>
-          <a:xfrm xmlns:a="http://schemas.openxmlformats.org/drawingml/2006/main">
-            <a:off x="6286500" y="3381375"/>
-            <a:ext cx="5238750" cy="381000"/>
-          </a:xfrm>
-          <a:prstGeom xmlns:a="http://schemas.openxmlformats.org/drawingml/2006/main" prst="rect">
-            <a:avLst/>
-          </a:prstGeom>
-          <a:noFill xmlns:a="http://schemas.openxmlformats.org/drawingml/2006/main"/>
-          <a:ln xmlns:a="http://schemas.openxmlformats.org/drawingml/2006/main" w="0">
-            <a:noFill/>
-          </a:ln>
-        </p:spPr>
-        <p:txBody>
-          <a:bodyPr xmlns:a="http://schemas.openxmlformats.org/drawingml/2006/main" lIns="0" tIns="0" rIns="0" bIns="0" anchor="t">
-            <a:noAutofit/>
-          </a:bodyPr>
-          <a:lstStyle xmlns:a="http://schemas.openxmlformats.org/drawingml/2006/main">
-            <a:defPPr>
-              <a:defRPr sz="1800" b="1">
-                <a:solidFill>
-                  <a:srgbClr val="111015"/>
-                </a:solidFill>
-                <a:latin typeface="Georgia"/>
-                <a:ea typeface="Georgia"/>
-                <a:cs typeface="Georgia"/>
-              </a:defRPr>
-            </a:defPPr>
-            <a:lvl1pPr>
-              <a:defRPr sz="1800" b="1">
-                <a:solidFill>
-                  <a:srgbClr val="111015"/>
-                </a:solidFill>
-                <a:latin typeface="Georgia"/>
-                <a:ea typeface="Georgia"/>
-                <a:cs typeface="Georgia"/>
-              </a:defRPr>
-            </a:lvl1pPr>
-            <a:lvl2pPr>
-              <a:defRPr sz="1800" b="1">
-                <a:solidFill>
-                  <a:srgbClr val="111015"/>
-                </a:solidFill>
-                <a:latin typeface="Georgia"/>
-                <a:ea typeface="Georgia"/>
-                <a:cs typeface="Georgia"/>
-              </a:defRPr>
-            </a:lvl2pPr>
-            <a:lvl3pPr>
-              <a:defRPr sz="1800" b="1">
-                <a:solidFill>
-                  <a:srgbClr val="111015"/>
-                </a:solidFill>
-                <a:latin typeface="Georgia"/>
-                <a:ea typeface="Georgia"/>
-                <a:cs typeface="Georgia"/>
-              </a:defRPr>
-            </a:lvl3pPr>
-            <a:lvl4pPr>
-              <a:defRPr sz="1800" b="1">
-                <a:solidFill>
-                  <a:srgbClr val="111015"/>
-                </a:solidFill>
-                <a:latin typeface="Georgia"/>
-                <a:ea typeface="Georgia"/>
-                <a:cs typeface="Georgia"/>
-              </a:defRPr>
-            </a:lvl4pPr>
-            <a:lvl5pPr>
-              <a:defRPr sz="1800" b="1">
-                <a:solidFill>
-                  <a:srgbClr val="111015"/>
-                </a:solidFill>
-                <a:latin typeface="Georgia"/>
-                <a:ea typeface="Georgia"/>
-                <a:cs typeface="Georgia"/>
-              </a:defRPr>
-            </a:lvl5pPr>
-            <a:lvl6pPr>
-              <a:defRPr sz="1800" b="1">
-                <a:solidFill>
-                  <a:srgbClr val="111015"/>
-                </a:solidFill>
-                <a:latin typeface="Georgia"/>
-                <a:ea typeface="Georgia"/>
-                <a:cs typeface="Georgia"/>
-              </a:defRPr>
-            </a:lvl6pPr>
-            <a:lvl7pPr>
-              <a:defRPr sz="1800" b="1">
-                <a:solidFill>
-                  <a:srgbClr val="111015"/>
-                </a:solidFill>
-                <a:latin typeface="Georgia"/>
-                <a:ea typeface="Georgia"/>
-                <a:cs typeface="Georgia"/>
-              </a:defRPr>
-            </a:lvl7pPr>
-            <a:lvl8pPr>
-              <a:defRPr sz="1800" b="1">
-                <a:solidFill>
-                  <a:srgbClr val="111015"/>
-                </a:solidFill>
-                <a:latin typeface="Georgia"/>
-                <a:ea typeface="Georgia"/>
-                <a:cs typeface="Georgia"/>
-              </a:defRPr>
-            </a:lvl8pPr>
-            <a:lvl9pPr>
-              <a:defRPr sz="1800" b="1">
-                <a:solidFill>
-                  <a:srgbClr val="111015"/>
-                </a:solidFill>
-                <a:latin typeface="Georgia"/>
-                <a:ea typeface="Georgia"/>
-                <a:cs typeface="Georgia"/>
-              </a:defRPr>
-            </a:lvl9pPr>
-          </a:lstStyle>
-          <a:p xmlns:a="http://schemas.openxmlformats.org/drawingml/2006/main">
-            <a:pPr>
-              <a:defRPr sz="1800" b="1">
-                <a:solidFill>
-                  <a:srgbClr val="111015"/>
-                </a:solidFill>
-                <a:latin typeface="Georgia"/>
-                <a:ea typeface="Georgia"/>
-                <a:cs typeface="Georgia"/>
-              </a:defRPr>
-            </a:pPr>
-            <a:r>
-              <a:rPr sz="1800" b="1">
-                <a:solidFill>
-                  <a:srgbClr val="111015"/>
-                </a:solidFill>
-                <a:latin typeface="Georgia"/>
-                <a:ea typeface="Georgia"/>
-                <a:cs typeface="Georgia"/>
-              </a:rPr>
-              <a:t>Product reviews &amp; tests</a:t>
-            </a:r>
-          </a:p>
-        </p:txBody>
-      </p:sp>
-      <p:sp>
-        <p:nvSpPr>
-          <p:cNvPr id="14" name="text-22">
-            <a:extLst xmlns:a="http://schemas.openxmlformats.org/drawingml/2006/main">
-              <a:ext uri="{FF2B5EF4-FFF2-40B4-BE49-F238E27FC236}">
-                <a16:creationId xmlns:a16="http://schemas.microsoft.com/office/drawing/2014/main" id="{18EEF85B-9C5D-4CC5-B817-352351A20997}"/>
-              </a:ext>
-            </a:extLst>
-          </p:cNvPr>
-          <p:cNvSpPr>
-            <a:spLocks xmlns:a="http://schemas.openxmlformats.org/drawingml/2006/main" noGrp="1"/>
-          </p:cNvSpPr>
-          <p:nvPr/>
-        </p:nvSpPr>
-        <p:spPr>
-          <a:xfrm xmlns:a="http://schemas.openxmlformats.org/drawingml/2006/main">
-            <a:off x="6286500" y="3790950"/>
-            <a:ext cx="5238750" cy="857250"/>
-          </a:xfrm>
-          <a:prstGeom xmlns:a="http://schemas.openxmlformats.org/drawingml/2006/main" prst="rect">
-            <a:avLst/>
-          </a:prstGeom>
-          <a:noFill xmlns:a="http://schemas.openxmlformats.org/drawingml/2006/main"/>
-          <a:ln xmlns:a="http://schemas.openxmlformats.org/drawingml/2006/main" w="0">
-            <a:noFill/>
-          </a:ln>
-        </p:spPr>
-        <p:txBody>
-          <a:bodyPr xmlns:a="http://schemas.openxmlformats.org/drawingml/2006/main" lIns="0" tIns="0" rIns="0" bIns="0" anchor="t">
-            <a:noAutofit/>
-          </a:bodyPr>
-          <a:lstStyle xmlns:a="http://schemas.openxmlformats.org/drawingml/2006/main">
-            <a:defPPr>
-              <a:defRPr sz="1575" b="0">
-                <a:solidFill>
-                  <a:srgbClr val="5F5A63"/>
-                </a:solidFill>
-                <a:latin typeface="Arial"/>
-                <a:ea typeface="Arial"/>
-                <a:cs typeface="Arial"/>
-              </a:defRPr>
-            </a:defPPr>
-            <a:lvl1pPr>
-              <a:defRPr sz="1575" b="0">
-                <a:solidFill>
-                  <a:srgbClr val="5F5A63"/>
-                </a:solidFill>
-                <a:latin typeface="Arial"/>
-                <a:ea typeface="Arial"/>
-                <a:cs typeface="Arial"/>
-              </a:defRPr>
-            </a:lvl1pPr>
-            <a:lvl2pPr>
-              <a:defRPr sz="1575" b="0">
-                <a:solidFill>
-                  <a:srgbClr val="5F5A63"/>
-                </a:solidFill>
-                <a:latin typeface="Arial"/>
-                <a:ea typeface="Arial"/>
-                <a:cs typeface="Arial"/>
-              </a:defRPr>
-            </a:lvl2pPr>
-            <a:lvl3pPr>
-              <a:defRPr sz="1575" b="0">
-                <a:solidFill>
-                  <a:srgbClr val="5F5A63"/>
-                </a:solidFill>
-                <a:latin typeface="Arial"/>
-                <a:ea typeface="Arial"/>
-                <a:cs typeface="Arial"/>
-              </a:defRPr>
-            </a:lvl3pPr>
-            <a:lvl4pPr>
-              <a:defRPr sz="1575" b="0">
-                <a:solidFill>
-                  <a:srgbClr val="5F5A63"/>
-                </a:solidFill>
-                <a:latin typeface="Arial"/>
-                <a:ea typeface="Arial"/>
-                <a:cs typeface="Arial"/>
-              </a:defRPr>
-            </a:lvl4pPr>
-            <a:lvl5pPr>
-              <a:defRPr sz="1575" b="0">
-                <a:solidFill>
-                  <a:srgbClr val="5F5A63"/>
-                </a:solidFill>
-                <a:latin typeface="Arial"/>
-                <a:ea typeface="Arial"/>
-                <a:cs typeface="Arial"/>
-              </a:defRPr>
-            </a:lvl5pPr>
-            <a:lvl6pPr>
-              <a:defRPr sz="1575" b="0">
-                <a:solidFill>
-                  <a:srgbClr val="5F5A63"/>
-                </a:solidFill>
-                <a:latin typeface="Arial"/>
-                <a:ea typeface="Arial"/>
-                <a:cs typeface="Arial"/>
-              </a:defRPr>
-            </a:lvl6pPr>
-            <a:lvl7pPr>
-              <a:defRPr sz="1575" b="0">
-                <a:solidFill>
-                  <a:srgbClr val="5F5A63"/>
-                </a:solidFill>
-                <a:latin typeface="Arial"/>
-                <a:ea typeface="Arial"/>
-                <a:cs typeface="Arial"/>
-              </a:defRPr>
-            </a:lvl7pPr>
-            <a:lvl8pPr>
-              <a:defRPr sz="1575" b="0">
-                <a:solidFill>
-                  <a:srgbClr val="5F5A63"/>
-                </a:solidFill>
-                <a:latin typeface="Arial"/>
-                <a:ea typeface="Arial"/>
-                <a:cs typeface="Arial"/>
-              </a:defRPr>
-            </a:lvl8pPr>
-            <a:lvl9pPr>
-              <a:defRPr sz="1575" b="0">
-                <a:solidFill>
-                  <a:srgbClr val="5F5A63"/>
-                </a:solidFill>
-                <a:latin typeface="Arial"/>
-                <a:ea typeface="Arial"/>
-                <a:cs typeface="Arial"/>
-              </a:defRPr>
-            </a:lvl9pPr>
-          </a:lstStyle>
-          <a:p xmlns:a="http://schemas.openxmlformats.org/drawingml/2006/main">
-            <a:pPr>
-              <a:defRPr sz="1575" b="0">
-                <a:solidFill>
-                  <a:srgbClr val="5F5A63"/>
-                </a:solidFill>
-                <a:latin typeface="Arial"/>
-                <a:ea typeface="Arial"/>
-                <a:cs typeface="Arial"/>
-              </a:defRPr>
-            </a:pPr>
-            <a:r>
-              <a:rPr sz="1575" b="0">
-                <a:solidFill>
-                  <a:srgbClr val="5F5A63"/>
-                </a:solidFill>
-                <a:latin typeface="Arial"/>
-                <a:ea typeface="Arial"/>
-                <a:cs typeface="Arial"/>
-              </a:rPr>
-              <a:t>Reviews of tools and materials for digital and traditional art, including drawing tablets, pen displays, digital pens, software, paints, brushes and other art supplies, exploring quality, performance and user experience.</a:t>
-            </a:r>
-          </a:p>
-        </p:txBody>
-      </p:sp>
-      <p:sp>
-        <p:nvSpPr>
-          <p:cNvPr id="15" name="text-23">
-            <a:extLst xmlns:a="http://schemas.openxmlformats.org/drawingml/2006/main">
-              <a:ext uri="{FF2B5EF4-FFF2-40B4-BE49-F238E27FC236}">
-                <a16:creationId xmlns:a16="http://schemas.microsoft.com/office/drawing/2014/main" id="{9080E12E-2670-4B6B-9FA2-AD7720FAC011}"/>
-              </a:ext>
-            </a:extLst>
-          </p:cNvPr>
-          <p:cNvSpPr>
-            <a:spLocks xmlns:a="http://schemas.openxmlformats.org/drawingml/2006/main" noGrp="1"/>
-          </p:cNvSpPr>
-          <p:nvPr/>
-        </p:nvSpPr>
-        <p:spPr>
-          <a:xfrm xmlns:a="http://schemas.openxmlformats.org/drawingml/2006/main">
-            <a:off x="6286500" y="5238750"/>
-            <a:ext cx="5238750" cy="381000"/>
-          </a:xfrm>
-          <a:prstGeom xmlns:a="http://schemas.openxmlformats.org/drawingml/2006/main" prst="rect">
-            <a:avLst/>
-          </a:prstGeom>
-          <a:noFill xmlns:a="http://schemas.openxmlformats.org/drawingml/2006/main"/>
-          <a:ln xmlns:a="http://schemas.openxmlformats.org/drawingml/2006/main" w="0">
-            <a:noFill/>
-          </a:ln>
-        </p:spPr>
-        <p:txBody>
-          <a:bodyPr xmlns:a="http://schemas.openxmlformats.org/drawingml/2006/main" lIns="0" tIns="0" rIns="0" bIns="0" anchor="t">
-            <a:noAutofit/>
-          </a:bodyPr>
-          <a:lstStyle xmlns:a="http://schemas.openxmlformats.org/drawingml/2006/main">
-            <a:defPPr>
-              <a:defRPr sz="1800" b="1">
-                <a:solidFill>
-                  <a:srgbClr val="111015"/>
-                </a:solidFill>
-                <a:latin typeface="Georgia"/>
-                <a:ea typeface="Georgia"/>
-                <a:cs typeface="Georgia"/>
-              </a:defRPr>
-            </a:defPPr>
-            <a:lvl1pPr>
-              <a:defRPr sz="1800" b="1">
-                <a:solidFill>
-                  <a:srgbClr val="111015"/>
-                </a:solidFill>
-                <a:latin typeface="Georgia"/>
-                <a:ea typeface="Georgia"/>
-                <a:cs typeface="Georgia"/>
-              </a:defRPr>
-            </a:lvl1pPr>
-            <a:lvl2pPr>
-              <a:defRPr sz="1800" b="1">
-                <a:solidFill>
-                  <a:srgbClr val="111015"/>
-                </a:solidFill>
-                <a:latin typeface="Georgia"/>
-                <a:ea typeface="Georgia"/>
-                <a:cs typeface="Georgia"/>
-              </a:defRPr>
-            </a:lvl2pPr>
-            <a:lvl3pPr>
-              <a:defRPr sz="1800" b="1">
-                <a:solidFill>
-                  <a:srgbClr val="111015"/>
-                </a:solidFill>
-                <a:latin typeface="Georgia"/>
-                <a:ea typeface="Georgia"/>
-                <a:cs typeface="Georgia"/>
-              </a:defRPr>
-            </a:lvl3pPr>
-            <a:lvl4pPr>
-              <a:defRPr sz="1800" b="1">
-                <a:solidFill>
-                  <a:srgbClr val="111015"/>
-                </a:solidFill>
-                <a:latin typeface="Georgia"/>
-                <a:ea typeface="Georgia"/>
-                <a:cs typeface="Georgia"/>
-              </a:defRPr>
-            </a:lvl4pPr>
-            <a:lvl5pPr>
-              <a:defRPr sz="1800" b="1">
-                <a:solidFill>
-                  <a:srgbClr val="111015"/>
-                </a:solidFill>
-                <a:latin typeface="Georgia"/>
-                <a:ea typeface="Georgia"/>
-                <a:cs typeface="Georgia"/>
-              </a:defRPr>
-            </a:lvl5pPr>
-            <a:lvl6pPr>
-              <a:defRPr sz="1800" b="1">
-                <a:solidFill>
-                  <a:srgbClr val="111015"/>
-                </a:solidFill>
-                <a:latin typeface="Georgia"/>
-                <a:ea typeface="Georgia"/>
-                <a:cs typeface="Georgia"/>
-              </a:defRPr>
-            </a:lvl6pPr>
-            <a:lvl7pPr>
-              <a:defRPr sz="1800" b="1">
-                <a:solidFill>
-                  <a:srgbClr val="111015"/>
-                </a:solidFill>
-                <a:latin typeface="Georgia"/>
-                <a:ea typeface="Georgia"/>
-                <a:cs typeface="Georgia"/>
-              </a:defRPr>
-            </a:lvl7pPr>
-            <a:lvl8pPr>
-              <a:defRPr sz="1800" b="1">
-                <a:solidFill>
-                  <a:srgbClr val="111015"/>
-                </a:solidFill>
-                <a:latin typeface="Georgia"/>
-                <a:ea typeface="Georgia"/>
-                <a:cs typeface="Georgia"/>
-              </a:defRPr>
-            </a:lvl8pPr>
-            <a:lvl9pPr>
-              <a:defRPr sz="1800" b="1">
-                <a:solidFill>
-                  <a:srgbClr val="111015"/>
-                </a:solidFill>
-                <a:latin typeface="Georgia"/>
-                <a:ea typeface="Georgia"/>
-                <a:cs typeface="Georgia"/>
-              </a:defRPr>
-            </a:lvl9pPr>
-          </a:lstStyle>
-          <a:p xmlns:a="http://schemas.openxmlformats.org/drawingml/2006/main">
-            <a:pPr>
-              <a:defRPr sz="1800" b="1">
-                <a:solidFill>
-                  <a:srgbClr val="111015"/>
-                </a:solidFill>
-                <a:latin typeface="Georgia"/>
-                <a:ea typeface="Georgia"/>
-                <a:cs typeface="Georgia"/>
-              </a:defRPr>
-            </a:pPr>
-            <a:r>
-              <a:rPr sz="1800" b="1">
-                <a:solidFill>
-                  <a:srgbClr val="111015"/>
-                </a:solidFill>
-                <a:latin typeface="Georgia"/>
-                <a:ea typeface="Georgia"/>
-                <a:cs typeface="Georgia"/>
-              </a:rPr>
-              <a:t>Art content &amp; demonstrations</a:t>
-            </a:r>
-          </a:p>
-        </p:txBody>
-      </p:sp>
-      <p:sp>
-        <p:nvSpPr>
-          <p:cNvPr id="16" name="text-24">
-            <a:extLst xmlns:a="http://schemas.openxmlformats.org/drawingml/2006/main">
-              <a:ext uri="{FF2B5EF4-FFF2-40B4-BE49-F238E27FC236}">
-                <a16:creationId xmlns:a16="http://schemas.microsoft.com/office/drawing/2014/main" id="{011F79F8-D8FC-4A17-8CFE-3FC5146BFBD8}"/>
-              </a:ext>
-            </a:extLst>
-          </p:cNvPr>
-          <p:cNvSpPr>
-            <a:spLocks xmlns:a="http://schemas.openxmlformats.org/drawingml/2006/main" noGrp="1"/>
-          </p:cNvSpPr>
-          <p:nvPr/>
-        </p:nvSpPr>
-        <p:spPr>
-          <a:xfrm xmlns:a="http://schemas.openxmlformats.org/drawingml/2006/main">
-            <a:off x="6286500" y="5648325"/>
-            <a:ext cx="5238750" cy="857250"/>
-          </a:xfrm>
-          <a:prstGeom xmlns:a="http://schemas.openxmlformats.org/drawingml/2006/main" prst="rect">
-            <a:avLst/>
-          </a:prstGeom>
-          <a:noFill xmlns:a="http://schemas.openxmlformats.org/drawingml/2006/main"/>
-          <a:ln xmlns:a="http://schemas.openxmlformats.org/drawingml/2006/main" w="0">
-            <a:noFill/>
-          </a:ln>
-        </p:spPr>
-        <p:txBody>
-          <a:bodyPr xmlns:a="http://schemas.openxmlformats.org/drawingml/2006/main" lIns="0" tIns="0" rIns="0" bIns="0" anchor="t">
-            <a:noAutofit/>
-          </a:bodyPr>
-          <a:lstStyle xmlns:a="http://schemas.openxmlformats.org/drawingml/2006/main">
-            <a:defPPr>
-              <a:defRPr sz="1575" b="0">
-                <a:solidFill>
-                  <a:srgbClr val="5F5A63"/>
-                </a:solidFill>
-                <a:latin typeface="Arial"/>
-                <a:ea typeface="Arial"/>
-                <a:cs typeface="Arial"/>
-              </a:defRPr>
-            </a:defPPr>
-            <a:lvl1pPr>
-              <a:defRPr sz="1575" b="0">
-                <a:solidFill>
-                  <a:srgbClr val="5F5A63"/>
-                </a:solidFill>
-                <a:latin typeface="Arial"/>
-                <a:ea typeface="Arial"/>
-                <a:cs typeface="Arial"/>
-              </a:defRPr>
-            </a:lvl1pPr>
-            <a:lvl2pPr>
-              <a:defRPr sz="1575" b="0">
-                <a:solidFill>
-                  <a:srgbClr val="5F5A63"/>
-                </a:solidFill>
-                <a:latin typeface="Arial"/>
-                <a:ea typeface="Arial"/>
-                <a:cs typeface="Arial"/>
-              </a:defRPr>
-            </a:lvl2pPr>
-            <a:lvl3pPr>
-              <a:defRPr sz="1575" b="0">
-                <a:solidFill>
-                  <a:srgbClr val="5F5A63"/>
-                </a:solidFill>
-                <a:latin typeface="Arial"/>
-                <a:ea typeface="Arial"/>
-                <a:cs typeface="Arial"/>
-              </a:defRPr>
-            </a:lvl3pPr>
-            <a:lvl4pPr>
-              <a:defRPr sz="1575" b="0">
-                <a:solidFill>
-                  <a:srgbClr val="5F5A63"/>
-                </a:solidFill>
-                <a:latin typeface="Arial"/>
-                <a:ea typeface="Arial"/>
-                <a:cs typeface="Arial"/>
-              </a:defRPr>
-            </a:lvl4pPr>
-            <a:lvl5pPr>
-              <a:defRPr sz="1575" b="0">
-                <a:solidFill>
-                  <a:srgbClr val="5F5A63"/>
-                </a:solidFill>
-                <a:latin typeface="Arial"/>
-                <a:ea typeface="Arial"/>
-                <a:cs typeface="Arial"/>
-              </a:defRPr>
-            </a:lvl5pPr>
-            <a:lvl6pPr>
-              <a:defRPr sz="1575" b="0">
-                <a:solidFill>
-                  <a:srgbClr val="5F5A63"/>
-                </a:solidFill>
-                <a:latin typeface="Arial"/>
-                <a:ea typeface="Arial"/>
-                <a:cs typeface="Arial"/>
-              </a:defRPr>
-            </a:lvl6pPr>
-            <a:lvl7pPr>
-              <a:defRPr sz="1575" b="0">
-                <a:solidFill>
-                  <a:srgbClr val="5F5A63"/>
-                </a:solidFill>
-                <a:latin typeface="Arial"/>
-                <a:ea typeface="Arial"/>
-                <a:cs typeface="Arial"/>
-              </a:defRPr>
-            </a:lvl7pPr>
-            <a:lvl8pPr>
-              <a:defRPr sz="1575" b="0">
-                <a:solidFill>
-                  <a:srgbClr val="5F5A63"/>
-                </a:solidFill>
-                <a:latin typeface="Arial"/>
-                <a:ea typeface="Arial"/>
-                <a:cs typeface="Arial"/>
-              </a:defRPr>
-            </a:lvl8pPr>
-            <a:lvl9pPr>
-              <a:defRPr sz="1575" b="0">
-                <a:solidFill>
-                  <a:srgbClr val="5F5A63"/>
-                </a:solidFill>
-                <a:latin typeface="Arial"/>
-                <a:ea typeface="Arial"/>
-                <a:cs typeface="Arial"/>
-              </a:defRPr>
-            </a:lvl9pPr>
-          </a:lstStyle>
-          <a:p xmlns:a="http://schemas.openxmlformats.org/drawingml/2006/main">
-            <a:pPr>
-              <a:defRPr sz="1575" b="0">
-                <a:solidFill>
-                  <a:srgbClr val="5F5A63"/>
-                </a:solidFill>
-                <a:latin typeface="Arial"/>
-                <a:ea typeface="Arial"/>
-                <a:cs typeface="Arial"/>
-              </a:defRPr>
-            </a:pPr>
-            <a:r>
-              <a:rPr sz="1575" b="0">
-                <a:solidFill>
-                  <a:srgbClr val="5F5A63"/>
-                </a:solidFill>
-                <a:latin typeface="Arial"/>
-                <a:ea typeface="Arial"/>
-                <a:cs typeface="Arial"/>
-              </a:rPr>
-              <a:t>Production of illustrations, tutorials and demonstrations with digital and traditional products, highlighting their creative applications in promotional content.</a:t>
+              <a:t>Content designed to connect brands with the creative community. Reviews of tools and materials for digital and traditional art, alongside illustrations, tutorials and demonstrations highlighting their applications in branding content.</a:t>
             </a:r>
           </a:p>
         </p:txBody>
@@ -10551,7 +9287,7 @@
     </p:spTree>
     <p:extLst>
       <p:ext uri="{BB962C8B-B14F-4D97-AF65-F5344CB8AC3E}">
-        <p14:creationId xmlns:p14="http://schemas.microsoft.com/office/powerpoint/2010/main" val="1413264004"/>
+        <p14:creationId xmlns:p14="http://schemas.microsoft.com/office/powerpoint/2010/main" val="1227667542"/>
       </p:ext>
     </p:extLst>
   </p:cSld>
@@ -10579,10 +9315,10 @@
       </p:grpSpPr>
       <p:sp>
         <p:nvSpPr>
-          <p:cNvPr id="12" name="text-25">
+          <p:cNvPr id="12" name="text-17">
             <a:extLst xmlns:a="http://schemas.openxmlformats.org/drawingml/2006/main">
               <a:ext uri="{FF2B5EF4-FFF2-40B4-BE49-F238E27FC236}">
-                <a16:creationId xmlns:a16="http://schemas.microsoft.com/office/drawing/2014/main" id="{7D505C45-865C-418B-BE7F-3E407FC576DE}"/>
+                <a16:creationId xmlns:a16="http://schemas.microsoft.com/office/drawing/2014/main" id="{BBA2FB27-728C-47E9-85CA-59AA291936B0}"/>
               </a:ext>
             </a:extLst>
           </p:cNvPr>
@@ -10737,10 +9473,10 @@
       </p:sp>
       <p:sp>
         <p:nvSpPr>
-          <p:cNvPr id="2" name="text-26">
+          <p:cNvPr id="2" name="text-18">
             <a:extLst xmlns:a="http://schemas.openxmlformats.org/drawingml/2006/main">
               <a:ext uri="{FF2B5EF4-FFF2-40B4-BE49-F238E27FC236}">
-                <a16:creationId xmlns:a16="http://schemas.microsoft.com/office/drawing/2014/main" id="{BC9B5C6F-2109-4DA5-BE9D-FFEADA337C78}"/>
+                <a16:creationId xmlns:a16="http://schemas.microsoft.com/office/drawing/2014/main" id="{8B20C9E2-86F9-42CE-AD2C-CDC6CEDFD868}"/>
               </a:ext>
             </a:extLst>
           </p:cNvPr>
@@ -10895,10 +9631,10 @@
       </p:sp>
       <p:sp>
         <p:nvSpPr>
-          <p:cNvPr id="3" name="text-27">
+          <p:cNvPr id="3" name="text-19">
             <a:extLst xmlns:a="http://schemas.openxmlformats.org/drawingml/2006/main">
               <a:ext uri="{FF2B5EF4-FFF2-40B4-BE49-F238E27FC236}">
-                <a16:creationId xmlns:a16="http://schemas.microsoft.com/office/drawing/2014/main" id="{4FBDABBA-8173-4F77-AD02-61B15DF3CF6C}"/>
+                <a16:creationId xmlns:a16="http://schemas.microsoft.com/office/drawing/2014/main" id="{D04ADEB5-DF59-4B65-BD6E-2CD98E294918}"/>
               </a:ext>
             </a:extLst>
           </p:cNvPr>
@@ -11053,10 +9789,10 @@
       </p:sp>
       <p:sp>
         <p:nvSpPr>
-          <p:cNvPr id="4" name="text-28">
+          <p:cNvPr id="4" name="text-20">
             <a:extLst xmlns:a="http://schemas.openxmlformats.org/drawingml/2006/main">
               <a:ext uri="{FF2B5EF4-FFF2-40B4-BE49-F238E27FC236}">
-                <a16:creationId xmlns:a16="http://schemas.microsoft.com/office/drawing/2014/main" id="{6143C37C-9B91-4943-A654-20A597BC9EBD}"/>
+                <a16:creationId xmlns:a16="http://schemas.microsoft.com/office/drawing/2014/main" id="{173DEF5A-9535-425E-BC4F-6C6783B82EF4}"/>
               </a:ext>
             </a:extLst>
           </p:cNvPr>
@@ -11211,10 +9947,10 @@
       </p:sp>
       <p:sp>
         <p:nvSpPr>
-          <p:cNvPr id="5" name="text-29">
+          <p:cNvPr id="5" name="text-21">
             <a:extLst xmlns:a="http://schemas.openxmlformats.org/drawingml/2006/main">
               <a:ext uri="{FF2B5EF4-FFF2-40B4-BE49-F238E27FC236}">
-                <a16:creationId xmlns:a16="http://schemas.microsoft.com/office/drawing/2014/main" id="{A5C40C4F-080B-4AAC-A377-AEE81D86D5C3}"/>
+                <a16:creationId xmlns:a16="http://schemas.microsoft.com/office/drawing/2014/main" id="{2341C5DB-D902-4A24-A19D-0F4D3898D58F}"/>
               </a:ext>
             </a:extLst>
           </p:cNvPr>
@@ -11369,10 +10105,10 @@
       </p:sp>
       <p:sp>
         <p:nvSpPr>
-          <p:cNvPr id="6" name="text-30">
+          <p:cNvPr id="6" name="text-22">
             <a:extLst xmlns:a="http://schemas.openxmlformats.org/drawingml/2006/main">
               <a:ext uri="{FF2B5EF4-FFF2-40B4-BE49-F238E27FC236}">
-                <a16:creationId xmlns:a16="http://schemas.microsoft.com/office/drawing/2014/main" id="{0D0C1B3D-FD1E-40F0-8279-CEE6AFD494D7}"/>
+                <a16:creationId xmlns:a16="http://schemas.microsoft.com/office/drawing/2014/main" id="{628C0809-BCB4-4D85-B6DA-C0EB9E48658D}"/>
               </a:ext>
             </a:extLst>
           </p:cNvPr>
@@ -11527,10 +10263,10 @@
       </p:sp>
       <p:sp>
         <p:nvSpPr>
-          <p:cNvPr id="7" name="text-31">
+          <p:cNvPr id="7" name="text-23">
             <a:extLst xmlns:a="http://schemas.openxmlformats.org/drawingml/2006/main">
               <a:ext uri="{FF2B5EF4-FFF2-40B4-BE49-F238E27FC236}">
-                <a16:creationId xmlns:a16="http://schemas.microsoft.com/office/drawing/2014/main" id="{4AAD0CDC-1969-447F-BE25-C6F2BAC804B6}"/>
+                <a16:creationId xmlns:a16="http://schemas.microsoft.com/office/drawing/2014/main" id="{E6D24AF8-74C4-4A52-8F07-E4986F33C7AF}"/>
               </a:ext>
             </a:extLst>
           </p:cNvPr>
@@ -11685,10 +10421,10 @@
       </p:sp>
       <p:sp>
         <p:nvSpPr>
-          <p:cNvPr id="8" name="text-32">
+          <p:cNvPr id="8" name="text-24">
             <a:extLst xmlns:a="http://schemas.openxmlformats.org/drawingml/2006/main">
               <a:ext uri="{FF2B5EF4-FFF2-40B4-BE49-F238E27FC236}">
-                <a16:creationId xmlns:a16="http://schemas.microsoft.com/office/drawing/2014/main" id="{B04FDD4D-1294-4BA8-A842-EAFE2E94CAAC}"/>
+                <a16:creationId xmlns:a16="http://schemas.microsoft.com/office/drawing/2014/main" id="{472A6E82-8D92-42CC-93BE-9EBA685F23A8}"/>
               </a:ext>
             </a:extLst>
           </p:cNvPr>
@@ -11835,7 +10571,7 @@
                 <a:latin typeface="Arial"/>
                 <a:ea typeface="Arial"/>
                 <a:cs typeface="Arial"/>
-                <a:hlinkClick xmlns:r="http://schemas.openxmlformats.org/officeDocument/2006/relationships" r:id="R95ce380112954059"/>
+                <a:hlinkClick xmlns:r="http://schemas.openxmlformats.org/officeDocument/2006/relationships" r:id="R772592cc61e043e8"/>
               </a:rPr>
               <a:t>patreon.com/giums</a:t>
             </a:r>
@@ -11847,7 +10583,7 @@
           <p:cNvPr id="9" name="">
             <a:extLst xmlns:a="http://schemas.openxmlformats.org/drawingml/2006/main">
               <a:ext uri="{FF2B5EF4-FFF2-40B4-BE49-F238E27FC236}">
-                <a16:creationId xmlns:a16="http://schemas.microsoft.com/office/drawing/2014/main" id="{601B7E2E-BFAF-4617-B89E-DDC2A64FAA41}"/>
+                <a16:creationId xmlns:a16="http://schemas.microsoft.com/office/drawing/2014/main" id="{1E6E280A-F2F0-4222-90D5-00E11D0CE9F7}"/>
               </a:ext>
             </a:extLst>
           </p:cNvPr>
@@ -11857,7 +10593,7 @@
           <p:nvPr/>
         </p:nvPicPr>
         <p:blipFill>
-          <a:blip xmlns:r="http://schemas.openxmlformats.org/officeDocument/2006/relationships" xmlns:a="http://schemas.openxmlformats.org/drawingml/2006/main" r:embed="R83ab0b32cc0346f3"/>
+          <a:blip xmlns:r="http://schemas.openxmlformats.org/officeDocument/2006/relationships" xmlns:a="http://schemas.openxmlformats.org/drawingml/2006/main" r:embed="R999c44127a8f4aa3"/>
           <a:srcRect xmlns:a="http://schemas.openxmlformats.org/drawingml/2006/main" l="10811" t="0" r="10811" b="0"/>
           <a:stretch xmlns:a="http://schemas.openxmlformats.org/drawingml/2006/main">
             <a:fillRect l="0" t="0" r="0" b="0"/>
@@ -11878,7 +10614,7 @@
           <p:cNvPr id="10" name="">
             <a:extLst xmlns:a="http://schemas.openxmlformats.org/drawingml/2006/main">
               <a:ext uri="{FF2B5EF4-FFF2-40B4-BE49-F238E27FC236}">
-                <a16:creationId xmlns:a16="http://schemas.microsoft.com/office/drawing/2014/main" id="{FACB9F6B-248B-472C-A730-B3CAFF3A5B20}"/>
+                <a16:creationId xmlns:a16="http://schemas.microsoft.com/office/drawing/2014/main" id="{73578E79-8A95-4BF9-A659-CE89D4D4306F}"/>
               </a:ext>
             </a:extLst>
           </p:cNvPr>
@@ -11888,7 +10624,7 @@
           <p:nvPr/>
         </p:nvPicPr>
         <p:blipFill>
-          <a:blip xmlns:r="http://schemas.openxmlformats.org/officeDocument/2006/relationships" xmlns:a="http://schemas.openxmlformats.org/drawingml/2006/main" r:embed="R4904a59bffba4411"/>
+          <a:blip xmlns:r="http://schemas.openxmlformats.org/officeDocument/2006/relationships" xmlns:a="http://schemas.openxmlformats.org/drawingml/2006/main" r:embed="R79f341a1671e46a1"/>
           <a:srcRect xmlns:a="http://schemas.openxmlformats.org/drawingml/2006/main" l="10811" t="0" r="10811" b="0"/>
           <a:stretch xmlns:a="http://schemas.openxmlformats.org/drawingml/2006/main">
             <a:fillRect l="0" t="0" r="0" b="0"/>
@@ -11909,7 +10645,7 @@
           <p:cNvPr id="11" name="">
             <a:extLst xmlns:a="http://schemas.openxmlformats.org/drawingml/2006/main">
               <a:ext uri="{FF2B5EF4-FFF2-40B4-BE49-F238E27FC236}">
-                <a16:creationId xmlns:a16="http://schemas.microsoft.com/office/drawing/2014/main" id="{E63EC822-D639-48D5-BC0D-47A4866D4156}"/>
+                <a16:creationId xmlns:a16="http://schemas.microsoft.com/office/drawing/2014/main" id="{D648657F-1CC7-4A07-B2C2-BE083CA97708}"/>
               </a:ext>
             </a:extLst>
           </p:cNvPr>
@@ -11919,7 +10655,7 @@
           <p:nvPr/>
         </p:nvPicPr>
         <p:blipFill>
-          <a:blip xmlns:r="http://schemas.openxmlformats.org/officeDocument/2006/relationships" xmlns:a="http://schemas.openxmlformats.org/drawingml/2006/main" r:embed="Rf01eebf1562c4892"/>
+          <a:blip xmlns:r="http://schemas.openxmlformats.org/officeDocument/2006/relationships" xmlns:a="http://schemas.openxmlformats.org/drawingml/2006/main" r:embed="R921bb5dbd63345cc"/>
           <a:srcRect xmlns:a="http://schemas.openxmlformats.org/drawingml/2006/main" l="10811" t="0" r="10811" b="0"/>
           <a:stretch xmlns:a="http://schemas.openxmlformats.org/drawingml/2006/main">
             <a:fillRect l="0" t="0" r="0" b="0"/>
@@ -11938,7 +10674,7 @@
     </p:spTree>
     <p:extLst>
       <p:ext uri="{BB962C8B-B14F-4D97-AF65-F5344CB8AC3E}">
-        <p14:creationId xmlns:p14="http://schemas.microsoft.com/office/powerpoint/2010/main" val="539773542"/>
+        <p14:creationId xmlns:p14="http://schemas.microsoft.com/office/powerpoint/2010/main" val="1048399284"/>
       </p:ext>
     </p:extLst>
   </p:cSld>
@@ -11966,10 +10702,10 @@
       </p:grpSpPr>
       <p:sp>
         <p:nvSpPr>
-          <p:cNvPr id="20" name="text-33">
+          <p:cNvPr id="20" name="text-25">
             <a:extLst xmlns:a="http://schemas.openxmlformats.org/drawingml/2006/main">
               <a:ext uri="{FF2B5EF4-FFF2-40B4-BE49-F238E27FC236}">
-                <a16:creationId xmlns:a16="http://schemas.microsoft.com/office/drawing/2014/main" id="{2DDB8881-91E3-4C3E-8A2C-A211DFB32C40}"/>
+                <a16:creationId xmlns:a16="http://schemas.microsoft.com/office/drawing/2014/main" id="{8BF767C2-3227-4C9C-94B1-EE43E1F2E4B7}"/>
               </a:ext>
             </a:extLst>
           </p:cNvPr>
@@ -12124,10 +10860,10 @@
       </p:sp>
       <p:sp>
         <p:nvSpPr>
-          <p:cNvPr id="2" name="text-34">
+          <p:cNvPr id="2" name="text-26">
             <a:extLst xmlns:a="http://schemas.openxmlformats.org/drawingml/2006/main">
               <a:ext uri="{FF2B5EF4-FFF2-40B4-BE49-F238E27FC236}">
-                <a16:creationId xmlns:a16="http://schemas.microsoft.com/office/drawing/2014/main" id="{9A32CAD0-E7DC-4459-A466-ADAFEE335C3A}"/>
+                <a16:creationId xmlns:a16="http://schemas.microsoft.com/office/drawing/2014/main" id="{103A8AB1-80B9-4745-8ED3-D8E713FCE69D}"/>
               </a:ext>
             </a:extLst>
           </p:cNvPr>
@@ -12282,10 +11018,10 @@
       </p:sp>
       <p:sp>
         <p:nvSpPr>
-          <p:cNvPr id="3" name="text-35">
+          <p:cNvPr id="3" name="text-27">
             <a:extLst xmlns:a="http://schemas.openxmlformats.org/drawingml/2006/main">
               <a:ext uri="{FF2B5EF4-FFF2-40B4-BE49-F238E27FC236}">
-                <a16:creationId xmlns:a16="http://schemas.microsoft.com/office/drawing/2014/main" id="{DF2AAAC9-686C-4769-B2CF-0677B6AF63CC}"/>
+                <a16:creationId xmlns:a16="http://schemas.microsoft.com/office/drawing/2014/main" id="{6580BC54-D13D-4CF1-8F84-25BEF3ED0E04}"/>
               </a:ext>
             </a:extLst>
           </p:cNvPr>
@@ -12440,10 +11176,10 @@
       </p:sp>
       <p:sp>
         <p:nvSpPr>
-          <p:cNvPr id="4" name="text-36">
+          <p:cNvPr id="4" name="text-28">
             <a:extLst xmlns:a="http://schemas.openxmlformats.org/drawingml/2006/main">
               <a:ext uri="{FF2B5EF4-FFF2-40B4-BE49-F238E27FC236}">
-                <a16:creationId xmlns:a16="http://schemas.microsoft.com/office/drawing/2014/main" id="{FDD5363E-50B9-4488-BADE-B5A5731599F2}"/>
+                <a16:creationId xmlns:a16="http://schemas.microsoft.com/office/drawing/2014/main" id="{2123A89C-97FB-46AC-A6BF-4A3356A4A70B}"/>
               </a:ext>
             </a:extLst>
           </p:cNvPr>
@@ -12598,10 +11334,10 @@
       </p:sp>
       <p:sp>
         <p:nvSpPr>
-          <p:cNvPr id="5" name="text-37">
+          <p:cNvPr id="5" name="text-29">
             <a:extLst xmlns:a="http://schemas.openxmlformats.org/drawingml/2006/main">
               <a:ext uri="{FF2B5EF4-FFF2-40B4-BE49-F238E27FC236}">
-                <a16:creationId xmlns:a16="http://schemas.microsoft.com/office/drawing/2014/main" id="{25215FB4-EB7B-461E-B34D-1CC402E5A6E3}"/>
+                <a16:creationId xmlns:a16="http://schemas.microsoft.com/office/drawing/2014/main" id="{1EC0CE72-0196-4943-B912-D5195B437034}"/>
               </a:ext>
             </a:extLst>
           </p:cNvPr>
@@ -12756,10 +11492,10 @@
       </p:sp>
       <p:sp>
         <p:nvSpPr>
-          <p:cNvPr id="6" name="text-38">
+          <p:cNvPr id="6" name="text-30">
             <a:extLst xmlns:a="http://schemas.openxmlformats.org/drawingml/2006/main">
               <a:ext uri="{FF2B5EF4-FFF2-40B4-BE49-F238E27FC236}">
-                <a16:creationId xmlns:a16="http://schemas.microsoft.com/office/drawing/2014/main" id="{0CA9CAB9-B7D6-4E4A-8784-1AE6BADDA5CA}"/>
+                <a16:creationId xmlns:a16="http://schemas.microsoft.com/office/drawing/2014/main" id="{12B0B3C3-EF0B-41FB-BC85-5274A829B1C8}"/>
               </a:ext>
             </a:extLst>
           </p:cNvPr>
@@ -12914,10 +11650,10 @@
       </p:sp>
       <p:sp>
         <p:nvSpPr>
-          <p:cNvPr id="7" name="text-39">
+          <p:cNvPr id="7" name="text-31">
             <a:extLst xmlns:a="http://schemas.openxmlformats.org/drawingml/2006/main">
               <a:ext uri="{FF2B5EF4-FFF2-40B4-BE49-F238E27FC236}">
-                <a16:creationId xmlns:a16="http://schemas.microsoft.com/office/drawing/2014/main" id="{CB7F7228-6BF2-4283-92B9-3B2919A1044A}"/>
+                <a16:creationId xmlns:a16="http://schemas.microsoft.com/office/drawing/2014/main" id="{CD7488F2-21C9-4158-B5A5-F3EA7E559A72}"/>
               </a:ext>
             </a:extLst>
           </p:cNvPr>
@@ -13072,10 +11808,10 @@
       </p:sp>
       <p:sp>
         <p:nvSpPr>
-          <p:cNvPr id="8" name="text-40">
+          <p:cNvPr id="8" name="text-32">
             <a:extLst xmlns:a="http://schemas.openxmlformats.org/drawingml/2006/main">
               <a:ext uri="{FF2B5EF4-FFF2-40B4-BE49-F238E27FC236}">
-                <a16:creationId xmlns:a16="http://schemas.microsoft.com/office/drawing/2014/main" id="{C7159980-7BDE-49DC-9029-71383455FD27}"/>
+                <a16:creationId xmlns:a16="http://schemas.microsoft.com/office/drawing/2014/main" id="{06BAAE48-ADCB-40E4-8F39-A45A78DFC50D}"/>
               </a:ext>
             </a:extLst>
           </p:cNvPr>
@@ -13230,10 +11966,10 @@
       </p:sp>
       <p:sp>
         <p:nvSpPr>
-          <p:cNvPr id="9" name="text-41">
+          <p:cNvPr id="9" name="text-33">
             <a:extLst xmlns:a="http://schemas.openxmlformats.org/drawingml/2006/main">
               <a:ext uri="{FF2B5EF4-FFF2-40B4-BE49-F238E27FC236}">
-                <a16:creationId xmlns:a16="http://schemas.microsoft.com/office/drawing/2014/main" id="{AD514BA8-6C27-4F86-B45F-ABFAEA8BFC57}"/>
+                <a16:creationId xmlns:a16="http://schemas.microsoft.com/office/drawing/2014/main" id="{18422DFF-1F5A-44AE-A37C-A7EA8D4DCA1D}"/>
               </a:ext>
             </a:extLst>
           </p:cNvPr>
@@ -13388,10 +12124,10 @@
       </p:sp>
       <p:sp>
         <p:nvSpPr>
-          <p:cNvPr id="10" name="text-42">
+          <p:cNvPr id="10" name="text-34">
             <a:extLst xmlns:a="http://schemas.openxmlformats.org/drawingml/2006/main">
               <a:ext uri="{FF2B5EF4-FFF2-40B4-BE49-F238E27FC236}">
-                <a16:creationId xmlns:a16="http://schemas.microsoft.com/office/drawing/2014/main" id="{1D289FF6-C2CF-4BE2-9FD8-DDFD30CAFE6E}"/>
+                <a16:creationId xmlns:a16="http://schemas.microsoft.com/office/drawing/2014/main" id="{FACDA34C-6B7E-4CD4-852C-DEE2EDC01725}"/>
               </a:ext>
             </a:extLst>
           </p:cNvPr>
@@ -13546,10 +12282,10 @@
       </p:sp>
       <p:sp>
         <p:nvSpPr>
-          <p:cNvPr id="11" name="text-43">
+          <p:cNvPr id="11" name="text-35">
             <a:extLst xmlns:a="http://schemas.openxmlformats.org/drawingml/2006/main">
               <a:ext uri="{FF2B5EF4-FFF2-40B4-BE49-F238E27FC236}">
-                <a16:creationId xmlns:a16="http://schemas.microsoft.com/office/drawing/2014/main" id="{FCDB84E2-D189-4298-B0AD-40BBBFB77881}"/>
+                <a16:creationId xmlns:a16="http://schemas.microsoft.com/office/drawing/2014/main" id="{30A749BB-5D27-4134-8F82-9127D97BB035}"/>
               </a:ext>
             </a:extLst>
           </p:cNvPr>
@@ -13704,10 +12440,10 @@
       </p:sp>
       <p:sp>
         <p:nvSpPr>
-          <p:cNvPr id="12" name="text-44">
+          <p:cNvPr id="12" name="text-36">
             <a:extLst xmlns:a="http://schemas.openxmlformats.org/drawingml/2006/main">
               <a:ext uri="{FF2B5EF4-FFF2-40B4-BE49-F238E27FC236}">
-                <a16:creationId xmlns:a16="http://schemas.microsoft.com/office/drawing/2014/main" id="{DA22F18E-6F5D-45F9-B1F1-C9D5739B06DF}"/>
+                <a16:creationId xmlns:a16="http://schemas.microsoft.com/office/drawing/2014/main" id="{1694F6F1-4C96-4E1E-BE18-2771C999974F}"/>
               </a:ext>
             </a:extLst>
           </p:cNvPr>
@@ -13862,10 +12598,10 @@
       </p:sp>
       <p:sp>
         <p:nvSpPr>
-          <p:cNvPr id="13" name="text-45">
+          <p:cNvPr id="13" name="text-37">
             <a:extLst xmlns:a="http://schemas.openxmlformats.org/drawingml/2006/main">
               <a:ext uri="{FF2B5EF4-FFF2-40B4-BE49-F238E27FC236}">
-                <a16:creationId xmlns:a16="http://schemas.microsoft.com/office/drawing/2014/main" id="{58135D55-13FD-47B5-A165-A540B972295A}"/>
+                <a16:creationId xmlns:a16="http://schemas.microsoft.com/office/drawing/2014/main" id="{4BBCAE3E-AF6B-44AD-84F6-41202F586E67}"/>
               </a:ext>
             </a:extLst>
           </p:cNvPr>
@@ -14020,10 +12756,10 @@
       </p:sp>
       <p:sp>
         <p:nvSpPr>
-          <p:cNvPr id="14" name="text-46">
+          <p:cNvPr id="14" name="text-38">
             <a:extLst xmlns:a="http://schemas.openxmlformats.org/drawingml/2006/main">
               <a:ext uri="{FF2B5EF4-FFF2-40B4-BE49-F238E27FC236}">
-                <a16:creationId xmlns:a16="http://schemas.microsoft.com/office/drawing/2014/main" id="{268C124D-A3FC-434B-B18F-84AFE8C3816C}"/>
+                <a16:creationId xmlns:a16="http://schemas.microsoft.com/office/drawing/2014/main" id="{97FD15BD-D498-4305-932A-D123A3743765}"/>
               </a:ext>
             </a:extLst>
           </p:cNvPr>
@@ -14178,10 +12914,10 @@
       </p:sp>
       <p:sp>
         <p:nvSpPr>
-          <p:cNvPr id="15" name="text-47">
+          <p:cNvPr id="15" name="text-39">
             <a:extLst xmlns:a="http://schemas.openxmlformats.org/drawingml/2006/main">
               <a:ext uri="{FF2B5EF4-FFF2-40B4-BE49-F238E27FC236}">
-                <a16:creationId xmlns:a16="http://schemas.microsoft.com/office/drawing/2014/main" id="{1564776C-94D9-4D51-A02F-8FA79713B1A3}"/>
+                <a16:creationId xmlns:a16="http://schemas.microsoft.com/office/drawing/2014/main" id="{C997A0BE-3F73-466A-BE9D-6D7E47F15C75}"/>
               </a:ext>
             </a:extLst>
           </p:cNvPr>
@@ -14336,10 +13072,10 @@
       </p:sp>
       <p:sp>
         <p:nvSpPr>
-          <p:cNvPr id="16" name="text-48">
+          <p:cNvPr id="16" name="text-40">
             <a:extLst xmlns:a="http://schemas.openxmlformats.org/drawingml/2006/main">
               <a:ext uri="{FF2B5EF4-FFF2-40B4-BE49-F238E27FC236}">
-                <a16:creationId xmlns:a16="http://schemas.microsoft.com/office/drawing/2014/main" id="{996BCB5D-6F9C-4E95-B287-4A4A1C196C5D}"/>
+                <a16:creationId xmlns:a16="http://schemas.microsoft.com/office/drawing/2014/main" id="{DB1D2D75-E8EA-40AE-9EFF-C5770A5316AE}"/>
               </a:ext>
             </a:extLst>
           </p:cNvPr>
@@ -14494,10 +13230,10 @@
       </p:sp>
       <p:sp>
         <p:nvSpPr>
-          <p:cNvPr id="17" name="text-49">
+          <p:cNvPr id="17" name="text-41">
             <a:extLst xmlns:a="http://schemas.openxmlformats.org/drawingml/2006/main">
               <a:ext uri="{FF2B5EF4-FFF2-40B4-BE49-F238E27FC236}">
-                <a16:creationId xmlns:a16="http://schemas.microsoft.com/office/drawing/2014/main" id="{82CEFD5D-F800-40A2-89FC-E6453AB74740}"/>
+                <a16:creationId xmlns:a16="http://schemas.microsoft.com/office/drawing/2014/main" id="{4CCAD913-218A-4AA2-BC6A-7A2CB106A6A6}"/>
               </a:ext>
             </a:extLst>
           </p:cNvPr>
@@ -14652,10 +13388,10 @@
       </p:sp>
       <p:sp>
         <p:nvSpPr>
-          <p:cNvPr id="18" name="text-50">
+          <p:cNvPr id="18" name="text-42">
             <a:extLst xmlns:a="http://schemas.openxmlformats.org/drawingml/2006/main">
               <a:ext uri="{FF2B5EF4-FFF2-40B4-BE49-F238E27FC236}">
-                <a16:creationId xmlns:a16="http://schemas.microsoft.com/office/drawing/2014/main" id="{4E49E0E4-2F4A-4376-8587-9A848E11E9C1}"/>
+                <a16:creationId xmlns:a16="http://schemas.microsoft.com/office/drawing/2014/main" id="{920886DA-D680-46F9-AE94-2CB931FF4962}"/>
               </a:ext>
             </a:extLst>
           </p:cNvPr>
@@ -14810,10 +13546,10 @@
       </p:sp>
       <p:sp>
         <p:nvSpPr>
-          <p:cNvPr id="19" name="text-51">
+          <p:cNvPr id="19" name="text-43">
             <a:extLst xmlns:a="http://schemas.openxmlformats.org/drawingml/2006/main">
               <a:ext uri="{FF2B5EF4-FFF2-40B4-BE49-F238E27FC236}">
-                <a16:creationId xmlns:a16="http://schemas.microsoft.com/office/drawing/2014/main" id="{7EBA8C48-CED4-4510-A87D-0415D178534C}"/>
+                <a16:creationId xmlns:a16="http://schemas.microsoft.com/office/drawing/2014/main" id="{06DFF50F-586A-4702-8E19-1ECCB9F1F83B}"/>
               </a:ext>
             </a:extLst>
           </p:cNvPr>
@@ -14969,7 +13705,7 @@
     </p:spTree>
     <p:extLst>
       <p:ext uri="{BB962C8B-B14F-4D97-AF65-F5344CB8AC3E}">
-        <p14:creationId xmlns:p14="http://schemas.microsoft.com/office/powerpoint/2010/main" val="180987645"/>
+        <p14:creationId xmlns:p14="http://schemas.microsoft.com/office/powerpoint/2010/main" val="1458442818"/>
       </p:ext>
     </p:extLst>
   </p:cSld>
@@ -14997,10 +13733,10 @@
       </p:grpSpPr>
       <p:sp>
         <p:nvSpPr>
-          <p:cNvPr id="14" name="text-52">
+          <p:cNvPr id="14" name="text-44">
             <a:extLst xmlns:a="http://schemas.openxmlformats.org/drawingml/2006/main">
               <a:ext uri="{FF2B5EF4-FFF2-40B4-BE49-F238E27FC236}">
-                <a16:creationId xmlns:a16="http://schemas.microsoft.com/office/drawing/2014/main" id="{98C76237-5E0A-4C29-B618-47D063BB68A9}"/>
+                <a16:creationId xmlns:a16="http://schemas.microsoft.com/office/drawing/2014/main" id="{D453A767-980A-40B8-97AD-8E2051E02B0B}"/>
               </a:ext>
             </a:extLst>
           </p:cNvPr>
@@ -15155,10 +13891,10 @@
       </p:sp>
       <p:sp>
         <p:nvSpPr>
-          <p:cNvPr id="2" name="text-53">
+          <p:cNvPr id="2" name="text-45">
             <a:extLst xmlns:a="http://schemas.openxmlformats.org/drawingml/2006/main">
               <a:ext uri="{FF2B5EF4-FFF2-40B4-BE49-F238E27FC236}">
-                <a16:creationId xmlns:a16="http://schemas.microsoft.com/office/drawing/2014/main" id="{639A40E6-DD15-4152-B1D1-A931539FAF85}"/>
+                <a16:creationId xmlns:a16="http://schemas.microsoft.com/office/drawing/2014/main" id="{68189845-5691-4CAF-9D9E-5567DBC5545E}"/>
               </a:ext>
             </a:extLst>
           </p:cNvPr>
@@ -15313,10 +14049,10 @@
       </p:sp>
       <p:sp>
         <p:nvSpPr>
-          <p:cNvPr id="3" name="text-54">
+          <p:cNvPr id="3" name="text-46">
             <a:extLst xmlns:a="http://schemas.openxmlformats.org/drawingml/2006/main">
               <a:ext uri="{FF2B5EF4-FFF2-40B4-BE49-F238E27FC236}">
-                <a16:creationId xmlns:a16="http://schemas.microsoft.com/office/drawing/2014/main" id="{AFEC182D-F57F-4AB2-99F4-996B91FC73D8}"/>
+                <a16:creationId xmlns:a16="http://schemas.microsoft.com/office/drawing/2014/main" id="{E52D5710-687B-4F88-B610-44B42C6C0B57}"/>
               </a:ext>
             </a:extLst>
           </p:cNvPr>
@@ -15471,10 +14207,10 @@
       </p:sp>
       <p:sp>
         <p:nvSpPr>
-          <p:cNvPr id="4" name="text-55">
+          <p:cNvPr id="4" name="text-47">
             <a:extLst xmlns:a="http://schemas.openxmlformats.org/drawingml/2006/main">
               <a:ext uri="{FF2B5EF4-FFF2-40B4-BE49-F238E27FC236}">
-                <a16:creationId xmlns:a16="http://schemas.microsoft.com/office/drawing/2014/main" id="{202C41FC-EF1B-4AF4-A21F-4F30C982CCE1}"/>
+                <a16:creationId xmlns:a16="http://schemas.microsoft.com/office/drawing/2014/main" id="{165288A1-0446-4158-9FAA-4ED12C1DDC21}"/>
               </a:ext>
             </a:extLst>
           </p:cNvPr>
@@ -15629,10 +14365,10 @@
       </p:sp>
       <p:sp>
         <p:nvSpPr>
-          <p:cNvPr id="5" name="text-56">
+          <p:cNvPr id="5" name="text-48">
             <a:extLst xmlns:a="http://schemas.openxmlformats.org/drawingml/2006/main">
               <a:ext uri="{FF2B5EF4-FFF2-40B4-BE49-F238E27FC236}">
-                <a16:creationId xmlns:a16="http://schemas.microsoft.com/office/drawing/2014/main" id="{93126DFA-0F70-49C9-9F58-7F78491F2FF2}"/>
+                <a16:creationId xmlns:a16="http://schemas.microsoft.com/office/drawing/2014/main" id="{9D8237A7-4EDF-4AEB-925E-E2290ECCC410}"/>
               </a:ext>
             </a:extLst>
           </p:cNvPr>
@@ -15787,10 +14523,10 @@
       </p:sp>
       <p:sp>
         <p:nvSpPr>
-          <p:cNvPr id="6" name="text-57">
+          <p:cNvPr id="6" name="text-49">
             <a:extLst xmlns:a="http://schemas.openxmlformats.org/drawingml/2006/main">
               <a:ext uri="{FF2B5EF4-FFF2-40B4-BE49-F238E27FC236}">
-                <a16:creationId xmlns:a16="http://schemas.microsoft.com/office/drawing/2014/main" id="{AD68E09B-239E-4F1E-9D6B-2F82104328A6}"/>
+                <a16:creationId xmlns:a16="http://schemas.microsoft.com/office/drawing/2014/main" id="{29D6D85D-63A7-4F4E-B286-B09B013D98E1}"/>
               </a:ext>
             </a:extLst>
           </p:cNvPr>
@@ -15945,10 +14681,10 @@
       </p:sp>
       <p:sp>
         <p:nvSpPr>
-          <p:cNvPr id="7" name="text-58">
+          <p:cNvPr id="7" name="text-50">
             <a:extLst xmlns:a="http://schemas.openxmlformats.org/drawingml/2006/main">
               <a:ext uri="{FF2B5EF4-FFF2-40B4-BE49-F238E27FC236}">
-                <a16:creationId xmlns:a16="http://schemas.microsoft.com/office/drawing/2014/main" id="{1374CAE0-9ACE-4C35-BA8A-17554D2E6464}"/>
+                <a16:creationId xmlns:a16="http://schemas.microsoft.com/office/drawing/2014/main" id="{B53A5537-F35A-4163-9D2F-B100C2C1DF8A}"/>
               </a:ext>
             </a:extLst>
           </p:cNvPr>
@@ -16103,10 +14839,10 @@
       </p:sp>
       <p:sp>
         <p:nvSpPr>
-          <p:cNvPr id="8" name="text-59">
+          <p:cNvPr id="8" name="text-51">
             <a:extLst xmlns:a="http://schemas.openxmlformats.org/drawingml/2006/main">
               <a:ext uri="{FF2B5EF4-FFF2-40B4-BE49-F238E27FC236}">
-                <a16:creationId xmlns:a16="http://schemas.microsoft.com/office/drawing/2014/main" id="{766ADC3F-FC5D-47BC-AA43-E332B565564F}"/>
+                <a16:creationId xmlns:a16="http://schemas.microsoft.com/office/drawing/2014/main" id="{5BA0D047-03B9-448D-9014-B5F7407011DA}"/>
               </a:ext>
             </a:extLst>
           </p:cNvPr>
@@ -16261,10 +14997,10 @@
       </p:sp>
       <p:sp>
         <p:nvSpPr>
-          <p:cNvPr id="9" name="text-60">
+          <p:cNvPr id="9" name="text-52">
             <a:extLst xmlns:a="http://schemas.openxmlformats.org/drawingml/2006/main">
               <a:ext uri="{FF2B5EF4-FFF2-40B4-BE49-F238E27FC236}">
-                <a16:creationId xmlns:a16="http://schemas.microsoft.com/office/drawing/2014/main" id="{61BF36CE-8236-4D9A-9B21-654F144DED31}"/>
+                <a16:creationId xmlns:a16="http://schemas.microsoft.com/office/drawing/2014/main" id="{1FCC8234-83BE-4DE4-84E2-D385D11398B7}"/>
               </a:ext>
             </a:extLst>
           </p:cNvPr>
@@ -16419,10 +15155,10 @@
       </p:sp>
       <p:sp>
         <p:nvSpPr>
-          <p:cNvPr id="10" name="text-61">
+          <p:cNvPr id="10" name="text-53">
             <a:extLst xmlns:a="http://schemas.openxmlformats.org/drawingml/2006/main">
               <a:ext uri="{FF2B5EF4-FFF2-40B4-BE49-F238E27FC236}">
-                <a16:creationId xmlns:a16="http://schemas.microsoft.com/office/drawing/2014/main" id="{47AB3C09-3E14-4748-99AB-416628E1D35A}"/>
+                <a16:creationId xmlns:a16="http://schemas.microsoft.com/office/drawing/2014/main" id="{BC3593E8-6C5B-47CE-B522-BC357D43E863}"/>
               </a:ext>
             </a:extLst>
           </p:cNvPr>
@@ -16577,10 +15313,10 @@
       </p:sp>
       <p:sp>
         <p:nvSpPr>
-          <p:cNvPr id="11" name="text-62">
+          <p:cNvPr id="11" name="text-54">
             <a:extLst xmlns:a="http://schemas.openxmlformats.org/drawingml/2006/main">
               <a:ext uri="{FF2B5EF4-FFF2-40B4-BE49-F238E27FC236}">
-                <a16:creationId xmlns:a16="http://schemas.microsoft.com/office/drawing/2014/main" id="{B94A642B-0C9D-4FCA-90E6-ECDADBBE58DB}"/>
+                <a16:creationId xmlns:a16="http://schemas.microsoft.com/office/drawing/2014/main" id="{A9844589-D6FE-4233-981B-61A0C77717E5}"/>
               </a:ext>
             </a:extLst>
           </p:cNvPr>
@@ -16735,10 +15471,10 @@
       </p:sp>
       <p:sp>
         <p:nvSpPr>
-          <p:cNvPr id="12" name="text-63">
+          <p:cNvPr id="12" name="text-55">
             <a:extLst xmlns:a="http://schemas.openxmlformats.org/drawingml/2006/main">
               <a:ext uri="{FF2B5EF4-FFF2-40B4-BE49-F238E27FC236}">
-                <a16:creationId xmlns:a16="http://schemas.microsoft.com/office/drawing/2014/main" id="{4ADCC55D-C346-4914-984A-FF60231510D1}"/>
+                <a16:creationId xmlns:a16="http://schemas.microsoft.com/office/drawing/2014/main" id="{40A2E44E-244E-4291-BAF3-4D88B0AB4B55}"/>
               </a:ext>
             </a:extLst>
           </p:cNvPr>
@@ -16893,10 +15629,10 @@
       </p:sp>
       <p:sp>
         <p:nvSpPr>
-          <p:cNvPr id="13" name="text-64">
+          <p:cNvPr id="13" name="text-56">
             <a:extLst xmlns:a="http://schemas.openxmlformats.org/drawingml/2006/main">
               <a:ext uri="{FF2B5EF4-FFF2-40B4-BE49-F238E27FC236}">
-                <a16:creationId xmlns:a16="http://schemas.microsoft.com/office/drawing/2014/main" id="{4A90244B-7CB8-49FD-BB7B-3E65F4EE6DD4}"/>
+                <a16:creationId xmlns:a16="http://schemas.microsoft.com/office/drawing/2014/main" id="{27D2F838-54AD-4F44-9289-FA2D076BA132}"/>
               </a:ext>
             </a:extLst>
           </p:cNvPr>
@@ -17052,7 +15788,7 @@
     </p:spTree>
     <p:extLst>
       <p:ext uri="{BB962C8B-B14F-4D97-AF65-F5344CB8AC3E}">
-        <p14:creationId xmlns:p14="http://schemas.microsoft.com/office/powerpoint/2010/main" val="2123486631"/>
+        <p14:creationId xmlns:p14="http://schemas.microsoft.com/office/powerpoint/2010/main" val="49924308"/>
       </p:ext>
     </p:extLst>
   </p:cSld>
@@ -17080,10 +15816,10 @@
       </p:grpSpPr>
       <p:sp>
         <p:nvSpPr>
-          <p:cNvPr id="31" name="text-65">
+          <p:cNvPr id="31" name="text-57">
             <a:extLst xmlns:a="http://schemas.openxmlformats.org/drawingml/2006/main">
               <a:ext uri="{FF2B5EF4-FFF2-40B4-BE49-F238E27FC236}">
-                <a16:creationId xmlns:a16="http://schemas.microsoft.com/office/drawing/2014/main" id="{575348EB-FEF6-4BB8-B3E3-610C40B606AA}"/>
+                <a16:creationId xmlns:a16="http://schemas.microsoft.com/office/drawing/2014/main" id="{66684BAB-CFE7-4309-A9D0-B35433456852}"/>
               </a:ext>
             </a:extLst>
           </p:cNvPr>
@@ -17238,10 +15974,10 @@
       </p:sp>
       <p:sp>
         <p:nvSpPr>
-          <p:cNvPr id="2" name="text-66">
+          <p:cNvPr id="2" name="text-58">
             <a:extLst xmlns:a="http://schemas.openxmlformats.org/drawingml/2006/main">
               <a:ext uri="{FF2B5EF4-FFF2-40B4-BE49-F238E27FC236}">
-                <a16:creationId xmlns:a16="http://schemas.microsoft.com/office/drawing/2014/main" id="{50FD0F30-9545-48F3-9BDC-CBB2530A43A2}"/>
+                <a16:creationId xmlns:a16="http://schemas.microsoft.com/office/drawing/2014/main" id="{A5F5DA3F-ECE6-4FE9-950B-199B2085EF48}"/>
               </a:ext>
             </a:extLst>
           </p:cNvPr>
@@ -17396,10 +16132,10 @@
       </p:sp>
       <p:sp>
         <p:nvSpPr>
-          <p:cNvPr id="3" name="text-67">
+          <p:cNvPr id="3" name="text-59">
             <a:extLst xmlns:a="http://schemas.openxmlformats.org/drawingml/2006/main">
               <a:ext uri="{FF2B5EF4-FFF2-40B4-BE49-F238E27FC236}">
-                <a16:creationId xmlns:a16="http://schemas.microsoft.com/office/drawing/2014/main" id="{1C0BF8B2-5148-40DA-BAE1-D527CA2A8D60}"/>
+                <a16:creationId xmlns:a16="http://schemas.microsoft.com/office/drawing/2014/main" id="{6589C12F-E1AE-45B0-9061-D08B6326BD0F}"/>
               </a:ext>
             </a:extLst>
           </p:cNvPr>
@@ -17554,10 +16290,10 @@
       </p:sp>
       <p:sp>
         <p:nvSpPr>
-          <p:cNvPr id="4" name="text-68">
+          <p:cNvPr id="4" name="text-60">
             <a:extLst xmlns:a="http://schemas.openxmlformats.org/drawingml/2006/main">
               <a:ext uri="{FF2B5EF4-FFF2-40B4-BE49-F238E27FC236}">
-                <a16:creationId xmlns:a16="http://schemas.microsoft.com/office/drawing/2014/main" id="{E360F62F-4592-4007-835C-0C11CECC0F72}"/>
+                <a16:creationId xmlns:a16="http://schemas.microsoft.com/office/drawing/2014/main" id="{1E413D9E-FFF3-4B09-93FA-D11961BD834C}"/>
               </a:ext>
             </a:extLst>
           </p:cNvPr>
@@ -17712,10 +16448,10 @@
       </p:sp>
       <p:sp>
         <p:nvSpPr>
-          <p:cNvPr id="5" name="text-69">
+          <p:cNvPr id="5" name="text-61">
             <a:extLst xmlns:a="http://schemas.openxmlformats.org/drawingml/2006/main">
               <a:ext uri="{FF2B5EF4-FFF2-40B4-BE49-F238E27FC236}">
-                <a16:creationId xmlns:a16="http://schemas.microsoft.com/office/drawing/2014/main" id="{487A51C6-0081-49A2-853E-9132F962022C}"/>
+                <a16:creationId xmlns:a16="http://schemas.microsoft.com/office/drawing/2014/main" id="{8C1F03AC-C17E-4DC3-B7BF-2D957AC22253}"/>
               </a:ext>
             </a:extLst>
           </p:cNvPr>
@@ -17870,10 +16606,10 @@
       </p:sp>
       <p:sp>
         <p:nvSpPr>
-          <p:cNvPr id="6" name="text-70">
+          <p:cNvPr id="6" name="text-62">
             <a:extLst xmlns:a="http://schemas.openxmlformats.org/drawingml/2006/main">
               <a:ext uri="{FF2B5EF4-FFF2-40B4-BE49-F238E27FC236}">
-                <a16:creationId xmlns:a16="http://schemas.microsoft.com/office/drawing/2014/main" id="{F5A40427-6B96-49DB-99F9-9B99F78DB9E6}"/>
+                <a16:creationId xmlns:a16="http://schemas.microsoft.com/office/drawing/2014/main" id="{4327A5BF-55AD-4C08-B7CF-DCACF43A0796}"/>
               </a:ext>
             </a:extLst>
           </p:cNvPr>
@@ -18028,10 +16764,10 @@
       </p:sp>
       <p:sp>
         <p:nvSpPr>
-          <p:cNvPr id="7" name="text-71">
+          <p:cNvPr id="7" name="text-63">
             <a:extLst xmlns:a="http://schemas.openxmlformats.org/drawingml/2006/main">
               <a:ext uri="{FF2B5EF4-FFF2-40B4-BE49-F238E27FC236}">
-                <a16:creationId xmlns:a16="http://schemas.microsoft.com/office/drawing/2014/main" id="{18BB2514-40DB-4883-9DC7-8D5B954C0B6B}"/>
+                <a16:creationId xmlns:a16="http://schemas.microsoft.com/office/drawing/2014/main" id="{CB6D1C19-B0DD-4DA5-8032-15F072472A1E}"/>
               </a:ext>
             </a:extLst>
           </p:cNvPr>
@@ -18186,10 +16922,10 @@
       </p:sp>
       <p:sp>
         <p:nvSpPr>
-          <p:cNvPr id="8" name="text-72">
+          <p:cNvPr id="8" name="text-64">
             <a:extLst xmlns:a="http://schemas.openxmlformats.org/drawingml/2006/main">
               <a:ext uri="{FF2B5EF4-FFF2-40B4-BE49-F238E27FC236}">
-                <a16:creationId xmlns:a16="http://schemas.microsoft.com/office/drawing/2014/main" id="{D6B5AC3A-19A6-440F-86DD-BB5D8445AB1C}"/>
+                <a16:creationId xmlns:a16="http://schemas.microsoft.com/office/drawing/2014/main" id="{AD494A8B-0ED4-4793-BE53-AD6F1EDE1B09}"/>
               </a:ext>
             </a:extLst>
           </p:cNvPr>
@@ -18344,10 +17080,10 @@
       </p:sp>
       <p:sp>
         <p:nvSpPr>
-          <p:cNvPr id="9" name="text-73">
+          <p:cNvPr id="9" name="text-65">
             <a:extLst xmlns:a="http://schemas.openxmlformats.org/drawingml/2006/main">
               <a:ext uri="{FF2B5EF4-FFF2-40B4-BE49-F238E27FC236}">
-                <a16:creationId xmlns:a16="http://schemas.microsoft.com/office/drawing/2014/main" id="{9A92DEE2-521F-43A9-BD4C-B886D76BB35C}"/>
+                <a16:creationId xmlns:a16="http://schemas.microsoft.com/office/drawing/2014/main" id="{772158EE-64AB-4C16-A1BF-C4FF923A37EF}"/>
               </a:ext>
             </a:extLst>
           </p:cNvPr>
@@ -18502,10 +17238,10 @@
       </p:sp>
       <p:sp>
         <p:nvSpPr>
-          <p:cNvPr id="10" name="text-74">
+          <p:cNvPr id="10" name="text-66">
             <a:extLst xmlns:a="http://schemas.openxmlformats.org/drawingml/2006/main">
               <a:ext uri="{FF2B5EF4-FFF2-40B4-BE49-F238E27FC236}">
-                <a16:creationId xmlns:a16="http://schemas.microsoft.com/office/drawing/2014/main" id="{DC2B3C39-EAC9-4F3B-929A-B27D64D1C872}"/>
+                <a16:creationId xmlns:a16="http://schemas.microsoft.com/office/drawing/2014/main" id="{4D847583-5300-447C-A29D-D9C2023145D3}"/>
               </a:ext>
             </a:extLst>
           </p:cNvPr>
@@ -18660,10 +17396,10 @@
       </p:sp>
       <p:sp>
         <p:nvSpPr>
-          <p:cNvPr id="11" name="text-75">
+          <p:cNvPr id="11" name="text-67">
             <a:extLst xmlns:a="http://schemas.openxmlformats.org/drawingml/2006/main">
               <a:ext uri="{FF2B5EF4-FFF2-40B4-BE49-F238E27FC236}">
-                <a16:creationId xmlns:a16="http://schemas.microsoft.com/office/drawing/2014/main" id="{5562CBFA-F4AB-40C8-B34E-2857FBF4E8E9}"/>
+                <a16:creationId xmlns:a16="http://schemas.microsoft.com/office/drawing/2014/main" id="{49C8FF31-4272-4439-8ABD-328E3E62B3F8}"/>
               </a:ext>
             </a:extLst>
           </p:cNvPr>
@@ -18818,10 +17554,10 @@
       </p:sp>
       <p:sp>
         <p:nvSpPr>
-          <p:cNvPr id="12" name="text-76">
+          <p:cNvPr id="12" name="text-68">
             <a:extLst xmlns:a="http://schemas.openxmlformats.org/drawingml/2006/main">
               <a:ext uri="{FF2B5EF4-FFF2-40B4-BE49-F238E27FC236}">
-                <a16:creationId xmlns:a16="http://schemas.microsoft.com/office/drawing/2014/main" id="{1F48E83E-7FAD-451E-92BC-58274CAD80B0}"/>
+                <a16:creationId xmlns:a16="http://schemas.microsoft.com/office/drawing/2014/main" id="{DE4882FE-E593-4880-8C17-FEC1D9BA4060}"/>
               </a:ext>
             </a:extLst>
           </p:cNvPr>
@@ -18976,10 +17712,10 @@
       </p:sp>
       <p:sp>
         <p:nvSpPr>
-          <p:cNvPr id="13" name="text-77">
+          <p:cNvPr id="13" name="text-69">
             <a:extLst xmlns:a="http://schemas.openxmlformats.org/drawingml/2006/main">
               <a:ext uri="{FF2B5EF4-FFF2-40B4-BE49-F238E27FC236}">
-                <a16:creationId xmlns:a16="http://schemas.microsoft.com/office/drawing/2014/main" id="{5E7D41BE-2C19-4D69-97D2-64D89213C324}"/>
+                <a16:creationId xmlns:a16="http://schemas.microsoft.com/office/drawing/2014/main" id="{29AF45F7-2AE2-4185-86F6-329FCC48CF5B}"/>
               </a:ext>
             </a:extLst>
           </p:cNvPr>
@@ -19134,10 +17870,10 @@
       </p:sp>
       <p:sp>
         <p:nvSpPr>
-          <p:cNvPr id="14" name="text-78">
+          <p:cNvPr id="14" name="text-70">
             <a:extLst xmlns:a="http://schemas.openxmlformats.org/drawingml/2006/main">
               <a:ext uri="{FF2B5EF4-FFF2-40B4-BE49-F238E27FC236}">
-                <a16:creationId xmlns:a16="http://schemas.microsoft.com/office/drawing/2014/main" id="{9927E664-FCAE-4817-863A-25B24370DF17}"/>
+                <a16:creationId xmlns:a16="http://schemas.microsoft.com/office/drawing/2014/main" id="{2E20E497-08A1-401A-9844-6986DA035A4D}"/>
               </a:ext>
             </a:extLst>
           </p:cNvPr>
@@ -19292,10 +18028,10 @@
       </p:sp>
       <p:sp>
         <p:nvSpPr>
-          <p:cNvPr id="15" name="text-79">
+          <p:cNvPr id="15" name="text-71">
             <a:extLst xmlns:a="http://schemas.openxmlformats.org/drawingml/2006/main">
               <a:ext uri="{FF2B5EF4-FFF2-40B4-BE49-F238E27FC236}">
-                <a16:creationId xmlns:a16="http://schemas.microsoft.com/office/drawing/2014/main" id="{1FD36DDE-233E-41CD-A511-D3D1A7ADEC7F}"/>
+                <a16:creationId xmlns:a16="http://schemas.microsoft.com/office/drawing/2014/main" id="{287C0830-B8D0-45A8-BF98-07320872BAE5}"/>
               </a:ext>
             </a:extLst>
           </p:cNvPr>
@@ -19450,10 +18186,10 @@
       </p:sp>
       <p:sp>
         <p:nvSpPr>
-          <p:cNvPr id="16" name="text-80">
+          <p:cNvPr id="16" name="text-72">
             <a:extLst xmlns:a="http://schemas.openxmlformats.org/drawingml/2006/main">
               <a:ext uri="{FF2B5EF4-FFF2-40B4-BE49-F238E27FC236}">
-                <a16:creationId xmlns:a16="http://schemas.microsoft.com/office/drawing/2014/main" id="{58D6C8E7-06CC-4586-B220-34384141E70D}"/>
+                <a16:creationId xmlns:a16="http://schemas.microsoft.com/office/drawing/2014/main" id="{C7C4E905-764C-4A1E-B88D-BFEC166DA1CF}"/>
               </a:ext>
             </a:extLst>
           </p:cNvPr>
@@ -19608,10 +18344,10 @@
       </p:sp>
       <p:sp>
         <p:nvSpPr>
-          <p:cNvPr id="17" name="text-81">
+          <p:cNvPr id="17" name="text-73">
             <a:extLst xmlns:a="http://schemas.openxmlformats.org/drawingml/2006/main">
               <a:ext uri="{FF2B5EF4-FFF2-40B4-BE49-F238E27FC236}">
-                <a16:creationId xmlns:a16="http://schemas.microsoft.com/office/drawing/2014/main" id="{DDE6FD4D-C8E7-44EF-B81B-8857BC8F33D3}"/>
+                <a16:creationId xmlns:a16="http://schemas.microsoft.com/office/drawing/2014/main" id="{E91D8568-335C-42E2-962A-434531E13DF2}"/>
               </a:ext>
             </a:extLst>
           </p:cNvPr>
@@ -19766,10 +18502,10 @@
       </p:sp>
       <p:sp>
         <p:nvSpPr>
-          <p:cNvPr id="18" name="text-82">
+          <p:cNvPr id="18" name="text-74">
             <a:extLst xmlns:a="http://schemas.openxmlformats.org/drawingml/2006/main">
               <a:ext uri="{FF2B5EF4-FFF2-40B4-BE49-F238E27FC236}">
-                <a16:creationId xmlns:a16="http://schemas.microsoft.com/office/drawing/2014/main" id="{18CB8DD2-6FFA-41B8-98B5-63BE05DC96F8}"/>
+                <a16:creationId xmlns:a16="http://schemas.microsoft.com/office/drawing/2014/main" id="{7C4D9DCF-B8E7-4D0A-9302-CD2E5DA08CC7}"/>
               </a:ext>
             </a:extLst>
           </p:cNvPr>
@@ -19924,10 +18660,10 @@
       </p:sp>
       <p:sp>
         <p:nvSpPr>
-          <p:cNvPr id="19" name="text-83">
+          <p:cNvPr id="19" name="text-75">
             <a:extLst xmlns:a="http://schemas.openxmlformats.org/drawingml/2006/main">
               <a:ext uri="{FF2B5EF4-FFF2-40B4-BE49-F238E27FC236}">
-                <a16:creationId xmlns:a16="http://schemas.microsoft.com/office/drawing/2014/main" id="{BAFCF245-D368-4AC9-90B9-EC7CB57A09F6}"/>
+                <a16:creationId xmlns:a16="http://schemas.microsoft.com/office/drawing/2014/main" id="{C1EA5706-8C12-4DE3-93D3-98A9878769B3}"/>
               </a:ext>
             </a:extLst>
           </p:cNvPr>
@@ -20082,10 +18818,10 @@
       </p:sp>
       <p:sp>
         <p:nvSpPr>
-          <p:cNvPr id="20" name="text-84">
+          <p:cNvPr id="20" name="text-76">
             <a:extLst xmlns:a="http://schemas.openxmlformats.org/drawingml/2006/main">
               <a:ext uri="{FF2B5EF4-FFF2-40B4-BE49-F238E27FC236}">
-                <a16:creationId xmlns:a16="http://schemas.microsoft.com/office/drawing/2014/main" id="{8CA4B52C-5F22-43BC-A503-5C184EB87E80}"/>
+                <a16:creationId xmlns:a16="http://schemas.microsoft.com/office/drawing/2014/main" id="{467EE981-FDA0-4D24-993A-28A6A52A4BE6}"/>
               </a:ext>
             </a:extLst>
           </p:cNvPr>
@@ -20240,10 +18976,10 @@
       </p:sp>
       <p:sp>
         <p:nvSpPr>
-          <p:cNvPr id="21" name="text-85">
+          <p:cNvPr id="21" name="text-77">
             <a:extLst xmlns:a="http://schemas.openxmlformats.org/drawingml/2006/main">
               <a:ext uri="{FF2B5EF4-FFF2-40B4-BE49-F238E27FC236}">
-                <a16:creationId xmlns:a16="http://schemas.microsoft.com/office/drawing/2014/main" id="{04399BA7-D5BA-4E32-AC77-ECAD32E4E5E3}"/>
+                <a16:creationId xmlns:a16="http://schemas.microsoft.com/office/drawing/2014/main" id="{3AE3980F-4067-4CF5-9D43-99D65D2EAFF6}"/>
               </a:ext>
             </a:extLst>
           </p:cNvPr>
@@ -20398,10 +19134,10 @@
       </p:sp>
       <p:sp>
         <p:nvSpPr>
-          <p:cNvPr id="22" name="text-86">
+          <p:cNvPr id="22" name="text-78">
             <a:extLst xmlns:a="http://schemas.openxmlformats.org/drawingml/2006/main">
               <a:ext uri="{FF2B5EF4-FFF2-40B4-BE49-F238E27FC236}">
-                <a16:creationId xmlns:a16="http://schemas.microsoft.com/office/drawing/2014/main" id="{36B2FDCD-FABA-489D-BEB4-1CFB95309CCE}"/>
+                <a16:creationId xmlns:a16="http://schemas.microsoft.com/office/drawing/2014/main" id="{46E28645-0E39-400F-88A3-5A26D2037BB6}"/>
               </a:ext>
             </a:extLst>
           </p:cNvPr>
@@ -20556,10 +19292,10 @@
       </p:sp>
       <p:sp>
         <p:nvSpPr>
-          <p:cNvPr id="23" name="text-87">
+          <p:cNvPr id="23" name="text-79">
             <a:extLst xmlns:a="http://schemas.openxmlformats.org/drawingml/2006/main">
               <a:ext uri="{FF2B5EF4-FFF2-40B4-BE49-F238E27FC236}">
-                <a16:creationId xmlns:a16="http://schemas.microsoft.com/office/drawing/2014/main" id="{2703D85B-DD49-46C0-90BB-921A26D9E965}"/>
+                <a16:creationId xmlns:a16="http://schemas.microsoft.com/office/drawing/2014/main" id="{16064E68-125F-4A67-8EC6-954A1879781C}"/>
               </a:ext>
             </a:extLst>
           </p:cNvPr>
@@ -20714,10 +19450,10 @@
       </p:sp>
       <p:sp>
         <p:nvSpPr>
-          <p:cNvPr id="24" name="text-88">
+          <p:cNvPr id="24" name="text-80">
             <a:extLst xmlns:a="http://schemas.openxmlformats.org/drawingml/2006/main">
               <a:ext uri="{FF2B5EF4-FFF2-40B4-BE49-F238E27FC236}">
-                <a16:creationId xmlns:a16="http://schemas.microsoft.com/office/drawing/2014/main" id="{87B3AF36-21CF-481C-8DC1-C6EA061BADFC}"/>
+                <a16:creationId xmlns:a16="http://schemas.microsoft.com/office/drawing/2014/main" id="{73E7A70D-F87C-4167-BBC0-D70734A7D3F0}"/>
               </a:ext>
             </a:extLst>
           </p:cNvPr>
@@ -20872,10 +19608,10 @@
       </p:sp>
       <p:sp>
         <p:nvSpPr>
-          <p:cNvPr id="25" name="text-89">
+          <p:cNvPr id="25" name="text-81">
             <a:extLst xmlns:a="http://schemas.openxmlformats.org/drawingml/2006/main">
               <a:ext uri="{FF2B5EF4-FFF2-40B4-BE49-F238E27FC236}">
-                <a16:creationId xmlns:a16="http://schemas.microsoft.com/office/drawing/2014/main" id="{9CA56063-F543-4192-8685-1D5B6FC0629C}"/>
+                <a16:creationId xmlns:a16="http://schemas.microsoft.com/office/drawing/2014/main" id="{B9E3B692-EE9D-483B-978D-D796EFC10B58}"/>
               </a:ext>
             </a:extLst>
           </p:cNvPr>
@@ -21030,10 +19766,10 @@
       </p:sp>
       <p:sp>
         <p:nvSpPr>
-          <p:cNvPr id="26" name="text-90">
+          <p:cNvPr id="26" name="text-82">
             <a:extLst xmlns:a="http://schemas.openxmlformats.org/drawingml/2006/main">
               <a:ext uri="{FF2B5EF4-FFF2-40B4-BE49-F238E27FC236}">
-                <a16:creationId xmlns:a16="http://schemas.microsoft.com/office/drawing/2014/main" id="{A912E48E-2B5B-4CCE-828E-746A704D0D9F}"/>
+                <a16:creationId xmlns:a16="http://schemas.microsoft.com/office/drawing/2014/main" id="{72777551-48D1-4E3C-957A-EEE5C6EB10CD}"/>
               </a:ext>
             </a:extLst>
           </p:cNvPr>
@@ -21188,10 +19924,10 @@
       </p:sp>
       <p:sp>
         <p:nvSpPr>
-          <p:cNvPr id="27" name="text-91">
+          <p:cNvPr id="27" name="text-83">
             <a:extLst xmlns:a="http://schemas.openxmlformats.org/drawingml/2006/main">
               <a:ext uri="{FF2B5EF4-FFF2-40B4-BE49-F238E27FC236}">
-                <a16:creationId xmlns:a16="http://schemas.microsoft.com/office/drawing/2014/main" id="{94A22376-FE61-4FE3-B195-0D6EE0C18E54}"/>
+                <a16:creationId xmlns:a16="http://schemas.microsoft.com/office/drawing/2014/main" id="{9963FAD8-CF50-40E2-B92F-60C3D53DAE05}"/>
               </a:ext>
             </a:extLst>
           </p:cNvPr>
@@ -21346,10 +20082,10 @@
       </p:sp>
       <p:sp>
         <p:nvSpPr>
-          <p:cNvPr id="28" name="text-92">
+          <p:cNvPr id="28" name="text-84">
             <a:extLst xmlns:a="http://schemas.openxmlformats.org/drawingml/2006/main">
               <a:ext uri="{FF2B5EF4-FFF2-40B4-BE49-F238E27FC236}">
-                <a16:creationId xmlns:a16="http://schemas.microsoft.com/office/drawing/2014/main" id="{E6A5AD8A-0D05-4C20-91AA-4586EDE4126A}"/>
+                <a16:creationId xmlns:a16="http://schemas.microsoft.com/office/drawing/2014/main" id="{D5C94C3E-AA1E-4A20-8B10-A34C8051638D}"/>
               </a:ext>
             </a:extLst>
           </p:cNvPr>
@@ -21504,10 +20240,10 @@
       </p:sp>
       <p:sp>
         <p:nvSpPr>
-          <p:cNvPr id="29" name="text-93">
+          <p:cNvPr id="29" name="text-85">
             <a:extLst xmlns:a="http://schemas.openxmlformats.org/drawingml/2006/main">
               <a:ext uri="{FF2B5EF4-FFF2-40B4-BE49-F238E27FC236}">
-                <a16:creationId xmlns:a16="http://schemas.microsoft.com/office/drawing/2014/main" id="{45A1BC3C-6608-4431-8602-D0207DCFAC3B}"/>
+                <a16:creationId xmlns:a16="http://schemas.microsoft.com/office/drawing/2014/main" id="{CFB52640-7587-4404-87E4-F57CF13B8E74}"/>
               </a:ext>
             </a:extLst>
           </p:cNvPr>
@@ -21662,10 +20398,10 @@
       </p:sp>
       <p:sp>
         <p:nvSpPr>
-          <p:cNvPr id="30" name="text-94">
+          <p:cNvPr id="30" name="text-86">
             <a:extLst xmlns:a="http://schemas.openxmlformats.org/drawingml/2006/main">
               <a:ext uri="{FF2B5EF4-FFF2-40B4-BE49-F238E27FC236}">
-                <a16:creationId xmlns:a16="http://schemas.microsoft.com/office/drawing/2014/main" id="{1F9A6F4E-1621-4EA4-B8E2-72E366900EBD}"/>
+                <a16:creationId xmlns:a16="http://schemas.microsoft.com/office/drawing/2014/main" id="{4DD1149C-D9C6-493F-883D-D61D3D8658BE}"/>
               </a:ext>
             </a:extLst>
           </p:cNvPr>
@@ -21821,7 +20557,7 @@
     </p:spTree>
     <p:extLst>
       <p:ext uri="{BB962C8B-B14F-4D97-AF65-F5344CB8AC3E}">
-        <p14:creationId xmlns:p14="http://schemas.microsoft.com/office/powerpoint/2010/main" val="1746944568"/>
+        <p14:creationId xmlns:p14="http://schemas.microsoft.com/office/powerpoint/2010/main" val="907203011"/>
       </p:ext>
     </p:extLst>
   </p:cSld>
@@ -21849,10 +20585,10 @@
       </p:grpSpPr>
       <p:sp>
         <p:nvSpPr>
-          <p:cNvPr id="17" name="text-95">
+          <p:cNvPr id="17" name="text-87">
             <a:extLst xmlns:a="http://schemas.openxmlformats.org/drawingml/2006/main">
               <a:ext uri="{FF2B5EF4-FFF2-40B4-BE49-F238E27FC236}">
-                <a16:creationId xmlns:a16="http://schemas.microsoft.com/office/drawing/2014/main" id="{A0FC9335-11CA-488D-9C6C-E207E79A4E37}"/>
+                <a16:creationId xmlns:a16="http://schemas.microsoft.com/office/drawing/2014/main" id="{6E9358E4-714E-4290-8BA1-C4AB51FE490D}"/>
               </a:ext>
             </a:extLst>
           </p:cNvPr>
@@ -22007,10 +20743,10 @@
       </p:sp>
       <p:sp>
         <p:nvSpPr>
-          <p:cNvPr id="2" name="text-96">
+          <p:cNvPr id="2" name="text-88">
             <a:extLst xmlns:a="http://schemas.openxmlformats.org/drawingml/2006/main">
               <a:ext uri="{FF2B5EF4-FFF2-40B4-BE49-F238E27FC236}">
-                <a16:creationId xmlns:a16="http://schemas.microsoft.com/office/drawing/2014/main" id="{12B08F25-D1D3-4080-A1E1-6B75098DB02F}"/>
+                <a16:creationId xmlns:a16="http://schemas.microsoft.com/office/drawing/2014/main" id="{52688828-32B0-4F83-B393-0FB8668E959C}"/>
               </a:ext>
             </a:extLst>
           </p:cNvPr>
@@ -22165,10 +20901,10 @@
       </p:sp>
       <p:sp>
         <p:nvSpPr>
-          <p:cNvPr id="3" name="text-97">
+          <p:cNvPr id="3" name="text-89">
             <a:extLst xmlns:a="http://schemas.openxmlformats.org/drawingml/2006/main">
               <a:ext uri="{FF2B5EF4-FFF2-40B4-BE49-F238E27FC236}">
-                <a16:creationId xmlns:a16="http://schemas.microsoft.com/office/drawing/2014/main" id="{1F13D23E-7C79-4341-8C77-73EA895E02BC}"/>
+                <a16:creationId xmlns:a16="http://schemas.microsoft.com/office/drawing/2014/main" id="{8853F6EB-D350-4DCB-BEFC-B566DFC47C8F}"/>
               </a:ext>
             </a:extLst>
           </p:cNvPr>
@@ -22323,10 +21059,10 @@
       </p:sp>
       <p:sp>
         <p:nvSpPr>
-          <p:cNvPr id="4" name="text-98">
+          <p:cNvPr id="4" name="text-90">
             <a:extLst xmlns:a="http://schemas.openxmlformats.org/drawingml/2006/main">
               <a:ext uri="{FF2B5EF4-FFF2-40B4-BE49-F238E27FC236}">
-                <a16:creationId xmlns:a16="http://schemas.microsoft.com/office/drawing/2014/main" id="{45FC40B0-BA01-4D85-9726-8EC9DED4571F}"/>
+                <a16:creationId xmlns:a16="http://schemas.microsoft.com/office/drawing/2014/main" id="{9E8F6286-D08A-42C1-AA38-B926307B233B}"/>
               </a:ext>
             </a:extLst>
           </p:cNvPr>
@@ -22481,10 +21217,10 @@
       </p:sp>
       <p:sp>
         <p:nvSpPr>
-          <p:cNvPr id="5" name="text-99">
+          <p:cNvPr id="5" name="text-91">
             <a:extLst xmlns:a="http://schemas.openxmlformats.org/drawingml/2006/main">
               <a:ext uri="{FF2B5EF4-FFF2-40B4-BE49-F238E27FC236}">
-                <a16:creationId xmlns:a16="http://schemas.microsoft.com/office/drawing/2014/main" id="{A22B0B53-7B3A-4AC3-AF03-CA094E8E519F}"/>
+                <a16:creationId xmlns:a16="http://schemas.microsoft.com/office/drawing/2014/main" id="{B8A70F43-758D-46CB-99B9-087E8BE2D435}"/>
               </a:ext>
             </a:extLst>
           </p:cNvPr>
@@ -22639,10 +21375,10 @@
       </p:sp>
       <p:sp>
         <p:nvSpPr>
-          <p:cNvPr id="6" name="text-100">
+          <p:cNvPr id="6" name="text-92">
             <a:extLst xmlns:a="http://schemas.openxmlformats.org/drawingml/2006/main">
               <a:ext uri="{FF2B5EF4-FFF2-40B4-BE49-F238E27FC236}">
-                <a16:creationId xmlns:a16="http://schemas.microsoft.com/office/drawing/2014/main" id="{D451FB12-14A9-4E1A-B328-840E3D6CC723}"/>
+                <a16:creationId xmlns:a16="http://schemas.microsoft.com/office/drawing/2014/main" id="{69BBC98F-CE2D-46EC-BBCE-89C49108F6DF}"/>
               </a:ext>
             </a:extLst>
           </p:cNvPr>
@@ -22797,10 +21533,10 @@
       </p:sp>
       <p:sp>
         <p:nvSpPr>
-          <p:cNvPr id="7" name="text-101">
+          <p:cNvPr id="7" name="text-93">
             <a:extLst xmlns:a="http://schemas.openxmlformats.org/drawingml/2006/main">
               <a:ext uri="{FF2B5EF4-FFF2-40B4-BE49-F238E27FC236}">
-                <a16:creationId xmlns:a16="http://schemas.microsoft.com/office/drawing/2014/main" id="{3342D7B2-F482-4A42-8C7D-016F79EA9A11}"/>
+                <a16:creationId xmlns:a16="http://schemas.microsoft.com/office/drawing/2014/main" id="{EF46F190-278A-46B7-ACCF-32F033F77BF4}"/>
               </a:ext>
             </a:extLst>
           </p:cNvPr>
@@ -22955,10 +21691,10 @@
       </p:sp>
       <p:sp>
         <p:nvSpPr>
-          <p:cNvPr id="8" name="text-102">
+          <p:cNvPr id="8" name="text-94">
             <a:extLst xmlns:a="http://schemas.openxmlformats.org/drawingml/2006/main">
               <a:ext uri="{FF2B5EF4-FFF2-40B4-BE49-F238E27FC236}">
-                <a16:creationId xmlns:a16="http://schemas.microsoft.com/office/drawing/2014/main" id="{F383E521-B246-445B-9893-BE5463A1DFB3}"/>
+                <a16:creationId xmlns:a16="http://schemas.microsoft.com/office/drawing/2014/main" id="{78BA0384-F13B-41AC-98D8-A26780FE0BF4}"/>
               </a:ext>
             </a:extLst>
           </p:cNvPr>
@@ -23113,10 +21849,10 @@
       </p:sp>
       <p:sp>
         <p:nvSpPr>
-          <p:cNvPr id="9" name="text-103">
+          <p:cNvPr id="9" name="text-95">
             <a:extLst xmlns:a="http://schemas.openxmlformats.org/drawingml/2006/main">
               <a:ext uri="{FF2B5EF4-FFF2-40B4-BE49-F238E27FC236}">
-                <a16:creationId xmlns:a16="http://schemas.microsoft.com/office/drawing/2014/main" id="{3DA3A1EB-243E-4684-9A71-8AC56D3FC846}"/>
+                <a16:creationId xmlns:a16="http://schemas.microsoft.com/office/drawing/2014/main" id="{A59546FA-74EC-4B5D-811E-4F15472B6EBA}"/>
               </a:ext>
             </a:extLst>
           </p:cNvPr>
@@ -23271,10 +22007,10 @@
       </p:sp>
       <p:sp>
         <p:nvSpPr>
-          <p:cNvPr id="10" name="text-104">
+          <p:cNvPr id="10" name="text-96">
             <a:extLst xmlns:a="http://schemas.openxmlformats.org/drawingml/2006/main">
               <a:ext uri="{FF2B5EF4-FFF2-40B4-BE49-F238E27FC236}">
-                <a16:creationId xmlns:a16="http://schemas.microsoft.com/office/drawing/2014/main" id="{695FF76E-39FE-43ED-8935-1BFB07DC3418}"/>
+                <a16:creationId xmlns:a16="http://schemas.microsoft.com/office/drawing/2014/main" id="{B23C7BC8-1C3F-41D6-A1DB-DF0B25AB2827}"/>
               </a:ext>
             </a:extLst>
           </p:cNvPr>
@@ -23429,10 +22165,10 @@
       </p:sp>
       <p:sp>
         <p:nvSpPr>
-          <p:cNvPr id="11" name="text-105">
+          <p:cNvPr id="11" name="text-97">
             <a:extLst xmlns:a="http://schemas.openxmlformats.org/drawingml/2006/main">
               <a:ext uri="{FF2B5EF4-FFF2-40B4-BE49-F238E27FC236}">
-                <a16:creationId xmlns:a16="http://schemas.microsoft.com/office/drawing/2014/main" id="{6FD53539-7AE2-4DC8-9327-69CC54B3DC59}"/>
+                <a16:creationId xmlns:a16="http://schemas.microsoft.com/office/drawing/2014/main" id="{1455F8AF-149F-4DD6-937C-82CEED8E3CFF}"/>
               </a:ext>
             </a:extLst>
           </p:cNvPr>
@@ -23587,10 +22323,10 @@
       </p:sp>
       <p:sp>
         <p:nvSpPr>
-          <p:cNvPr id="12" name="text-106">
+          <p:cNvPr id="12" name="text-98">
             <a:extLst xmlns:a="http://schemas.openxmlformats.org/drawingml/2006/main">
               <a:ext uri="{FF2B5EF4-FFF2-40B4-BE49-F238E27FC236}">
-                <a16:creationId xmlns:a16="http://schemas.microsoft.com/office/drawing/2014/main" id="{D8F2D2F4-227F-4BCE-A89C-5C08AE45C406}"/>
+                <a16:creationId xmlns:a16="http://schemas.microsoft.com/office/drawing/2014/main" id="{F9748B1D-DCD0-4644-ADC1-5895D4CD6AF3}"/>
               </a:ext>
             </a:extLst>
           </p:cNvPr>
@@ -23745,10 +22481,10 @@
       </p:sp>
       <p:sp>
         <p:nvSpPr>
-          <p:cNvPr id="13" name="text-107">
+          <p:cNvPr id="13" name="text-99">
             <a:extLst xmlns:a="http://schemas.openxmlformats.org/drawingml/2006/main">
               <a:ext uri="{FF2B5EF4-FFF2-40B4-BE49-F238E27FC236}">
-                <a16:creationId xmlns:a16="http://schemas.microsoft.com/office/drawing/2014/main" id="{E141DD22-ED5D-4430-BCA2-C951DC3AC386}"/>
+                <a16:creationId xmlns:a16="http://schemas.microsoft.com/office/drawing/2014/main" id="{DF28F454-EEA0-4D69-B652-185A2AECE4B7}"/>
               </a:ext>
             </a:extLst>
           </p:cNvPr>
@@ -23903,10 +22639,10 @@
       </p:sp>
       <p:sp>
         <p:nvSpPr>
-          <p:cNvPr id="14" name="text-108">
+          <p:cNvPr id="14" name="text-100">
             <a:extLst xmlns:a="http://schemas.openxmlformats.org/drawingml/2006/main">
               <a:ext uri="{FF2B5EF4-FFF2-40B4-BE49-F238E27FC236}">
-                <a16:creationId xmlns:a16="http://schemas.microsoft.com/office/drawing/2014/main" id="{2D6C966E-44F9-4D62-91CD-4314357CC6AD}"/>
+                <a16:creationId xmlns:a16="http://schemas.microsoft.com/office/drawing/2014/main" id="{4D3AEB0A-16E0-42AF-BD85-91376372058A}"/>
               </a:ext>
             </a:extLst>
           </p:cNvPr>
@@ -24061,10 +22797,10 @@
       </p:sp>
       <p:sp>
         <p:nvSpPr>
-          <p:cNvPr id="15" name="text-109">
+          <p:cNvPr id="15" name="text-101">
             <a:extLst xmlns:a="http://schemas.openxmlformats.org/drawingml/2006/main">
               <a:ext uri="{FF2B5EF4-FFF2-40B4-BE49-F238E27FC236}">
-                <a16:creationId xmlns:a16="http://schemas.microsoft.com/office/drawing/2014/main" id="{9A8D85D5-4B3E-467C-815E-78BD7AFE22DA}"/>
+                <a16:creationId xmlns:a16="http://schemas.microsoft.com/office/drawing/2014/main" id="{10B69BDC-41E1-4CD9-BEDE-3F3E3FE82AF2}"/>
               </a:ext>
             </a:extLst>
           </p:cNvPr>
@@ -24219,10 +22955,10 @@
       </p:sp>
       <p:sp>
         <p:nvSpPr>
-          <p:cNvPr id="16" name="text-110">
+          <p:cNvPr id="16" name="text-102">
             <a:extLst xmlns:a="http://schemas.openxmlformats.org/drawingml/2006/main">
               <a:ext uri="{FF2B5EF4-FFF2-40B4-BE49-F238E27FC236}">
-                <a16:creationId xmlns:a16="http://schemas.microsoft.com/office/drawing/2014/main" id="{988E230F-6D88-47BC-BFE9-E24E7CB5BC4D}"/>
+                <a16:creationId xmlns:a16="http://schemas.microsoft.com/office/drawing/2014/main" id="{EE9AC705-ECA1-4CF1-B99E-66DB306CD0C5}"/>
               </a:ext>
             </a:extLst>
           </p:cNvPr>
@@ -24378,7 +23114,7 @@
     </p:spTree>
     <p:extLst>
       <p:ext uri="{BB962C8B-B14F-4D97-AF65-F5344CB8AC3E}">
-        <p14:creationId xmlns:p14="http://schemas.microsoft.com/office/powerpoint/2010/main" val="156723007"/>
+        <p14:creationId xmlns:p14="http://schemas.microsoft.com/office/powerpoint/2010/main" val="345243968"/>
       </p:ext>
     </p:extLst>
   </p:cSld>
@@ -24406,10 +23142,10 @@
       </p:grpSpPr>
       <p:sp>
         <p:nvSpPr>
-          <p:cNvPr id="16" name="text-111">
+          <p:cNvPr id="16" name="text-103">
             <a:extLst xmlns:a="http://schemas.openxmlformats.org/drawingml/2006/main">
               <a:ext uri="{FF2B5EF4-FFF2-40B4-BE49-F238E27FC236}">
-                <a16:creationId xmlns:a16="http://schemas.microsoft.com/office/drawing/2014/main" id="{DC229D87-047C-4F5F-BEC9-FB45D0E787A0}"/>
+                <a16:creationId xmlns:a16="http://schemas.microsoft.com/office/drawing/2014/main" id="{14AFC934-2219-4064-9D11-3FAB19BA026F}"/>
               </a:ext>
             </a:extLst>
           </p:cNvPr>
@@ -24564,10 +23300,10 @@
       </p:sp>
       <p:sp>
         <p:nvSpPr>
-          <p:cNvPr id="2" name="text-112">
+          <p:cNvPr id="2" name="text-104">
             <a:extLst xmlns:a="http://schemas.openxmlformats.org/drawingml/2006/main">
               <a:ext uri="{FF2B5EF4-FFF2-40B4-BE49-F238E27FC236}">
-                <a16:creationId xmlns:a16="http://schemas.microsoft.com/office/drawing/2014/main" id="{AA756DFC-732C-4755-95B5-32EB35CE31B7}"/>
+                <a16:creationId xmlns:a16="http://schemas.microsoft.com/office/drawing/2014/main" id="{8356AA17-A720-4C7D-941F-3E8CCD512827}"/>
               </a:ext>
             </a:extLst>
           </p:cNvPr>
@@ -24722,10 +23458,10 @@
       </p:sp>
       <p:sp>
         <p:nvSpPr>
-          <p:cNvPr id="3" name="text-113">
+          <p:cNvPr id="3" name="text-105">
             <a:extLst xmlns:a="http://schemas.openxmlformats.org/drawingml/2006/main">
               <a:ext uri="{FF2B5EF4-FFF2-40B4-BE49-F238E27FC236}">
-                <a16:creationId xmlns:a16="http://schemas.microsoft.com/office/drawing/2014/main" id="{6C023763-7B68-4B5D-9CAD-E03C99FE3905}"/>
+                <a16:creationId xmlns:a16="http://schemas.microsoft.com/office/drawing/2014/main" id="{7262F578-9499-4716-A7CD-578A51882583}"/>
               </a:ext>
             </a:extLst>
           </p:cNvPr>
@@ -24880,10 +23616,10 @@
       </p:sp>
       <p:sp>
         <p:nvSpPr>
-          <p:cNvPr id="4" name="text-114">
+          <p:cNvPr id="4" name="text-106">
             <a:extLst xmlns:a="http://schemas.openxmlformats.org/drawingml/2006/main">
               <a:ext uri="{FF2B5EF4-FFF2-40B4-BE49-F238E27FC236}">
-                <a16:creationId xmlns:a16="http://schemas.microsoft.com/office/drawing/2014/main" id="{3B44B315-4553-4415-86F2-92CF789A976D}"/>
+                <a16:creationId xmlns:a16="http://schemas.microsoft.com/office/drawing/2014/main" id="{0D933BAC-B084-4A99-B94E-D3670C8B0387}"/>
               </a:ext>
             </a:extLst>
           </p:cNvPr>
@@ -25038,10 +23774,10 @@
       </p:sp>
       <p:sp>
         <p:nvSpPr>
-          <p:cNvPr id="5" name="text-115">
+          <p:cNvPr id="5" name="text-107">
             <a:extLst xmlns:a="http://schemas.openxmlformats.org/drawingml/2006/main">
               <a:ext uri="{FF2B5EF4-FFF2-40B4-BE49-F238E27FC236}">
-                <a16:creationId xmlns:a16="http://schemas.microsoft.com/office/drawing/2014/main" id="{45D9441B-8060-4C02-9E6F-4F6CC003B589}"/>
+                <a16:creationId xmlns:a16="http://schemas.microsoft.com/office/drawing/2014/main" id="{7EECDA4E-BAE6-46C1-88D9-29147DC747F9}"/>
               </a:ext>
             </a:extLst>
           </p:cNvPr>
@@ -25199,7 +23935,7 @@
           <p:cNvPr id="6" name="">
             <a:extLst xmlns:a="http://schemas.openxmlformats.org/drawingml/2006/main">
               <a:ext uri="{FF2B5EF4-FFF2-40B4-BE49-F238E27FC236}">
-                <a16:creationId xmlns:a16="http://schemas.microsoft.com/office/drawing/2014/main" id="{F1F627EB-70F5-4A6D-AB7D-DF4E3B4AE691}"/>
+                <a16:creationId xmlns:a16="http://schemas.microsoft.com/office/drawing/2014/main" id="{0F0B08C2-222E-4113-A76B-08281A91A015}"/>
               </a:ext>
             </a:extLst>
           </p:cNvPr>
@@ -25209,7 +23945,7 @@
           <p:nvPr/>
         </p:nvPicPr>
         <p:blipFill>
-          <a:blip xmlns:r="http://schemas.openxmlformats.org/officeDocument/2006/relationships" xmlns:a="http://schemas.openxmlformats.org/drawingml/2006/main" r:embed="Rd3377e219de04440"/>
+          <a:blip xmlns:r="http://schemas.openxmlformats.org/officeDocument/2006/relationships" xmlns:a="http://schemas.openxmlformats.org/drawingml/2006/main" r:embed="R34806c57809e42fc"/>
           <a:stretch xmlns:a="http://schemas.openxmlformats.org/drawingml/2006/main"/>
         </p:blipFill>
         <p:spPr>
@@ -25227,7 +23963,7 @@
           <p:cNvPr id="7" name="">
             <a:extLst xmlns:a="http://schemas.openxmlformats.org/drawingml/2006/main">
               <a:ext uri="{FF2B5EF4-FFF2-40B4-BE49-F238E27FC236}">
-                <a16:creationId xmlns:a16="http://schemas.microsoft.com/office/drawing/2014/main" id="{CAEA0F89-5F71-4C93-92EA-8E4301BDAF3F}"/>
+                <a16:creationId xmlns:a16="http://schemas.microsoft.com/office/drawing/2014/main" id="{4C9CC1D3-53BE-4736-93FE-2EFAD76D1D10}"/>
               </a:ext>
             </a:extLst>
           </p:cNvPr>
@@ -25237,7 +23973,7 @@
           <p:nvPr/>
         </p:nvPicPr>
         <p:blipFill>
-          <a:blip xmlns:r="http://schemas.openxmlformats.org/officeDocument/2006/relationships" xmlns:a="http://schemas.openxmlformats.org/drawingml/2006/main" r:embed="R525257fe1bb247ef"/>
+          <a:blip xmlns:r="http://schemas.openxmlformats.org/officeDocument/2006/relationships" xmlns:a="http://schemas.openxmlformats.org/drawingml/2006/main" r:embed="R3a6040aae6e045ca"/>
           <a:stretch xmlns:a="http://schemas.openxmlformats.org/drawingml/2006/main"/>
         </p:blipFill>
         <p:spPr>
@@ -25252,10 +23988,10 @@
       </p:pic>
       <p:sp>
         <p:nvSpPr>
-          <p:cNvPr id="8" name="text-116">
+          <p:cNvPr id="8" name="text-108">
             <a:extLst xmlns:a="http://schemas.openxmlformats.org/drawingml/2006/main">
               <a:ext uri="{FF2B5EF4-FFF2-40B4-BE49-F238E27FC236}">
-                <a16:creationId xmlns:a16="http://schemas.microsoft.com/office/drawing/2014/main" id="{897F1C62-DD86-44D4-BB33-BDF87E369437}"/>
+                <a16:creationId xmlns:a16="http://schemas.microsoft.com/office/drawing/2014/main" id="{FEDD5091-D90C-48A3-80C1-D3432AA739BD}"/>
               </a:ext>
             </a:extLst>
           </p:cNvPr>
@@ -25410,10 +24146,10 @@
       </p:sp>
       <p:sp>
         <p:nvSpPr>
-          <p:cNvPr id="9" name="text-117">
+          <p:cNvPr id="9" name="text-109">
             <a:extLst xmlns:a="http://schemas.openxmlformats.org/drawingml/2006/main">
               <a:ext uri="{FF2B5EF4-FFF2-40B4-BE49-F238E27FC236}">
-                <a16:creationId xmlns:a16="http://schemas.microsoft.com/office/drawing/2014/main" id="{6D4EDB00-15E5-4B24-B623-10981D0D4C04}"/>
+                <a16:creationId xmlns:a16="http://schemas.microsoft.com/office/drawing/2014/main" id="{F5836B57-0D27-425A-B5A5-5521160CCD33}"/>
               </a:ext>
             </a:extLst>
           </p:cNvPr>
@@ -25568,10 +24304,10 @@
       </p:sp>
       <p:sp>
         <p:nvSpPr>
-          <p:cNvPr id="10" name="text-118">
+          <p:cNvPr id="10" name="text-110">
             <a:extLst xmlns:a="http://schemas.openxmlformats.org/drawingml/2006/main">
               <a:ext uri="{FF2B5EF4-FFF2-40B4-BE49-F238E27FC236}">
-                <a16:creationId xmlns:a16="http://schemas.microsoft.com/office/drawing/2014/main" id="{FB491E8E-E44C-4B40-B770-0FC690689DCD}"/>
+                <a16:creationId xmlns:a16="http://schemas.microsoft.com/office/drawing/2014/main" id="{1018172C-8AC4-4F23-ABC8-EBE9099E63D3}"/>
               </a:ext>
             </a:extLst>
           </p:cNvPr>
@@ -25726,10 +24462,10 @@
       </p:sp>
       <p:sp>
         <p:nvSpPr>
-          <p:cNvPr id="11" name="text-119">
+          <p:cNvPr id="11" name="text-111">
             <a:extLst xmlns:a="http://schemas.openxmlformats.org/drawingml/2006/main">
               <a:ext uri="{FF2B5EF4-FFF2-40B4-BE49-F238E27FC236}">
-                <a16:creationId xmlns:a16="http://schemas.microsoft.com/office/drawing/2014/main" id="{75066D12-63EC-4001-9BFD-9300FCCECC8F}"/>
+                <a16:creationId xmlns:a16="http://schemas.microsoft.com/office/drawing/2014/main" id="{880EDB2B-9C53-42A4-AF29-DD80E53C871C}"/>
               </a:ext>
             </a:extLst>
           </p:cNvPr>
@@ -25884,10 +24620,10 @@
       </p:sp>
       <p:sp>
         <p:nvSpPr>
-          <p:cNvPr id="12" name="text-120">
+          <p:cNvPr id="12" name="text-112">
             <a:extLst xmlns:a="http://schemas.openxmlformats.org/drawingml/2006/main">
               <a:ext uri="{FF2B5EF4-FFF2-40B4-BE49-F238E27FC236}">
-                <a16:creationId xmlns:a16="http://schemas.microsoft.com/office/drawing/2014/main" id="{5D34C92E-0D19-4A7A-AC7A-226AA168933B}"/>
+                <a16:creationId xmlns:a16="http://schemas.microsoft.com/office/drawing/2014/main" id="{EE36967E-23C3-4C99-A158-660A1D889B09}"/>
               </a:ext>
             </a:extLst>
           </p:cNvPr>
@@ -26042,10 +24778,10 @@
       </p:sp>
       <p:sp>
         <p:nvSpPr>
-          <p:cNvPr id="13" name="text-121">
+          <p:cNvPr id="13" name="text-113">
             <a:extLst xmlns:a="http://schemas.openxmlformats.org/drawingml/2006/main">
               <a:ext uri="{FF2B5EF4-FFF2-40B4-BE49-F238E27FC236}">
-                <a16:creationId xmlns:a16="http://schemas.microsoft.com/office/drawing/2014/main" id="{B28EA89E-C169-4BA2-89DD-B1E458B6D237}"/>
+                <a16:creationId xmlns:a16="http://schemas.microsoft.com/office/drawing/2014/main" id="{FEB2BC51-4CE9-4A3B-82A4-6F82996A894D}"/>
               </a:ext>
             </a:extLst>
           </p:cNvPr>
@@ -26200,10 +24936,10 @@
       </p:sp>
       <p:sp>
         <p:nvSpPr>
-          <p:cNvPr id="14" name="text-122">
+          <p:cNvPr id="14" name="text-114">
             <a:extLst xmlns:a="http://schemas.openxmlformats.org/drawingml/2006/main">
               <a:ext uri="{FF2B5EF4-FFF2-40B4-BE49-F238E27FC236}">
-                <a16:creationId xmlns:a16="http://schemas.microsoft.com/office/drawing/2014/main" id="{60602A11-5A86-4403-AA46-8DC5E310288D}"/>
+                <a16:creationId xmlns:a16="http://schemas.microsoft.com/office/drawing/2014/main" id="{63EA9CBB-D31E-442F-8DE8-53324AFB1BFB}"/>
               </a:ext>
             </a:extLst>
           </p:cNvPr>
@@ -26350,7 +25086,7 @@
                 <a:latin typeface="Arial"/>
                 <a:ea typeface="Arial"/>
                 <a:cs typeface="Arial"/>
-                <a:hlinkClick xmlns:r="http://schemas.openxmlformats.org/officeDocument/2006/relationships" r:id="Rb803a3bf534d4d86"/>
+                <a:hlinkClick xmlns:r="http://schemas.openxmlformats.org/officeDocument/2006/relationships" r:id="R93f50b8ed4e64756"/>
               </a:rPr>
               <a:t>YouTube</a:t>
             </a:r>
@@ -26359,10 +25095,10 @@
       </p:sp>
       <p:sp>
         <p:nvSpPr>
-          <p:cNvPr id="15" name="text-123">
+          <p:cNvPr id="15" name="text-115">
             <a:extLst xmlns:a="http://schemas.openxmlformats.org/drawingml/2006/main">
               <a:ext uri="{FF2B5EF4-FFF2-40B4-BE49-F238E27FC236}">
-                <a16:creationId xmlns:a16="http://schemas.microsoft.com/office/drawing/2014/main" id="{41985280-DD60-4E6D-AED0-92D8BEEAFC51}"/>
+                <a16:creationId xmlns:a16="http://schemas.microsoft.com/office/drawing/2014/main" id="{F04A5E64-7571-4D2F-B081-43C8A1AA2961}"/>
               </a:ext>
             </a:extLst>
           </p:cNvPr>
@@ -26509,7 +25245,7 @@
                 <a:latin typeface="Arial"/>
                 <a:ea typeface="Arial"/>
                 <a:cs typeface="Arial"/>
-                <a:hlinkClick xmlns:r="http://schemas.openxmlformats.org/officeDocument/2006/relationships" r:id="Rcada429be12b4324"/>
+                <a:hlinkClick xmlns:r="http://schemas.openxmlformats.org/officeDocument/2006/relationships" r:id="R9412f077344a4b50"/>
               </a:rPr>
               <a:t>Instagram</a:t>
             </a:r>
@@ -26519,7 +25255,7 @@
     </p:spTree>
     <p:extLst>
       <p:ext uri="{BB962C8B-B14F-4D97-AF65-F5344CB8AC3E}">
-        <p14:creationId xmlns:p14="http://schemas.microsoft.com/office/powerpoint/2010/main" val="1211795026"/>
+        <p14:creationId xmlns:p14="http://schemas.microsoft.com/office/powerpoint/2010/main" val="964973109"/>
       </p:ext>
     </p:extLst>
   </p:cSld>

</xml_diff>

<commit_message>
Simplify Yathra description in artist biography
</commit_message>
<xml_diff>
--- a/GIUMS-MediaKit-EN.pptx
+++ b/GIUMS-MediaKit-EN.pptx
@@ -2,18 +2,18 @@
 <file path=ppt/presentation.xml><?xml version="1.0" encoding="utf-8"?>
 <p:presentation xmlns:p="http://schemas.openxmlformats.org/presentationml/2006/main">
   <p:sldMasterIdLst>
-    <p:sldMasterId xmlns:r="http://schemas.openxmlformats.org/officeDocument/2006/relationships" id="2147483648" r:id="Rbe082baac6f54de4"/>
+    <p:sldMasterId xmlns:r="http://schemas.openxmlformats.org/officeDocument/2006/relationships" id="2147483648" r:id="R21e86f28aafa4006"/>
   </p:sldMasterIdLst>
   <p:notesMasterIdLst>
-    <p:notesMasterId xmlns:r="http://schemas.openxmlformats.org/officeDocument/2006/relationships" r:id="R10f789c1c6db4562"/>
+    <p:notesMasterId xmlns:r="http://schemas.openxmlformats.org/officeDocument/2006/relationships" r:id="Rafae1512767246a1"/>
   </p:notesMasterIdLst>
   <p:sldIdLst>
-    <p:sldId xmlns:r="http://schemas.openxmlformats.org/officeDocument/2006/relationships" id="256" r:id="R218707b0a0b7425c"/>
-    <p:sldId xmlns:r="http://schemas.openxmlformats.org/officeDocument/2006/relationships" id="257" r:id="R211c2ec5aa724caa"/>
-    <p:sldId xmlns:r="http://schemas.openxmlformats.org/officeDocument/2006/relationships" id="258" r:id="R3f33f47ed58b4808"/>
-    <p:sldId xmlns:r="http://schemas.openxmlformats.org/officeDocument/2006/relationships" id="259" r:id="Rac31628f3ddf47b9"/>
-    <p:sldId xmlns:r="http://schemas.openxmlformats.org/officeDocument/2006/relationships" id="260" r:id="Rcc88f33e64354ace"/>
-    <p:sldId xmlns:r="http://schemas.openxmlformats.org/officeDocument/2006/relationships" id="261" r:id="Rfcf5758dff524cc8"/>
+    <p:sldId xmlns:r="http://schemas.openxmlformats.org/officeDocument/2006/relationships" id="256" r:id="R0d9c5643459d4d42"/>
+    <p:sldId xmlns:r="http://schemas.openxmlformats.org/officeDocument/2006/relationships" id="257" r:id="R215b7a00de4a476c"/>
+    <p:sldId xmlns:r="http://schemas.openxmlformats.org/officeDocument/2006/relationships" id="258" r:id="R2922f1ad294d4a0a"/>
+    <p:sldId xmlns:r="http://schemas.openxmlformats.org/officeDocument/2006/relationships" id="259" r:id="Re0c0893152f9401b"/>
+    <p:sldId xmlns:r="http://schemas.openxmlformats.org/officeDocument/2006/relationships" id="260" r:id="R9ae14f341bb6467e"/>
+    <p:sldId xmlns:r="http://schemas.openxmlformats.org/officeDocument/2006/relationships" id="261" r:id="R7843cfae4c9240a3"/>
   </p:sldIdLst>
   <p:sldSz cx="12192000" cy="6858000"/>
   <p:notesSz cx="6858000" cy="9144000"/>
@@ -844,7 +844,7 @@
           <p:cNvPr id="3" name="Title">
             <a:extLst xmlns:a="http://schemas.openxmlformats.org/drawingml/2006/main">
               <a:ext uri="{FF2B5EF4-FFF2-40B4-BE49-F238E27FC236}">
-                <a16:creationId xmlns:a16="http://schemas.microsoft.com/office/drawing/2014/main" id="{6B226EFA-5226-41FD-A515-502DB86A1AC6}"/>
+                <a16:creationId xmlns:a16="http://schemas.microsoft.com/office/drawing/2014/main" id="{24677B12-51B8-4FD6-89D7-3F803B722780}"/>
               </a:ext>
             </a:extLst>
           </p:cNvPr>
@@ -1073,7 +1073,7 @@
           <p:cNvPr id="2" name="Subtitle">
             <a:extLst xmlns:a="http://schemas.openxmlformats.org/drawingml/2006/main">
               <a:ext uri="{FF2B5EF4-FFF2-40B4-BE49-F238E27FC236}">
-                <a16:creationId xmlns:a16="http://schemas.microsoft.com/office/drawing/2014/main" id="{90467842-8371-48CF-8568-0453B5A044DF}"/>
+                <a16:creationId xmlns:a16="http://schemas.microsoft.com/office/drawing/2014/main" id="{FD7F9E2C-39E3-4CD7-921A-B2705C83C8B7}"/>
               </a:ext>
             </a:extLst>
           </p:cNvPr>
@@ -1319,7 +1319,7 @@
           <p:cNvPr id="2" name="Section title">
             <a:extLst xmlns:a="http://schemas.openxmlformats.org/drawingml/2006/main">
               <a:ext uri="{FF2B5EF4-FFF2-40B4-BE49-F238E27FC236}">
-                <a16:creationId xmlns:a16="http://schemas.microsoft.com/office/drawing/2014/main" id="{103835AC-7F84-4C7A-8E18-B0C8BDC209F9}"/>
+                <a16:creationId xmlns:a16="http://schemas.microsoft.com/office/drawing/2014/main" id="{FB0748AD-3C4D-4E59-A668-32FE1E71248A}"/>
               </a:ext>
             </a:extLst>
           </p:cNvPr>
@@ -1565,7 +1565,7 @@
           <p:cNvPr id="3" name="Title">
             <a:extLst xmlns:a="http://schemas.openxmlformats.org/drawingml/2006/main">
               <a:ext uri="{FF2B5EF4-FFF2-40B4-BE49-F238E27FC236}">
-                <a16:creationId xmlns:a16="http://schemas.microsoft.com/office/drawing/2014/main" id="{4EC5FFF3-2720-40A2-80F6-4D032ACCC421}"/>
+                <a16:creationId xmlns:a16="http://schemas.microsoft.com/office/drawing/2014/main" id="{CE61C182-1116-4934-80D3-DB238BFB3978}"/>
               </a:ext>
             </a:extLst>
           </p:cNvPr>
@@ -1794,7 +1794,7 @@
           <p:cNvPr id="2" name="Body">
             <a:extLst xmlns:a="http://schemas.openxmlformats.org/drawingml/2006/main">
               <a:ext uri="{FF2B5EF4-FFF2-40B4-BE49-F238E27FC236}">
-                <a16:creationId xmlns:a16="http://schemas.microsoft.com/office/drawing/2014/main" id="{FA02251B-44D8-4BAE-A65E-3A5BA936B944}"/>
+                <a16:creationId xmlns:a16="http://schemas.microsoft.com/office/drawing/2014/main" id="{22895959-472A-46D3-A52C-C107953A2A11}"/>
               </a:ext>
             </a:extLst>
           </p:cNvPr>
@@ -2040,7 +2040,7 @@
           <p:cNvPr id="4" name="Title">
             <a:extLst xmlns:a="http://schemas.openxmlformats.org/drawingml/2006/main">
               <a:ext uri="{FF2B5EF4-FFF2-40B4-BE49-F238E27FC236}">
-                <a16:creationId xmlns:a16="http://schemas.microsoft.com/office/drawing/2014/main" id="{BDA09F45-D6BD-4134-8C47-2375C8B1EBE1}"/>
+                <a16:creationId xmlns:a16="http://schemas.microsoft.com/office/drawing/2014/main" id="{9723493F-A01A-498E-8D5F-DAE8939C9ED6}"/>
               </a:ext>
             </a:extLst>
           </p:cNvPr>
@@ -2269,7 +2269,7 @@
           <p:cNvPr id="2" name="Left column">
             <a:extLst xmlns:a="http://schemas.openxmlformats.org/drawingml/2006/main">
               <a:ext uri="{FF2B5EF4-FFF2-40B4-BE49-F238E27FC236}">
-                <a16:creationId xmlns:a16="http://schemas.microsoft.com/office/drawing/2014/main" id="{01BE6A5C-2037-46B2-85A9-42175CF23037}"/>
+                <a16:creationId xmlns:a16="http://schemas.microsoft.com/office/drawing/2014/main" id="{81958C54-4CA1-4568-BCF9-7BFF9477437E}"/>
               </a:ext>
             </a:extLst>
           </p:cNvPr>
@@ -2498,7 +2498,7 @@
           <p:cNvPr id="3" name="Right column">
             <a:extLst xmlns:a="http://schemas.openxmlformats.org/drawingml/2006/main">
               <a:ext uri="{FF2B5EF4-FFF2-40B4-BE49-F238E27FC236}">
-                <a16:creationId xmlns:a16="http://schemas.microsoft.com/office/drawing/2014/main" id="{018DB94F-088D-4BD4-B47A-5C25EEB9D799}"/>
+                <a16:creationId xmlns:a16="http://schemas.microsoft.com/office/drawing/2014/main" id="{AEFB9CAF-8377-45B5-9CA5-0E115318696B}"/>
               </a:ext>
             </a:extLst>
           </p:cNvPr>
@@ -2744,7 +2744,7 @@
           <p:cNvPr id="3" name="Title">
             <a:extLst xmlns:a="http://schemas.openxmlformats.org/drawingml/2006/main">
               <a:ext uri="{FF2B5EF4-FFF2-40B4-BE49-F238E27FC236}">
-                <a16:creationId xmlns:a16="http://schemas.microsoft.com/office/drawing/2014/main" id="{68298EE8-6660-4FC0-8B74-C86074742EDD}"/>
+                <a16:creationId xmlns:a16="http://schemas.microsoft.com/office/drawing/2014/main" id="{28E0F5D8-F7C7-483E-8090-B870AA69CF83}"/>
               </a:ext>
             </a:extLst>
           </p:cNvPr>
@@ -2973,7 +2973,7 @@
           <p:cNvPr id="2" name="Left column">
             <a:extLst xmlns:a="http://schemas.openxmlformats.org/drawingml/2006/main">
               <a:ext uri="{FF2B5EF4-FFF2-40B4-BE49-F238E27FC236}">
-                <a16:creationId xmlns:a16="http://schemas.microsoft.com/office/drawing/2014/main" id="{766483A5-21AF-4BC9-8C54-6FD420F566E8}"/>
+                <a16:creationId xmlns:a16="http://schemas.microsoft.com/office/drawing/2014/main" id="{0769DCFD-8281-4891-9547-B50DFB853A32}"/>
               </a:ext>
             </a:extLst>
           </p:cNvPr>
@@ -3240,12 +3240,12 @@
   </p:cSld>
   <p:clrMap bg1="lt1" tx1="dk1" bg2="lt2" tx2="dk2" accent1="accent1" accent2="accent2" accent3="accent3" accent4="accent4" accent5="accent5" accent6="accent6" hlink="hlink" folHlink="folHlink"/>
   <p:sldLayoutIdLst>
-    <p:sldLayoutId xmlns:r="http://schemas.openxmlformats.org/officeDocument/2006/relationships" id="2147483649" r:id="Rf7814fee5b1542e2"/>
-    <p:sldLayoutId xmlns:r="http://schemas.openxmlformats.org/officeDocument/2006/relationships" id="2147483650" r:id="R4f7a2d604d44437b"/>
-    <p:sldLayoutId xmlns:r="http://schemas.openxmlformats.org/officeDocument/2006/relationships" id="2147483651" r:id="Rd86e301171a84d20"/>
-    <p:sldLayoutId xmlns:r="http://schemas.openxmlformats.org/officeDocument/2006/relationships" id="2147483652" r:id="Rf569b904badb4a3b"/>
-    <p:sldLayoutId xmlns:r="http://schemas.openxmlformats.org/officeDocument/2006/relationships" id="2147483653" r:id="Rf4175aa9a8f54aff"/>
-    <p:sldLayoutId xmlns:r="http://schemas.openxmlformats.org/officeDocument/2006/relationships" id="2147483654" r:id="R2c15876dd4024cf7"/>
+    <p:sldLayoutId xmlns:r="http://schemas.openxmlformats.org/officeDocument/2006/relationships" id="2147483649" r:id="Rc788c7ca170246d0"/>
+    <p:sldLayoutId xmlns:r="http://schemas.openxmlformats.org/officeDocument/2006/relationships" id="2147483650" r:id="R3048ec9ac90e4a99"/>
+    <p:sldLayoutId xmlns:r="http://schemas.openxmlformats.org/officeDocument/2006/relationships" id="2147483651" r:id="Ra6e693fa6a5e4e9c"/>
+    <p:sldLayoutId xmlns:r="http://schemas.openxmlformats.org/officeDocument/2006/relationships" id="2147483652" r:id="R7b6d9e11ae0d4553"/>
+    <p:sldLayoutId xmlns:r="http://schemas.openxmlformats.org/officeDocument/2006/relationships" id="2147483653" r:id="R281b13af78944233"/>
+    <p:sldLayoutId xmlns:r="http://schemas.openxmlformats.org/officeDocument/2006/relationships" id="2147483654" r:id="Rf78b1bc2db0a48c5"/>
   </p:sldLayoutIdLst>
   <p:txStyles>
     <p:titleStyle>
@@ -3796,7 +3796,7 @@
           <p:cNvPr id="2" name="">
             <a:extLst xmlns:a="http://schemas.openxmlformats.org/drawingml/2006/main">
               <a:ext uri="{FF2B5EF4-FFF2-40B4-BE49-F238E27FC236}">
-                <a16:creationId xmlns:a16="http://schemas.microsoft.com/office/drawing/2014/main" id="{DED10167-6D2B-4FB4-B72E-6F7B07AC0C90}"/>
+                <a16:creationId xmlns:a16="http://schemas.microsoft.com/office/drawing/2014/main" id="{BCA2990A-B84E-495A-A76A-492486E9AC70}"/>
               </a:ext>
             </a:extLst>
           </p:cNvPr>
@@ -3806,7 +3806,7 @@
           <p:nvPr/>
         </p:nvPicPr>
         <p:blipFill>
-          <a:blip xmlns:r="http://schemas.openxmlformats.org/officeDocument/2006/relationships" xmlns:a="http://schemas.openxmlformats.org/drawingml/2006/main" r:embed="Rc5a3814f228545ef"/>
+          <a:blip xmlns:r="http://schemas.openxmlformats.org/officeDocument/2006/relationships" xmlns:a="http://schemas.openxmlformats.org/drawingml/2006/main" r:embed="Rc40fd7722c654629"/>
           <a:stretch xmlns:a="http://schemas.openxmlformats.org/drawingml/2006/main"/>
         </p:blipFill>
         <p:spPr>
@@ -3822,7 +3822,7 @@
     </p:spTree>
     <p:extLst>
       <p:ext uri="{BB962C8B-B14F-4D97-AF65-F5344CB8AC3E}">
-        <p14:creationId xmlns:p14="http://schemas.microsoft.com/office/powerpoint/2010/main" val="93915464"/>
+        <p14:creationId xmlns:p14="http://schemas.microsoft.com/office/powerpoint/2010/main" val="270790382"/>
       </p:ext>
     </p:extLst>
   </p:cSld>
@@ -3853,7 +3853,7 @@
           <p:cNvPr id="2" name="">
             <a:extLst xmlns:a="http://schemas.openxmlformats.org/drawingml/2006/main">
               <a:ext uri="{FF2B5EF4-FFF2-40B4-BE49-F238E27FC236}">
-                <a16:creationId xmlns:a16="http://schemas.microsoft.com/office/drawing/2014/main" id="{2DC0F34E-0909-45B5-8BF3-A8CC9CBB3F25}"/>
+                <a16:creationId xmlns:a16="http://schemas.microsoft.com/office/drawing/2014/main" id="{5821BCBE-9072-4E28-BCBD-E1AE8FB6F24C}"/>
               </a:ext>
             </a:extLst>
           </p:cNvPr>
@@ -3863,7 +3863,7 @@
           <p:nvPr/>
         </p:nvPicPr>
         <p:blipFill>
-          <a:blip xmlns:r="http://schemas.openxmlformats.org/officeDocument/2006/relationships" xmlns:a="http://schemas.openxmlformats.org/drawingml/2006/main" r:embed="R9de11946570a497c"/>
+          <a:blip xmlns:r="http://schemas.openxmlformats.org/officeDocument/2006/relationships" xmlns:a="http://schemas.openxmlformats.org/drawingml/2006/main" r:embed="R11d45cd706dd46eb"/>
           <a:stretch xmlns:a="http://schemas.openxmlformats.org/drawingml/2006/main"/>
         </p:blipFill>
         <p:spPr>
@@ -3879,7 +3879,7 @@
     </p:spTree>
     <p:extLst>
       <p:ext uri="{BB962C8B-B14F-4D97-AF65-F5344CB8AC3E}">
-        <p14:creationId xmlns:p14="http://schemas.microsoft.com/office/powerpoint/2010/main" val="1631072123"/>
+        <p14:creationId xmlns:p14="http://schemas.microsoft.com/office/powerpoint/2010/main" val="728855703"/>
       </p:ext>
     </p:extLst>
   </p:cSld>
@@ -3910,7 +3910,7 @@
           <p:cNvPr id="3" name="">
             <a:extLst xmlns:a="http://schemas.openxmlformats.org/drawingml/2006/main">
               <a:ext uri="{FF2B5EF4-FFF2-40B4-BE49-F238E27FC236}">
-                <a16:creationId xmlns:a16="http://schemas.microsoft.com/office/drawing/2014/main" id="{689D61E4-0538-45FC-AB28-E7F5645D565A}"/>
+                <a16:creationId xmlns:a16="http://schemas.microsoft.com/office/drawing/2014/main" id="{055897E5-7635-46F7-8B22-40113648F3D7}"/>
               </a:ext>
             </a:extLst>
           </p:cNvPr>
@@ -3920,7 +3920,7 @@
           <p:nvPr/>
         </p:nvPicPr>
         <p:blipFill>
-          <a:blip xmlns:r="http://schemas.openxmlformats.org/officeDocument/2006/relationships" xmlns:a="http://schemas.openxmlformats.org/drawingml/2006/main" r:embed="R69966856556442c9"/>
+          <a:blip xmlns:r="http://schemas.openxmlformats.org/officeDocument/2006/relationships" xmlns:a="http://schemas.openxmlformats.org/drawingml/2006/main" r:embed="Rf6bc9573b9884829"/>
           <a:stretch xmlns:a="http://schemas.openxmlformats.org/drawingml/2006/main"/>
         </p:blipFill>
         <p:spPr>
@@ -3938,7 +3938,7 @@
           <p:cNvPr id="2" name="hotspot-1">
             <a:extLst xmlns:a="http://schemas.openxmlformats.org/drawingml/2006/main">
               <a:ext uri="{FF2B5EF4-FFF2-40B4-BE49-F238E27FC236}">
-                <a16:creationId xmlns:a16="http://schemas.microsoft.com/office/drawing/2014/main" id="{73804576-A160-4A89-846C-228EC9E275E9}"/>
+                <a16:creationId xmlns:a16="http://schemas.microsoft.com/office/drawing/2014/main" id="{A30D4E09-05DC-46A1-8AA8-D5E36C3DF405}"/>
               </a:ext>
             </a:extLst>
             <ns0:hlinkClick xmlns:ns0="http://schemas.openxmlformats.org/drawingml/2006/main" xmlns:ns1="http://schemas.openxmlformats.org/officeDocument/2006/relationships" ns1:id="rIdClick1"/>
@@ -3969,7 +3969,7 @@
     </p:spTree>
     <p:extLst>
       <p:ext uri="{BB962C8B-B14F-4D97-AF65-F5344CB8AC3E}">
-        <p14:creationId xmlns:p14="http://schemas.microsoft.com/office/powerpoint/2010/main" val="89011651"/>
+        <p14:creationId xmlns:p14="http://schemas.microsoft.com/office/powerpoint/2010/main" val="2004176023"/>
       </p:ext>
     </p:extLst>
   </p:cSld>
@@ -4000,7 +4000,7 @@
           <p:cNvPr id="4" name="">
             <a:extLst xmlns:a="http://schemas.openxmlformats.org/drawingml/2006/main">
               <a:ext uri="{FF2B5EF4-FFF2-40B4-BE49-F238E27FC236}">
-                <a16:creationId xmlns:a16="http://schemas.microsoft.com/office/drawing/2014/main" id="{6AFDCF25-3EAF-4D12-931D-B4A687446679}"/>
+                <a16:creationId xmlns:a16="http://schemas.microsoft.com/office/drawing/2014/main" id="{59BE0C08-AC3F-4D11-AE13-B99CA32F56DB}"/>
               </a:ext>
             </a:extLst>
           </p:cNvPr>
@@ -4010,7 +4010,7 @@
           <p:nvPr/>
         </p:nvPicPr>
         <p:blipFill>
-          <a:blip xmlns:r="http://schemas.openxmlformats.org/officeDocument/2006/relationships" xmlns:a="http://schemas.openxmlformats.org/drawingml/2006/main" r:embed="R69c0676365614ef6"/>
+          <a:blip xmlns:r="http://schemas.openxmlformats.org/officeDocument/2006/relationships" xmlns:a="http://schemas.openxmlformats.org/drawingml/2006/main" r:embed="R61d0b7dcda6d4ed5"/>
           <a:stretch xmlns:a="http://schemas.openxmlformats.org/drawingml/2006/main"/>
         </p:blipFill>
         <p:spPr>
@@ -4028,7 +4028,7 @@
           <p:cNvPr id="2" name="hotspot-1">
             <a:extLst xmlns:a="http://schemas.openxmlformats.org/drawingml/2006/main">
               <a:ext uri="{FF2B5EF4-FFF2-40B4-BE49-F238E27FC236}">
-                <a16:creationId xmlns:a16="http://schemas.microsoft.com/office/drawing/2014/main" id="{1D9A04AA-B9DB-46C1-8A79-E5241BB09493}"/>
+                <a16:creationId xmlns:a16="http://schemas.microsoft.com/office/drawing/2014/main" id="{0F8CCA3F-FBE1-485F-AF9F-2B0E0515C4DE}"/>
               </a:ext>
             </a:extLst>
             <ns0:hlinkClick xmlns:ns0="http://schemas.openxmlformats.org/drawingml/2006/main" xmlns:ns1="http://schemas.openxmlformats.org/officeDocument/2006/relationships" ns1:id="rIdClick1"/>
@@ -4061,7 +4061,7 @@
           <p:cNvPr id="3" name="hotspot-2">
             <a:extLst xmlns:a="http://schemas.openxmlformats.org/drawingml/2006/main">
               <a:ext uri="{FF2B5EF4-FFF2-40B4-BE49-F238E27FC236}">
-                <a16:creationId xmlns:a16="http://schemas.microsoft.com/office/drawing/2014/main" id="{855E7D1E-E90E-41B3-A16A-C933A4A4D234}"/>
+                <a16:creationId xmlns:a16="http://schemas.microsoft.com/office/drawing/2014/main" id="{F6AEC7DA-9099-424A-A49A-FB06944A914A}"/>
               </a:ext>
             </a:extLst>
             <ns2:hlinkClick xmlns:ns2="http://schemas.openxmlformats.org/drawingml/2006/main" xmlns:ns3="http://schemas.openxmlformats.org/officeDocument/2006/relationships" ns3:id="rIdClick2"/>
@@ -4092,7 +4092,7 @@
     </p:spTree>
     <p:extLst>
       <p:ext uri="{BB962C8B-B14F-4D97-AF65-F5344CB8AC3E}">
-        <p14:creationId xmlns:p14="http://schemas.microsoft.com/office/powerpoint/2010/main" val="1868590869"/>
+        <p14:creationId xmlns:p14="http://schemas.microsoft.com/office/powerpoint/2010/main" val="208266912"/>
       </p:ext>
     </p:extLst>
   </p:cSld>
@@ -4123,7 +4123,7 @@
           <p:cNvPr id="5" name="">
             <a:extLst xmlns:a="http://schemas.openxmlformats.org/drawingml/2006/main">
               <a:ext uri="{FF2B5EF4-FFF2-40B4-BE49-F238E27FC236}">
-                <a16:creationId xmlns:a16="http://schemas.microsoft.com/office/drawing/2014/main" id="{F898A9D3-7F7F-4A8D-9EB5-8140B68CED5A}"/>
+                <a16:creationId xmlns:a16="http://schemas.microsoft.com/office/drawing/2014/main" id="{BC6A7438-F02B-4CCD-8570-1AD84D005E2A}"/>
               </a:ext>
             </a:extLst>
           </p:cNvPr>
@@ -4133,7 +4133,7 @@
           <p:nvPr/>
         </p:nvPicPr>
         <p:blipFill>
-          <a:blip xmlns:r="http://schemas.openxmlformats.org/officeDocument/2006/relationships" xmlns:a="http://schemas.openxmlformats.org/drawingml/2006/main" r:embed="Rd86438fcb1ab43d6"/>
+          <a:blip xmlns:r="http://schemas.openxmlformats.org/officeDocument/2006/relationships" xmlns:a="http://schemas.openxmlformats.org/drawingml/2006/main" r:embed="Rdb75ea499d4343c5"/>
           <a:stretch xmlns:a="http://schemas.openxmlformats.org/drawingml/2006/main"/>
         </p:blipFill>
         <p:spPr>
@@ -4151,7 +4151,7 @@
           <p:cNvPr id="2" name="hotspot-1">
             <a:extLst xmlns:a="http://schemas.openxmlformats.org/drawingml/2006/main">
               <a:ext uri="{FF2B5EF4-FFF2-40B4-BE49-F238E27FC236}">
-                <a16:creationId xmlns:a16="http://schemas.microsoft.com/office/drawing/2014/main" id="{4D56DBC7-5ECC-46A6-8113-73E69542F3C0}"/>
+                <a16:creationId xmlns:a16="http://schemas.microsoft.com/office/drawing/2014/main" id="{D3FEEDBA-5C55-415F-8937-DCC1AA2AAF1C}"/>
               </a:ext>
             </a:extLst>
             <ns0:hlinkClick xmlns:ns0="http://schemas.openxmlformats.org/drawingml/2006/main" xmlns:ns1="http://schemas.openxmlformats.org/officeDocument/2006/relationships" ns1:id="rIdClick1"/>
@@ -4184,7 +4184,7 @@
           <p:cNvPr id="3" name="hotspot-2">
             <a:extLst xmlns:a="http://schemas.openxmlformats.org/drawingml/2006/main">
               <a:ext uri="{FF2B5EF4-FFF2-40B4-BE49-F238E27FC236}">
-                <a16:creationId xmlns:a16="http://schemas.microsoft.com/office/drawing/2014/main" id="{2B695B85-5FBC-40DE-AB2F-ED60C1AF8430}"/>
+                <a16:creationId xmlns:a16="http://schemas.microsoft.com/office/drawing/2014/main" id="{06E9174C-A8A8-4363-BA27-E9BBB6D89121}"/>
               </a:ext>
             </a:extLst>
             <ns2:hlinkClick xmlns:ns2="http://schemas.openxmlformats.org/drawingml/2006/main" xmlns:ns3="http://schemas.openxmlformats.org/officeDocument/2006/relationships" ns3:id="rIdClick2"/>
@@ -4217,7 +4217,7 @@
           <p:cNvPr id="4" name="hotspot-3">
             <a:extLst xmlns:a="http://schemas.openxmlformats.org/drawingml/2006/main">
               <a:ext uri="{FF2B5EF4-FFF2-40B4-BE49-F238E27FC236}">
-                <a16:creationId xmlns:a16="http://schemas.microsoft.com/office/drawing/2014/main" id="{9BC4694F-55E5-427D-BFE1-9A23DAB04321}"/>
+                <a16:creationId xmlns:a16="http://schemas.microsoft.com/office/drawing/2014/main" id="{1085EC14-3214-4B24-9483-61E3F90CB370}"/>
               </a:ext>
             </a:extLst>
             <ns4:hlinkClick xmlns:ns4="http://schemas.openxmlformats.org/drawingml/2006/main" xmlns:ns5="http://schemas.openxmlformats.org/officeDocument/2006/relationships" ns5:id="rIdClick3"/>
@@ -4248,7 +4248,7 @@
     </p:spTree>
     <p:extLst>
       <p:ext uri="{BB962C8B-B14F-4D97-AF65-F5344CB8AC3E}">
-        <p14:creationId xmlns:p14="http://schemas.microsoft.com/office/powerpoint/2010/main" val="1110200911"/>
+        <p14:creationId xmlns:p14="http://schemas.microsoft.com/office/powerpoint/2010/main" val="170261986"/>
       </p:ext>
     </p:extLst>
   </p:cSld>
@@ -4279,7 +4279,7 @@
           <p:cNvPr id="9" name="">
             <a:extLst xmlns:a="http://schemas.openxmlformats.org/drawingml/2006/main">
               <a:ext uri="{FF2B5EF4-FFF2-40B4-BE49-F238E27FC236}">
-                <a16:creationId xmlns:a16="http://schemas.microsoft.com/office/drawing/2014/main" id="{FE506067-E5A6-4399-A429-2D8FEF24D420}"/>
+                <a16:creationId xmlns:a16="http://schemas.microsoft.com/office/drawing/2014/main" id="{C9AC05B9-3D3D-4BF2-930C-E618E7426C8A}"/>
               </a:ext>
             </a:extLst>
           </p:cNvPr>
@@ -4289,7 +4289,7 @@
           <p:nvPr/>
         </p:nvPicPr>
         <p:blipFill>
-          <a:blip xmlns:r="http://schemas.openxmlformats.org/officeDocument/2006/relationships" xmlns:a="http://schemas.openxmlformats.org/drawingml/2006/main" r:embed="R0eda6b64b2c74f57"/>
+          <a:blip xmlns:r="http://schemas.openxmlformats.org/officeDocument/2006/relationships" xmlns:a="http://schemas.openxmlformats.org/drawingml/2006/main" r:embed="Rda996972f26d46b7"/>
           <a:stretch xmlns:a="http://schemas.openxmlformats.org/drawingml/2006/main"/>
         </p:blipFill>
         <p:spPr>
@@ -4307,7 +4307,7 @@
           <p:cNvPr id="2" name="hotspot-1">
             <a:extLst xmlns:a="http://schemas.openxmlformats.org/drawingml/2006/main">
               <a:ext uri="{FF2B5EF4-FFF2-40B4-BE49-F238E27FC236}">
-                <a16:creationId xmlns:a16="http://schemas.microsoft.com/office/drawing/2014/main" id="{76BB5670-C02F-4D48-BF03-03B16572827F}"/>
+                <a16:creationId xmlns:a16="http://schemas.microsoft.com/office/drawing/2014/main" id="{1610FCB6-2409-4B0F-ABF9-7C9836DB369D}"/>
               </a:ext>
             </a:extLst>
             <ns0:hlinkClick xmlns:ns0="http://schemas.openxmlformats.org/drawingml/2006/main" xmlns:ns1="http://schemas.openxmlformats.org/officeDocument/2006/relationships" ns1:id="rIdClick1"/>
@@ -4340,7 +4340,7 @@
           <p:cNvPr id="3" name="hotspot-2">
             <a:extLst xmlns:a="http://schemas.openxmlformats.org/drawingml/2006/main">
               <a:ext uri="{FF2B5EF4-FFF2-40B4-BE49-F238E27FC236}">
-                <a16:creationId xmlns:a16="http://schemas.microsoft.com/office/drawing/2014/main" id="{DE041D0C-9D4C-4931-80BE-F4D706EDCAE4}"/>
+                <a16:creationId xmlns:a16="http://schemas.microsoft.com/office/drawing/2014/main" id="{76DB2D56-1288-4CBB-AB34-2B71AD69C61D}"/>
               </a:ext>
             </a:extLst>
             <ns2:hlinkClick xmlns:ns2="http://schemas.openxmlformats.org/drawingml/2006/main" xmlns:ns3="http://schemas.openxmlformats.org/officeDocument/2006/relationships" ns3:id="rIdClick2"/>
@@ -4373,7 +4373,7 @@
           <p:cNvPr id="4" name="hotspot-3">
             <a:extLst xmlns:a="http://schemas.openxmlformats.org/drawingml/2006/main">
               <a:ext uri="{FF2B5EF4-FFF2-40B4-BE49-F238E27FC236}">
-                <a16:creationId xmlns:a16="http://schemas.microsoft.com/office/drawing/2014/main" id="{B8D7EC59-03CE-4DB8-A7CF-A49F55A8CD6A}"/>
+                <a16:creationId xmlns:a16="http://schemas.microsoft.com/office/drawing/2014/main" id="{ADB8A8F4-A318-4024-9870-DF3AD1D42B8F}"/>
               </a:ext>
             </a:extLst>
             <ns4:hlinkClick xmlns:ns4="http://schemas.openxmlformats.org/drawingml/2006/main" xmlns:ns5="http://schemas.openxmlformats.org/officeDocument/2006/relationships" ns5:id="rIdClick3"/>
@@ -4406,7 +4406,7 @@
           <p:cNvPr id="5" name="hotspot-4">
             <a:extLst xmlns:a="http://schemas.openxmlformats.org/drawingml/2006/main">
               <a:ext uri="{FF2B5EF4-FFF2-40B4-BE49-F238E27FC236}">
-                <a16:creationId xmlns:a16="http://schemas.microsoft.com/office/drawing/2014/main" id="{2A983EA0-258D-49E6-A5C8-1C086274A77F}"/>
+                <a16:creationId xmlns:a16="http://schemas.microsoft.com/office/drawing/2014/main" id="{3BD7D483-0089-45C2-8FA7-AE5B015D3AAB}"/>
               </a:ext>
             </a:extLst>
             <ns6:hlinkClick xmlns:ns6="http://schemas.openxmlformats.org/drawingml/2006/main" xmlns:ns7="http://schemas.openxmlformats.org/officeDocument/2006/relationships" ns7:id="rIdClick4"/>
@@ -4439,7 +4439,7 @@
           <p:cNvPr id="6" name="hotspot-5">
             <a:extLst xmlns:a="http://schemas.openxmlformats.org/drawingml/2006/main">
               <a:ext uri="{FF2B5EF4-FFF2-40B4-BE49-F238E27FC236}">
-                <a16:creationId xmlns:a16="http://schemas.microsoft.com/office/drawing/2014/main" id="{8F361B89-7EDD-4BBF-925B-4FF7F46E0687}"/>
+                <a16:creationId xmlns:a16="http://schemas.microsoft.com/office/drawing/2014/main" id="{575E9BBB-14A2-49F8-ADA3-7DEA8ACB5658}"/>
               </a:ext>
             </a:extLst>
             <ns8:hlinkClick xmlns:ns8="http://schemas.openxmlformats.org/drawingml/2006/main" xmlns:ns9="http://schemas.openxmlformats.org/officeDocument/2006/relationships" ns9:id="rIdClick5"/>
@@ -4472,7 +4472,7 @@
           <p:cNvPr id="7" name="hotspot-6">
             <a:extLst xmlns:a="http://schemas.openxmlformats.org/drawingml/2006/main">
               <a:ext uri="{FF2B5EF4-FFF2-40B4-BE49-F238E27FC236}">
-                <a16:creationId xmlns:a16="http://schemas.microsoft.com/office/drawing/2014/main" id="{F78B5090-B244-45EC-83A9-CEC20A1F55D2}"/>
+                <a16:creationId xmlns:a16="http://schemas.microsoft.com/office/drawing/2014/main" id="{2FEB6E62-B790-4D91-B065-5FA17591927B}"/>
               </a:ext>
             </a:extLst>
             <ns10:hlinkClick xmlns:ns10="http://schemas.openxmlformats.org/drawingml/2006/main" xmlns:ns11="http://schemas.openxmlformats.org/officeDocument/2006/relationships" ns11:id="rIdClick6"/>
@@ -4505,7 +4505,7 @@
           <p:cNvPr id="8" name="hotspot-7">
             <a:extLst xmlns:a="http://schemas.openxmlformats.org/drawingml/2006/main">
               <a:ext uri="{FF2B5EF4-FFF2-40B4-BE49-F238E27FC236}">
-                <a16:creationId xmlns:a16="http://schemas.microsoft.com/office/drawing/2014/main" id="{1BE00513-085B-4776-B52D-D20D0D20CDAA}"/>
+                <a16:creationId xmlns:a16="http://schemas.microsoft.com/office/drawing/2014/main" id="{8A0DFA8B-7259-4CC9-8137-E73C99EC07CB}"/>
               </a:ext>
             </a:extLst>
             <ns12:hlinkClick xmlns:ns12="http://schemas.openxmlformats.org/drawingml/2006/main" xmlns:ns13="http://schemas.openxmlformats.org/officeDocument/2006/relationships" ns13:id="rIdClick7"/>
@@ -4536,7 +4536,7 @@
     </p:spTree>
     <p:extLst>
       <p:ext uri="{BB962C8B-B14F-4D97-AF65-F5344CB8AC3E}">
-        <p14:creationId xmlns:p14="http://schemas.microsoft.com/office/powerpoint/2010/main" val="1807329165"/>
+        <p14:creationId xmlns:p14="http://schemas.microsoft.com/office/powerpoint/2010/main" val="1519158456"/>
       </p:ext>
     </p:extLst>
   </p:cSld>

</xml_diff>

<commit_message>
Remove Patreon tier paragraph from Yathra section
</commit_message>
<xml_diff>
--- a/GIUMS-MediaKit-EN.pptx
+++ b/GIUMS-MediaKit-EN.pptx
@@ -2,18 +2,18 @@
 <file path=ppt/presentation.xml><?xml version="1.0" encoding="utf-8"?>
 <p:presentation xmlns:p="http://schemas.openxmlformats.org/presentationml/2006/main">
   <p:sldMasterIdLst>
-    <p:sldMasterId xmlns:r="http://schemas.openxmlformats.org/officeDocument/2006/relationships" id="2147483648" r:id="R21e86f28aafa4006"/>
+    <p:sldMasterId xmlns:r="http://schemas.openxmlformats.org/officeDocument/2006/relationships" id="2147483648" r:id="R2569ce781bdf4bec"/>
   </p:sldMasterIdLst>
   <p:notesMasterIdLst>
-    <p:notesMasterId xmlns:r="http://schemas.openxmlformats.org/officeDocument/2006/relationships" r:id="Rafae1512767246a1"/>
+    <p:notesMasterId xmlns:r="http://schemas.openxmlformats.org/officeDocument/2006/relationships" r:id="R0e994b4aa7244ddf"/>
   </p:notesMasterIdLst>
   <p:sldIdLst>
-    <p:sldId xmlns:r="http://schemas.openxmlformats.org/officeDocument/2006/relationships" id="256" r:id="R0d9c5643459d4d42"/>
-    <p:sldId xmlns:r="http://schemas.openxmlformats.org/officeDocument/2006/relationships" id="257" r:id="R215b7a00de4a476c"/>
-    <p:sldId xmlns:r="http://schemas.openxmlformats.org/officeDocument/2006/relationships" id="258" r:id="R2922f1ad294d4a0a"/>
-    <p:sldId xmlns:r="http://schemas.openxmlformats.org/officeDocument/2006/relationships" id="259" r:id="Re0c0893152f9401b"/>
-    <p:sldId xmlns:r="http://schemas.openxmlformats.org/officeDocument/2006/relationships" id="260" r:id="R9ae14f341bb6467e"/>
-    <p:sldId xmlns:r="http://schemas.openxmlformats.org/officeDocument/2006/relationships" id="261" r:id="R7843cfae4c9240a3"/>
+    <p:sldId xmlns:r="http://schemas.openxmlformats.org/officeDocument/2006/relationships" id="256" r:id="R23c7084c89c240e7"/>
+    <p:sldId xmlns:r="http://schemas.openxmlformats.org/officeDocument/2006/relationships" id="257" r:id="R76f0bdc20a604953"/>
+    <p:sldId xmlns:r="http://schemas.openxmlformats.org/officeDocument/2006/relationships" id="258" r:id="R768abdf2d8b24738"/>
+    <p:sldId xmlns:r="http://schemas.openxmlformats.org/officeDocument/2006/relationships" id="259" r:id="R0d62a19c3b374fc8"/>
+    <p:sldId xmlns:r="http://schemas.openxmlformats.org/officeDocument/2006/relationships" id="260" r:id="Rcb9b09683969490a"/>
+    <p:sldId xmlns:r="http://schemas.openxmlformats.org/officeDocument/2006/relationships" id="261" r:id="R862c71c2fa804793"/>
   </p:sldIdLst>
   <p:sldSz cx="12192000" cy="6858000"/>
   <p:notesSz cx="6858000" cy="9144000"/>
@@ -844,7 +844,7 @@
           <p:cNvPr id="3" name="Title">
             <a:extLst xmlns:a="http://schemas.openxmlformats.org/drawingml/2006/main">
               <a:ext uri="{FF2B5EF4-FFF2-40B4-BE49-F238E27FC236}">
-                <a16:creationId xmlns:a16="http://schemas.microsoft.com/office/drawing/2014/main" id="{24677B12-51B8-4FD6-89D7-3F803B722780}"/>
+                <a16:creationId xmlns:a16="http://schemas.microsoft.com/office/drawing/2014/main" id="{C5EF70A2-1718-4194-A97A-F1B94BD90224}"/>
               </a:ext>
             </a:extLst>
           </p:cNvPr>
@@ -1073,7 +1073,7 @@
           <p:cNvPr id="2" name="Subtitle">
             <a:extLst xmlns:a="http://schemas.openxmlformats.org/drawingml/2006/main">
               <a:ext uri="{FF2B5EF4-FFF2-40B4-BE49-F238E27FC236}">
-                <a16:creationId xmlns:a16="http://schemas.microsoft.com/office/drawing/2014/main" id="{FD7F9E2C-39E3-4CD7-921A-B2705C83C8B7}"/>
+                <a16:creationId xmlns:a16="http://schemas.microsoft.com/office/drawing/2014/main" id="{DE4D054B-0F45-442B-B540-9CFDCFBCDF9F}"/>
               </a:ext>
             </a:extLst>
           </p:cNvPr>
@@ -1319,7 +1319,7 @@
           <p:cNvPr id="2" name="Section title">
             <a:extLst xmlns:a="http://schemas.openxmlformats.org/drawingml/2006/main">
               <a:ext uri="{FF2B5EF4-FFF2-40B4-BE49-F238E27FC236}">
-                <a16:creationId xmlns:a16="http://schemas.microsoft.com/office/drawing/2014/main" id="{FB0748AD-3C4D-4E59-A668-32FE1E71248A}"/>
+                <a16:creationId xmlns:a16="http://schemas.microsoft.com/office/drawing/2014/main" id="{53EAE7E6-C514-4E17-8588-49988AB180EB}"/>
               </a:ext>
             </a:extLst>
           </p:cNvPr>
@@ -1565,7 +1565,7 @@
           <p:cNvPr id="3" name="Title">
             <a:extLst xmlns:a="http://schemas.openxmlformats.org/drawingml/2006/main">
               <a:ext uri="{FF2B5EF4-FFF2-40B4-BE49-F238E27FC236}">
-                <a16:creationId xmlns:a16="http://schemas.microsoft.com/office/drawing/2014/main" id="{CE61C182-1116-4934-80D3-DB238BFB3978}"/>
+                <a16:creationId xmlns:a16="http://schemas.microsoft.com/office/drawing/2014/main" id="{DA018134-F55E-4E7D-8B33-4CBFE1498DC7}"/>
               </a:ext>
             </a:extLst>
           </p:cNvPr>
@@ -1794,7 +1794,7 @@
           <p:cNvPr id="2" name="Body">
             <a:extLst xmlns:a="http://schemas.openxmlformats.org/drawingml/2006/main">
               <a:ext uri="{FF2B5EF4-FFF2-40B4-BE49-F238E27FC236}">
-                <a16:creationId xmlns:a16="http://schemas.microsoft.com/office/drawing/2014/main" id="{22895959-472A-46D3-A52C-C107953A2A11}"/>
+                <a16:creationId xmlns:a16="http://schemas.microsoft.com/office/drawing/2014/main" id="{23A42C52-FCA9-4300-8464-61336C59CF02}"/>
               </a:ext>
             </a:extLst>
           </p:cNvPr>
@@ -2040,7 +2040,7 @@
           <p:cNvPr id="4" name="Title">
             <a:extLst xmlns:a="http://schemas.openxmlformats.org/drawingml/2006/main">
               <a:ext uri="{FF2B5EF4-FFF2-40B4-BE49-F238E27FC236}">
-                <a16:creationId xmlns:a16="http://schemas.microsoft.com/office/drawing/2014/main" id="{9723493F-A01A-498E-8D5F-DAE8939C9ED6}"/>
+                <a16:creationId xmlns:a16="http://schemas.microsoft.com/office/drawing/2014/main" id="{51974517-1C96-4B1E-8BEB-1DA4C52CF820}"/>
               </a:ext>
             </a:extLst>
           </p:cNvPr>
@@ -2269,7 +2269,7 @@
           <p:cNvPr id="2" name="Left column">
             <a:extLst xmlns:a="http://schemas.openxmlformats.org/drawingml/2006/main">
               <a:ext uri="{FF2B5EF4-FFF2-40B4-BE49-F238E27FC236}">
-                <a16:creationId xmlns:a16="http://schemas.microsoft.com/office/drawing/2014/main" id="{81958C54-4CA1-4568-BCF9-7BFF9477437E}"/>
+                <a16:creationId xmlns:a16="http://schemas.microsoft.com/office/drawing/2014/main" id="{6A5E3C96-1345-4D81-831B-8AEC4C62876C}"/>
               </a:ext>
             </a:extLst>
           </p:cNvPr>
@@ -2498,7 +2498,7 @@
           <p:cNvPr id="3" name="Right column">
             <a:extLst xmlns:a="http://schemas.openxmlformats.org/drawingml/2006/main">
               <a:ext uri="{FF2B5EF4-FFF2-40B4-BE49-F238E27FC236}">
-                <a16:creationId xmlns:a16="http://schemas.microsoft.com/office/drawing/2014/main" id="{AEFB9CAF-8377-45B5-9CA5-0E115318696B}"/>
+                <a16:creationId xmlns:a16="http://schemas.microsoft.com/office/drawing/2014/main" id="{F1486D6E-B5B2-46A0-B3A6-9FE184B43EA6}"/>
               </a:ext>
             </a:extLst>
           </p:cNvPr>
@@ -2744,7 +2744,7 @@
           <p:cNvPr id="3" name="Title">
             <a:extLst xmlns:a="http://schemas.openxmlformats.org/drawingml/2006/main">
               <a:ext uri="{FF2B5EF4-FFF2-40B4-BE49-F238E27FC236}">
-                <a16:creationId xmlns:a16="http://schemas.microsoft.com/office/drawing/2014/main" id="{28E0F5D8-F7C7-483E-8090-B870AA69CF83}"/>
+                <a16:creationId xmlns:a16="http://schemas.microsoft.com/office/drawing/2014/main" id="{9ADC984C-057B-456F-BF1D-F8F6DDAAB650}"/>
               </a:ext>
             </a:extLst>
           </p:cNvPr>
@@ -2973,7 +2973,7 @@
           <p:cNvPr id="2" name="Left column">
             <a:extLst xmlns:a="http://schemas.openxmlformats.org/drawingml/2006/main">
               <a:ext uri="{FF2B5EF4-FFF2-40B4-BE49-F238E27FC236}">
-                <a16:creationId xmlns:a16="http://schemas.microsoft.com/office/drawing/2014/main" id="{0769DCFD-8281-4891-9547-B50DFB853A32}"/>
+                <a16:creationId xmlns:a16="http://schemas.microsoft.com/office/drawing/2014/main" id="{23465F4F-5DB4-4820-867B-78302FC6E53D}"/>
               </a:ext>
             </a:extLst>
           </p:cNvPr>
@@ -3240,12 +3240,12 @@
   </p:cSld>
   <p:clrMap bg1="lt1" tx1="dk1" bg2="lt2" tx2="dk2" accent1="accent1" accent2="accent2" accent3="accent3" accent4="accent4" accent5="accent5" accent6="accent6" hlink="hlink" folHlink="folHlink"/>
   <p:sldLayoutIdLst>
-    <p:sldLayoutId xmlns:r="http://schemas.openxmlformats.org/officeDocument/2006/relationships" id="2147483649" r:id="Rc788c7ca170246d0"/>
-    <p:sldLayoutId xmlns:r="http://schemas.openxmlformats.org/officeDocument/2006/relationships" id="2147483650" r:id="R3048ec9ac90e4a99"/>
-    <p:sldLayoutId xmlns:r="http://schemas.openxmlformats.org/officeDocument/2006/relationships" id="2147483651" r:id="Ra6e693fa6a5e4e9c"/>
-    <p:sldLayoutId xmlns:r="http://schemas.openxmlformats.org/officeDocument/2006/relationships" id="2147483652" r:id="R7b6d9e11ae0d4553"/>
-    <p:sldLayoutId xmlns:r="http://schemas.openxmlformats.org/officeDocument/2006/relationships" id="2147483653" r:id="R281b13af78944233"/>
-    <p:sldLayoutId xmlns:r="http://schemas.openxmlformats.org/officeDocument/2006/relationships" id="2147483654" r:id="Rf78b1bc2db0a48c5"/>
+    <p:sldLayoutId xmlns:r="http://schemas.openxmlformats.org/officeDocument/2006/relationships" id="2147483649" r:id="Re2406b7ee4d44433"/>
+    <p:sldLayoutId xmlns:r="http://schemas.openxmlformats.org/officeDocument/2006/relationships" id="2147483650" r:id="Rde2903971b054f84"/>
+    <p:sldLayoutId xmlns:r="http://schemas.openxmlformats.org/officeDocument/2006/relationships" id="2147483651" r:id="R125cba3084c54a7a"/>
+    <p:sldLayoutId xmlns:r="http://schemas.openxmlformats.org/officeDocument/2006/relationships" id="2147483652" r:id="R2b37679f462a41eb"/>
+    <p:sldLayoutId xmlns:r="http://schemas.openxmlformats.org/officeDocument/2006/relationships" id="2147483653" r:id="Rb96554afbdbd4566"/>
+    <p:sldLayoutId xmlns:r="http://schemas.openxmlformats.org/officeDocument/2006/relationships" id="2147483654" r:id="Rb96948c6f0ca40cb"/>
   </p:sldLayoutIdLst>
   <p:txStyles>
     <p:titleStyle>
@@ -3796,7 +3796,7 @@
           <p:cNvPr id="2" name="">
             <a:extLst xmlns:a="http://schemas.openxmlformats.org/drawingml/2006/main">
               <a:ext uri="{FF2B5EF4-FFF2-40B4-BE49-F238E27FC236}">
-                <a16:creationId xmlns:a16="http://schemas.microsoft.com/office/drawing/2014/main" id="{BCA2990A-B84E-495A-A76A-492486E9AC70}"/>
+                <a16:creationId xmlns:a16="http://schemas.microsoft.com/office/drawing/2014/main" id="{8686BF91-CF5B-459B-9C7D-F489E238BA95}"/>
               </a:ext>
             </a:extLst>
           </p:cNvPr>
@@ -3806,7 +3806,7 @@
           <p:nvPr/>
         </p:nvPicPr>
         <p:blipFill>
-          <a:blip xmlns:r="http://schemas.openxmlformats.org/officeDocument/2006/relationships" xmlns:a="http://schemas.openxmlformats.org/drawingml/2006/main" r:embed="Rc40fd7722c654629"/>
+          <a:blip xmlns:r="http://schemas.openxmlformats.org/officeDocument/2006/relationships" xmlns:a="http://schemas.openxmlformats.org/drawingml/2006/main" r:embed="Re50c5fd35d2d4655"/>
           <a:stretch xmlns:a="http://schemas.openxmlformats.org/drawingml/2006/main"/>
         </p:blipFill>
         <p:spPr>
@@ -3822,7 +3822,7 @@
     </p:spTree>
     <p:extLst>
       <p:ext uri="{BB962C8B-B14F-4D97-AF65-F5344CB8AC3E}">
-        <p14:creationId xmlns:p14="http://schemas.microsoft.com/office/powerpoint/2010/main" val="270790382"/>
+        <p14:creationId xmlns:p14="http://schemas.microsoft.com/office/powerpoint/2010/main" val="914410755"/>
       </p:ext>
     </p:extLst>
   </p:cSld>
@@ -3853,7 +3853,7 @@
           <p:cNvPr id="2" name="">
             <a:extLst xmlns:a="http://schemas.openxmlformats.org/drawingml/2006/main">
               <a:ext uri="{FF2B5EF4-FFF2-40B4-BE49-F238E27FC236}">
-                <a16:creationId xmlns:a16="http://schemas.microsoft.com/office/drawing/2014/main" id="{5821BCBE-9072-4E28-BCBD-E1AE8FB6F24C}"/>
+                <a16:creationId xmlns:a16="http://schemas.microsoft.com/office/drawing/2014/main" id="{531D56C8-1FF6-4B86-980E-4AF3A9FDFC70}"/>
               </a:ext>
             </a:extLst>
           </p:cNvPr>
@@ -3863,7 +3863,7 @@
           <p:nvPr/>
         </p:nvPicPr>
         <p:blipFill>
-          <a:blip xmlns:r="http://schemas.openxmlformats.org/officeDocument/2006/relationships" xmlns:a="http://schemas.openxmlformats.org/drawingml/2006/main" r:embed="R11d45cd706dd46eb"/>
+          <a:blip xmlns:r="http://schemas.openxmlformats.org/officeDocument/2006/relationships" xmlns:a="http://schemas.openxmlformats.org/drawingml/2006/main" r:embed="R62002e0cbc944026"/>
           <a:stretch xmlns:a="http://schemas.openxmlformats.org/drawingml/2006/main"/>
         </p:blipFill>
         <p:spPr>
@@ -3879,7 +3879,7 @@
     </p:spTree>
     <p:extLst>
       <p:ext uri="{BB962C8B-B14F-4D97-AF65-F5344CB8AC3E}">
-        <p14:creationId xmlns:p14="http://schemas.microsoft.com/office/powerpoint/2010/main" val="728855703"/>
+        <p14:creationId xmlns:p14="http://schemas.microsoft.com/office/powerpoint/2010/main" val="1004746364"/>
       </p:ext>
     </p:extLst>
   </p:cSld>
@@ -3910,7 +3910,7 @@
           <p:cNvPr id="3" name="">
             <a:extLst xmlns:a="http://schemas.openxmlformats.org/drawingml/2006/main">
               <a:ext uri="{FF2B5EF4-FFF2-40B4-BE49-F238E27FC236}">
-                <a16:creationId xmlns:a16="http://schemas.microsoft.com/office/drawing/2014/main" id="{055897E5-7635-46F7-8B22-40113648F3D7}"/>
+                <a16:creationId xmlns:a16="http://schemas.microsoft.com/office/drawing/2014/main" id="{E38F6F42-27FE-45EA-B3AB-EE4C67FF4ED4}"/>
               </a:ext>
             </a:extLst>
           </p:cNvPr>
@@ -3920,7 +3920,7 @@
           <p:nvPr/>
         </p:nvPicPr>
         <p:blipFill>
-          <a:blip xmlns:r="http://schemas.openxmlformats.org/officeDocument/2006/relationships" xmlns:a="http://schemas.openxmlformats.org/drawingml/2006/main" r:embed="Rf6bc9573b9884829"/>
+          <a:blip xmlns:r="http://schemas.openxmlformats.org/officeDocument/2006/relationships" xmlns:a="http://schemas.openxmlformats.org/drawingml/2006/main" r:embed="R4a26cf5aefe04832"/>
           <a:stretch xmlns:a="http://schemas.openxmlformats.org/drawingml/2006/main"/>
         </p:blipFill>
         <p:spPr>
@@ -3938,7 +3938,7 @@
           <p:cNvPr id="2" name="hotspot-1">
             <a:extLst xmlns:a="http://schemas.openxmlformats.org/drawingml/2006/main">
               <a:ext uri="{FF2B5EF4-FFF2-40B4-BE49-F238E27FC236}">
-                <a16:creationId xmlns:a16="http://schemas.microsoft.com/office/drawing/2014/main" id="{A30D4E09-05DC-46A1-8AA8-D5E36C3DF405}"/>
+                <a16:creationId xmlns:a16="http://schemas.microsoft.com/office/drawing/2014/main" id="{7C704100-7E8B-4FB3-BFC9-0FCEE5715254}"/>
               </a:ext>
             </a:extLst>
             <ns0:hlinkClick xmlns:ns0="http://schemas.openxmlformats.org/drawingml/2006/main" xmlns:ns1="http://schemas.openxmlformats.org/officeDocument/2006/relationships" ns1:id="rIdClick1"/>
@@ -3950,7 +3950,7 @@
         </p:nvSpPr>
         <p:spPr>
           <a:xfrm xmlns:a="http://schemas.openxmlformats.org/drawingml/2006/main">
-            <a:off x="737250" y="5902650"/>
+            <a:off x="737250" y="5233050"/>
             <a:ext cx="1894950" cy="144000"/>
           </a:xfrm>
           <a:prstGeom xmlns:a="http://schemas.openxmlformats.org/drawingml/2006/main" prst="rect">
@@ -3969,7 +3969,7 @@
     </p:spTree>
     <p:extLst>
       <p:ext uri="{BB962C8B-B14F-4D97-AF65-F5344CB8AC3E}">
-        <p14:creationId xmlns:p14="http://schemas.microsoft.com/office/powerpoint/2010/main" val="2004176023"/>
+        <p14:creationId xmlns:p14="http://schemas.microsoft.com/office/powerpoint/2010/main" val="374918454"/>
       </p:ext>
     </p:extLst>
   </p:cSld>
@@ -4000,7 +4000,7 @@
           <p:cNvPr id="4" name="">
             <a:extLst xmlns:a="http://schemas.openxmlformats.org/drawingml/2006/main">
               <a:ext uri="{FF2B5EF4-FFF2-40B4-BE49-F238E27FC236}">
-                <a16:creationId xmlns:a16="http://schemas.microsoft.com/office/drawing/2014/main" id="{59BE0C08-AC3F-4D11-AE13-B99CA32F56DB}"/>
+                <a16:creationId xmlns:a16="http://schemas.microsoft.com/office/drawing/2014/main" id="{4B1B6D08-58EE-4FE3-8367-19F28BCCD519}"/>
               </a:ext>
             </a:extLst>
           </p:cNvPr>
@@ -4010,7 +4010,7 @@
           <p:nvPr/>
         </p:nvPicPr>
         <p:blipFill>
-          <a:blip xmlns:r="http://schemas.openxmlformats.org/officeDocument/2006/relationships" xmlns:a="http://schemas.openxmlformats.org/drawingml/2006/main" r:embed="R61d0b7dcda6d4ed5"/>
+          <a:blip xmlns:r="http://schemas.openxmlformats.org/officeDocument/2006/relationships" xmlns:a="http://schemas.openxmlformats.org/drawingml/2006/main" r:embed="R0605f95d13f343ae"/>
           <a:stretch xmlns:a="http://schemas.openxmlformats.org/drawingml/2006/main"/>
         </p:blipFill>
         <p:spPr>
@@ -4028,7 +4028,7 @@
           <p:cNvPr id="2" name="hotspot-1">
             <a:extLst xmlns:a="http://schemas.openxmlformats.org/drawingml/2006/main">
               <a:ext uri="{FF2B5EF4-FFF2-40B4-BE49-F238E27FC236}">
-                <a16:creationId xmlns:a16="http://schemas.microsoft.com/office/drawing/2014/main" id="{0F8CCA3F-FBE1-485F-AF9F-2B0E0515C4DE}"/>
+                <a16:creationId xmlns:a16="http://schemas.microsoft.com/office/drawing/2014/main" id="{065C8897-820D-459D-9E61-ED982D959FCF}"/>
               </a:ext>
             </a:extLst>
             <ns0:hlinkClick xmlns:ns0="http://schemas.openxmlformats.org/drawingml/2006/main" xmlns:ns1="http://schemas.openxmlformats.org/officeDocument/2006/relationships" ns1:id="rIdClick1"/>
@@ -4061,7 +4061,7 @@
           <p:cNvPr id="3" name="hotspot-2">
             <a:extLst xmlns:a="http://schemas.openxmlformats.org/drawingml/2006/main">
               <a:ext uri="{FF2B5EF4-FFF2-40B4-BE49-F238E27FC236}">
-                <a16:creationId xmlns:a16="http://schemas.microsoft.com/office/drawing/2014/main" id="{F6AEC7DA-9099-424A-A49A-FB06944A914A}"/>
+                <a16:creationId xmlns:a16="http://schemas.microsoft.com/office/drawing/2014/main" id="{FE1A24CD-154C-4230-8A15-2EDF2A332304}"/>
               </a:ext>
             </a:extLst>
             <ns2:hlinkClick xmlns:ns2="http://schemas.openxmlformats.org/drawingml/2006/main" xmlns:ns3="http://schemas.openxmlformats.org/officeDocument/2006/relationships" ns3:id="rIdClick2"/>
@@ -4092,7 +4092,7 @@
     </p:spTree>
     <p:extLst>
       <p:ext uri="{BB962C8B-B14F-4D97-AF65-F5344CB8AC3E}">
-        <p14:creationId xmlns:p14="http://schemas.microsoft.com/office/powerpoint/2010/main" val="208266912"/>
+        <p14:creationId xmlns:p14="http://schemas.microsoft.com/office/powerpoint/2010/main" val="2084656290"/>
       </p:ext>
     </p:extLst>
   </p:cSld>
@@ -4123,7 +4123,7 @@
           <p:cNvPr id="5" name="">
             <a:extLst xmlns:a="http://schemas.openxmlformats.org/drawingml/2006/main">
               <a:ext uri="{FF2B5EF4-FFF2-40B4-BE49-F238E27FC236}">
-                <a16:creationId xmlns:a16="http://schemas.microsoft.com/office/drawing/2014/main" id="{BC6A7438-F02B-4CCD-8570-1AD84D005E2A}"/>
+                <a16:creationId xmlns:a16="http://schemas.microsoft.com/office/drawing/2014/main" id="{613E4426-93E2-44C6-A51C-A93F160A4160}"/>
               </a:ext>
             </a:extLst>
           </p:cNvPr>
@@ -4133,7 +4133,7 @@
           <p:nvPr/>
         </p:nvPicPr>
         <p:blipFill>
-          <a:blip xmlns:r="http://schemas.openxmlformats.org/officeDocument/2006/relationships" xmlns:a="http://schemas.openxmlformats.org/drawingml/2006/main" r:embed="Rdb75ea499d4343c5"/>
+          <a:blip xmlns:r="http://schemas.openxmlformats.org/officeDocument/2006/relationships" xmlns:a="http://schemas.openxmlformats.org/drawingml/2006/main" r:embed="R527e3f4394224c86"/>
           <a:stretch xmlns:a="http://schemas.openxmlformats.org/drawingml/2006/main"/>
         </p:blipFill>
         <p:spPr>
@@ -4151,7 +4151,7 @@
           <p:cNvPr id="2" name="hotspot-1">
             <a:extLst xmlns:a="http://schemas.openxmlformats.org/drawingml/2006/main">
               <a:ext uri="{FF2B5EF4-FFF2-40B4-BE49-F238E27FC236}">
-                <a16:creationId xmlns:a16="http://schemas.microsoft.com/office/drawing/2014/main" id="{D3FEEDBA-5C55-415F-8937-DCC1AA2AAF1C}"/>
+                <a16:creationId xmlns:a16="http://schemas.microsoft.com/office/drawing/2014/main" id="{36E04253-44AF-4937-B919-AFAE5DE382DF}"/>
               </a:ext>
             </a:extLst>
             <ns0:hlinkClick xmlns:ns0="http://schemas.openxmlformats.org/drawingml/2006/main" xmlns:ns1="http://schemas.openxmlformats.org/officeDocument/2006/relationships" ns1:id="rIdClick1"/>
@@ -4184,7 +4184,7 @@
           <p:cNvPr id="3" name="hotspot-2">
             <a:extLst xmlns:a="http://schemas.openxmlformats.org/drawingml/2006/main">
               <a:ext uri="{FF2B5EF4-FFF2-40B4-BE49-F238E27FC236}">
-                <a16:creationId xmlns:a16="http://schemas.microsoft.com/office/drawing/2014/main" id="{06E9174C-A8A8-4363-BA27-E9BBB6D89121}"/>
+                <a16:creationId xmlns:a16="http://schemas.microsoft.com/office/drawing/2014/main" id="{DF75118A-BF9A-4E21-B8B6-3E5E676142C2}"/>
               </a:ext>
             </a:extLst>
             <ns2:hlinkClick xmlns:ns2="http://schemas.openxmlformats.org/drawingml/2006/main" xmlns:ns3="http://schemas.openxmlformats.org/officeDocument/2006/relationships" ns3:id="rIdClick2"/>
@@ -4217,7 +4217,7 @@
           <p:cNvPr id="4" name="hotspot-3">
             <a:extLst xmlns:a="http://schemas.openxmlformats.org/drawingml/2006/main">
               <a:ext uri="{FF2B5EF4-FFF2-40B4-BE49-F238E27FC236}">
-                <a16:creationId xmlns:a16="http://schemas.microsoft.com/office/drawing/2014/main" id="{1085EC14-3214-4B24-9483-61E3F90CB370}"/>
+                <a16:creationId xmlns:a16="http://schemas.microsoft.com/office/drawing/2014/main" id="{E93312A4-9330-4446-A2EB-6516C38510EC}"/>
               </a:ext>
             </a:extLst>
             <ns4:hlinkClick xmlns:ns4="http://schemas.openxmlformats.org/drawingml/2006/main" xmlns:ns5="http://schemas.openxmlformats.org/officeDocument/2006/relationships" ns5:id="rIdClick3"/>
@@ -4248,7 +4248,7 @@
     </p:spTree>
     <p:extLst>
       <p:ext uri="{BB962C8B-B14F-4D97-AF65-F5344CB8AC3E}">
-        <p14:creationId xmlns:p14="http://schemas.microsoft.com/office/powerpoint/2010/main" val="170261986"/>
+        <p14:creationId xmlns:p14="http://schemas.microsoft.com/office/powerpoint/2010/main" val="1273302595"/>
       </p:ext>
     </p:extLst>
   </p:cSld>
@@ -4279,7 +4279,7 @@
           <p:cNvPr id="9" name="">
             <a:extLst xmlns:a="http://schemas.openxmlformats.org/drawingml/2006/main">
               <a:ext uri="{FF2B5EF4-FFF2-40B4-BE49-F238E27FC236}">
-                <a16:creationId xmlns:a16="http://schemas.microsoft.com/office/drawing/2014/main" id="{C9AC05B9-3D3D-4BF2-930C-E618E7426C8A}"/>
+                <a16:creationId xmlns:a16="http://schemas.microsoft.com/office/drawing/2014/main" id="{BF9D60E7-6A22-4CAC-B0C2-FB4E8C15D14B}"/>
               </a:ext>
             </a:extLst>
           </p:cNvPr>
@@ -4289,7 +4289,7 @@
           <p:nvPr/>
         </p:nvPicPr>
         <p:blipFill>
-          <a:blip xmlns:r="http://schemas.openxmlformats.org/officeDocument/2006/relationships" xmlns:a="http://schemas.openxmlformats.org/drawingml/2006/main" r:embed="Rda996972f26d46b7"/>
+          <a:blip xmlns:r="http://schemas.openxmlformats.org/officeDocument/2006/relationships" xmlns:a="http://schemas.openxmlformats.org/drawingml/2006/main" r:embed="Rd057aef8d8eb4beb"/>
           <a:stretch xmlns:a="http://schemas.openxmlformats.org/drawingml/2006/main"/>
         </p:blipFill>
         <p:spPr>
@@ -4307,7 +4307,7 @@
           <p:cNvPr id="2" name="hotspot-1">
             <a:extLst xmlns:a="http://schemas.openxmlformats.org/drawingml/2006/main">
               <a:ext uri="{FF2B5EF4-FFF2-40B4-BE49-F238E27FC236}">
-                <a16:creationId xmlns:a16="http://schemas.microsoft.com/office/drawing/2014/main" id="{1610FCB6-2409-4B0F-ABF9-7C9836DB369D}"/>
+                <a16:creationId xmlns:a16="http://schemas.microsoft.com/office/drawing/2014/main" id="{AD3EBD61-E187-4DEA-BFBD-4661D03A39B7}"/>
               </a:ext>
             </a:extLst>
             <ns0:hlinkClick xmlns:ns0="http://schemas.openxmlformats.org/drawingml/2006/main" xmlns:ns1="http://schemas.openxmlformats.org/officeDocument/2006/relationships" ns1:id="rIdClick1"/>
@@ -4340,7 +4340,7 @@
           <p:cNvPr id="3" name="hotspot-2">
             <a:extLst xmlns:a="http://schemas.openxmlformats.org/drawingml/2006/main">
               <a:ext uri="{FF2B5EF4-FFF2-40B4-BE49-F238E27FC236}">
-                <a16:creationId xmlns:a16="http://schemas.microsoft.com/office/drawing/2014/main" id="{76DB2D56-1288-4CBB-AB34-2B71AD69C61D}"/>
+                <a16:creationId xmlns:a16="http://schemas.microsoft.com/office/drawing/2014/main" id="{BE8A42AA-F26A-4A6A-B289-B2AED63A0505}"/>
               </a:ext>
             </a:extLst>
             <ns2:hlinkClick xmlns:ns2="http://schemas.openxmlformats.org/drawingml/2006/main" xmlns:ns3="http://schemas.openxmlformats.org/officeDocument/2006/relationships" ns3:id="rIdClick2"/>
@@ -4373,7 +4373,7 @@
           <p:cNvPr id="4" name="hotspot-3">
             <a:extLst xmlns:a="http://schemas.openxmlformats.org/drawingml/2006/main">
               <a:ext uri="{FF2B5EF4-FFF2-40B4-BE49-F238E27FC236}">
-                <a16:creationId xmlns:a16="http://schemas.microsoft.com/office/drawing/2014/main" id="{ADB8A8F4-A318-4024-9870-DF3AD1D42B8F}"/>
+                <a16:creationId xmlns:a16="http://schemas.microsoft.com/office/drawing/2014/main" id="{A1497DD1-EAAD-43FA-9BEF-361127280D95}"/>
               </a:ext>
             </a:extLst>
             <ns4:hlinkClick xmlns:ns4="http://schemas.openxmlformats.org/drawingml/2006/main" xmlns:ns5="http://schemas.openxmlformats.org/officeDocument/2006/relationships" ns5:id="rIdClick3"/>
@@ -4406,7 +4406,7 @@
           <p:cNvPr id="5" name="hotspot-4">
             <a:extLst xmlns:a="http://schemas.openxmlformats.org/drawingml/2006/main">
               <a:ext uri="{FF2B5EF4-FFF2-40B4-BE49-F238E27FC236}">
-                <a16:creationId xmlns:a16="http://schemas.microsoft.com/office/drawing/2014/main" id="{3BD7D483-0089-45C2-8FA7-AE5B015D3AAB}"/>
+                <a16:creationId xmlns:a16="http://schemas.microsoft.com/office/drawing/2014/main" id="{70F5E777-D374-431A-A2A3-F24E9BC271D7}"/>
               </a:ext>
             </a:extLst>
             <ns6:hlinkClick xmlns:ns6="http://schemas.openxmlformats.org/drawingml/2006/main" xmlns:ns7="http://schemas.openxmlformats.org/officeDocument/2006/relationships" ns7:id="rIdClick4"/>
@@ -4439,7 +4439,7 @@
           <p:cNvPr id="6" name="hotspot-5">
             <a:extLst xmlns:a="http://schemas.openxmlformats.org/drawingml/2006/main">
               <a:ext uri="{FF2B5EF4-FFF2-40B4-BE49-F238E27FC236}">
-                <a16:creationId xmlns:a16="http://schemas.microsoft.com/office/drawing/2014/main" id="{575E9BBB-14A2-49F8-ADA3-7DEA8ACB5658}"/>
+                <a16:creationId xmlns:a16="http://schemas.microsoft.com/office/drawing/2014/main" id="{BE7826BF-1845-40EB-9A15-1148203A5881}"/>
               </a:ext>
             </a:extLst>
             <ns8:hlinkClick xmlns:ns8="http://schemas.openxmlformats.org/drawingml/2006/main" xmlns:ns9="http://schemas.openxmlformats.org/officeDocument/2006/relationships" ns9:id="rIdClick5"/>
@@ -4472,7 +4472,7 @@
           <p:cNvPr id="7" name="hotspot-6">
             <a:extLst xmlns:a="http://schemas.openxmlformats.org/drawingml/2006/main">
               <a:ext uri="{FF2B5EF4-FFF2-40B4-BE49-F238E27FC236}">
-                <a16:creationId xmlns:a16="http://schemas.microsoft.com/office/drawing/2014/main" id="{2FEB6E62-B790-4D91-B065-5FA17591927B}"/>
+                <a16:creationId xmlns:a16="http://schemas.microsoft.com/office/drawing/2014/main" id="{8B3EF45C-82E7-4882-913A-B06E4645BF02}"/>
               </a:ext>
             </a:extLst>
             <ns10:hlinkClick xmlns:ns10="http://schemas.openxmlformats.org/drawingml/2006/main" xmlns:ns11="http://schemas.openxmlformats.org/officeDocument/2006/relationships" ns11:id="rIdClick6"/>
@@ -4505,7 +4505,7 @@
           <p:cNvPr id="8" name="hotspot-7">
             <a:extLst xmlns:a="http://schemas.openxmlformats.org/drawingml/2006/main">
               <a:ext uri="{FF2B5EF4-FFF2-40B4-BE49-F238E27FC236}">
-                <a16:creationId xmlns:a16="http://schemas.microsoft.com/office/drawing/2014/main" id="{8A0DFA8B-7259-4CC9-8137-E73C99EC07CB}"/>
+                <a16:creationId xmlns:a16="http://schemas.microsoft.com/office/drawing/2014/main" id="{49414A2C-1BFE-4404-A884-6E50250036D3}"/>
               </a:ext>
             </a:extLst>
             <ns12:hlinkClick xmlns:ns12="http://schemas.openxmlformats.org/drawingml/2006/main" xmlns:ns13="http://schemas.openxmlformats.org/officeDocument/2006/relationships" ns13:id="rIdClick7"/>
@@ -4536,7 +4536,7 @@
     </p:spTree>
     <p:extLst>
       <p:ext uri="{BB962C8B-B14F-4D97-AF65-F5344CB8AC3E}">
-        <p14:creationId xmlns:p14="http://schemas.microsoft.com/office/powerpoint/2010/main" val="1519158456"/>
+        <p14:creationId xmlns:p14="http://schemas.microsoft.com/office/powerpoint/2010/main" val="590623528"/>
       </p:ext>
     </p:extLst>
   </p:cSld>

</xml_diff>

<commit_message>
Add revised Patreon supporter description to Yathra
</commit_message>
<xml_diff>
--- a/GIUMS-MediaKit-EN.pptx
+++ b/GIUMS-MediaKit-EN.pptx
@@ -2,18 +2,18 @@
 <file path=ppt/presentation.xml><?xml version="1.0" encoding="utf-8"?>
 <p:presentation xmlns:p="http://schemas.openxmlformats.org/presentationml/2006/main">
   <p:sldMasterIdLst>
-    <p:sldMasterId xmlns:r="http://schemas.openxmlformats.org/officeDocument/2006/relationships" id="2147483648" r:id="R2569ce781bdf4bec"/>
+    <p:sldMasterId xmlns:r="http://schemas.openxmlformats.org/officeDocument/2006/relationships" id="2147483648" r:id="R1910ce6d874b488a"/>
   </p:sldMasterIdLst>
   <p:notesMasterIdLst>
-    <p:notesMasterId xmlns:r="http://schemas.openxmlformats.org/officeDocument/2006/relationships" r:id="R0e994b4aa7244ddf"/>
+    <p:notesMasterId xmlns:r="http://schemas.openxmlformats.org/officeDocument/2006/relationships" r:id="R04e2197ba36c4b03"/>
   </p:notesMasterIdLst>
   <p:sldIdLst>
-    <p:sldId xmlns:r="http://schemas.openxmlformats.org/officeDocument/2006/relationships" id="256" r:id="R23c7084c89c240e7"/>
-    <p:sldId xmlns:r="http://schemas.openxmlformats.org/officeDocument/2006/relationships" id="257" r:id="R76f0bdc20a604953"/>
-    <p:sldId xmlns:r="http://schemas.openxmlformats.org/officeDocument/2006/relationships" id="258" r:id="R768abdf2d8b24738"/>
-    <p:sldId xmlns:r="http://schemas.openxmlformats.org/officeDocument/2006/relationships" id="259" r:id="R0d62a19c3b374fc8"/>
-    <p:sldId xmlns:r="http://schemas.openxmlformats.org/officeDocument/2006/relationships" id="260" r:id="Rcb9b09683969490a"/>
-    <p:sldId xmlns:r="http://schemas.openxmlformats.org/officeDocument/2006/relationships" id="261" r:id="R862c71c2fa804793"/>
+    <p:sldId xmlns:r="http://schemas.openxmlformats.org/officeDocument/2006/relationships" id="256" r:id="Rb53f894ab6a44b66"/>
+    <p:sldId xmlns:r="http://schemas.openxmlformats.org/officeDocument/2006/relationships" id="257" r:id="R27db83c3feab4c39"/>
+    <p:sldId xmlns:r="http://schemas.openxmlformats.org/officeDocument/2006/relationships" id="258" r:id="R001855c52fe14170"/>
+    <p:sldId xmlns:r="http://schemas.openxmlformats.org/officeDocument/2006/relationships" id="259" r:id="R73176fc8a9654b52"/>
+    <p:sldId xmlns:r="http://schemas.openxmlformats.org/officeDocument/2006/relationships" id="260" r:id="R78e8eeca0c444657"/>
+    <p:sldId xmlns:r="http://schemas.openxmlformats.org/officeDocument/2006/relationships" id="261" r:id="R892333cd836d4386"/>
   </p:sldIdLst>
   <p:sldSz cx="12192000" cy="6858000"/>
   <p:notesSz cx="6858000" cy="9144000"/>
@@ -844,7 +844,7 @@
           <p:cNvPr id="3" name="Title">
             <a:extLst xmlns:a="http://schemas.openxmlformats.org/drawingml/2006/main">
               <a:ext uri="{FF2B5EF4-FFF2-40B4-BE49-F238E27FC236}">
-                <a16:creationId xmlns:a16="http://schemas.microsoft.com/office/drawing/2014/main" id="{C5EF70A2-1718-4194-A97A-F1B94BD90224}"/>
+                <a16:creationId xmlns:a16="http://schemas.microsoft.com/office/drawing/2014/main" id="{30753447-954A-451A-B87C-AAC1F5E5D5A6}"/>
               </a:ext>
             </a:extLst>
           </p:cNvPr>
@@ -1073,7 +1073,7 @@
           <p:cNvPr id="2" name="Subtitle">
             <a:extLst xmlns:a="http://schemas.openxmlformats.org/drawingml/2006/main">
               <a:ext uri="{FF2B5EF4-FFF2-40B4-BE49-F238E27FC236}">
-                <a16:creationId xmlns:a16="http://schemas.microsoft.com/office/drawing/2014/main" id="{DE4D054B-0F45-442B-B540-9CFDCFBCDF9F}"/>
+                <a16:creationId xmlns:a16="http://schemas.microsoft.com/office/drawing/2014/main" id="{029FF5D8-CC7E-42B9-B6F5-4BA45F20D648}"/>
               </a:ext>
             </a:extLst>
           </p:cNvPr>
@@ -1319,7 +1319,7 @@
           <p:cNvPr id="2" name="Section title">
             <a:extLst xmlns:a="http://schemas.openxmlformats.org/drawingml/2006/main">
               <a:ext uri="{FF2B5EF4-FFF2-40B4-BE49-F238E27FC236}">
-                <a16:creationId xmlns:a16="http://schemas.microsoft.com/office/drawing/2014/main" id="{53EAE7E6-C514-4E17-8588-49988AB180EB}"/>
+                <a16:creationId xmlns:a16="http://schemas.microsoft.com/office/drawing/2014/main" id="{8440512D-43F4-4A00-B779-82F7335BF10D}"/>
               </a:ext>
             </a:extLst>
           </p:cNvPr>
@@ -1565,7 +1565,7 @@
           <p:cNvPr id="3" name="Title">
             <a:extLst xmlns:a="http://schemas.openxmlformats.org/drawingml/2006/main">
               <a:ext uri="{FF2B5EF4-FFF2-40B4-BE49-F238E27FC236}">
-                <a16:creationId xmlns:a16="http://schemas.microsoft.com/office/drawing/2014/main" id="{DA018134-F55E-4E7D-8B33-4CBFE1498DC7}"/>
+                <a16:creationId xmlns:a16="http://schemas.microsoft.com/office/drawing/2014/main" id="{F1AAD3C8-08F0-4857-89AC-CD99A148C2B9}"/>
               </a:ext>
             </a:extLst>
           </p:cNvPr>
@@ -1794,7 +1794,7 @@
           <p:cNvPr id="2" name="Body">
             <a:extLst xmlns:a="http://schemas.openxmlformats.org/drawingml/2006/main">
               <a:ext uri="{FF2B5EF4-FFF2-40B4-BE49-F238E27FC236}">
-                <a16:creationId xmlns:a16="http://schemas.microsoft.com/office/drawing/2014/main" id="{23A42C52-FCA9-4300-8464-61336C59CF02}"/>
+                <a16:creationId xmlns:a16="http://schemas.microsoft.com/office/drawing/2014/main" id="{80F29E72-91EA-482C-9414-1A508D5A650F}"/>
               </a:ext>
             </a:extLst>
           </p:cNvPr>
@@ -2040,7 +2040,7 @@
           <p:cNvPr id="4" name="Title">
             <a:extLst xmlns:a="http://schemas.openxmlformats.org/drawingml/2006/main">
               <a:ext uri="{FF2B5EF4-FFF2-40B4-BE49-F238E27FC236}">
-                <a16:creationId xmlns:a16="http://schemas.microsoft.com/office/drawing/2014/main" id="{51974517-1C96-4B1E-8BEB-1DA4C52CF820}"/>
+                <a16:creationId xmlns:a16="http://schemas.microsoft.com/office/drawing/2014/main" id="{4F508001-67A5-4E67-BEE1-57A1320BB2AE}"/>
               </a:ext>
             </a:extLst>
           </p:cNvPr>
@@ -2269,7 +2269,7 @@
           <p:cNvPr id="2" name="Left column">
             <a:extLst xmlns:a="http://schemas.openxmlformats.org/drawingml/2006/main">
               <a:ext uri="{FF2B5EF4-FFF2-40B4-BE49-F238E27FC236}">
-                <a16:creationId xmlns:a16="http://schemas.microsoft.com/office/drawing/2014/main" id="{6A5E3C96-1345-4D81-831B-8AEC4C62876C}"/>
+                <a16:creationId xmlns:a16="http://schemas.microsoft.com/office/drawing/2014/main" id="{3A88138D-4B66-4976-87A3-1F4BBCFFEAB1}"/>
               </a:ext>
             </a:extLst>
           </p:cNvPr>
@@ -2498,7 +2498,7 @@
           <p:cNvPr id="3" name="Right column">
             <a:extLst xmlns:a="http://schemas.openxmlformats.org/drawingml/2006/main">
               <a:ext uri="{FF2B5EF4-FFF2-40B4-BE49-F238E27FC236}">
-                <a16:creationId xmlns:a16="http://schemas.microsoft.com/office/drawing/2014/main" id="{F1486D6E-B5B2-46A0-B3A6-9FE184B43EA6}"/>
+                <a16:creationId xmlns:a16="http://schemas.microsoft.com/office/drawing/2014/main" id="{E69D834F-2E24-43AE-AAFA-7911D73C8307}"/>
               </a:ext>
             </a:extLst>
           </p:cNvPr>
@@ -2744,7 +2744,7 @@
           <p:cNvPr id="3" name="Title">
             <a:extLst xmlns:a="http://schemas.openxmlformats.org/drawingml/2006/main">
               <a:ext uri="{FF2B5EF4-FFF2-40B4-BE49-F238E27FC236}">
-                <a16:creationId xmlns:a16="http://schemas.microsoft.com/office/drawing/2014/main" id="{9ADC984C-057B-456F-BF1D-F8F6DDAAB650}"/>
+                <a16:creationId xmlns:a16="http://schemas.microsoft.com/office/drawing/2014/main" id="{715E5909-23F0-436C-AB6A-8C6E8485DAC7}"/>
               </a:ext>
             </a:extLst>
           </p:cNvPr>
@@ -2973,7 +2973,7 @@
           <p:cNvPr id="2" name="Left column">
             <a:extLst xmlns:a="http://schemas.openxmlformats.org/drawingml/2006/main">
               <a:ext uri="{FF2B5EF4-FFF2-40B4-BE49-F238E27FC236}">
-                <a16:creationId xmlns:a16="http://schemas.microsoft.com/office/drawing/2014/main" id="{23465F4F-5DB4-4820-867B-78302FC6E53D}"/>
+                <a16:creationId xmlns:a16="http://schemas.microsoft.com/office/drawing/2014/main" id="{A97392BF-3E83-48DC-B32D-CEEF2CF7E155}"/>
               </a:ext>
             </a:extLst>
           </p:cNvPr>
@@ -3240,12 +3240,12 @@
   </p:cSld>
   <p:clrMap bg1="lt1" tx1="dk1" bg2="lt2" tx2="dk2" accent1="accent1" accent2="accent2" accent3="accent3" accent4="accent4" accent5="accent5" accent6="accent6" hlink="hlink" folHlink="folHlink"/>
   <p:sldLayoutIdLst>
-    <p:sldLayoutId xmlns:r="http://schemas.openxmlformats.org/officeDocument/2006/relationships" id="2147483649" r:id="Re2406b7ee4d44433"/>
-    <p:sldLayoutId xmlns:r="http://schemas.openxmlformats.org/officeDocument/2006/relationships" id="2147483650" r:id="Rde2903971b054f84"/>
-    <p:sldLayoutId xmlns:r="http://schemas.openxmlformats.org/officeDocument/2006/relationships" id="2147483651" r:id="R125cba3084c54a7a"/>
-    <p:sldLayoutId xmlns:r="http://schemas.openxmlformats.org/officeDocument/2006/relationships" id="2147483652" r:id="R2b37679f462a41eb"/>
-    <p:sldLayoutId xmlns:r="http://schemas.openxmlformats.org/officeDocument/2006/relationships" id="2147483653" r:id="Rb96554afbdbd4566"/>
-    <p:sldLayoutId xmlns:r="http://schemas.openxmlformats.org/officeDocument/2006/relationships" id="2147483654" r:id="Rb96948c6f0ca40cb"/>
+    <p:sldLayoutId xmlns:r="http://schemas.openxmlformats.org/officeDocument/2006/relationships" id="2147483649" r:id="R1125b81a8e8a4aa9"/>
+    <p:sldLayoutId xmlns:r="http://schemas.openxmlformats.org/officeDocument/2006/relationships" id="2147483650" r:id="R5085602f80b04013"/>
+    <p:sldLayoutId xmlns:r="http://schemas.openxmlformats.org/officeDocument/2006/relationships" id="2147483651" r:id="R2d539a70107b43ce"/>
+    <p:sldLayoutId xmlns:r="http://schemas.openxmlformats.org/officeDocument/2006/relationships" id="2147483652" r:id="R898328d176ba4d14"/>
+    <p:sldLayoutId xmlns:r="http://schemas.openxmlformats.org/officeDocument/2006/relationships" id="2147483653" r:id="R413120d20e494340"/>
+    <p:sldLayoutId xmlns:r="http://schemas.openxmlformats.org/officeDocument/2006/relationships" id="2147483654" r:id="R52696566373f4061"/>
   </p:sldLayoutIdLst>
   <p:txStyles>
     <p:titleStyle>
@@ -3796,7 +3796,7 @@
           <p:cNvPr id="2" name="">
             <a:extLst xmlns:a="http://schemas.openxmlformats.org/drawingml/2006/main">
               <a:ext uri="{FF2B5EF4-FFF2-40B4-BE49-F238E27FC236}">
-                <a16:creationId xmlns:a16="http://schemas.microsoft.com/office/drawing/2014/main" id="{8686BF91-CF5B-459B-9C7D-F489E238BA95}"/>
+                <a16:creationId xmlns:a16="http://schemas.microsoft.com/office/drawing/2014/main" id="{558D9C6C-C01F-4B80-980F-21893C377993}"/>
               </a:ext>
             </a:extLst>
           </p:cNvPr>
@@ -3806,7 +3806,7 @@
           <p:nvPr/>
         </p:nvPicPr>
         <p:blipFill>
-          <a:blip xmlns:r="http://schemas.openxmlformats.org/officeDocument/2006/relationships" xmlns:a="http://schemas.openxmlformats.org/drawingml/2006/main" r:embed="Re50c5fd35d2d4655"/>
+          <a:blip xmlns:r="http://schemas.openxmlformats.org/officeDocument/2006/relationships" xmlns:a="http://schemas.openxmlformats.org/drawingml/2006/main" r:embed="R9c2d0183fc3942a9"/>
           <a:stretch xmlns:a="http://schemas.openxmlformats.org/drawingml/2006/main"/>
         </p:blipFill>
         <p:spPr>
@@ -3822,7 +3822,7 @@
     </p:spTree>
     <p:extLst>
       <p:ext uri="{BB962C8B-B14F-4D97-AF65-F5344CB8AC3E}">
-        <p14:creationId xmlns:p14="http://schemas.microsoft.com/office/powerpoint/2010/main" val="914410755"/>
+        <p14:creationId xmlns:p14="http://schemas.microsoft.com/office/powerpoint/2010/main" val="1455303302"/>
       </p:ext>
     </p:extLst>
   </p:cSld>
@@ -3853,7 +3853,7 @@
           <p:cNvPr id="2" name="">
             <a:extLst xmlns:a="http://schemas.openxmlformats.org/drawingml/2006/main">
               <a:ext uri="{FF2B5EF4-FFF2-40B4-BE49-F238E27FC236}">
-                <a16:creationId xmlns:a16="http://schemas.microsoft.com/office/drawing/2014/main" id="{531D56C8-1FF6-4B86-980E-4AF3A9FDFC70}"/>
+                <a16:creationId xmlns:a16="http://schemas.microsoft.com/office/drawing/2014/main" id="{FF0408DF-D856-48A4-9F84-2688EE1E473A}"/>
               </a:ext>
             </a:extLst>
           </p:cNvPr>
@@ -3863,7 +3863,7 @@
           <p:nvPr/>
         </p:nvPicPr>
         <p:blipFill>
-          <a:blip xmlns:r="http://schemas.openxmlformats.org/officeDocument/2006/relationships" xmlns:a="http://schemas.openxmlformats.org/drawingml/2006/main" r:embed="R62002e0cbc944026"/>
+          <a:blip xmlns:r="http://schemas.openxmlformats.org/officeDocument/2006/relationships" xmlns:a="http://schemas.openxmlformats.org/drawingml/2006/main" r:embed="Rafee4ab5a4e24082"/>
           <a:stretch xmlns:a="http://schemas.openxmlformats.org/drawingml/2006/main"/>
         </p:blipFill>
         <p:spPr>
@@ -3879,7 +3879,7 @@
     </p:spTree>
     <p:extLst>
       <p:ext uri="{BB962C8B-B14F-4D97-AF65-F5344CB8AC3E}">
-        <p14:creationId xmlns:p14="http://schemas.microsoft.com/office/powerpoint/2010/main" val="1004746364"/>
+        <p14:creationId xmlns:p14="http://schemas.microsoft.com/office/powerpoint/2010/main" val="217791931"/>
       </p:ext>
     </p:extLst>
   </p:cSld>
@@ -3910,7 +3910,7 @@
           <p:cNvPr id="3" name="">
             <a:extLst xmlns:a="http://schemas.openxmlformats.org/drawingml/2006/main">
               <a:ext uri="{FF2B5EF4-FFF2-40B4-BE49-F238E27FC236}">
-                <a16:creationId xmlns:a16="http://schemas.microsoft.com/office/drawing/2014/main" id="{E38F6F42-27FE-45EA-B3AB-EE4C67FF4ED4}"/>
+                <a16:creationId xmlns:a16="http://schemas.microsoft.com/office/drawing/2014/main" id="{3087E8CE-113C-4EAF-9785-17DD3290B47D}"/>
               </a:ext>
             </a:extLst>
           </p:cNvPr>
@@ -3920,7 +3920,7 @@
           <p:nvPr/>
         </p:nvPicPr>
         <p:blipFill>
-          <a:blip xmlns:r="http://schemas.openxmlformats.org/officeDocument/2006/relationships" xmlns:a="http://schemas.openxmlformats.org/drawingml/2006/main" r:embed="R4a26cf5aefe04832"/>
+          <a:blip xmlns:r="http://schemas.openxmlformats.org/officeDocument/2006/relationships" xmlns:a="http://schemas.openxmlformats.org/drawingml/2006/main" r:embed="Rc648b4e6d5764b93"/>
           <a:stretch xmlns:a="http://schemas.openxmlformats.org/drawingml/2006/main"/>
         </p:blipFill>
         <p:spPr>
@@ -3938,7 +3938,7 @@
           <p:cNvPr id="2" name="hotspot-1">
             <a:extLst xmlns:a="http://schemas.openxmlformats.org/drawingml/2006/main">
               <a:ext uri="{FF2B5EF4-FFF2-40B4-BE49-F238E27FC236}">
-                <a16:creationId xmlns:a16="http://schemas.microsoft.com/office/drawing/2014/main" id="{7C704100-7E8B-4FB3-BFC9-0FCEE5715254}"/>
+                <a16:creationId xmlns:a16="http://schemas.microsoft.com/office/drawing/2014/main" id="{2C5B558F-671B-479D-AF43-5CFDFD642369}"/>
               </a:ext>
             </a:extLst>
             <ns0:hlinkClick xmlns:ns0="http://schemas.openxmlformats.org/drawingml/2006/main" xmlns:ns1="http://schemas.openxmlformats.org/officeDocument/2006/relationships" ns1:id="rIdClick1"/>
@@ -3950,7 +3950,7 @@
         </p:nvSpPr>
         <p:spPr>
           <a:xfrm xmlns:a="http://schemas.openxmlformats.org/drawingml/2006/main">
-            <a:off x="737250" y="5233050"/>
+            <a:off x="737250" y="5902650"/>
             <a:ext cx="1894950" cy="144000"/>
           </a:xfrm>
           <a:prstGeom xmlns:a="http://schemas.openxmlformats.org/drawingml/2006/main" prst="rect">
@@ -3969,7 +3969,7 @@
     </p:spTree>
     <p:extLst>
       <p:ext uri="{BB962C8B-B14F-4D97-AF65-F5344CB8AC3E}">
-        <p14:creationId xmlns:p14="http://schemas.microsoft.com/office/powerpoint/2010/main" val="374918454"/>
+        <p14:creationId xmlns:p14="http://schemas.microsoft.com/office/powerpoint/2010/main" val="1454193177"/>
       </p:ext>
     </p:extLst>
   </p:cSld>
@@ -4000,7 +4000,7 @@
           <p:cNvPr id="4" name="">
             <a:extLst xmlns:a="http://schemas.openxmlformats.org/drawingml/2006/main">
               <a:ext uri="{FF2B5EF4-FFF2-40B4-BE49-F238E27FC236}">
-                <a16:creationId xmlns:a16="http://schemas.microsoft.com/office/drawing/2014/main" id="{4B1B6D08-58EE-4FE3-8367-19F28BCCD519}"/>
+                <a16:creationId xmlns:a16="http://schemas.microsoft.com/office/drawing/2014/main" id="{7C39D128-DE9E-4072-B4C3-60EEDDEC834F}"/>
               </a:ext>
             </a:extLst>
           </p:cNvPr>
@@ -4010,7 +4010,7 @@
           <p:nvPr/>
         </p:nvPicPr>
         <p:blipFill>
-          <a:blip xmlns:r="http://schemas.openxmlformats.org/officeDocument/2006/relationships" xmlns:a="http://schemas.openxmlformats.org/drawingml/2006/main" r:embed="R0605f95d13f343ae"/>
+          <a:blip xmlns:r="http://schemas.openxmlformats.org/officeDocument/2006/relationships" xmlns:a="http://schemas.openxmlformats.org/drawingml/2006/main" r:embed="R91d1a7479d304b3a"/>
           <a:stretch xmlns:a="http://schemas.openxmlformats.org/drawingml/2006/main"/>
         </p:blipFill>
         <p:spPr>
@@ -4028,7 +4028,7 @@
           <p:cNvPr id="2" name="hotspot-1">
             <a:extLst xmlns:a="http://schemas.openxmlformats.org/drawingml/2006/main">
               <a:ext uri="{FF2B5EF4-FFF2-40B4-BE49-F238E27FC236}">
-                <a16:creationId xmlns:a16="http://schemas.microsoft.com/office/drawing/2014/main" id="{065C8897-820D-459D-9E61-ED982D959FCF}"/>
+                <a16:creationId xmlns:a16="http://schemas.microsoft.com/office/drawing/2014/main" id="{24D1358D-9726-44AF-90C1-2559704595B2}"/>
               </a:ext>
             </a:extLst>
             <ns0:hlinkClick xmlns:ns0="http://schemas.openxmlformats.org/drawingml/2006/main" xmlns:ns1="http://schemas.openxmlformats.org/officeDocument/2006/relationships" ns1:id="rIdClick1"/>
@@ -4061,7 +4061,7 @@
           <p:cNvPr id="3" name="hotspot-2">
             <a:extLst xmlns:a="http://schemas.openxmlformats.org/drawingml/2006/main">
               <a:ext uri="{FF2B5EF4-FFF2-40B4-BE49-F238E27FC236}">
-                <a16:creationId xmlns:a16="http://schemas.microsoft.com/office/drawing/2014/main" id="{FE1A24CD-154C-4230-8A15-2EDF2A332304}"/>
+                <a16:creationId xmlns:a16="http://schemas.microsoft.com/office/drawing/2014/main" id="{8A44F953-3C35-4250-A69D-38CBBB95061D}"/>
               </a:ext>
             </a:extLst>
             <ns2:hlinkClick xmlns:ns2="http://schemas.openxmlformats.org/drawingml/2006/main" xmlns:ns3="http://schemas.openxmlformats.org/officeDocument/2006/relationships" ns3:id="rIdClick2"/>
@@ -4092,7 +4092,7 @@
     </p:spTree>
     <p:extLst>
       <p:ext uri="{BB962C8B-B14F-4D97-AF65-F5344CB8AC3E}">
-        <p14:creationId xmlns:p14="http://schemas.microsoft.com/office/powerpoint/2010/main" val="2084656290"/>
+        <p14:creationId xmlns:p14="http://schemas.microsoft.com/office/powerpoint/2010/main" val="1024873678"/>
       </p:ext>
     </p:extLst>
   </p:cSld>
@@ -4123,7 +4123,7 @@
           <p:cNvPr id="5" name="">
             <a:extLst xmlns:a="http://schemas.openxmlformats.org/drawingml/2006/main">
               <a:ext uri="{FF2B5EF4-FFF2-40B4-BE49-F238E27FC236}">
-                <a16:creationId xmlns:a16="http://schemas.microsoft.com/office/drawing/2014/main" id="{613E4426-93E2-44C6-A51C-A93F160A4160}"/>
+                <a16:creationId xmlns:a16="http://schemas.microsoft.com/office/drawing/2014/main" id="{2456E9B7-F765-4AE5-9AB4-0D854510A058}"/>
               </a:ext>
             </a:extLst>
           </p:cNvPr>
@@ -4133,7 +4133,7 @@
           <p:nvPr/>
         </p:nvPicPr>
         <p:blipFill>
-          <a:blip xmlns:r="http://schemas.openxmlformats.org/officeDocument/2006/relationships" xmlns:a="http://schemas.openxmlformats.org/drawingml/2006/main" r:embed="R527e3f4394224c86"/>
+          <a:blip xmlns:r="http://schemas.openxmlformats.org/officeDocument/2006/relationships" xmlns:a="http://schemas.openxmlformats.org/drawingml/2006/main" r:embed="Rde6747d4770744f2"/>
           <a:stretch xmlns:a="http://schemas.openxmlformats.org/drawingml/2006/main"/>
         </p:blipFill>
         <p:spPr>
@@ -4151,7 +4151,7 @@
           <p:cNvPr id="2" name="hotspot-1">
             <a:extLst xmlns:a="http://schemas.openxmlformats.org/drawingml/2006/main">
               <a:ext uri="{FF2B5EF4-FFF2-40B4-BE49-F238E27FC236}">
-                <a16:creationId xmlns:a16="http://schemas.microsoft.com/office/drawing/2014/main" id="{36E04253-44AF-4937-B919-AFAE5DE382DF}"/>
+                <a16:creationId xmlns:a16="http://schemas.microsoft.com/office/drawing/2014/main" id="{3F0764B7-AEAF-480F-91C4-9150CDECA25D}"/>
               </a:ext>
             </a:extLst>
             <ns0:hlinkClick xmlns:ns0="http://schemas.openxmlformats.org/drawingml/2006/main" xmlns:ns1="http://schemas.openxmlformats.org/officeDocument/2006/relationships" ns1:id="rIdClick1"/>
@@ -4184,7 +4184,7 @@
           <p:cNvPr id="3" name="hotspot-2">
             <a:extLst xmlns:a="http://schemas.openxmlformats.org/drawingml/2006/main">
               <a:ext uri="{FF2B5EF4-FFF2-40B4-BE49-F238E27FC236}">
-                <a16:creationId xmlns:a16="http://schemas.microsoft.com/office/drawing/2014/main" id="{DF75118A-BF9A-4E21-B8B6-3E5E676142C2}"/>
+                <a16:creationId xmlns:a16="http://schemas.microsoft.com/office/drawing/2014/main" id="{D997E9E5-63B4-425D-AF87-76FE7261B668}"/>
               </a:ext>
             </a:extLst>
             <ns2:hlinkClick xmlns:ns2="http://schemas.openxmlformats.org/drawingml/2006/main" xmlns:ns3="http://schemas.openxmlformats.org/officeDocument/2006/relationships" ns3:id="rIdClick2"/>
@@ -4217,7 +4217,7 @@
           <p:cNvPr id="4" name="hotspot-3">
             <a:extLst xmlns:a="http://schemas.openxmlformats.org/drawingml/2006/main">
               <a:ext uri="{FF2B5EF4-FFF2-40B4-BE49-F238E27FC236}">
-                <a16:creationId xmlns:a16="http://schemas.microsoft.com/office/drawing/2014/main" id="{E93312A4-9330-4446-A2EB-6516C38510EC}"/>
+                <a16:creationId xmlns:a16="http://schemas.microsoft.com/office/drawing/2014/main" id="{7BDFC04C-2D78-41EF-9D3B-7215B5ABE3E5}"/>
               </a:ext>
             </a:extLst>
             <ns4:hlinkClick xmlns:ns4="http://schemas.openxmlformats.org/drawingml/2006/main" xmlns:ns5="http://schemas.openxmlformats.org/officeDocument/2006/relationships" ns5:id="rIdClick3"/>
@@ -4248,7 +4248,7 @@
     </p:spTree>
     <p:extLst>
       <p:ext uri="{BB962C8B-B14F-4D97-AF65-F5344CB8AC3E}">
-        <p14:creationId xmlns:p14="http://schemas.microsoft.com/office/powerpoint/2010/main" val="1273302595"/>
+        <p14:creationId xmlns:p14="http://schemas.microsoft.com/office/powerpoint/2010/main" val="960048804"/>
       </p:ext>
     </p:extLst>
   </p:cSld>
@@ -4279,7 +4279,7 @@
           <p:cNvPr id="9" name="">
             <a:extLst xmlns:a="http://schemas.openxmlformats.org/drawingml/2006/main">
               <a:ext uri="{FF2B5EF4-FFF2-40B4-BE49-F238E27FC236}">
-                <a16:creationId xmlns:a16="http://schemas.microsoft.com/office/drawing/2014/main" id="{BF9D60E7-6A22-4CAC-B0C2-FB4E8C15D14B}"/>
+                <a16:creationId xmlns:a16="http://schemas.microsoft.com/office/drawing/2014/main" id="{64C0A09D-95C9-4A87-BD5B-E2968D3F553A}"/>
               </a:ext>
             </a:extLst>
           </p:cNvPr>
@@ -4289,7 +4289,7 @@
           <p:nvPr/>
         </p:nvPicPr>
         <p:blipFill>
-          <a:blip xmlns:r="http://schemas.openxmlformats.org/officeDocument/2006/relationships" xmlns:a="http://schemas.openxmlformats.org/drawingml/2006/main" r:embed="Rd057aef8d8eb4beb"/>
+          <a:blip xmlns:r="http://schemas.openxmlformats.org/officeDocument/2006/relationships" xmlns:a="http://schemas.openxmlformats.org/drawingml/2006/main" r:embed="R9248ead78b834de9"/>
           <a:stretch xmlns:a="http://schemas.openxmlformats.org/drawingml/2006/main"/>
         </p:blipFill>
         <p:spPr>
@@ -4307,7 +4307,7 @@
           <p:cNvPr id="2" name="hotspot-1">
             <a:extLst xmlns:a="http://schemas.openxmlformats.org/drawingml/2006/main">
               <a:ext uri="{FF2B5EF4-FFF2-40B4-BE49-F238E27FC236}">
-                <a16:creationId xmlns:a16="http://schemas.microsoft.com/office/drawing/2014/main" id="{AD3EBD61-E187-4DEA-BFBD-4661D03A39B7}"/>
+                <a16:creationId xmlns:a16="http://schemas.microsoft.com/office/drawing/2014/main" id="{748C022C-5193-4288-B6B4-D32EB4617399}"/>
               </a:ext>
             </a:extLst>
             <ns0:hlinkClick xmlns:ns0="http://schemas.openxmlformats.org/drawingml/2006/main" xmlns:ns1="http://schemas.openxmlformats.org/officeDocument/2006/relationships" ns1:id="rIdClick1"/>
@@ -4340,7 +4340,7 @@
           <p:cNvPr id="3" name="hotspot-2">
             <a:extLst xmlns:a="http://schemas.openxmlformats.org/drawingml/2006/main">
               <a:ext uri="{FF2B5EF4-FFF2-40B4-BE49-F238E27FC236}">
-                <a16:creationId xmlns:a16="http://schemas.microsoft.com/office/drawing/2014/main" id="{BE8A42AA-F26A-4A6A-B289-B2AED63A0505}"/>
+                <a16:creationId xmlns:a16="http://schemas.microsoft.com/office/drawing/2014/main" id="{9C6E67C1-D6D0-4C27-90D6-857E4DD517B8}"/>
               </a:ext>
             </a:extLst>
             <ns2:hlinkClick xmlns:ns2="http://schemas.openxmlformats.org/drawingml/2006/main" xmlns:ns3="http://schemas.openxmlformats.org/officeDocument/2006/relationships" ns3:id="rIdClick2"/>
@@ -4373,7 +4373,7 @@
           <p:cNvPr id="4" name="hotspot-3">
             <a:extLst xmlns:a="http://schemas.openxmlformats.org/drawingml/2006/main">
               <a:ext uri="{FF2B5EF4-FFF2-40B4-BE49-F238E27FC236}">
-                <a16:creationId xmlns:a16="http://schemas.microsoft.com/office/drawing/2014/main" id="{A1497DD1-EAAD-43FA-9BEF-361127280D95}"/>
+                <a16:creationId xmlns:a16="http://schemas.microsoft.com/office/drawing/2014/main" id="{5F796726-9A8F-4DDD-A9E5-9C016125D812}"/>
               </a:ext>
             </a:extLst>
             <ns4:hlinkClick xmlns:ns4="http://schemas.openxmlformats.org/drawingml/2006/main" xmlns:ns5="http://schemas.openxmlformats.org/officeDocument/2006/relationships" ns5:id="rIdClick3"/>
@@ -4406,7 +4406,7 @@
           <p:cNvPr id="5" name="hotspot-4">
             <a:extLst xmlns:a="http://schemas.openxmlformats.org/drawingml/2006/main">
               <a:ext uri="{FF2B5EF4-FFF2-40B4-BE49-F238E27FC236}">
-                <a16:creationId xmlns:a16="http://schemas.microsoft.com/office/drawing/2014/main" id="{70F5E777-D374-431A-A2A3-F24E9BC271D7}"/>
+                <a16:creationId xmlns:a16="http://schemas.microsoft.com/office/drawing/2014/main" id="{31E843A0-83E7-489E-89C4-176AE0EF6822}"/>
               </a:ext>
             </a:extLst>
             <ns6:hlinkClick xmlns:ns6="http://schemas.openxmlformats.org/drawingml/2006/main" xmlns:ns7="http://schemas.openxmlformats.org/officeDocument/2006/relationships" ns7:id="rIdClick4"/>
@@ -4439,7 +4439,7 @@
           <p:cNvPr id="6" name="hotspot-5">
             <a:extLst xmlns:a="http://schemas.openxmlformats.org/drawingml/2006/main">
               <a:ext uri="{FF2B5EF4-FFF2-40B4-BE49-F238E27FC236}">
-                <a16:creationId xmlns:a16="http://schemas.microsoft.com/office/drawing/2014/main" id="{BE7826BF-1845-40EB-9A15-1148203A5881}"/>
+                <a16:creationId xmlns:a16="http://schemas.microsoft.com/office/drawing/2014/main" id="{48A233BA-F1A6-4488-A84A-1584AAC85D1C}"/>
               </a:ext>
             </a:extLst>
             <ns8:hlinkClick xmlns:ns8="http://schemas.openxmlformats.org/drawingml/2006/main" xmlns:ns9="http://schemas.openxmlformats.org/officeDocument/2006/relationships" ns9:id="rIdClick5"/>
@@ -4472,7 +4472,7 @@
           <p:cNvPr id="7" name="hotspot-6">
             <a:extLst xmlns:a="http://schemas.openxmlformats.org/drawingml/2006/main">
               <a:ext uri="{FF2B5EF4-FFF2-40B4-BE49-F238E27FC236}">
-                <a16:creationId xmlns:a16="http://schemas.microsoft.com/office/drawing/2014/main" id="{8B3EF45C-82E7-4882-913A-B06E4645BF02}"/>
+                <a16:creationId xmlns:a16="http://schemas.microsoft.com/office/drawing/2014/main" id="{B1034C33-9BA1-45F1-B162-6C848BE638C7}"/>
               </a:ext>
             </a:extLst>
             <ns10:hlinkClick xmlns:ns10="http://schemas.openxmlformats.org/drawingml/2006/main" xmlns:ns11="http://schemas.openxmlformats.org/officeDocument/2006/relationships" ns11:id="rIdClick6"/>
@@ -4505,7 +4505,7 @@
           <p:cNvPr id="8" name="hotspot-7">
             <a:extLst xmlns:a="http://schemas.openxmlformats.org/drawingml/2006/main">
               <a:ext uri="{FF2B5EF4-FFF2-40B4-BE49-F238E27FC236}">
-                <a16:creationId xmlns:a16="http://schemas.microsoft.com/office/drawing/2014/main" id="{49414A2C-1BFE-4404-A884-6E50250036D3}"/>
+                <a16:creationId xmlns:a16="http://schemas.microsoft.com/office/drawing/2014/main" id="{D7EA1A00-D797-4205-AD2B-06796A1CCADF}"/>
               </a:ext>
             </a:extLst>
             <ns12:hlinkClick xmlns:ns12="http://schemas.openxmlformats.org/drawingml/2006/main" xmlns:ns13="http://schemas.openxmlformats.org/officeDocument/2006/relationships" ns13:id="rIdClick7"/>
@@ -4536,7 +4536,7 @@
     </p:spTree>
     <p:extLst>
       <p:ext uri="{BB962C8B-B14F-4D97-AF65-F5344CB8AC3E}">
-        <p14:creationId xmlns:p14="http://schemas.microsoft.com/office/powerpoint/2010/main" val="590623528"/>
+        <p14:creationId xmlns:p14="http://schemas.microsoft.com/office/powerpoint/2010/main" val="1620150984"/>
       </p:ext>
     </p:extLst>
   </p:cSld>

</xml_diff>

<commit_message>
Refine Patreon participation wording in Yathra section
</commit_message>
<xml_diff>
--- a/GIUMS-MediaKit-EN.pptx
+++ b/GIUMS-MediaKit-EN.pptx
@@ -2,18 +2,18 @@
 <file path=ppt/presentation.xml><?xml version="1.0" encoding="utf-8"?>
 <p:presentation xmlns:p="http://schemas.openxmlformats.org/presentationml/2006/main">
   <p:sldMasterIdLst>
-    <p:sldMasterId xmlns:r="http://schemas.openxmlformats.org/officeDocument/2006/relationships" id="2147483648" r:id="R1910ce6d874b488a"/>
+    <p:sldMasterId xmlns:r="http://schemas.openxmlformats.org/officeDocument/2006/relationships" id="2147483648" r:id="Rb8687375419e480b"/>
   </p:sldMasterIdLst>
   <p:notesMasterIdLst>
-    <p:notesMasterId xmlns:r="http://schemas.openxmlformats.org/officeDocument/2006/relationships" r:id="R04e2197ba36c4b03"/>
+    <p:notesMasterId xmlns:r="http://schemas.openxmlformats.org/officeDocument/2006/relationships" r:id="R5ca3ec40ae22437a"/>
   </p:notesMasterIdLst>
   <p:sldIdLst>
-    <p:sldId xmlns:r="http://schemas.openxmlformats.org/officeDocument/2006/relationships" id="256" r:id="Rb53f894ab6a44b66"/>
-    <p:sldId xmlns:r="http://schemas.openxmlformats.org/officeDocument/2006/relationships" id="257" r:id="R27db83c3feab4c39"/>
-    <p:sldId xmlns:r="http://schemas.openxmlformats.org/officeDocument/2006/relationships" id="258" r:id="R001855c52fe14170"/>
-    <p:sldId xmlns:r="http://schemas.openxmlformats.org/officeDocument/2006/relationships" id="259" r:id="R73176fc8a9654b52"/>
-    <p:sldId xmlns:r="http://schemas.openxmlformats.org/officeDocument/2006/relationships" id="260" r:id="R78e8eeca0c444657"/>
-    <p:sldId xmlns:r="http://schemas.openxmlformats.org/officeDocument/2006/relationships" id="261" r:id="R892333cd836d4386"/>
+    <p:sldId xmlns:r="http://schemas.openxmlformats.org/officeDocument/2006/relationships" id="256" r:id="R4442942e68a04ab0"/>
+    <p:sldId xmlns:r="http://schemas.openxmlformats.org/officeDocument/2006/relationships" id="257" r:id="R2fcbc6eaf0174120"/>
+    <p:sldId xmlns:r="http://schemas.openxmlformats.org/officeDocument/2006/relationships" id="258" r:id="Rb9f20dfd26f9496c"/>
+    <p:sldId xmlns:r="http://schemas.openxmlformats.org/officeDocument/2006/relationships" id="259" r:id="R70bb3e41e6a845eb"/>
+    <p:sldId xmlns:r="http://schemas.openxmlformats.org/officeDocument/2006/relationships" id="260" r:id="R7f787a6d4dc14e08"/>
+    <p:sldId xmlns:r="http://schemas.openxmlformats.org/officeDocument/2006/relationships" id="261" r:id="R70a7262fe9384df8"/>
   </p:sldIdLst>
   <p:sldSz cx="12192000" cy="6858000"/>
   <p:notesSz cx="6858000" cy="9144000"/>
@@ -844,7 +844,7 @@
           <p:cNvPr id="3" name="Title">
             <a:extLst xmlns:a="http://schemas.openxmlformats.org/drawingml/2006/main">
               <a:ext uri="{FF2B5EF4-FFF2-40B4-BE49-F238E27FC236}">
-                <a16:creationId xmlns:a16="http://schemas.microsoft.com/office/drawing/2014/main" id="{30753447-954A-451A-B87C-AAC1F5E5D5A6}"/>
+                <a16:creationId xmlns:a16="http://schemas.microsoft.com/office/drawing/2014/main" id="{234159B5-45D4-4368-A181-DD9D1E48CCCF}"/>
               </a:ext>
             </a:extLst>
           </p:cNvPr>
@@ -1073,7 +1073,7 @@
           <p:cNvPr id="2" name="Subtitle">
             <a:extLst xmlns:a="http://schemas.openxmlformats.org/drawingml/2006/main">
               <a:ext uri="{FF2B5EF4-FFF2-40B4-BE49-F238E27FC236}">
-                <a16:creationId xmlns:a16="http://schemas.microsoft.com/office/drawing/2014/main" id="{029FF5D8-CC7E-42B9-B6F5-4BA45F20D648}"/>
+                <a16:creationId xmlns:a16="http://schemas.microsoft.com/office/drawing/2014/main" id="{65624BF4-70AE-4655-82AB-139943EA8611}"/>
               </a:ext>
             </a:extLst>
           </p:cNvPr>
@@ -1319,7 +1319,7 @@
           <p:cNvPr id="2" name="Section title">
             <a:extLst xmlns:a="http://schemas.openxmlformats.org/drawingml/2006/main">
               <a:ext uri="{FF2B5EF4-FFF2-40B4-BE49-F238E27FC236}">
-                <a16:creationId xmlns:a16="http://schemas.microsoft.com/office/drawing/2014/main" id="{8440512D-43F4-4A00-B779-82F7335BF10D}"/>
+                <a16:creationId xmlns:a16="http://schemas.microsoft.com/office/drawing/2014/main" id="{C0E0FF07-A198-4AFB-B6C2-89C01BA4B913}"/>
               </a:ext>
             </a:extLst>
           </p:cNvPr>
@@ -1565,7 +1565,7 @@
           <p:cNvPr id="3" name="Title">
             <a:extLst xmlns:a="http://schemas.openxmlformats.org/drawingml/2006/main">
               <a:ext uri="{FF2B5EF4-FFF2-40B4-BE49-F238E27FC236}">
-                <a16:creationId xmlns:a16="http://schemas.microsoft.com/office/drawing/2014/main" id="{F1AAD3C8-08F0-4857-89AC-CD99A148C2B9}"/>
+                <a16:creationId xmlns:a16="http://schemas.microsoft.com/office/drawing/2014/main" id="{D04C22A3-9E87-4A64-977F-5EB75D4B0224}"/>
               </a:ext>
             </a:extLst>
           </p:cNvPr>
@@ -1794,7 +1794,7 @@
           <p:cNvPr id="2" name="Body">
             <a:extLst xmlns:a="http://schemas.openxmlformats.org/drawingml/2006/main">
               <a:ext uri="{FF2B5EF4-FFF2-40B4-BE49-F238E27FC236}">
-                <a16:creationId xmlns:a16="http://schemas.microsoft.com/office/drawing/2014/main" id="{80F29E72-91EA-482C-9414-1A508D5A650F}"/>
+                <a16:creationId xmlns:a16="http://schemas.microsoft.com/office/drawing/2014/main" id="{9E4296BE-8C36-47A2-B4AF-BDE29C8FF6DC}"/>
               </a:ext>
             </a:extLst>
           </p:cNvPr>
@@ -2040,7 +2040,7 @@
           <p:cNvPr id="4" name="Title">
             <a:extLst xmlns:a="http://schemas.openxmlformats.org/drawingml/2006/main">
               <a:ext uri="{FF2B5EF4-FFF2-40B4-BE49-F238E27FC236}">
-                <a16:creationId xmlns:a16="http://schemas.microsoft.com/office/drawing/2014/main" id="{4F508001-67A5-4E67-BEE1-57A1320BB2AE}"/>
+                <a16:creationId xmlns:a16="http://schemas.microsoft.com/office/drawing/2014/main" id="{BDAD9003-144C-4FB4-A36F-7F4032485C41}"/>
               </a:ext>
             </a:extLst>
           </p:cNvPr>
@@ -2269,7 +2269,7 @@
           <p:cNvPr id="2" name="Left column">
             <a:extLst xmlns:a="http://schemas.openxmlformats.org/drawingml/2006/main">
               <a:ext uri="{FF2B5EF4-FFF2-40B4-BE49-F238E27FC236}">
-                <a16:creationId xmlns:a16="http://schemas.microsoft.com/office/drawing/2014/main" id="{3A88138D-4B66-4976-87A3-1F4BBCFFEAB1}"/>
+                <a16:creationId xmlns:a16="http://schemas.microsoft.com/office/drawing/2014/main" id="{4139F898-7715-4851-8513-0AEC96B1FBF8}"/>
               </a:ext>
             </a:extLst>
           </p:cNvPr>
@@ -2498,7 +2498,7 @@
           <p:cNvPr id="3" name="Right column">
             <a:extLst xmlns:a="http://schemas.openxmlformats.org/drawingml/2006/main">
               <a:ext uri="{FF2B5EF4-FFF2-40B4-BE49-F238E27FC236}">
-                <a16:creationId xmlns:a16="http://schemas.microsoft.com/office/drawing/2014/main" id="{E69D834F-2E24-43AE-AAFA-7911D73C8307}"/>
+                <a16:creationId xmlns:a16="http://schemas.microsoft.com/office/drawing/2014/main" id="{71B4DF7C-11F3-4510-91F3-EA217DCC4DA1}"/>
               </a:ext>
             </a:extLst>
           </p:cNvPr>
@@ -2744,7 +2744,7 @@
           <p:cNvPr id="3" name="Title">
             <a:extLst xmlns:a="http://schemas.openxmlformats.org/drawingml/2006/main">
               <a:ext uri="{FF2B5EF4-FFF2-40B4-BE49-F238E27FC236}">
-                <a16:creationId xmlns:a16="http://schemas.microsoft.com/office/drawing/2014/main" id="{715E5909-23F0-436C-AB6A-8C6E8485DAC7}"/>
+                <a16:creationId xmlns:a16="http://schemas.microsoft.com/office/drawing/2014/main" id="{F9532AC1-C99F-42D9-A6CB-03E699D2091B}"/>
               </a:ext>
             </a:extLst>
           </p:cNvPr>
@@ -2973,7 +2973,7 @@
           <p:cNvPr id="2" name="Left column">
             <a:extLst xmlns:a="http://schemas.openxmlformats.org/drawingml/2006/main">
               <a:ext uri="{FF2B5EF4-FFF2-40B4-BE49-F238E27FC236}">
-                <a16:creationId xmlns:a16="http://schemas.microsoft.com/office/drawing/2014/main" id="{A97392BF-3E83-48DC-B32D-CEEF2CF7E155}"/>
+                <a16:creationId xmlns:a16="http://schemas.microsoft.com/office/drawing/2014/main" id="{2ED607A7-4ED2-4091-B2BA-37A1C8C22730}"/>
               </a:ext>
             </a:extLst>
           </p:cNvPr>
@@ -3240,12 +3240,12 @@
   </p:cSld>
   <p:clrMap bg1="lt1" tx1="dk1" bg2="lt2" tx2="dk2" accent1="accent1" accent2="accent2" accent3="accent3" accent4="accent4" accent5="accent5" accent6="accent6" hlink="hlink" folHlink="folHlink"/>
   <p:sldLayoutIdLst>
-    <p:sldLayoutId xmlns:r="http://schemas.openxmlformats.org/officeDocument/2006/relationships" id="2147483649" r:id="R1125b81a8e8a4aa9"/>
-    <p:sldLayoutId xmlns:r="http://schemas.openxmlformats.org/officeDocument/2006/relationships" id="2147483650" r:id="R5085602f80b04013"/>
-    <p:sldLayoutId xmlns:r="http://schemas.openxmlformats.org/officeDocument/2006/relationships" id="2147483651" r:id="R2d539a70107b43ce"/>
-    <p:sldLayoutId xmlns:r="http://schemas.openxmlformats.org/officeDocument/2006/relationships" id="2147483652" r:id="R898328d176ba4d14"/>
-    <p:sldLayoutId xmlns:r="http://schemas.openxmlformats.org/officeDocument/2006/relationships" id="2147483653" r:id="R413120d20e494340"/>
-    <p:sldLayoutId xmlns:r="http://schemas.openxmlformats.org/officeDocument/2006/relationships" id="2147483654" r:id="R52696566373f4061"/>
+    <p:sldLayoutId xmlns:r="http://schemas.openxmlformats.org/officeDocument/2006/relationships" id="2147483649" r:id="R64175f3b41214590"/>
+    <p:sldLayoutId xmlns:r="http://schemas.openxmlformats.org/officeDocument/2006/relationships" id="2147483650" r:id="R3c3da4ba175143bb"/>
+    <p:sldLayoutId xmlns:r="http://schemas.openxmlformats.org/officeDocument/2006/relationships" id="2147483651" r:id="Rdf59846def474ce3"/>
+    <p:sldLayoutId xmlns:r="http://schemas.openxmlformats.org/officeDocument/2006/relationships" id="2147483652" r:id="R8dd6e6137b1d4ff4"/>
+    <p:sldLayoutId xmlns:r="http://schemas.openxmlformats.org/officeDocument/2006/relationships" id="2147483653" r:id="R04aaccf78fb746c6"/>
+    <p:sldLayoutId xmlns:r="http://schemas.openxmlformats.org/officeDocument/2006/relationships" id="2147483654" r:id="Re26275e3dd9e4e27"/>
   </p:sldLayoutIdLst>
   <p:txStyles>
     <p:titleStyle>
@@ -3796,7 +3796,7 @@
           <p:cNvPr id="2" name="">
             <a:extLst xmlns:a="http://schemas.openxmlformats.org/drawingml/2006/main">
               <a:ext uri="{FF2B5EF4-FFF2-40B4-BE49-F238E27FC236}">
-                <a16:creationId xmlns:a16="http://schemas.microsoft.com/office/drawing/2014/main" id="{558D9C6C-C01F-4B80-980F-21893C377993}"/>
+                <a16:creationId xmlns:a16="http://schemas.microsoft.com/office/drawing/2014/main" id="{3E32C2BA-CDA6-4D61-B2BE-7C424A9C61DD}"/>
               </a:ext>
             </a:extLst>
           </p:cNvPr>
@@ -3806,7 +3806,7 @@
           <p:nvPr/>
         </p:nvPicPr>
         <p:blipFill>
-          <a:blip xmlns:r="http://schemas.openxmlformats.org/officeDocument/2006/relationships" xmlns:a="http://schemas.openxmlformats.org/drawingml/2006/main" r:embed="R9c2d0183fc3942a9"/>
+          <a:blip xmlns:r="http://schemas.openxmlformats.org/officeDocument/2006/relationships" xmlns:a="http://schemas.openxmlformats.org/drawingml/2006/main" r:embed="R005f9bb04dde41c2"/>
           <a:stretch xmlns:a="http://schemas.openxmlformats.org/drawingml/2006/main"/>
         </p:blipFill>
         <p:spPr>
@@ -3822,7 +3822,7 @@
     </p:spTree>
     <p:extLst>
       <p:ext uri="{BB962C8B-B14F-4D97-AF65-F5344CB8AC3E}">
-        <p14:creationId xmlns:p14="http://schemas.microsoft.com/office/powerpoint/2010/main" val="1455303302"/>
+        <p14:creationId xmlns:p14="http://schemas.microsoft.com/office/powerpoint/2010/main" val="562503352"/>
       </p:ext>
     </p:extLst>
   </p:cSld>
@@ -3853,7 +3853,7 @@
           <p:cNvPr id="2" name="">
             <a:extLst xmlns:a="http://schemas.openxmlformats.org/drawingml/2006/main">
               <a:ext uri="{FF2B5EF4-FFF2-40B4-BE49-F238E27FC236}">
-                <a16:creationId xmlns:a16="http://schemas.microsoft.com/office/drawing/2014/main" id="{FF0408DF-D856-48A4-9F84-2688EE1E473A}"/>
+                <a16:creationId xmlns:a16="http://schemas.microsoft.com/office/drawing/2014/main" id="{55B28CB2-3312-4403-88E4-1298B18971FD}"/>
               </a:ext>
             </a:extLst>
           </p:cNvPr>
@@ -3863,7 +3863,7 @@
           <p:nvPr/>
         </p:nvPicPr>
         <p:blipFill>
-          <a:blip xmlns:r="http://schemas.openxmlformats.org/officeDocument/2006/relationships" xmlns:a="http://schemas.openxmlformats.org/drawingml/2006/main" r:embed="Rafee4ab5a4e24082"/>
+          <a:blip xmlns:r="http://schemas.openxmlformats.org/officeDocument/2006/relationships" xmlns:a="http://schemas.openxmlformats.org/drawingml/2006/main" r:embed="Rca58037801794b68"/>
           <a:stretch xmlns:a="http://schemas.openxmlformats.org/drawingml/2006/main"/>
         </p:blipFill>
         <p:spPr>
@@ -3879,7 +3879,7 @@
     </p:spTree>
     <p:extLst>
       <p:ext uri="{BB962C8B-B14F-4D97-AF65-F5344CB8AC3E}">
-        <p14:creationId xmlns:p14="http://schemas.microsoft.com/office/powerpoint/2010/main" val="217791931"/>
+        <p14:creationId xmlns:p14="http://schemas.microsoft.com/office/powerpoint/2010/main" val="869642108"/>
       </p:ext>
     </p:extLst>
   </p:cSld>
@@ -3910,7 +3910,7 @@
           <p:cNvPr id="3" name="">
             <a:extLst xmlns:a="http://schemas.openxmlformats.org/drawingml/2006/main">
               <a:ext uri="{FF2B5EF4-FFF2-40B4-BE49-F238E27FC236}">
-                <a16:creationId xmlns:a16="http://schemas.microsoft.com/office/drawing/2014/main" id="{3087E8CE-113C-4EAF-9785-17DD3290B47D}"/>
+                <a16:creationId xmlns:a16="http://schemas.microsoft.com/office/drawing/2014/main" id="{B7EF89D7-61F1-4660-972C-D18263C99147}"/>
               </a:ext>
             </a:extLst>
           </p:cNvPr>
@@ -3920,7 +3920,7 @@
           <p:nvPr/>
         </p:nvPicPr>
         <p:blipFill>
-          <a:blip xmlns:r="http://schemas.openxmlformats.org/officeDocument/2006/relationships" xmlns:a="http://schemas.openxmlformats.org/drawingml/2006/main" r:embed="Rc648b4e6d5764b93"/>
+          <a:blip xmlns:r="http://schemas.openxmlformats.org/officeDocument/2006/relationships" xmlns:a="http://schemas.openxmlformats.org/drawingml/2006/main" r:embed="Rbaacde7e73314847"/>
           <a:stretch xmlns:a="http://schemas.openxmlformats.org/drawingml/2006/main"/>
         </p:blipFill>
         <p:spPr>
@@ -3938,7 +3938,7 @@
           <p:cNvPr id="2" name="hotspot-1">
             <a:extLst xmlns:a="http://schemas.openxmlformats.org/drawingml/2006/main">
               <a:ext uri="{FF2B5EF4-FFF2-40B4-BE49-F238E27FC236}">
-                <a16:creationId xmlns:a16="http://schemas.microsoft.com/office/drawing/2014/main" id="{2C5B558F-671B-479D-AF43-5CFDFD642369}"/>
+                <a16:creationId xmlns:a16="http://schemas.microsoft.com/office/drawing/2014/main" id="{A7DF9FAD-D37B-4236-84A7-0F2FB4A990EF}"/>
               </a:ext>
             </a:extLst>
             <ns0:hlinkClick xmlns:ns0="http://schemas.openxmlformats.org/drawingml/2006/main" xmlns:ns1="http://schemas.openxmlformats.org/officeDocument/2006/relationships" ns1:id="rIdClick1"/>
@@ -3969,7 +3969,7 @@
     </p:spTree>
     <p:extLst>
       <p:ext uri="{BB962C8B-B14F-4D97-AF65-F5344CB8AC3E}">
-        <p14:creationId xmlns:p14="http://schemas.microsoft.com/office/powerpoint/2010/main" val="1454193177"/>
+        <p14:creationId xmlns:p14="http://schemas.microsoft.com/office/powerpoint/2010/main" val="476394012"/>
       </p:ext>
     </p:extLst>
   </p:cSld>
@@ -4000,7 +4000,7 @@
           <p:cNvPr id="4" name="">
             <a:extLst xmlns:a="http://schemas.openxmlformats.org/drawingml/2006/main">
               <a:ext uri="{FF2B5EF4-FFF2-40B4-BE49-F238E27FC236}">
-                <a16:creationId xmlns:a16="http://schemas.microsoft.com/office/drawing/2014/main" id="{7C39D128-DE9E-4072-B4C3-60EEDDEC834F}"/>
+                <a16:creationId xmlns:a16="http://schemas.microsoft.com/office/drawing/2014/main" id="{66A678F8-C21C-4FB0-B946-9F29CAB7187A}"/>
               </a:ext>
             </a:extLst>
           </p:cNvPr>
@@ -4010,7 +4010,7 @@
           <p:nvPr/>
         </p:nvPicPr>
         <p:blipFill>
-          <a:blip xmlns:r="http://schemas.openxmlformats.org/officeDocument/2006/relationships" xmlns:a="http://schemas.openxmlformats.org/drawingml/2006/main" r:embed="R91d1a7479d304b3a"/>
+          <a:blip xmlns:r="http://schemas.openxmlformats.org/officeDocument/2006/relationships" xmlns:a="http://schemas.openxmlformats.org/drawingml/2006/main" r:embed="Rfe35959ec77a495e"/>
           <a:stretch xmlns:a="http://schemas.openxmlformats.org/drawingml/2006/main"/>
         </p:blipFill>
         <p:spPr>
@@ -4028,7 +4028,7 @@
           <p:cNvPr id="2" name="hotspot-1">
             <a:extLst xmlns:a="http://schemas.openxmlformats.org/drawingml/2006/main">
               <a:ext uri="{FF2B5EF4-FFF2-40B4-BE49-F238E27FC236}">
-                <a16:creationId xmlns:a16="http://schemas.microsoft.com/office/drawing/2014/main" id="{24D1358D-9726-44AF-90C1-2559704595B2}"/>
+                <a16:creationId xmlns:a16="http://schemas.microsoft.com/office/drawing/2014/main" id="{A8A0EF92-0589-43A1-870B-4218A3E98B1D}"/>
               </a:ext>
             </a:extLst>
             <ns0:hlinkClick xmlns:ns0="http://schemas.openxmlformats.org/drawingml/2006/main" xmlns:ns1="http://schemas.openxmlformats.org/officeDocument/2006/relationships" ns1:id="rIdClick1"/>
@@ -4061,7 +4061,7 @@
           <p:cNvPr id="3" name="hotspot-2">
             <a:extLst xmlns:a="http://schemas.openxmlformats.org/drawingml/2006/main">
               <a:ext uri="{FF2B5EF4-FFF2-40B4-BE49-F238E27FC236}">
-                <a16:creationId xmlns:a16="http://schemas.microsoft.com/office/drawing/2014/main" id="{8A44F953-3C35-4250-A69D-38CBBB95061D}"/>
+                <a16:creationId xmlns:a16="http://schemas.microsoft.com/office/drawing/2014/main" id="{6BB12C95-FA42-419D-BCF9-D1866220435F}"/>
               </a:ext>
             </a:extLst>
             <ns2:hlinkClick xmlns:ns2="http://schemas.openxmlformats.org/drawingml/2006/main" xmlns:ns3="http://schemas.openxmlformats.org/officeDocument/2006/relationships" ns3:id="rIdClick2"/>
@@ -4092,7 +4092,7 @@
     </p:spTree>
     <p:extLst>
       <p:ext uri="{BB962C8B-B14F-4D97-AF65-F5344CB8AC3E}">
-        <p14:creationId xmlns:p14="http://schemas.microsoft.com/office/powerpoint/2010/main" val="1024873678"/>
+        <p14:creationId xmlns:p14="http://schemas.microsoft.com/office/powerpoint/2010/main" val="1941081783"/>
       </p:ext>
     </p:extLst>
   </p:cSld>
@@ -4123,7 +4123,7 @@
           <p:cNvPr id="5" name="">
             <a:extLst xmlns:a="http://schemas.openxmlformats.org/drawingml/2006/main">
               <a:ext uri="{FF2B5EF4-FFF2-40B4-BE49-F238E27FC236}">
-                <a16:creationId xmlns:a16="http://schemas.microsoft.com/office/drawing/2014/main" id="{2456E9B7-F765-4AE5-9AB4-0D854510A058}"/>
+                <a16:creationId xmlns:a16="http://schemas.microsoft.com/office/drawing/2014/main" id="{10B94A31-E935-43C1-B4D0-E5CFE0EA5B9B}"/>
               </a:ext>
             </a:extLst>
           </p:cNvPr>
@@ -4133,7 +4133,7 @@
           <p:nvPr/>
         </p:nvPicPr>
         <p:blipFill>
-          <a:blip xmlns:r="http://schemas.openxmlformats.org/officeDocument/2006/relationships" xmlns:a="http://schemas.openxmlformats.org/drawingml/2006/main" r:embed="Rde6747d4770744f2"/>
+          <a:blip xmlns:r="http://schemas.openxmlformats.org/officeDocument/2006/relationships" xmlns:a="http://schemas.openxmlformats.org/drawingml/2006/main" r:embed="R5cbfe296a59c40c2"/>
           <a:stretch xmlns:a="http://schemas.openxmlformats.org/drawingml/2006/main"/>
         </p:blipFill>
         <p:spPr>
@@ -4151,7 +4151,7 @@
           <p:cNvPr id="2" name="hotspot-1">
             <a:extLst xmlns:a="http://schemas.openxmlformats.org/drawingml/2006/main">
               <a:ext uri="{FF2B5EF4-FFF2-40B4-BE49-F238E27FC236}">
-                <a16:creationId xmlns:a16="http://schemas.microsoft.com/office/drawing/2014/main" id="{3F0764B7-AEAF-480F-91C4-9150CDECA25D}"/>
+                <a16:creationId xmlns:a16="http://schemas.microsoft.com/office/drawing/2014/main" id="{D9D5FE0B-097B-4940-8D1F-1EEA9FC0D2B0}"/>
               </a:ext>
             </a:extLst>
             <ns0:hlinkClick xmlns:ns0="http://schemas.openxmlformats.org/drawingml/2006/main" xmlns:ns1="http://schemas.openxmlformats.org/officeDocument/2006/relationships" ns1:id="rIdClick1"/>
@@ -4184,7 +4184,7 @@
           <p:cNvPr id="3" name="hotspot-2">
             <a:extLst xmlns:a="http://schemas.openxmlformats.org/drawingml/2006/main">
               <a:ext uri="{FF2B5EF4-FFF2-40B4-BE49-F238E27FC236}">
-                <a16:creationId xmlns:a16="http://schemas.microsoft.com/office/drawing/2014/main" id="{D997E9E5-63B4-425D-AF87-76FE7261B668}"/>
+                <a16:creationId xmlns:a16="http://schemas.microsoft.com/office/drawing/2014/main" id="{6D7DCB18-7EA2-427A-A6D3-A3B3496C820F}"/>
               </a:ext>
             </a:extLst>
             <ns2:hlinkClick xmlns:ns2="http://schemas.openxmlformats.org/drawingml/2006/main" xmlns:ns3="http://schemas.openxmlformats.org/officeDocument/2006/relationships" ns3:id="rIdClick2"/>
@@ -4217,7 +4217,7 @@
           <p:cNvPr id="4" name="hotspot-3">
             <a:extLst xmlns:a="http://schemas.openxmlformats.org/drawingml/2006/main">
               <a:ext uri="{FF2B5EF4-FFF2-40B4-BE49-F238E27FC236}">
-                <a16:creationId xmlns:a16="http://schemas.microsoft.com/office/drawing/2014/main" id="{7BDFC04C-2D78-41EF-9D3B-7215B5ABE3E5}"/>
+                <a16:creationId xmlns:a16="http://schemas.microsoft.com/office/drawing/2014/main" id="{E124692C-6768-410A-87AB-1CC01D3E5D3B}"/>
               </a:ext>
             </a:extLst>
             <ns4:hlinkClick xmlns:ns4="http://schemas.openxmlformats.org/drawingml/2006/main" xmlns:ns5="http://schemas.openxmlformats.org/officeDocument/2006/relationships" ns5:id="rIdClick3"/>
@@ -4248,7 +4248,7 @@
     </p:spTree>
     <p:extLst>
       <p:ext uri="{BB962C8B-B14F-4D97-AF65-F5344CB8AC3E}">
-        <p14:creationId xmlns:p14="http://schemas.microsoft.com/office/powerpoint/2010/main" val="960048804"/>
+        <p14:creationId xmlns:p14="http://schemas.microsoft.com/office/powerpoint/2010/main" val="955424941"/>
       </p:ext>
     </p:extLst>
   </p:cSld>
@@ -4279,7 +4279,7 @@
           <p:cNvPr id="9" name="">
             <a:extLst xmlns:a="http://schemas.openxmlformats.org/drawingml/2006/main">
               <a:ext uri="{FF2B5EF4-FFF2-40B4-BE49-F238E27FC236}">
-                <a16:creationId xmlns:a16="http://schemas.microsoft.com/office/drawing/2014/main" id="{64C0A09D-95C9-4A87-BD5B-E2968D3F553A}"/>
+                <a16:creationId xmlns:a16="http://schemas.microsoft.com/office/drawing/2014/main" id="{0B56EA57-8760-439C-8D4C-CB54F95379F0}"/>
               </a:ext>
             </a:extLst>
           </p:cNvPr>
@@ -4289,7 +4289,7 @@
           <p:nvPr/>
         </p:nvPicPr>
         <p:blipFill>
-          <a:blip xmlns:r="http://schemas.openxmlformats.org/officeDocument/2006/relationships" xmlns:a="http://schemas.openxmlformats.org/drawingml/2006/main" r:embed="R9248ead78b834de9"/>
+          <a:blip xmlns:r="http://schemas.openxmlformats.org/officeDocument/2006/relationships" xmlns:a="http://schemas.openxmlformats.org/drawingml/2006/main" r:embed="R9e1495aadc304810"/>
           <a:stretch xmlns:a="http://schemas.openxmlformats.org/drawingml/2006/main"/>
         </p:blipFill>
         <p:spPr>
@@ -4307,7 +4307,7 @@
           <p:cNvPr id="2" name="hotspot-1">
             <a:extLst xmlns:a="http://schemas.openxmlformats.org/drawingml/2006/main">
               <a:ext uri="{FF2B5EF4-FFF2-40B4-BE49-F238E27FC236}">
-                <a16:creationId xmlns:a16="http://schemas.microsoft.com/office/drawing/2014/main" id="{748C022C-5193-4288-B6B4-D32EB4617399}"/>
+                <a16:creationId xmlns:a16="http://schemas.microsoft.com/office/drawing/2014/main" id="{41CE4041-A94B-4865-B7CE-7A1C4CE9442F}"/>
               </a:ext>
             </a:extLst>
             <ns0:hlinkClick xmlns:ns0="http://schemas.openxmlformats.org/drawingml/2006/main" xmlns:ns1="http://schemas.openxmlformats.org/officeDocument/2006/relationships" ns1:id="rIdClick1"/>
@@ -4340,7 +4340,7 @@
           <p:cNvPr id="3" name="hotspot-2">
             <a:extLst xmlns:a="http://schemas.openxmlformats.org/drawingml/2006/main">
               <a:ext uri="{FF2B5EF4-FFF2-40B4-BE49-F238E27FC236}">
-                <a16:creationId xmlns:a16="http://schemas.microsoft.com/office/drawing/2014/main" id="{9C6E67C1-D6D0-4C27-90D6-857E4DD517B8}"/>
+                <a16:creationId xmlns:a16="http://schemas.microsoft.com/office/drawing/2014/main" id="{8957E1DA-760B-4D16-A01C-B314BDC9AA11}"/>
               </a:ext>
             </a:extLst>
             <ns2:hlinkClick xmlns:ns2="http://schemas.openxmlformats.org/drawingml/2006/main" xmlns:ns3="http://schemas.openxmlformats.org/officeDocument/2006/relationships" ns3:id="rIdClick2"/>
@@ -4373,7 +4373,7 @@
           <p:cNvPr id="4" name="hotspot-3">
             <a:extLst xmlns:a="http://schemas.openxmlformats.org/drawingml/2006/main">
               <a:ext uri="{FF2B5EF4-FFF2-40B4-BE49-F238E27FC236}">
-                <a16:creationId xmlns:a16="http://schemas.microsoft.com/office/drawing/2014/main" id="{5F796726-9A8F-4DDD-A9E5-9C016125D812}"/>
+                <a16:creationId xmlns:a16="http://schemas.microsoft.com/office/drawing/2014/main" id="{5B9BB20C-E8B8-479B-A2B7-BFB327072427}"/>
               </a:ext>
             </a:extLst>
             <ns4:hlinkClick xmlns:ns4="http://schemas.openxmlformats.org/drawingml/2006/main" xmlns:ns5="http://schemas.openxmlformats.org/officeDocument/2006/relationships" ns5:id="rIdClick3"/>
@@ -4406,7 +4406,7 @@
           <p:cNvPr id="5" name="hotspot-4">
             <a:extLst xmlns:a="http://schemas.openxmlformats.org/drawingml/2006/main">
               <a:ext uri="{FF2B5EF4-FFF2-40B4-BE49-F238E27FC236}">
-                <a16:creationId xmlns:a16="http://schemas.microsoft.com/office/drawing/2014/main" id="{31E843A0-83E7-489E-89C4-176AE0EF6822}"/>
+                <a16:creationId xmlns:a16="http://schemas.microsoft.com/office/drawing/2014/main" id="{C1866DEB-90FD-4433-8B20-3EF3FD09D512}"/>
               </a:ext>
             </a:extLst>
             <ns6:hlinkClick xmlns:ns6="http://schemas.openxmlformats.org/drawingml/2006/main" xmlns:ns7="http://schemas.openxmlformats.org/officeDocument/2006/relationships" ns7:id="rIdClick4"/>
@@ -4439,7 +4439,7 @@
           <p:cNvPr id="6" name="hotspot-5">
             <a:extLst xmlns:a="http://schemas.openxmlformats.org/drawingml/2006/main">
               <a:ext uri="{FF2B5EF4-FFF2-40B4-BE49-F238E27FC236}">
-                <a16:creationId xmlns:a16="http://schemas.microsoft.com/office/drawing/2014/main" id="{48A233BA-F1A6-4488-A84A-1584AAC85D1C}"/>
+                <a16:creationId xmlns:a16="http://schemas.microsoft.com/office/drawing/2014/main" id="{A9BD8475-5F11-47D2-A8DF-AA85FA0A33EB}"/>
               </a:ext>
             </a:extLst>
             <ns8:hlinkClick xmlns:ns8="http://schemas.openxmlformats.org/drawingml/2006/main" xmlns:ns9="http://schemas.openxmlformats.org/officeDocument/2006/relationships" ns9:id="rIdClick5"/>
@@ -4472,7 +4472,7 @@
           <p:cNvPr id="7" name="hotspot-6">
             <a:extLst xmlns:a="http://schemas.openxmlformats.org/drawingml/2006/main">
               <a:ext uri="{FF2B5EF4-FFF2-40B4-BE49-F238E27FC236}">
-                <a16:creationId xmlns:a16="http://schemas.microsoft.com/office/drawing/2014/main" id="{B1034C33-9BA1-45F1-B162-6C848BE638C7}"/>
+                <a16:creationId xmlns:a16="http://schemas.microsoft.com/office/drawing/2014/main" id="{03746347-BACF-4446-B16E-AC91EA1E80A8}"/>
               </a:ext>
             </a:extLst>
             <ns10:hlinkClick xmlns:ns10="http://schemas.openxmlformats.org/drawingml/2006/main" xmlns:ns11="http://schemas.openxmlformats.org/officeDocument/2006/relationships" ns11:id="rIdClick6"/>
@@ -4505,7 +4505,7 @@
           <p:cNvPr id="8" name="hotspot-7">
             <a:extLst xmlns:a="http://schemas.openxmlformats.org/drawingml/2006/main">
               <a:ext uri="{FF2B5EF4-FFF2-40B4-BE49-F238E27FC236}">
-                <a16:creationId xmlns:a16="http://schemas.microsoft.com/office/drawing/2014/main" id="{D7EA1A00-D797-4205-AD2B-06796A1CCADF}"/>
+                <a16:creationId xmlns:a16="http://schemas.microsoft.com/office/drawing/2014/main" id="{8A31529A-0B29-410E-A378-A722EEEDD6F0}"/>
               </a:ext>
             </a:extLst>
             <ns12:hlinkClick xmlns:ns12="http://schemas.openxmlformats.org/drawingml/2006/main" xmlns:ns13="http://schemas.openxmlformats.org/officeDocument/2006/relationships" ns13:id="rIdClick7"/>
@@ -4536,7 +4536,7 @@
     </p:spTree>
     <p:extLst>
       <p:ext uri="{BB962C8B-B14F-4D97-AF65-F5344CB8AC3E}">
-        <p14:creationId xmlns:p14="http://schemas.microsoft.com/office/powerpoint/2010/main" val="1620150984"/>
+        <p14:creationId xmlns:p14="http://schemas.microsoft.com/office/powerpoint/2010/main" val="1848270409"/>
       </p:ext>
     </p:extLst>
   </p:cSld>

</xml_diff>

<commit_message>
Refine PowerPoint cover and audience metrics grid
</commit_message>
<xml_diff>
--- a/GIUMS-MediaKit-EN.pptx
+++ b/GIUMS-MediaKit-EN.pptx
@@ -2,18 +2,18 @@
 <file path=ppt/presentation.xml><?xml version="1.0" encoding="utf-8"?>
 <p:presentation xmlns:p="http://schemas.openxmlformats.org/presentationml/2006/main">
   <p:sldMasterIdLst>
-    <p:sldMasterId xmlns:r="http://schemas.openxmlformats.org/officeDocument/2006/relationships" id="2147483648" r:id="R51d93df5a8ff4e76"/>
+    <p:sldMasterId xmlns:r="http://schemas.openxmlformats.org/officeDocument/2006/relationships" id="2147483648" r:id="R0cce1cc69a584324"/>
   </p:sldMasterIdLst>
   <p:notesMasterIdLst>
-    <p:notesMasterId xmlns:r="http://schemas.openxmlformats.org/officeDocument/2006/relationships" r:id="Re7ad6b65d2a14fd2"/>
+    <p:notesMasterId xmlns:r="http://schemas.openxmlformats.org/officeDocument/2006/relationships" r:id="Ra30d3af13c61400c"/>
   </p:notesMasterIdLst>
   <p:sldIdLst>
-    <p:sldId xmlns:r="http://schemas.openxmlformats.org/officeDocument/2006/relationships" id="256" r:id="R83dca1716c8c4594"/>
-    <p:sldId xmlns:r="http://schemas.openxmlformats.org/officeDocument/2006/relationships" id="257" r:id="R015a639332c84867"/>
-    <p:sldId xmlns:r="http://schemas.openxmlformats.org/officeDocument/2006/relationships" id="258" r:id="R17e68e5ed3ba41b9"/>
-    <p:sldId xmlns:r="http://schemas.openxmlformats.org/officeDocument/2006/relationships" id="259" r:id="Rc66a4ed25992472e"/>
-    <p:sldId xmlns:r="http://schemas.openxmlformats.org/officeDocument/2006/relationships" id="260" r:id="R31e8352b324b46a3"/>
-    <p:sldId xmlns:r="http://schemas.openxmlformats.org/officeDocument/2006/relationships" id="261" r:id="Rc93909ba43fd47fb"/>
+    <p:sldId xmlns:r="http://schemas.openxmlformats.org/officeDocument/2006/relationships" id="256" r:id="R42665107bf464e83"/>
+    <p:sldId xmlns:r="http://schemas.openxmlformats.org/officeDocument/2006/relationships" id="257" r:id="R5603f4ccbbf044a7"/>
+    <p:sldId xmlns:r="http://schemas.openxmlformats.org/officeDocument/2006/relationships" id="258" r:id="R62b2054dd13d404e"/>
+    <p:sldId xmlns:r="http://schemas.openxmlformats.org/officeDocument/2006/relationships" id="259" r:id="R0d9486795d794fc0"/>
+    <p:sldId xmlns:r="http://schemas.openxmlformats.org/officeDocument/2006/relationships" id="260" r:id="R4ed5b108d50f465c"/>
+    <p:sldId xmlns:r="http://schemas.openxmlformats.org/officeDocument/2006/relationships" id="261" r:id="Rd48602d07bd04865"/>
   </p:sldIdLst>
   <p:sldSz cx="12192000" cy="6858000"/>
   <p:notesSz cx="6858000" cy="9144000"/>
@@ -844,7 +844,7 @@
           <p:cNvPr id="3" name="Title">
             <a:extLst xmlns:a="http://schemas.openxmlformats.org/drawingml/2006/main">
               <a:ext uri="{FF2B5EF4-FFF2-40B4-BE49-F238E27FC236}">
-                <a16:creationId xmlns:a16="http://schemas.microsoft.com/office/drawing/2014/main" id="{B1B37833-29BE-4805-BC07-502BBB4BAAC6}"/>
+                <a16:creationId xmlns:a16="http://schemas.microsoft.com/office/drawing/2014/main" id="{8AD4D517-E74C-4C02-886F-F3CA18C33178}"/>
               </a:ext>
             </a:extLst>
           </p:cNvPr>
@@ -1073,7 +1073,7 @@
           <p:cNvPr id="2" name="Subtitle">
             <a:extLst xmlns:a="http://schemas.openxmlformats.org/drawingml/2006/main">
               <a:ext uri="{FF2B5EF4-FFF2-40B4-BE49-F238E27FC236}">
-                <a16:creationId xmlns:a16="http://schemas.microsoft.com/office/drawing/2014/main" id="{B25C4BE7-75CE-452A-88D9-0AB8F63E4DFB}"/>
+                <a16:creationId xmlns:a16="http://schemas.microsoft.com/office/drawing/2014/main" id="{F31FDA71-F557-42B5-B7D4-2AB1994F68D3}"/>
               </a:ext>
             </a:extLst>
           </p:cNvPr>
@@ -1319,7 +1319,7 @@
           <p:cNvPr id="2" name="Section title">
             <a:extLst xmlns:a="http://schemas.openxmlformats.org/drawingml/2006/main">
               <a:ext uri="{FF2B5EF4-FFF2-40B4-BE49-F238E27FC236}">
-                <a16:creationId xmlns:a16="http://schemas.microsoft.com/office/drawing/2014/main" id="{6B54121A-012F-4A78-8EE5-7C4E83E0A969}"/>
+                <a16:creationId xmlns:a16="http://schemas.microsoft.com/office/drawing/2014/main" id="{28364DF9-9231-47DB-B9D6-BC8A5F4AABEF}"/>
               </a:ext>
             </a:extLst>
           </p:cNvPr>
@@ -1565,7 +1565,7 @@
           <p:cNvPr id="3" name="Title">
             <a:extLst xmlns:a="http://schemas.openxmlformats.org/drawingml/2006/main">
               <a:ext uri="{FF2B5EF4-FFF2-40B4-BE49-F238E27FC236}">
-                <a16:creationId xmlns:a16="http://schemas.microsoft.com/office/drawing/2014/main" id="{4A8E4B01-963C-4BE0-9CF3-26B5AF5C7E29}"/>
+                <a16:creationId xmlns:a16="http://schemas.microsoft.com/office/drawing/2014/main" id="{C55485D8-2E32-4BFD-AB19-5EDAF28FE7FE}"/>
               </a:ext>
             </a:extLst>
           </p:cNvPr>
@@ -1794,7 +1794,7 @@
           <p:cNvPr id="2" name="Body">
             <a:extLst xmlns:a="http://schemas.openxmlformats.org/drawingml/2006/main">
               <a:ext uri="{FF2B5EF4-FFF2-40B4-BE49-F238E27FC236}">
-                <a16:creationId xmlns:a16="http://schemas.microsoft.com/office/drawing/2014/main" id="{DB7ABB11-BE9C-4139-B983-4B862FD0857B}"/>
+                <a16:creationId xmlns:a16="http://schemas.microsoft.com/office/drawing/2014/main" id="{BDB30232-3C12-402C-BB24-DC87F1894188}"/>
               </a:ext>
             </a:extLst>
           </p:cNvPr>
@@ -2040,7 +2040,7 @@
           <p:cNvPr id="4" name="Title">
             <a:extLst xmlns:a="http://schemas.openxmlformats.org/drawingml/2006/main">
               <a:ext uri="{FF2B5EF4-FFF2-40B4-BE49-F238E27FC236}">
-                <a16:creationId xmlns:a16="http://schemas.microsoft.com/office/drawing/2014/main" id="{8CEBEFEA-09D0-49F0-A222-D35261169947}"/>
+                <a16:creationId xmlns:a16="http://schemas.microsoft.com/office/drawing/2014/main" id="{A6605522-76EC-4CDA-8933-DFC6689027A8}"/>
               </a:ext>
             </a:extLst>
           </p:cNvPr>
@@ -2269,7 +2269,7 @@
           <p:cNvPr id="2" name="Left column">
             <a:extLst xmlns:a="http://schemas.openxmlformats.org/drawingml/2006/main">
               <a:ext uri="{FF2B5EF4-FFF2-40B4-BE49-F238E27FC236}">
-                <a16:creationId xmlns:a16="http://schemas.microsoft.com/office/drawing/2014/main" id="{635D70B5-E850-429A-ADF5-937CAFEAB7AB}"/>
+                <a16:creationId xmlns:a16="http://schemas.microsoft.com/office/drawing/2014/main" id="{79273F5F-8106-453C-8748-85E9E5157892}"/>
               </a:ext>
             </a:extLst>
           </p:cNvPr>
@@ -2498,7 +2498,7 @@
           <p:cNvPr id="3" name="Right column">
             <a:extLst xmlns:a="http://schemas.openxmlformats.org/drawingml/2006/main">
               <a:ext uri="{FF2B5EF4-FFF2-40B4-BE49-F238E27FC236}">
-                <a16:creationId xmlns:a16="http://schemas.microsoft.com/office/drawing/2014/main" id="{A8FE4EB2-BC45-435D-8BB2-1FC9EB579B0C}"/>
+                <a16:creationId xmlns:a16="http://schemas.microsoft.com/office/drawing/2014/main" id="{2F7C8E20-E108-4FEF-8A47-C3B330A5C426}"/>
               </a:ext>
             </a:extLst>
           </p:cNvPr>
@@ -2744,7 +2744,7 @@
           <p:cNvPr id="3" name="Title">
             <a:extLst xmlns:a="http://schemas.openxmlformats.org/drawingml/2006/main">
               <a:ext uri="{FF2B5EF4-FFF2-40B4-BE49-F238E27FC236}">
-                <a16:creationId xmlns:a16="http://schemas.microsoft.com/office/drawing/2014/main" id="{AAB74C02-AA21-4388-9168-F1763B210FCA}"/>
+                <a16:creationId xmlns:a16="http://schemas.microsoft.com/office/drawing/2014/main" id="{57EC7FCF-DC53-400F-A93F-6C1C79E68880}"/>
               </a:ext>
             </a:extLst>
           </p:cNvPr>
@@ -2973,7 +2973,7 @@
           <p:cNvPr id="2" name="Left column">
             <a:extLst xmlns:a="http://schemas.openxmlformats.org/drawingml/2006/main">
               <a:ext uri="{FF2B5EF4-FFF2-40B4-BE49-F238E27FC236}">
-                <a16:creationId xmlns:a16="http://schemas.microsoft.com/office/drawing/2014/main" id="{A8A2EF8D-4009-42ED-974B-7198D26C1992}"/>
+                <a16:creationId xmlns:a16="http://schemas.microsoft.com/office/drawing/2014/main" id="{EFAF6C0F-D04B-4FD0-9439-9B0A1AF28DDA}"/>
               </a:ext>
             </a:extLst>
           </p:cNvPr>
@@ -3240,12 +3240,12 @@
   </p:cSld>
   <p:clrMap bg1="lt1" tx1="dk1" bg2="lt2" tx2="dk2" accent1="accent1" accent2="accent2" accent3="accent3" accent4="accent4" accent5="accent5" accent6="accent6" hlink="hlink" folHlink="folHlink"/>
   <p:sldLayoutIdLst>
-    <p:sldLayoutId xmlns:r="http://schemas.openxmlformats.org/officeDocument/2006/relationships" id="2147483649" r:id="Rc9b906acc9b94231"/>
-    <p:sldLayoutId xmlns:r="http://schemas.openxmlformats.org/officeDocument/2006/relationships" id="2147483650" r:id="R848b160a080b43c0"/>
-    <p:sldLayoutId xmlns:r="http://schemas.openxmlformats.org/officeDocument/2006/relationships" id="2147483651" r:id="R12dd656c07114754"/>
-    <p:sldLayoutId xmlns:r="http://schemas.openxmlformats.org/officeDocument/2006/relationships" id="2147483652" r:id="R3219d68c76ba4cb8"/>
-    <p:sldLayoutId xmlns:r="http://schemas.openxmlformats.org/officeDocument/2006/relationships" id="2147483653" r:id="Rd44fa56c861443f0"/>
-    <p:sldLayoutId xmlns:r="http://schemas.openxmlformats.org/officeDocument/2006/relationships" id="2147483654" r:id="Rf0be267705374516"/>
+    <p:sldLayoutId xmlns:r="http://schemas.openxmlformats.org/officeDocument/2006/relationships" id="2147483649" r:id="Re469f2296e154062"/>
+    <p:sldLayoutId xmlns:r="http://schemas.openxmlformats.org/officeDocument/2006/relationships" id="2147483650" r:id="Rd637862b1dab4022"/>
+    <p:sldLayoutId xmlns:r="http://schemas.openxmlformats.org/officeDocument/2006/relationships" id="2147483651" r:id="Rcba2d2479100491b"/>
+    <p:sldLayoutId xmlns:r="http://schemas.openxmlformats.org/officeDocument/2006/relationships" id="2147483652" r:id="R83e931eb9b864744"/>
+    <p:sldLayoutId xmlns:r="http://schemas.openxmlformats.org/officeDocument/2006/relationships" id="2147483653" r:id="R2b92e1cc954f4d81"/>
+    <p:sldLayoutId xmlns:r="http://schemas.openxmlformats.org/officeDocument/2006/relationships" id="2147483654" r:id="R2dca8672064f45cb"/>
   </p:sldLayoutIdLst>
   <p:txStyles>
     <p:titleStyle>
@@ -3793,10 +3793,10 @@
       </p:grpSpPr>
       <p:sp>
         <p:nvSpPr>
-          <p:cNvPr id="10" name="box-134">
+          <p:cNvPr id="8" name="box-132">
             <a:extLst xmlns:a="http://schemas.openxmlformats.org/drawingml/2006/main">
               <a:ext uri="{FF2B5EF4-FFF2-40B4-BE49-F238E27FC236}">
-                <a16:creationId xmlns:a16="http://schemas.microsoft.com/office/drawing/2014/main" id="{DE297DEC-69D4-4575-A8DF-334D3D41BBE5}"/>
+                <a16:creationId xmlns:a16="http://schemas.microsoft.com/office/drawing/2014/main" id="{892ECB49-4AD4-4970-9B72-C54DF2AAA46B}"/>
               </a:ext>
             </a:extLst>
           </p:cNvPr>
@@ -3823,40 +3823,10 @@
       </p:sp>
       <p:sp>
         <p:nvSpPr>
-          <p:cNvPr id="2" name="box-135">
+          <p:cNvPr id="2" name="text-133">
             <a:extLst xmlns:a="http://schemas.openxmlformats.org/drawingml/2006/main">
               <a:ext uri="{FF2B5EF4-FFF2-40B4-BE49-F238E27FC236}">
-                <a16:creationId xmlns:a16="http://schemas.microsoft.com/office/drawing/2014/main" id="{F6A81FC2-498A-49AB-9F14-9DB0DB5A750A}"/>
-              </a:ext>
-            </a:extLst>
-          </p:cNvPr>
-          <p:cNvSpPr>
-            <a:spLocks xmlns:a="http://schemas.openxmlformats.org/drawingml/2006/main" noGrp="1"/>
-          </p:cNvSpPr>
-          <p:nvPr/>
-        </p:nvSpPr>
-        <p:spPr>
-          <a:xfrm xmlns:a="http://schemas.openxmlformats.org/drawingml/2006/main">
-            <a:off x="0" y="5810250"/>
-            <a:ext cx="12192000" cy="1047750"/>
-          </a:xfrm>
-          <a:prstGeom xmlns:a="http://schemas.openxmlformats.org/drawingml/2006/main" prst="rect">
-            <a:avLst/>
-          </a:prstGeom>
-          <a:solidFill xmlns:a="http://schemas.openxmlformats.org/drawingml/2006/main">
-            <a:srgbClr val="26070F"/>
-          </a:solidFill>
-          <a:ln xmlns:a="http://schemas.openxmlformats.org/drawingml/2006/main" w="0">
-            <a:noFill/>
-          </a:ln>
-        </p:spPr>
-      </p:sp>
-      <p:sp>
-        <p:nvSpPr>
-          <p:cNvPr id="3" name="text-136">
-            <a:extLst xmlns:a="http://schemas.openxmlformats.org/drawingml/2006/main">
-              <a:ext uri="{FF2B5EF4-FFF2-40B4-BE49-F238E27FC236}">
-                <a16:creationId xmlns:a16="http://schemas.microsoft.com/office/drawing/2014/main" id="{DBD71058-7043-4956-A76E-52593B73F4BB}"/>
+                <a16:creationId xmlns:a16="http://schemas.microsoft.com/office/drawing/2014/main" id="{2E991410-3856-4DE5-BDF3-3742CA03D759}"/>
               </a:ext>
             </a:extLst>
           </p:cNvPr>
@@ -4011,10 +3981,10 @@
       </p:sp>
       <p:sp>
         <p:nvSpPr>
-          <p:cNvPr id="4" name="text-137">
+          <p:cNvPr id="3" name="text-134">
             <a:extLst xmlns:a="http://schemas.openxmlformats.org/drawingml/2006/main">
               <a:ext uri="{FF2B5EF4-FFF2-40B4-BE49-F238E27FC236}">
-                <a16:creationId xmlns:a16="http://schemas.microsoft.com/office/drawing/2014/main" id="{C61EC5E8-880C-4E38-8231-7E4BC90B067F}"/>
+                <a16:creationId xmlns:a16="http://schemas.microsoft.com/office/drawing/2014/main" id="{D30FD3E2-F815-4005-8F3A-68568515C3D2}"/>
               </a:ext>
             </a:extLst>
           </p:cNvPr>
@@ -4169,10 +4139,10 @@
       </p:sp>
       <p:sp>
         <p:nvSpPr>
-          <p:cNvPr id="5" name="text-138">
+          <p:cNvPr id="4" name="text-135">
             <a:extLst xmlns:a="http://schemas.openxmlformats.org/drawingml/2006/main">
               <a:ext uri="{FF2B5EF4-FFF2-40B4-BE49-F238E27FC236}">
-                <a16:creationId xmlns:a16="http://schemas.microsoft.com/office/drawing/2014/main" id="{A7698A3E-5104-4DC1-96C2-FE041A0CD7C6}"/>
+                <a16:creationId xmlns:a16="http://schemas.microsoft.com/office/drawing/2014/main" id="{A0BC0012-6027-4264-BB26-B605F7444EC4}"/>
               </a:ext>
             </a:extLst>
           </p:cNvPr>
@@ -4327,10 +4297,10 @@
       </p:sp>
       <p:sp>
         <p:nvSpPr>
-          <p:cNvPr id="6" name="text-139">
+          <p:cNvPr id="5" name="text-136">
             <a:extLst xmlns:a="http://schemas.openxmlformats.org/drawingml/2006/main">
               <a:ext uri="{FF2B5EF4-FFF2-40B4-BE49-F238E27FC236}">
-                <a16:creationId xmlns:a16="http://schemas.microsoft.com/office/drawing/2014/main" id="{3CA836E3-E719-4350-BA43-21F2D8F2FE0D}"/>
+                <a16:creationId xmlns:a16="http://schemas.microsoft.com/office/drawing/2014/main" id="{4E3158F9-BF78-4A16-A689-2CD250E4DD5B}"/>
               </a:ext>
             </a:extLst>
           </p:cNvPr>
@@ -4485,10 +4455,10 @@
       </p:sp>
       <p:sp>
         <p:nvSpPr>
-          <p:cNvPr id="7" name="text-140">
+          <p:cNvPr id="6" name="text-137">
             <a:extLst xmlns:a="http://schemas.openxmlformats.org/drawingml/2006/main">
               <a:ext uri="{FF2B5EF4-FFF2-40B4-BE49-F238E27FC236}">
-                <a16:creationId xmlns:a16="http://schemas.microsoft.com/office/drawing/2014/main" id="{D0B63824-5399-4C25-9A51-37297DD69F7F}"/>
+                <a16:creationId xmlns:a16="http://schemas.microsoft.com/office/drawing/2014/main" id="{EA05390B-81D0-48EE-A861-B67F53F4200F}"/>
               </a:ext>
             </a:extLst>
           </p:cNvPr>
@@ -4643,10 +4613,10 @@
       </p:sp>
       <p:pic>
         <p:nvPicPr>
-          <p:cNvPr id="8" name="">
+          <p:cNvPr id="7" name="">
             <a:extLst xmlns:a="http://schemas.openxmlformats.org/drawingml/2006/main">
               <a:ext uri="{FF2B5EF4-FFF2-40B4-BE49-F238E27FC236}">
-                <a16:creationId xmlns:a16="http://schemas.microsoft.com/office/drawing/2014/main" id="{0B6ACC22-94F2-4E93-B857-6AD71B21410F}"/>
+                <a16:creationId xmlns:a16="http://schemas.microsoft.com/office/drawing/2014/main" id="{4C00B9C9-53DB-4400-B082-6F69DB0CCA66}"/>
               </a:ext>
             </a:extLst>
           </p:cNvPr>
@@ -4656,7 +4626,7 @@
           <p:nvPr/>
         </p:nvPicPr>
         <p:blipFill>
-          <a:blip xmlns:r="http://schemas.openxmlformats.org/officeDocument/2006/relationships" xmlns:a="http://schemas.openxmlformats.org/drawingml/2006/main" r:embed="R679a4828afda4b12"/>
+          <a:blip xmlns:r="http://schemas.openxmlformats.org/officeDocument/2006/relationships" xmlns:a="http://schemas.openxmlformats.org/drawingml/2006/main" r:embed="R65249179533c4ef7"/>
           <a:stretch xmlns:a="http://schemas.openxmlformats.org/drawingml/2006/main"/>
         </p:blipFill>
         <p:spPr>
@@ -4669,40 +4639,10 @@
           </a:prstGeom>
         </p:spPr>
       </p:pic>
-      <p:sp>
-        <p:nvSpPr>
-          <p:cNvPr id="9" name="rule-141">
-            <a:extLst xmlns:a="http://schemas.openxmlformats.org/drawingml/2006/main">
-              <a:ext uri="{FF2B5EF4-FFF2-40B4-BE49-F238E27FC236}">
-                <a16:creationId xmlns:a16="http://schemas.microsoft.com/office/drawing/2014/main" id="{D45CF486-8805-4E13-8815-D3B3E38F0836}"/>
-              </a:ext>
-            </a:extLst>
-          </p:cNvPr>
-          <p:cNvSpPr>
-            <a:spLocks xmlns:a="http://schemas.openxmlformats.org/drawingml/2006/main" noGrp="1"/>
-          </p:cNvSpPr>
-          <p:nvPr/>
-        </p:nvSpPr>
-        <p:spPr>
-          <a:xfrm xmlns:a="http://schemas.openxmlformats.org/drawingml/2006/main">
-            <a:off x="0" y="6791325"/>
-            <a:ext cx="12192000" cy="66675"/>
-          </a:xfrm>
-          <a:prstGeom xmlns:a="http://schemas.openxmlformats.org/drawingml/2006/main" prst="rect">
-            <a:avLst/>
-          </a:prstGeom>
-          <a:solidFill xmlns:a="http://schemas.openxmlformats.org/drawingml/2006/main">
-            <a:srgbClr val="C2142F"/>
-          </a:solidFill>
-          <a:ln xmlns:a="http://schemas.openxmlformats.org/drawingml/2006/main" w="0">
-            <a:noFill/>
-          </a:ln>
-        </p:spPr>
-      </p:sp>
     </p:spTree>
     <p:extLst>
       <p:ext uri="{BB962C8B-B14F-4D97-AF65-F5344CB8AC3E}">
-        <p14:creationId xmlns:p14="http://schemas.microsoft.com/office/powerpoint/2010/main" val="1773056271"/>
+        <p14:creationId xmlns:p14="http://schemas.microsoft.com/office/powerpoint/2010/main" val="310982546"/>
       </p:ext>
     </p:extLst>
   </p:cSld>
@@ -4730,10 +4670,10 @@
       </p:grpSpPr>
       <p:sp>
         <p:nvSpPr>
-          <p:cNvPr id="24" name="text-142">
+          <p:cNvPr id="24" name="text-138">
             <a:extLst xmlns:a="http://schemas.openxmlformats.org/drawingml/2006/main">
               <a:ext uri="{FF2B5EF4-FFF2-40B4-BE49-F238E27FC236}">
-                <a16:creationId xmlns:a16="http://schemas.microsoft.com/office/drawing/2014/main" id="{422ABC1E-E308-4523-9B21-7E38DF91E296}"/>
+                <a16:creationId xmlns:a16="http://schemas.microsoft.com/office/drawing/2014/main" id="{E87A58C9-AE58-469E-8BBF-99949D326BF4}"/>
               </a:ext>
             </a:extLst>
           </p:cNvPr>
@@ -4888,10 +4828,10 @@
       </p:sp>
       <p:sp>
         <p:nvSpPr>
-          <p:cNvPr id="2" name="text-143">
+          <p:cNvPr id="2" name="text-139">
             <a:extLst xmlns:a="http://schemas.openxmlformats.org/drawingml/2006/main">
               <a:ext uri="{FF2B5EF4-FFF2-40B4-BE49-F238E27FC236}">
-                <a16:creationId xmlns:a16="http://schemas.microsoft.com/office/drawing/2014/main" id="{A8CDCE5E-A784-4868-9BC8-E952190846AC}"/>
+                <a16:creationId xmlns:a16="http://schemas.microsoft.com/office/drawing/2014/main" id="{503084A2-CDDE-44F9-8FD9-B63ED83152EE}"/>
               </a:ext>
             </a:extLst>
           </p:cNvPr>
@@ -5046,10 +4986,10 @@
       </p:sp>
       <p:sp>
         <p:nvSpPr>
-          <p:cNvPr id="3" name="rule-144">
+          <p:cNvPr id="3" name="rule-140">
             <a:extLst xmlns:a="http://schemas.openxmlformats.org/drawingml/2006/main">
               <a:ext uri="{FF2B5EF4-FFF2-40B4-BE49-F238E27FC236}">
-                <a16:creationId xmlns:a16="http://schemas.microsoft.com/office/drawing/2014/main" id="{9AC86C81-DF62-4151-A8F1-EEB16BE5B5E8}"/>
+                <a16:creationId xmlns:a16="http://schemas.microsoft.com/office/drawing/2014/main" id="{7DA08BF7-191A-46AA-9987-7BC8BE14512C}"/>
               </a:ext>
             </a:extLst>
           </p:cNvPr>
@@ -5076,10 +5016,10 @@
       </p:sp>
       <p:sp>
         <p:nvSpPr>
-          <p:cNvPr id="4" name="text-145">
+          <p:cNvPr id="4" name="text-141">
             <a:extLst xmlns:a="http://schemas.openxmlformats.org/drawingml/2006/main">
               <a:ext uri="{FF2B5EF4-FFF2-40B4-BE49-F238E27FC236}">
-                <a16:creationId xmlns:a16="http://schemas.microsoft.com/office/drawing/2014/main" id="{FBD9BA09-3E10-42D6-AAB2-61C73B881C1C}"/>
+                <a16:creationId xmlns:a16="http://schemas.microsoft.com/office/drawing/2014/main" id="{94E9B7FE-4E37-4B05-9645-08B4EE5B6859}"/>
               </a:ext>
             </a:extLst>
           </p:cNvPr>
@@ -5234,10 +5174,10 @@
       </p:sp>
       <p:sp>
         <p:nvSpPr>
-          <p:cNvPr id="5" name="text-146">
+          <p:cNvPr id="5" name="text-142">
             <a:extLst xmlns:a="http://schemas.openxmlformats.org/drawingml/2006/main">
               <a:ext uri="{FF2B5EF4-FFF2-40B4-BE49-F238E27FC236}">
-                <a16:creationId xmlns:a16="http://schemas.microsoft.com/office/drawing/2014/main" id="{F18697A5-E80E-4880-A828-47052425DEEF}"/>
+                <a16:creationId xmlns:a16="http://schemas.microsoft.com/office/drawing/2014/main" id="{61795D0A-59BF-4F3F-A2A4-4F871EBB75CD}"/>
               </a:ext>
             </a:extLst>
           </p:cNvPr>
@@ -5395,7 +5335,7 @@
           <p:cNvPr id="6" name="">
             <a:extLst xmlns:a="http://schemas.openxmlformats.org/drawingml/2006/main">
               <a:ext uri="{FF2B5EF4-FFF2-40B4-BE49-F238E27FC236}">
-                <a16:creationId xmlns:a16="http://schemas.microsoft.com/office/drawing/2014/main" id="{2291B738-8D19-4A02-B84F-43D2A70BD4A8}"/>
+                <a16:creationId xmlns:a16="http://schemas.microsoft.com/office/drawing/2014/main" id="{EEB6C901-A9BE-40FB-BD2F-1EB7575E46F1}"/>
               </a:ext>
             </a:extLst>
           </p:cNvPr>
@@ -5405,7 +5345,7 @@
           <p:nvPr/>
         </p:nvPicPr>
         <p:blipFill>
-          <a:blip xmlns:r="http://schemas.openxmlformats.org/officeDocument/2006/relationships" xmlns:a="http://schemas.openxmlformats.org/drawingml/2006/main" r:embed="R0170414faba14330"/>
+          <a:blip xmlns:r="http://schemas.openxmlformats.org/officeDocument/2006/relationships" xmlns:a="http://schemas.openxmlformats.org/drawingml/2006/main" r:embed="R466d34fd0d2c45fd"/>
           <a:srcRect xmlns:a="http://schemas.openxmlformats.org/drawingml/2006/main" l="0" t="6534" r="0" b="6534"/>
           <a:stretch xmlns:a="http://schemas.openxmlformats.org/drawingml/2006/main">
             <a:fillRect l="0" t="0" r="0" b="0"/>
@@ -5423,10 +5363,10 @@
       </p:pic>
       <p:sp>
         <p:nvSpPr>
-          <p:cNvPr id="7" name="rule-147">
+          <p:cNvPr id="7" name="rule-143">
             <a:extLst xmlns:a="http://schemas.openxmlformats.org/drawingml/2006/main">
               <a:ext uri="{FF2B5EF4-FFF2-40B4-BE49-F238E27FC236}">
-                <a16:creationId xmlns:a16="http://schemas.microsoft.com/office/drawing/2014/main" id="{1D03221C-6490-470F-AE16-2D6361A7594A}"/>
+                <a16:creationId xmlns:a16="http://schemas.microsoft.com/office/drawing/2014/main" id="{BAC4EBC0-076D-442D-ACDD-879F4E2DAF0F}"/>
               </a:ext>
             </a:extLst>
           </p:cNvPr>
@@ -5453,10 +5393,10 @@
       </p:sp>
       <p:sp>
         <p:nvSpPr>
-          <p:cNvPr id="8" name="text-148">
+          <p:cNvPr id="8" name="text-144">
             <a:extLst xmlns:a="http://schemas.openxmlformats.org/drawingml/2006/main">
               <a:ext uri="{FF2B5EF4-FFF2-40B4-BE49-F238E27FC236}">
-                <a16:creationId xmlns:a16="http://schemas.microsoft.com/office/drawing/2014/main" id="{BB28D5D1-BF9F-4DBA-AFB7-35AC5EC1E0B6}"/>
+                <a16:creationId xmlns:a16="http://schemas.microsoft.com/office/drawing/2014/main" id="{268F25A9-E072-4220-B607-993972336258}"/>
               </a:ext>
             </a:extLst>
           </p:cNvPr>
@@ -5611,10 +5551,10 @@
       </p:sp>
       <p:sp>
         <p:nvSpPr>
-          <p:cNvPr id="9" name="text-149">
+          <p:cNvPr id="9" name="text-145">
             <a:extLst xmlns:a="http://schemas.openxmlformats.org/drawingml/2006/main">
               <a:ext uri="{FF2B5EF4-FFF2-40B4-BE49-F238E27FC236}">
-                <a16:creationId xmlns:a16="http://schemas.microsoft.com/office/drawing/2014/main" id="{B4C2AB99-5B4E-43C8-B52F-D3547AD6D641}"/>
+                <a16:creationId xmlns:a16="http://schemas.microsoft.com/office/drawing/2014/main" id="{70809EDB-B90E-40C2-9049-3436B02C02A1}"/>
               </a:ext>
             </a:extLst>
           </p:cNvPr>
@@ -5769,10 +5709,10 @@
       </p:sp>
       <p:sp>
         <p:nvSpPr>
-          <p:cNvPr id="10" name="text-150">
+          <p:cNvPr id="10" name="text-146">
             <a:extLst xmlns:a="http://schemas.openxmlformats.org/drawingml/2006/main">
               <a:ext uri="{FF2B5EF4-FFF2-40B4-BE49-F238E27FC236}">
-                <a16:creationId xmlns:a16="http://schemas.microsoft.com/office/drawing/2014/main" id="{82D62DD2-CC91-41EE-81AC-35F21F76FA0F}"/>
+                <a16:creationId xmlns:a16="http://schemas.microsoft.com/office/drawing/2014/main" id="{38FEF51A-E201-4C85-AFEF-C127B844020B}"/>
               </a:ext>
             </a:extLst>
           </p:cNvPr>
@@ -5927,10 +5867,10 @@
       </p:sp>
       <p:sp>
         <p:nvSpPr>
-          <p:cNvPr id="11" name="text-151">
+          <p:cNvPr id="11" name="text-147">
             <a:extLst xmlns:a="http://schemas.openxmlformats.org/drawingml/2006/main">
               <a:ext uri="{FF2B5EF4-FFF2-40B4-BE49-F238E27FC236}">
-                <a16:creationId xmlns:a16="http://schemas.microsoft.com/office/drawing/2014/main" id="{3DEEBA2A-5A97-42A1-A79F-9C734E4F7767}"/>
+                <a16:creationId xmlns:a16="http://schemas.microsoft.com/office/drawing/2014/main" id="{2DFA2A2A-A4F3-4C36-BED4-57E7573E60A9}"/>
               </a:ext>
             </a:extLst>
           </p:cNvPr>
@@ -6085,10 +6025,10 @@
       </p:sp>
       <p:sp>
         <p:nvSpPr>
-          <p:cNvPr id="12" name="text-152">
+          <p:cNvPr id="12" name="text-148">
             <a:extLst xmlns:a="http://schemas.openxmlformats.org/drawingml/2006/main">
               <a:ext uri="{FF2B5EF4-FFF2-40B4-BE49-F238E27FC236}">
-                <a16:creationId xmlns:a16="http://schemas.microsoft.com/office/drawing/2014/main" id="{569D7412-F382-4A44-AB36-732628FDDFE2}"/>
+                <a16:creationId xmlns:a16="http://schemas.microsoft.com/office/drawing/2014/main" id="{720D1A11-C9D6-47B7-94F9-325CEC8A4023}"/>
               </a:ext>
             </a:extLst>
           </p:cNvPr>
@@ -6243,10 +6183,10 @@
       </p:sp>
       <p:sp>
         <p:nvSpPr>
-          <p:cNvPr id="13" name="rule-153">
+          <p:cNvPr id="13" name="rule-149">
             <a:extLst xmlns:a="http://schemas.openxmlformats.org/drawingml/2006/main">
               <a:ext uri="{FF2B5EF4-FFF2-40B4-BE49-F238E27FC236}">
-                <a16:creationId xmlns:a16="http://schemas.microsoft.com/office/drawing/2014/main" id="{2C8FE789-18E0-4491-9776-DEF806827B27}"/>
+                <a16:creationId xmlns:a16="http://schemas.microsoft.com/office/drawing/2014/main" id="{89CD1302-3B19-42A7-8F1D-1F8F6188C426}"/>
               </a:ext>
             </a:extLst>
           </p:cNvPr>
@@ -6276,7 +6216,7 @@
           <p:cNvPr id="14" name="hotspot-1">
             <a:extLst xmlns:a="http://schemas.openxmlformats.org/drawingml/2006/main">
               <a:ext uri="{FF2B5EF4-FFF2-40B4-BE49-F238E27FC236}">
-                <a16:creationId xmlns:a16="http://schemas.microsoft.com/office/drawing/2014/main" id="{5BD285A8-C407-43F7-9E4D-A943398E47B8}"/>
+                <a16:creationId xmlns:a16="http://schemas.microsoft.com/office/drawing/2014/main" id="{CD4386C8-67ED-47B9-A3B2-2047D76ABE4B}"/>
               </a:ext>
             </a:extLst>
             <ns0:hlinkClick xmlns:ns0="http://schemas.openxmlformats.org/drawingml/2006/main" xmlns:ns1="http://schemas.openxmlformats.org/officeDocument/2006/relationships" ns1:id="rIdClick1"/>
@@ -6306,10 +6246,10 @@
       </p:sp>
       <p:sp>
         <p:nvSpPr>
-          <p:cNvPr id="15" name="text-155">
+          <p:cNvPr id="15" name="text-151">
             <a:extLst xmlns:a="http://schemas.openxmlformats.org/drawingml/2006/main">
               <a:ext uri="{FF2B5EF4-FFF2-40B4-BE49-F238E27FC236}">
-                <a16:creationId xmlns:a16="http://schemas.microsoft.com/office/drawing/2014/main" id="{8743E349-BB0F-4F79-BF06-6A8D39D74FF2}"/>
+                <a16:creationId xmlns:a16="http://schemas.microsoft.com/office/drawing/2014/main" id="{AD022267-C33E-4624-9EC9-465A8E7DE8EA}"/>
               </a:ext>
             </a:extLst>
           </p:cNvPr>
@@ -6464,10 +6404,10 @@
       </p:sp>
       <p:sp>
         <p:nvSpPr>
-          <p:cNvPr id="16" name="text-156">
+          <p:cNvPr id="16" name="text-152">
             <a:extLst xmlns:a="http://schemas.openxmlformats.org/drawingml/2006/main">
               <a:ext uri="{FF2B5EF4-FFF2-40B4-BE49-F238E27FC236}">
-                <a16:creationId xmlns:a16="http://schemas.microsoft.com/office/drawing/2014/main" id="{D516D132-72C8-4807-BFB8-4A79DAD4CF3C}"/>
+                <a16:creationId xmlns:a16="http://schemas.microsoft.com/office/drawing/2014/main" id="{852B7B38-20B6-4EDA-BA93-E73FADA0A24A}"/>
               </a:ext>
             </a:extLst>
           </p:cNvPr>
@@ -6622,10 +6562,10 @@
       </p:sp>
       <p:sp>
         <p:nvSpPr>
-          <p:cNvPr id="17" name="rule-157">
+          <p:cNvPr id="17" name="rule-153">
             <a:extLst xmlns:a="http://schemas.openxmlformats.org/drawingml/2006/main">
               <a:ext uri="{FF2B5EF4-FFF2-40B4-BE49-F238E27FC236}">
-                <a16:creationId xmlns:a16="http://schemas.microsoft.com/office/drawing/2014/main" id="{6B7F0494-C713-4092-BD43-45FD523F95FA}"/>
+                <a16:creationId xmlns:a16="http://schemas.microsoft.com/office/drawing/2014/main" id="{283BA426-87F5-4358-8160-89249D1A9434}"/>
               </a:ext>
             </a:extLst>
           </p:cNvPr>
@@ -6655,7 +6595,7 @@
           <p:cNvPr id="18" name="hotspot-2">
             <a:extLst xmlns:a="http://schemas.openxmlformats.org/drawingml/2006/main">
               <a:ext uri="{FF2B5EF4-FFF2-40B4-BE49-F238E27FC236}">
-                <a16:creationId xmlns:a16="http://schemas.microsoft.com/office/drawing/2014/main" id="{83315D9B-8507-429D-8A62-5870A3850D5D}"/>
+                <a16:creationId xmlns:a16="http://schemas.microsoft.com/office/drawing/2014/main" id="{1711299F-1D06-42D0-B941-5D8AFEEF8D2C}"/>
               </a:ext>
             </a:extLst>
             <ns2:hlinkClick xmlns:ns2="http://schemas.openxmlformats.org/drawingml/2006/main" xmlns:ns3="http://schemas.openxmlformats.org/officeDocument/2006/relationships" ns3:id="rIdClick2"/>
@@ -6685,10 +6625,10 @@
       </p:sp>
       <p:sp>
         <p:nvSpPr>
-          <p:cNvPr id="19" name="text-159">
+          <p:cNvPr id="19" name="text-155">
             <a:extLst xmlns:a="http://schemas.openxmlformats.org/drawingml/2006/main">
               <a:ext uri="{FF2B5EF4-FFF2-40B4-BE49-F238E27FC236}">
-                <a16:creationId xmlns:a16="http://schemas.microsoft.com/office/drawing/2014/main" id="{AB4B1B44-19F0-413A-9D62-E91F32A147FA}"/>
+                <a16:creationId xmlns:a16="http://schemas.microsoft.com/office/drawing/2014/main" id="{CE6ED388-7C06-4224-9020-AC565CDE531E}"/>
               </a:ext>
             </a:extLst>
           </p:cNvPr>
@@ -6843,10 +6783,10 @@
       </p:sp>
       <p:sp>
         <p:nvSpPr>
-          <p:cNvPr id="20" name="text-160">
+          <p:cNvPr id="20" name="text-156">
             <a:extLst xmlns:a="http://schemas.openxmlformats.org/drawingml/2006/main">
               <a:ext uri="{FF2B5EF4-FFF2-40B4-BE49-F238E27FC236}">
-                <a16:creationId xmlns:a16="http://schemas.microsoft.com/office/drawing/2014/main" id="{100F8055-4BB9-4FC4-9401-F8F65C88E9D3}"/>
+                <a16:creationId xmlns:a16="http://schemas.microsoft.com/office/drawing/2014/main" id="{AC7F7DA4-9B62-4DD9-AE69-889754DFB542}"/>
               </a:ext>
             </a:extLst>
           </p:cNvPr>
@@ -7001,10 +6941,10 @@
       </p:sp>
       <p:sp>
         <p:nvSpPr>
-          <p:cNvPr id="21" name="rule-161">
+          <p:cNvPr id="21" name="rule-157">
             <a:extLst xmlns:a="http://schemas.openxmlformats.org/drawingml/2006/main">
               <a:ext uri="{FF2B5EF4-FFF2-40B4-BE49-F238E27FC236}">
-                <a16:creationId xmlns:a16="http://schemas.microsoft.com/office/drawing/2014/main" id="{2B04FA18-1BDD-4906-9C87-350C6D1F166A}"/>
+                <a16:creationId xmlns:a16="http://schemas.microsoft.com/office/drawing/2014/main" id="{D7440BC3-D916-4952-9BD3-092D3C6CD47D}"/>
               </a:ext>
             </a:extLst>
           </p:cNvPr>
@@ -7034,7 +6974,7 @@
           <p:cNvPr id="22" name="hotspot-3">
             <a:extLst xmlns:a="http://schemas.openxmlformats.org/drawingml/2006/main">
               <a:ext uri="{FF2B5EF4-FFF2-40B4-BE49-F238E27FC236}">
-                <a16:creationId xmlns:a16="http://schemas.microsoft.com/office/drawing/2014/main" id="{15EAFACE-FD72-4C4C-9197-E68EC621DC4D}"/>
+                <a16:creationId xmlns:a16="http://schemas.microsoft.com/office/drawing/2014/main" id="{1A9D23E8-BFD6-4882-A097-8014FE1B8191}"/>
               </a:ext>
             </a:extLst>
             <ns4:hlinkClick xmlns:ns4="http://schemas.openxmlformats.org/drawingml/2006/main" xmlns:ns5="http://schemas.openxmlformats.org/officeDocument/2006/relationships" ns5:id="rIdClick3"/>
@@ -7064,10 +7004,10 @@
       </p:sp>
       <p:sp>
         <p:nvSpPr>
-          <p:cNvPr id="23" name="text-163">
+          <p:cNvPr id="23" name="text-159">
             <a:extLst xmlns:a="http://schemas.openxmlformats.org/drawingml/2006/main">
               <a:ext uri="{FF2B5EF4-FFF2-40B4-BE49-F238E27FC236}">
-                <a16:creationId xmlns:a16="http://schemas.microsoft.com/office/drawing/2014/main" id="{CC5EEEA0-CA37-4FA0-A7BF-689A2E010A4A}"/>
+                <a16:creationId xmlns:a16="http://schemas.microsoft.com/office/drawing/2014/main" id="{08C205E4-D0B0-4060-9187-B6B1E25D2929}"/>
               </a:ext>
             </a:extLst>
           </p:cNvPr>
@@ -7223,7 +7163,7 @@
     </p:spTree>
     <p:extLst>
       <p:ext uri="{BB962C8B-B14F-4D97-AF65-F5344CB8AC3E}">
-        <p14:creationId xmlns:p14="http://schemas.microsoft.com/office/powerpoint/2010/main" val="2124893539"/>
+        <p14:creationId xmlns:p14="http://schemas.microsoft.com/office/powerpoint/2010/main" val="374731772"/>
       </p:ext>
     </p:extLst>
   </p:cSld>
@@ -7251,10 +7191,10 @@
       </p:grpSpPr>
       <p:sp>
         <p:nvSpPr>
-          <p:cNvPr id="15" name="text-164">
+          <p:cNvPr id="15" name="text-160">
             <a:extLst xmlns:a="http://schemas.openxmlformats.org/drawingml/2006/main">
               <a:ext uri="{FF2B5EF4-FFF2-40B4-BE49-F238E27FC236}">
-                <a16:creationId xmlns:a16="http://schemas.microsoft.com/office/drawing/2014/main" id="{B66063F6-7131-4475-8876-F12858622817}"/>
+                <a16:creationId xmlns:a16="http://schemas.microsoft.com/office/drawing/2014/main" id="{008EC1EB-394D-49EE-BCBD-CE4B5BAE111F}"/>
               </a:ext>
             </a:extLst>
           </p:cNvPr>
@@ -7409,10 +7349,10 @@
       </p:sp>
       <p:sp>
         <p:nvSpPr>
-          <p:cNvPr id="2" name="text-165">
+          <p:cNvPr id="2" name="text-161">
             <a:extLst xmlns:a="http://schemas.openxmlformats.org/drawingml/2006/main">
               <a:ext uri="{FF2B5EF4-FFF2-40B4-BE49-F238E27FC236}">
-                <a16:creationId xmlns:a16="http://schemas.microsoft.com/office/drawing/2014/main" id="{05B64FB3-E727-4F6F-9BAC-9CC019494D13}"/>
+                <a16:creationId xmlns:a16="http://schemas.microsoft.com/office/drawing/2014/main" id="{E283BE96-4AF6-467A-8ABB-C846C5BA4C9B}"/>
               </a:ext>
             </a:extLst>
           </p:cNvPr>
@@ -7567,10 +7507,10 @@
       </p:sp>
       <p:sp>
         <p:nvSpPr>
-          <p:cNvPr id="3" name="rule-166">
+          <p:cNvPr id="3" name="rule-162">
             <a:extLst xmlns:a="http://schemas.openxmlformats.org/drawingml/2006/main">
               <a:ext uri="{FF2B5EF4-FFF2-40B4-BE49-F238E27FC236}">
-                <a16:creationId xmlns:a16="http://schemas.microsoft.com/office/drawing/2014/main" id="{7992D6C3-D5A0-41F8-9BB1-C077A515001A}"/>
+                <a16:creationId xmlns:a16="http://schemas.microsoft.com/office/drawing/2014/main" id="{B6D55C49-41F6-4D3A-A78B-A4465169504B}"/>
               </a:ext>
             </a:extLst>
           </p:cNvPr>
@@ -7597,10 +7537,10 @@
       </p:sp>
       <p:sp>
         <p:nvSpPr>
-          <p:cNvPr id="4" name="text-167">
+          <p:cNvPr id="4" name="text-163">
             <a:extLst xmlns:a="http://schemas.openxmlformats.org/drawingml/2006/main">
               <a:ext uri="{FF2B5EF4-FFF2-40B4-BE49-F238E27FC236}">
-                <a16:creationId xmlns:a16="http://schemas.microsoft.com/office/drawing/2014/main" id="{6996F9E8-246B-4B26-8A79-6674BC999AB8}"/>
+                <a16:creationId xmlns:a16="http://schemas.microsoft.com/office/drawing/2014/main" id="{FDC5FE31-7DCF-4E2B-8286-9E2DED4809FA}"/>
               </a:ext>
             </a:extLst>
           </p:cNvPr>
@@ -7755,10 +7695,10 @@
       </p:sp>
       <p:sp>
         <p:nvSpPr>
-          <p:cNvPr id="5" name="text-168">
+          <p:cNvPr id="5" name="text-164">
             <a:extLst xmlns:a="http://schemas.openxmlformats.org/drawingml/2006/main">
               <a:ext uri="{FF2B5EF4-FFF2-40B4-BE49-F238E27FC236}">
-                <a16:creationId xmlns:a16="http://schemas.microsoft.com/office/drawing/2014/main" id="{6C6680A1-DC32-4742-B175-C7047EB70552}"/>
+                <a16:creationId xmlns:a16="http://schemas.microsoft.com/office/drawing/2014/main" id="{9C6C72D9-042C-411D-BE97-FC54A4D878F6}"/>
               </a:ext>
             </a:extLst>
           </p:cNvPr>
@@ -7913,10 +7853,10 @@
       </p:sp>
       <p:sp>
         <p:nvSpPr>
-          <p:cNvPr id="6" name="text-169">
+          <p:cNvPr id="6" name="text-165">
             <a:extLst xmlns:a="http://schemas.openxmlformats.org/drawingml/2006/main">
               <a:ext uri="{FF2B5EF4-FFF2-40B4-BE49-F238E27FC236}">
-                <a16:creationId xmlns:a16="http://schemas.microsoft.com/office/drawing/2014/main" id="{02832E4F-FA47-40D2-9DC5-A22DA79DDAF9}"/>
+                <a16:creationId xmlns:a16="http://schemas.microsoft.com/office/drawing/2014/main" id="{0E70CEAA-B0D9-45C3-8AE9-B063A8F5F6D8}"/>
               </a:ext>
             </a:extLst>
           </p:cNvPr>
@@ -8071,10 +8011,10 @@
       </p:sp>
       <p:sp>
         <p:nvSpPr>
-          <p:cNvPr id="7" name="text-170">
+          <p:cNvPr id="7" name="text-166">
             <a:extLst xmlns:a="http://schemas.openxmlformats.org/drawingml/2006/main">
               <a:ext uri="{FF2B5EF4-FFF2-40B4-BE49-F238E27FC236}">
-                <a16:creationId xmlns:a16="http://schemas.microsoft.com/office/drawing/2014/main" id="{1439F876-C5FD-43E0-AFF1-AED77357DD13}"/>
+                <a16:creationId xmlns:a16="http://schemas.microsoft.com/office/drawing/2014/main" id="{00F87F39-36AC-43BC-951D-A71D5BB678CA}"/>
               </a:ext>
             </a:extLst>
           </p:cNvPr>
@@ -8229,10 +8169,10 @@
       </p:sp>
       <p:sp>
         <p:nvSpPr>
-          <p:cNvPr id="8" name="text-171">
+          <p:cNvPr id="8" name="text-167">
             <a:extLst xmlns:a="http://schemas.openxmlformats.org/drawingml/2006/main">
               <a:ext uri="{FF2B5EF4-FFF2-40B4-BE49-F238E27FC236}">
-                <a16:creationId xmlns:a16="http://schemas.microsoft.com/office/drawing/2014/main" id="{FD6A542F-A43A-4A9A-B240-2B821B5211DE}"/>
+                <a16:creationId xmlns:a16="http://schemas.microsoft.com/office/drawing/2014/main" id="{7D0469AE-AF52-474D-841E-D60B7C693119}"/>
               </a:ext>
             </a:extLst>
           </p:cNvPr>
@@ -8387,10 +8327,10 @@
       </p:sp>
       <p:sp>
         <p:nvSpPr>
-          <p:cNvPr id="9" name="text-172">
+          <p:cNvPr id="9" name="text-168">
             <a:extLst xmlns:a="http://schemas.openxmlformats.org/drawingml/2006/main">
               <a:ext uri="{FF2B5EF4-FFF2-40B4-BE49-F238E27FC236}">
-                <a16:creationId xmlns:a16="http://schemas.microsoft.com/office/drawing/2014/main" id="{BAE1F5FD-986C-4125-8C85-BA0854C03988}"/>
+                <a16:creationId xmlns:a16="http://schemas.microsoft.com/office/drawing/2014/main" id="{69C5ED07-E356-46F8-A0C1-8DB309610F6A}"/>
               </a:ext>
             </a:extLst>
           </p:cNvPr>
@@ -8545,10 +8485,10 @@
       </p:sp>
       <p:sp>
         <p:nvSpPr>
-          <p:cNvPr id="10" name="rule-173">
+          <p:cNvPr id="10" name="rule-169">
             <a:extLst xmlns:a="http://schemas.openxmlformats.org/drawingml/2006/main">
               <a:ext uri="{FF2B5EF4-FFF2-40B4-BE49-F238E27FC236}">
-                <a16:creationId xmlns:a16="http://schemas.microsoft.com/office/drawing/2014/main" id="{2E2CEE25-C91E-4D08-8DA0-4C38EEFAE787}"/>
+                <a16:creationId xmlns:a16="http://schemas.microsoft.com/office/drawing/2014/main" id="{EDFCFA09-FAA1-49C0-878D-51D1DE753302}"/>
               </a:ext>
             </a:extLst>
           </p:cNvPr>
@@ -8578,7 +8518,7 @@
           <p:cNvPr id="11" name="hotspot-1">
             <a:extLst xmlns:a="http://schemas.openxmlformats.org/drawingml/2006/main">
               <a:ext uri="{FF2B5EF4-FFF2-40B4-BE49-F238E27FC236}">
-                <a16:creationId xmlns:a16="http://schemas.microsoft.com/office/drawing/2014/main" id="{E31FC996-B127-442C-BBD7-1164038D016E}"/>
+                <a16:creationId xmlns:a16="http://schemas.microsoft.com/office/drawing/2014/main" id="{4FB7C62D-5863-4A64-95AA-1E03E745B7D2}"/>
               </a:ext>
             </a:extLst>
             <ns0:hlinkClick xmlns:ns0="http://schemas.openxmlformats.org/drawingml/2006/main" xmlns:ns1="http://schemas.openxmlformats.org/officeDocument/2006/relationships" ns1:id="rIdClick1"/>
@@ -8611,7 +8551,7 @@
           <p:cNvPr id="12" name="">
             <a:extLst xmlns:a="http://schemas.openxmlformats.org/drawingml/2006/main">
               <a:ext uri="{FF2B5EF4-FFF2-40B4-BE49-F238E27FC236}">
-                <a16:creationId xmlns:a16="http://schemas.microsoft.com/office/drawing/2014/main" id="{59B1EAE2-6120-4F31-8D15-C44C6D89E957}"/>
+                <a16:creationId xmlns:a16="http://schemas.microsoft.com/office/drawing/2014/main" id="{47A87F64-0F48-4695-A56F-22BD6B74CFDF}"/>
               </a:ext>
             </a:extLst>
           </p:cNvPr>
@@ -8621,7 +8561,7 @@
           <p:nvPr/>
         </p:nvPicPr>
         <p:blipFill>
-          <a:blip xmlns:r="http://schemas.openxmlformats.org/officeDocument/2006/relationships" xmlns:a="http://schemas.openxmlformats.org/drawingml/2006/main" r:embed="Rea6324a60f444532"/>
+          <a:blip xmlns:r="http://schemas.openxmlformats.org/officeDocument/2006/relationships" xmlns:a="http://schemas.openxmlformats.org/drawingml/2006/main" r:embed="R09921e5850f54d46"/>
           <a:srcRect xmlns:a="http://schemas.openxmlformats.org/drawingml/2006/main" l="16053" t="0" r="16053" b="0"/>
           <a:stretch xmlns:a="http://schemas.openxmlformats.org/drawingml/2006/main">
             <a:fillRect l="0" t="0" r="0" b="0"/>
@@ -8642,7 +8582,7 @@
           <p:cNvPr id="13" name="">
             <a:extLst xmlns:a="http://schemas.openxmlformats.org/drawingml/2006/main">
               <a:ext uri="{FF2B5EF4-FFF2-40B4-BE49-F238E27FC236}">
-                <a16:creationId xmlns:a16="http://schemas.microsoft.com/office/drawing/2014/main" id="{8E7672BA-31ED-4DB8-9E92-2B70EAE4B0BD}"/>
+                <a16:creationId xmlns:a16="http://schemas.microsoft.com/office/drawing/2014/main" id="{692EEF67-F01C-4F57-A911-E12C47DCFAD5}"/>
               </a:ext>
             </a:extLst>
           </p:cNvPr>
@@ -8652,7 +8592,7 @@
           <p:nvPr/>
         </p:nvPicPr>
         <p:blipFill>
-          <a:blip xmlns:r="http://schemas.openxmlformats.org/officeDocument/2006/relationships" xmlns:a="http://schemas.openxmlformats.org/drawingml/2006/main" r:embed="R81498304674c420d"/>
+          <a:blip xmlns:r="http://schemas.openxmlformats.org/officeDocument/2006/relationships" xmlns:a="http://schemas.openxmlformats.org/drawingml/2006/main" r:embed="Rd6e538c503db467e"/>
           <a:srcRect xmlns:a="http://schemas.openxmlformats.org/drawingml/2006/main" l="16053" t="0" r="16053" b="0"/>
           <a:stretch xmlns:a="http://schemas.openxmlformats.org/drawingml/2006/main">
             <a:fillRect l="0" t="0" r="0" b="0"/>
@@ -8673,7 +8613,7 @@
           <p:cNvPr id="14" name="">
             <a:extLst xmlns:a="http://schemas.openxmlformats.org/drawingml/2006/main">
               <a:ext uri="{FF2B5EF4-FFF2-40B4-BE49-F238E27FC236}">
-                <a16:creationId xmlns:a16="http://schemas.microsoft.com/office/drawing/2014/main" id="{CF97381F-1D5A-4284-B983-F84A147456BB}"/>
+                <a16:creationId xmlns:a16="http://schemas.microsoft.com/office/drawing/2014/main" id="{498DA1E2-153D-4253-9140-13A57AEE0F6D}"/>
               </a:ext>
             </a:extLst>
           </p:cNvPr>
@@ -8683,7 +8623,7 @@
           <p:nvPr/>
         </p:nvPicPr>
         <p:blipFill>
-          <a:blip xmlns:r="http://schemas.openxmlformats.org/officeDocument/2006/relationships" xmlns:a="http://schemas.openxmlformats.org/drawingml/2006/main" r:embed="Rbee7f399c5c84c7b"/>
+          <a:blip xmlns:r="http://schemas.openxmlformats.org/officeDocument/2006/relationships" xmlns:a="http://schemas.openxmlformats.org/drawingml/2006/main" r:embed="R453f82647745440e"/>
           <a:srcRect xmlns:a="http://schemas.openxmlformats.org/drawingml/2006/main" l="16053" t="0" r="16053" b="0"/>
           <a:stretch xmlns:a="http://schemas.openxmlformats.org/drawingml/2006/main">
             <a:fillRect l="0" t="0" r="0" b="0"/>
@@ -8702,7 +8642,7 @@
     </p:spTree>
     <p:extLst>
       <p:ext uri="{BB962C8B-B14F-4D97-AF65-F5344CB8AC3E}">
-        <p14:creationId xmlns:p14="http://schemas.microsoft.com/office/powerpoint/2010/main" val="2118725841"/>
+        <p14:creationId xmlns:p14="http://schemas.microsoft.com/office/powerpoint/2010/main" val="558776650"/>
       </p:ext>
     </p:extLst>
   </p:cSld>
@@ -8730,10 +8670,10 @@
       </p:grpSpPr>
       <p:sp>
         <p:nvSpPr>
-          <p:cNvPr id="53" name="text-175">
+          <p:cNvPr id="53" name="text-171">
             <a:extLst xmlns:a="http://schemas.openxmlformats.org/drawingml/2006/main">
               <a:ext uri="{FF2B5EF4-FFF2-40B4-BE49-F238E27FC236}">
-                <a16:creationId xmlns:a16="http://schemas.microsoft.com/office/drawing/2014/main" id="{2A2ACAA3-A8DB-45DC-AB31-807E30EDFBFE}"/>
+                <a16:creationId xmlns:a16="http://schemas.microsoft.com/office/drawing/2014/main" id="{0845FE2A-52CE-40FD-BBCF-DCDF39CBAB8D}"/>
               </a:ext>
             </a:extLst>
           </p:cNvPr>
@@ -8888,10 +8828,10 @@
       </p:sp>
       <p:sp>
         <p:nvSpPr>
-          <p:cNvPr id="2" name="text-176">
+          <p:cNvPr id="2" name="text-172">
             <a:extLst xmlns:a="http://schemas.openxmlformats.org/drawingml/2006/main">
               <a:ext uri="{FF2B5EF4-FFF2-40B4-BE49-F238E27FC236}">
-                <a16:creationId xmlns:a16="http://schemas.microsoft.com/office/drawing/2014/main" id="{5ED421F1-845E-4F2B-B2CF-D6D28FC818DF}"/>
+                <a16:creationId xmlns:a16="http://schemas.microsoft.com/office/drawing/2014/main" id="{21B19472-D429-4E0B-98CF-DA626A218853}"/>
               </a:ext>
             </a:extLst>
           </p:cNvPr>
@@ -9046,10 +8986,10 @@
       </p:sp>
       <p:sp>
         <p:nvSpPr>
-          <p:cNvPr id="3" name="rule-177">
+          <p:cNvPr id="3" name="rule-173">
             <a:extLst xmlns:a="http://schemas.openxmlformats.org/drawingml/2006/main">
               <a:ext uri="{FF2B5EF4-FFF2-40B4-BE49-F238E27FC236}">
-                <a16:creationId xmlns:a16="http://schemas.microsoft.com/office/drawing/2014/main" id="{27BE1401-7221-44BD-81F2-79A8B61CCE8F}"/>
+                <a16:creationId xmlns:a16="http://schemas.microsoft.com/office/drawing/2014/main" id="{0E002973-81B5-4177-B02A-89FE5895519C}"/>
               </a:ext>
             </a:extLst>
           </p:cNvPr>
@@ -9076,10 +9016,10 @@
       </p:sp>
       <p:sp>
         <p:nvSpPr>
-          <p:cNvPr id="4" name="text-178">
+          <p:cNvPr id="4" name="text-174">
             <a:extLst xmlns:a="http://schemas.openxmlformats.org/drawingml/2006/main">
               <a:ext uri="{FF2B5EF4-FFF2-40B4-BE49-F238E27FC236}">
-                <a16:creationId xmlns:a16="http://schemas.microsoft.com/office/drawing/2014/main" id="{8D34FDB9-272E-4545-A2AA-10896AD439CA}"/>
+                <a16:creationId xmlns:a16="http://schemas.microsoft.com/office/drawing/2014/main" id="{91C825B0-C965-46A4-882D-965A8D5E8F61}"/>
               </a:ext>
             </a:extLst>
           </p:cNvPr>
@@ -9234,10 +9174,10 @@
       </p:sp>
       <p:sp>
         <p:nvSpPr>
-          <p:cNvPr id="5" name="text-179">
+          <p:cNvPr id="5" name="text-175">
             <a:extLst xmlns:a="http://schemas.openxmlformats.org/drawingml/2006/main">
               <a:ext uri="{FF2B5EF4-FFF2-40B4-BE49-F238E27FC236}">
-                <a16:creationId xmlns:a16="http://schemas.microsoft.com/office/drawing/2014/main" id="{16A66284-7892-4C2A-86DE-122AD538B486}"/>
+                <a16:creationId xmlns:a16="http://schemas.microsoft.com/office/drawing/2014/main" id="{D5512898-476E-4604-A91F-42FB26BE7E84}"/>
               </a:ext>
             </a:extLst>
           </p:cNvPr>
@@ -9392,10 +9332,10 @@
       </p:sp>
       <p:sp>
         <p:nvSpPr>
-          <p:cNvPr id="6" name="text-180">
+          <p:cNvPr id="6" name="text-176">
             <a:extLst xmlns:a="http://schemas.openxmlformats.org/drawingml/2006/main">
               <a:ext uri="{FF2B5EF4-FFF2-40B4-BE49-F238E27FC236}">
-                <a16:creationId xmlns:a16="http://schemas.microsoft.com/office/drawing/2014/main" id="{FF776B9D-CDF9-44B2-8CB3-273C76E4F886}"/>
+                <a16:creationId xmlns:a16="http://schemas.microsoft.com/office/drawing/2014/main" id="{6A64A987-D318-4977-A81A-1DAC6E4BC2A8}"/>
               </a:ext>
             </a:extLst>
           </p:cNvPr>
@@ -9550,10 +9490,10 @@
       </p:sp>
       <p:sp>
         <p:nvSpPr>
-          <p:cNvPr id="7" name="text-181">
+          <p:cNvPr id="7" name="text-177">
             <a:extLst xmlns:a="http://schemas.openxmlformats.org/drawingml/2006/main">
               <a:ext uri="{FF2B5EF4-FFF2-40B4-BE49-F238E27FC236}">
-                <a16:creationId xmlns:a16="http://schemas.microsoft.com/office/drawing/2014/main" id="{201E81EB-8412-450F-96C6-08DE019974BE}"/>
+                <a16:creationId xmlns:a16="http://schemas.microsoft.com/office/drawing/2014/main" id="{FD29D4EC-9DEB-4632-ABFD-068BA66D9FAA}"/>
               </a:ext>
             </a:extLst>
           </p:cNvPr>
@@ -9708,10 +9648,10 @@
       </p:sp>
       <p:sp>
         <p:nvSpPr>
-          <p:cNvPr id="8" name="text-182">
+          <p:cNvPr id="8" name="text-178">
             <a:extLst xmlns:a="http://schemas.openxmlformats.org/drawingml/2006/main">
               <a:ext uri="{FF2B5EF4-FFF2-40B4-BE49-F238E27FC236}">
-                <a16:creationId xmlns:a16="http://schemas.microsoft.com/office/drawing/2014/main" id="{F45224CE-DC23-4A22-BF1C-57C858FA55FE}"/>
+                <a16:creationId xmlns:a16="http://schemas.microsoft.com/office/drawing/2014/main" id="{C8194B8A-70C9-4DD5-BD33-CDBA4830F995}"/>
               </a:ext>
             </a:extLst>
           </p:cNvPr>
@@ -9722,8 +9662,8 @@
         </p:nvSpPr>
         <p:spPr>
           <a:xfrm xmlns:a="http://schemas.openxmlformats.org/drawingml/2006/main">
-            <a:off x="571500" y="2028825"/>
-            <a:ext cx="2952750" cy="666750"/>
+            <a:off x="571500" y="1971675"/>
+            <a:ext cx="3333750" cy="666750"/>
           </a:xfrm>
           <a:prstGeom xmlns:a="http://schemas.openxmlformats.org/drawingml/2006/main" prst="rect">
             <a:avLst/>
@@ -9739,7 +9679,7 @@
           </a:bodyPr>
           <a:lstStyle xmlns:a="http://schemas.openxmlformats.org/drawingml/2006/main">
             <a:defPPr>
-              <a:defRPr sz="5025" b="0">
+              <a:defRPr sz="4425" b="0">
                 <a:solidFill>
                   <a:srgbClr val="C2142F"/>
                 </a:solidFill>
@@ -9749,7 +9689,7 @@
               </a:defRPr>
             </a:defPPr>
             <a:lvl1pPr>
-              <a:defRPr sz="5025" b="0">
+              <a:defRPr sz="4425" b="0">
                 <a:solidFill>
                   <a:srgbClr val="C2142F"/>
                 </a:solidFill>
@@ -9759,7 +9699,7 @@
               </a:defRPr>
             </a:lvl1pPr>
             <a:lvl2pPr>
-              <a:defRPr sz="5025" b="0">
+              <a:defRPr sz="4425" b="0">
                 <a:solidFill>
                   <a:srgbClr val="C2142F"/>
                 </a:solidFill>
@@ -9769,7 +9709,7 @@
               </a:defRPr>
             </a:lvl2pPr>
             <a:lvl3pPr>
-              <a:defRPr sz="5025" b="0">
+              <a:defRPr sz="4425" b="0">
                 <a:solidFill>
                   <a:srgbClr val="C2142F"/>
                 </a:solidFill>
@@ -9779,7 +9719,7 @@
               </a:defRPr>
             </a:lvl3pPr>
             <a:lvl4pPr>
-              <a:defRPr sz="5025" b="0">
+              <a:defRPr sz="4425" b="0">
                 <a:solidFill>
                   <a:srgbClr val="C2142F"/>
                 </a:solidFill>
@@ -9789,7 +9729,7 @@
               </a:defRPr>
             </a:lvl4pPr>
             <a:lvl5pPr>
-              <a:defRPr sz="5025" b="0">
+              <a:defRPr sz="4425" b="0">
                 <a:solidFill>
                   <a:srgbClr val="C2142F"/>
                 </a:solidFill>
@@ -9799,7 +9739,7 @@
               </a:defRPr>
             </a:lvl5pPr>
             <a:lvl6pPr>
-              <a:defRPr sz="5025" b="0">
+              <a:defRPr sz="4425" b="0">
                 <a:solidFill>
                   <a:srgbClr val="C2142F"/>
                 </a:solidFill>
@@ -9809,7 +9749,7 @@
               </a:defRPr>
             </a:lvl6pPr>
             <a:lvl7pPr>
-              <a:defRPr sz="5025" b="0">
+              <a:defRPr sz="4425" b="0">
                 <a:solidFill>
                   <a:srgbClr val="C2142F"/>
                 </a:solidFill>
@@ -9819,7 +9759,7 @@
               </a:defRPr>
             </a:lvl7pPr>
             <a:lvl8pPr>
-              <a:defRPr sz="5025" b="0">
+              <a:defRPr sz="4425" b="0">
                 <a:solidFill>
                   <a:srgbClr val="C2142F"/>
                 </a:solidFill>
@@ -9829,7 +9769,7 @@
               </a:defRPr>
             </a:lvl8pPr>
             <a:lvl9pPr>
-              <a:defRPr sz="5025" b="0">
+              <a:defRPr sz="4425" b="0">
                 <a:solidFill>
                   <a:srgbClr val="C2142F"/>
                 </a:solidFill>
@@ -9841,7 +9781,7 @@
           </a:lstStyle>
           <a:p xmlns:a="http://schemas.openxmlformats.org/drawingml/2006/main">
             <a:pPr>
-              <a:defRPr sz="5025" b="0">
+              <a:defRPr sz="4425" b="0">
                 <a:solidFill>
                   <a:srgbClr val="C2142F"/>
                 </a:solidFill>
@@ -9851,7 +9791,7 @@
               </a:defRPr>
             </a:pPr>
             <a:r>
-              <a:rPr sz="5025" b="0">
+              <a:rPr sz="4425" b="0">
                 <a:solidFill>
                   <a:srgbClr val="C2142F"/>
                 </a:solidFill>
@@ -9866,10 +9806,10 @@
       </p:sp>
       <p:sp>
         <p:nvSpPr>
-          <p:cNvPr id="9" name="text-183">
+          <p:cNvPr id="9" name="text-179">
             <a:extLst xmlns:a="http://schemas.openxmlformats.org/drawingml/2006/main">
               <a:ext uri="{FF2B5EF4-FFF2-40B4-BE49-F238E27FC236}">
-                <a16:creationId xmlns:a16="http://schemas.microsoft.com/office/drawing/2014/main" id="{A07D33F0-3675-4983-8ADE-47F6D7833322}"/>
+                <a16:creationId xmlns:a16="http://schemas.microsoft.com/office/drawing/2014/main" id="{3EA46CB2-DF97-4505-9ADD-51790B2D9B47}"/>
               </a:ext>
             </a:extLst>
           </p:cNvPr>
@@ -9880,8 +9820,8 @@
         </p:nvSpPr>
         <p:spPr>
           <a:xfrm xmlns:a="http://schemas.openxmlformats.org/drawingml/2006/main">
-            <a:off x="571500" y="2809875"/>
-            <a:ext cx="2952750" cy="323850"/>
+            <a:off x="571500" y="2752725"/>
+            <a:ext cx="3333750" cy="323850"/>
           </a:xfrm>
           <a:prstGeom xmlns:a="http://schemas.openxmlformats.org/drawingml/2006/main" prst="rect">
             <a:avLst/>
@@ -10024,10 +9964,10 @@
       </p:sp>
       <p:sp>
         <p:nvSpPr>
-          <p:cNvPr id="10" name="text-184">
+          <p:cNvPr id="10" name="text-180">
             <a:extLst xmlns:a="http://schemas.openxmlformats.org/drawingml/2006/main">
               <a:ext uri="{FF2B5EF4-FFF2-40B4-BE49-F238E27FC236}">
-                <a16:creationId xmlns:a16="http://schemas.microsoft.com/office/drawing/2014/main" id="{DC91F55A-0760-4893-A223-A31C12285D07}"/>
+                <a16:creationId xmlns:a16="http://schemas.microsoft.com/office/drawing/2014/main" id="{6BAB1A6B-A4D8-4E6D-96AC-5F30F936D44B}"/>
               </a:ext>
             </a:extLst>
           </p:cNvPr>
@@ -10038,8 +9978,8 @@
         </p:nvSpPr>
         <p:spPr>
           <a:xfrm xmlns:a="http://schemas.openxmlformats.org/drawingml/2006/main">
-            <a:off x="3619500" y="2124075"/>
-            <a:ext cx="2476500" cy="666750"/>
+            <a:off x="4429125" y="1971675"/>
+            <a:ext cx="3333750" cy="666750"/>
           </a:xfrm>
           <a:prstGeom xmlns:a="http://schemas.openxmlformats.org/drawingml/2006/main" prst="rect">
             <a:avLst/>
@@ -10055,7 +9995,7 @@
           </a:bodyPr>
           <a:lstStyle xmlns:a="http://schemas.openxmlformats.org/drawingml/2006/main">
             <a:defPPr>
-              <a:defRPr sz="3225" b="0">
+              <a:defRPr sz="3750" b="0">
                 <a:solidFill>
                   <a:srgbClr val="0D0B10"/>
                 </a:solidFill>
@@ -10065,7 +10005,7 @@
               </a:defRPr>
             </a:defPPr>
             <a:lvl1pPr>
-              <a:defRPr sz="3225" b="0">
+              <a:defRPr sz="3750" b="0">
                 <a:solidFill>
                   <a:srgbClr val="0D0B10"/>
                 </a:solidFill>
@@ -10075,7 +10015,7 @@
               </a:defRPr>
             </a:lvl1pPr>
             <a:lvl2pPr>
-              <a:defRPr sz="3225" b="0">
+              <a:defRPr sz="3750" b="0">
                 <a:solidFill>
                   <a:srgbClr val="0D0B10"/>
                 </a:solidFill>
@@ -10085,7 +10025,7 @@
               </a:defRPr>
             </a:lvl2pPr>
             <a:lvl3pPr>
-              <a:defRPr sz="3225" b="0">
+              <a:defRPr sz="3750" b="0">
                 <a:solidFill>
                   <a:srgbClr val="0D0B10"/>
                 </a:solidFill>
@@ -10095,7 +10035,7 @@
               </a:defRPr>
             </a:lvl3pPr>
             <a:lvl4pPr>
-              <a:defRPr sz="3225" b="0">
+              <a:defRPr sz="3750" b="0">
                 <a:solidFill>
                   <a:srgbClr val="0D0B10"/>
                 </a:solidFill>
@@ -10105,7 +10045,7 @@
               </a:defRPr>
             </a:lvl4pPr>
             <a:lvl5pPr>
-              <a:defRPr sz="3225" b="0">
+              <a:defRPr sz="3750" b="0">
                 <a:solidFill>
                   <a:srgbClr val="0D0B10"/>
                 </a:solidFill>
@@ -10115,7 +10055,7 @@
               </a:defRPr>
             </a:lvl5pPr>
             <a:lvl6pPr>
-              <a:defRPr sz="3225" b="0">
+              <a:defRPr sz="3750" b="0">
                 <a:solidFill>
                   <a:srgbClr val="0D0B10"/>
                 </a:solidFill>
@@ -10125,7 +10065,7 @@
               </a:defRPr>
             </a:lvl6pPr>
             <a:lvl7pPr>
-              <a:defRPr sz="3225" b="0">
+              <a:defRPr sz="3750" b="0">
                 <a:solidFill>
                   <a:srgbClr val="0D0B10"/>
                 </a:solidFill>
@@ -10135,7 +10075,7 @@
               </a:defRPr>
             </a:lvl7pPr>
             <a:lvl8pPr>
-              <a:defRPr sz="3225" b="0">
+              <a:defRPr sz="3750" b="0">
                 <a:solidFill>
                   <a:srgbClr val="0D0B10"/>
                 </a:solidFill>
@@ -10145,7 +10085,7 @@
               </a:defRPr>
             </a:lvl8pPr>
             <a:lvl9pPr>
-              <a:defRPr sz="3225" b="0">
+              <a:defRPr sz="3750" b="0">
                 <a:solidFill>
                   <a:srgbClr val="0D0B10"/>
                 </a:solidFill>
@@ -10157,7 +10097,7 @@
           </a:lstStyle>
           <a:p xmlns:a="http://schemas.openxmlformats.org/drawingml/2006/main">
             <a:pPr>
-              <a:defRPr sz="3225" b="0">
+              <a:defRPr sz="3750" b="0">
                 <a:solidFill>
                   <a:srgbClr val="0D0B10"/>
                 </a:solidFill>
@@ -10167,7 +10107,7 @@
               </a:defRPr>
             </a:pPr>
             <a:r>
-              <a:rPr sz="3225" b="0">
+              <a:rPr sz="3750" b="0">
                 <a:solidFill>
                   <a:srgbClr val="0D0B10"/>
                 </a:solidFill>
@@ -10182,10 +10122,10 @@
       </p:sp>
       <p:sp>
         <p:nvSpPr>
-          <p:cNvPr id="11" name="text-185">
+          <p:cNvPr id="11" name="text-181">
             <a:extLst xmlns:a="http://schemas.openxmlformats.org/drawingml/2006/main">
               <a:ext uri="{FF2B5EF4-FFF2-40B4-BE49-F238E27FC236}">
-                <a16:creationId xmlns:a16="http://schemas.microsoft.com/office/drawing/2014/main" id="{14FA7B04-2CFE-4D19-A608-9F9DF35E4C77}"/>
+                <a16:creationId xmlns:a16="http://schemas.microsoft.com/office/drawing/2014/main" id="{E86F0715-B7FA-4423-9586-E6C1C030B0C0}"/>
               </a:ext>
             </a:extLst>
           </p:cNvPr>
@@ -10196,8 +10136,8 @@
         </p:nvSpPr>
         <p:spPr>
           <a:xfrm xmlns:a="http://schemas.openxmlformats.org/drawingml/2006/main">
-            <a:off x="3619500" y="2905125"/>
-            <a:ext cx="2476500" cy="323850"/>
+            <a:off x="4429125" y="2752725"/>
+            <a:ext cx="3333750" cy="323850"/>
           </a:xfrm>
           <a:prstGeom xmlns:a="http://schemas.openxmlformats.org/drawingml/2006/main" prst="rect">
             <a:avLst/>
@@ -10340,10 +10280,10 @@
       </p:sp>
       <p:sp>
         <p:nvSpPr>
-          <p:cNvPr id="12" name="text-186">
+          <p:cNvPr id="12" name="text-182">
             <a:extLst xmlns:a="http://schemas.openxmlformats.org/drawingml/2006/main">
               <a:ext uri="{FF2B5EF4-FFF2-40B4-BE49-F238E27FC236}">
-                <a16:creationId xmlns:a16="http://schemas.microsoft.com/office/drawing/2014/main" id="{BA93C30A-8E24-4F05-A35B-B29B3062D4F8}"/>
+                <a16:creationId xmlns:a16="http://schemas.microsoft.com/office/drawing/2014/main" id="{B8044DCB-B1B3-4DD3-B9DC-5E1890503E92}"/>
               </a:ext>
             </a:extLst>
           </p:cNvPr>
@@ -10354,8 +10294,8 @@
         </p:nvSpPr>
         <p:spPr>
           <a:xfrm xmlns:a="http://schemas.openxmlformats.org/drawingml/2006/main">
-            <a:off x="6181725" y="2124075"/>
-            <a:ext cx="2476500" cy="666750"/>
+            <a:off x="8286750" y="1971675"/>
+            <a:ext cx="3333750" cy="666750"/>
           </a:xfrm>
           <a:prstGeom xmlns:a="http://schemas.openxmlformats.org/drawingml/2006/main" prst="rect">
             <a:avLst/>
@@ -10371,7 +10311,7 @@
           </a:bodyPr>
           <a:lstStyle xmlns:a="http://schemas.openxmlformats.org/drawingml/2006/main">
             <a:defPPr>
-              <a:defRPr sz="3225" b="0">
+              <a:defRPr sz="3750" b="0">
                 <a:solidFill>
                   <a:srgbClr val="0D0B10"/>
                 </a:solidFill>
@@ -10381,7 +10321,7 @@
               </a:defRPr>
             </a:defPPr>
             <a:lvl1pPr>
-              <a:defRPr sz="3225" b="0">
+              <a:defRPr sz="3750" b="0">
                 <a:solidFill>
                   <a:srgbClr val="0D0B10"/>
                 </a:solidFill>
@@ -10391,7 +10331,7 @@
               </a:defRPr>
             </a:lvl1pPr>
             <a:lvl2pPr>
-              <a:defRPr sz="3225" b="0">
+              <a:defRPr sz="3750" b="0">
                 <a:solidFill>
                   <a:srgbClr val="0D0B10"/>
                 </a:solidFill>
@@ -10401,7 +10341,7 @@
               </a:defRPr>
             </a:lvl2pPr>
             <a:lvl3pPr>
-              <a:defRPr sz="3225" b="0">
+              <a:defRPr sz="3750" b="0">
                 <a:solidFill>
                   <a:srgbClr val="0D0B10"/>
                 </a:solidFill>
@@ -10411,7 +10351,7 @@
               </a:defRPr>
             </a:lvl3pPr>
             <a:lvl4pPr>
-              <a:defRPr sz="3225" b="0">
+              <a:defRPr sz="3750" b="0">
                 <a:solidFill>
                   <a:srgbClr val="0D0B10"/>
                 </a:solidFill>
@@ -10421,7 +10361,7 @@
               </a:defRPr>
             </a:lvl4pPr>
             <a:lvl5pPr>
-              <a:defRPr sz="3225" b="0">
+              <a:defRPr sz="3750" b="0">
                 <a:solidFill>
                   <a:srgbClr val="0D0B10"/>
                 </a:solidFill>
@@ -10431,7 +10371,7 @@
               </a:defRPr>
             </a:lvl5pPr>
             <a:lvl6pPr>
-              <a:defRPr sz="3225" b="0">
+              <a:defRPr sz="3750" b="0">
                 <a:solidFill>
                   <a:srgbClr val="0D0B10"/>
                 </a:solidFill>
@@ -10441,7 +10381,7 @@
               </a:defRPr>
             </a:lvl6pPr>
             <a:lvl7pPr>
-              <a:defRPr sz="3225" b="0">
+              <a:defRPr sz="3750" b="0">
                 <a:solidFill>
                   <a:srgbClr val="0D0B10"/>
                 </a:solidFill>
@@ -10451,7 +10391,7 @@
               </a:defRPr>
             </a:lvl7pPr>
             <a:lvl8pPr>
-              <a:defRPr sz="3225" b="0">
+              <a:defRPr sz="3750" b="0">
                 <a:solidFill>
                   <a:srgbClr val="0D0B10"/>
                 </a:solidFill>
@@ -10461,7 +10401,7 @@
               </a:defRPr>
             </a:lvl8pPr>
             <a:lvl9pPr>
-              <a:defRPr sz="3225" b="0">
+              <a:defRPr sz="3750" b="0">
                 <a:solidFill>
                   <a:srgbClr val="0D0B10"/>
                 </a:solidFill>
@@ -10473,7 +10413,7 @@
           </a:lstStyle>
           <a:p xmlns:a="http://schemas.openxmlformats.org/drawingml/2006/main">
             <a:pPr>
-              <a:defRPr sz="3225" b="0">
+              <a:defRPr sz="3750" b="0">
                 <a:solidFill>
                   <a:srgbClr val="0D0B10"/>
                 </a:solidFill>
@@ -10483,7 +10423,7 @@
               </a:defRPr>
             </a:pPr>
             <a:r>
-              <a:rPr sz="3225" b="0">
+              <a:rPr sz="3750" b="0">
                 <a:solidFill>
                   <a:srgbClr val="0D0B10"/>
                 </a:solidFill>
@@ -10498,10 +10438,10 @@
       </p:sp>
       <p:sp>
         <p:nvSpPr>
-          <p:cNvPr id="13" name="text-187">
+          <p:cNvPr id="13" name="text-183">
             <a:extLst xmlns:a="http://schemas.openxmlformats.org/drawingml/2006/main">
               <a:ext uri="{FF2B5EF4-FFF2-40B4-BE49-F238E27FC236}">
-                <a16:creationId xmlns:a16="http://schemas.microsoft.com/office/drawing/2014/main" id="{FE692172-0F95-4C73-88D5-1223F183C07E}"/>
+                <a16:creationId xmlns:a16="http://schemas.microsoft.com/office/drawing/2014/main" id="{59746EF5-57F7-439B-8934-9177DCEA0C85}"/>
               </a:ext>
             </a:extLst>
           </p:cNvPr>
@@ -10512,8 +10452,8 @@
         </p:nvSpPr>
         <p:spPr>
           <a:xfrm xmlns:a="http://schemas.openxmlformats.org/drawingml/2006/main">
-            <a:off x="6181725" y="2905125"/>
-            <a:ext cx="2476500" cy="323850"/>
+            <a:off x="8286750" y="2752725"/>
+            <a:ext cx="3333750" cy="323850"/>
           </a:xfrm>
           <a:prstGeom xmlns:a="http://schemas.openxmlformats.org/drawingml/2006/main" prst="rect">
             <a:avLst/>
@@ -10656,326 +10596,10 @@
       </p:sp>
       <p:sp>
         <p:nvSpPr>
-          <p:cNvPr id="14" name="text-188">
+          <p:cNvPr id="14" name="rule-184">
             <a:extLst xmlns:a="http://schemas.openxmlformats.org/drawingml/2006/main">
               <a:ext uri="{FF2B5EF4-FFF2-40B4-BE49-F238E27FC236}">
-                <a16:creationId xmlns:a16="http://schemas.microsoft.com/office/drawing/2014/main" id="{F830D94F-F4C8-4D3B-B0EE-382B944965A0}"/>
-              </a:ext>
-            </a:extLst>
-          </p:cNvPr>
-          <p:cNvSpPr>
-            <a:spLocks xmlns:a="http://schemas.openxmlformats.org/drawingml/2006/main" noGrp="1"/>
-          </p:cNvSpPr>
-          <p:nvPr/>
-        </p:nvSpPr>
-        <p:spPr>
-          <a:xfrm xmlns:a="http://schemas.openxmlformats.org/drawingml/2006/main">
-            <a:off x="8810625" y="2124075"/>
-            <a:ext cx="2714625" cy="666750"/>
-          </a:xfrm>
-          <a:prstGeom xmlns:a="http://schemas.openxmlformats.org/drawingml/2006/main" prst="rect">
-            <a:avLst/>
-          </a:prstGeom>
-          <a:noFill xmlns:a="http://schemas.openxmlformats.org/drawingml/2006/main"/>
-          <a:ln xmlns:a="http://schemas.openxmlformats.org/drawingml/2006/main" w="0">
-            <a:noFill/>
-          </a:ln>
-        </p:spPr>
-        <p:txBody>
-          <a:bodyPr xmlns:a="http://schemas.openxmlformats.org/drawingml/2006/main" lIns="0" tIns="0" rIns="0" bIns="0" anchor="t">
-            <a:noAutofit/>
-          </a:bodyPr>
-          <a:lstStyle xmlns:a="http://schemas.openxmlformats.org/drawingml/2006/main">
-            <a:defPPr>
-              <a:defRPr sz="3225" b="0">
-                <a:solidFill>
-                  <a:srgbClr val="0D0B10"/>
-                </a:solidFill>
-                <a:latin typeface="Georgia"/>
-                <a:ea typeface="Georgia"/>
-                <a:cs typeface="Georgia"/>
-              </a:defRPr>
-            </a:defPPr>
-            <a:lvl1pPr>
-              <a:defRPr sz="3225" b="0">
-                <a:solidFill>
-                  <a:srgbClr val="0D0B10"/>
-                </a:solidFill>
-                <a:latin typeface="Georgia"/>
-                <a:ea typeface="Georgia"/>
-                <a:cs typeface="Georgia"/>
-              </a:defRPr>
-            </a:lvl1pPr>
-            <a:lvl2pPr>
-              <a:defRPr sz="3225" b="0">
-                <a:solidFill>
-                  <a:srgbClr val="0D0B10"/>
-                </a:solidFill>
-                <a:latin typeface="Georgia"/>
-                <a:ea typeface="Georgia"/>
-                <a:cs typeface="Georgia"/>
-              </a:defRPr>
-            </a:lvl2pPr>
-            <a:lvl3pPr>
-              <a:defRPr sz="3225" b="0">
-                <a:solidFill>
-                  <a:srgbClr val="0D0B10"/>
-                </a:solidFill>
-                <a:latin typeface="Georgia"/>
-                <a:ea typeface="Georgia"/>
-                <a:cs typeface="Georgia"/>
-              </a:defRPr>
-            </a:lvl3pPr>
-            <a:lvl4pPr>
-              <a:defRPr sz="3225" b="0">
-                <a:solidFill>
-                  <a:srgbClr val="0D0B10"/>
-                </a:solidFill>
-                <a:latin typeface="Georgia"/>
-                <a:ea typeface="Georgia"/>
-                <a:cs typeface="Georgia"/>
-              </a:defRPr>
-            </a:lvl4pPr>
-            <a:lvl5pPr>
-              <a:defRPr sz="3225" b="0">
-                <a:solidFill>
-                  <a:srgbClr val="0D0B10"/>
-                </a:solidFill>
-                <a:latin typeface="Georgia"/>
-                <a:ea typeface="Georgia"/>
-                <a:cs typeface="Georgia"/>
-              </a:defRPr>
-            </a:lvl5pPr>
-            <a:lvl6pPr>
-              <a:defRPr sz="3225" b="0">
-                <a:solidFill>
-                  <a:srgbClr val="0D0B10"/>
-                </a:solidFill>
-                <a:latin typeface="Georgia"/>
-                <a:ea typeface="Georgia"/>
-                <a:cs typeface="Georgia"/>
-              </a:defRPr>
-            </a:lvl6pPr>
-            <a:lvl7pPr>
-              <a:defRPr sz="3225" b="0">
-                <a:solidFill>
-                  <a:srgbClr val="0D0B10"/>
-                </a:solidFill>
-                <a:latin typeface="Georgia"/>
-                <a:ea typeface="Georgia"/>
-                <a:cs typeface="Georgia"/>
-              </a:defRPr>
-            </a:lvl7pPr>
-            <a:lvl8pPr>
-              <a:defRPr sz="3225" b="0">
-                <a:solidFill>
-                  <a:srgbClr val="0D0B10"/>
-                </a:solidFill>
-                <a:latin typeface="Georgia"/>
-                <a:ea typeface="Georgia"/>
-                <a:cs typeface="Georgia"/>
-              </a:defRPr>
-            </a:lvl8pPr>
-            <a:lvl9pPr>
-              <a:defRPr sz="3225" b="0">
-                <a:solidFill>
-                  <a:srgbClr val="0D0B10"/>
-                </a:solidFill>
-                <a:latin typeface="Georgia"/>
-                <a:ea typeface="Georgia"/>
-                <a:cs typeface="Georgia"/>
-              </a:defRPr>
-            </a:lvl9pPr>
-          </a:lstStyle>
-          <a:p xmlns:a="http://schemas.openxmlformats.org/drawingml/2006/main">
-            <a:pPr>
-              <a:defRPr sz="3225" b="0">
-                <a:solidFill>
-                  <a:srgbClr val="0D0B10"/>
-                </a:solidFill>
-                <a:latin typeface="Georgia"/>
-                <a:ea typeface="Georgia"/>
-                <a:cs typeface="Georgia"/>
-              </a:defRPr>
-            </a:pPr>
-            <a:r>
-              <a:rPr sz="3225" b="0">
-                <a:solidFill>
-                  <a:srgbClr val="0D0B10"/>
-                </a:solidFill>
-                <a:latin typeface="Georgia"/>
-                <a:ea typeface="Georgia"/>
-                <a:cs typeface="Georgia"/>
-              </a:rPr>
-              <a:t>31</a:t>
-            </a:r>
-          </a:p>
-        </p:txBody>
-      </p:sp>
-      <p:sp>
-        <p:nvSpPr>
-          <p:cNvPr id="15" name="text-189">
-            <a:extLst xmlns:a="http://schemas.openxmlformats.org/drawingml/2006/main">
-              <a:ext uri="{FF2B5EF4-FFF2-40B4-BE49-F238E27FC236}">
-                <a16:creationId xmlns:a16="http://schemas.microsoft.com/office/drawing/2014/main" id="{E6D0F860-1009-42B5-8143-A3DA40090F63}"/>
-              </a:ext>
-            </a:extLst>
-          </p:cNvPr>
-          <p:cNvSpPr>
-            <a:spLocks xmlns:a="http://schemas.openxmlformats.org/drawingml/2006/main" noGrp="1"/>
-          </p:cNvSpPr>
-          <p:nvPr/>
-        </p:nvSpPr>
-        <p:spPr>
-          <a:xfrm xmlns:a="http://schemas.openxmlformats.org/drawingml/2006/main">
-            <a:off x="8810625" y="2905125"/>
-            <a:ext cx="2714625" cy="323850"/>
-          </a:xfrm>
-          <a:prstGeom xmlns:a="http://schemas.openxmlformats.org/drawingml/2006/main" prst="rect">
-            <a:avLst/>
-          </a:prstGeom>
-          <a:noFill xmlns:a="http://schemas.openxmlformats.org/drawingml/2006/main"/>
-          <a:ln xmlns:a="http://schemas.openxmlformats.org/drawingml/2006/main" w="0">
-            <a:noFill/>
-          </a:ln>
-        </p:spPr>
-        <p:txBody>
-          <a:bodyPr xmlns:a="http://schemas.openxmlformats.org/drawingml/2006/main" lIns="0" tIns="0" rIns="0" bIns="0" anchor="t">
-            <a:noAutofit/>
-          </a:bodyPr>
-          <a:lstStyle xmlns:a="http://schemas.openxmlformats.org/drawingml/2006/main">
-            <a:defPPr>
-              <a:defRPr sz="1200" b="0">
-                <a:solidFill>
-                  <a:srgbClr val="5D555A"/>
-                </a:solidFill>
-                <a:latin typeface="Arial"/>
-                <a:ea typeface="Arial"/>
-                <a:cs typeface="Arial"/>
-              </a:defRPr>
-            </a:defPPr>
-            <a:lvl1pPr>
-              <a:defRPr sz="1200" b="0">
-                <a:solidFill>
-                  <a:srgbClr val="5D555A"/>
-                </a:solidFill>
-                <a:latin typeface="Arial"/>
-                <a:ea typeface="Arial"/>
-                <a:cs typeface="Arial"/>
-              </a:defRPr>
-            </a:lvl1pPr>
-            <a:lvl2pPr>
-              <a:defRPr sz="1200" b="0">
-                <a:solidFill>
-                  <a:srgbClr val="5D555A"/>
-                </a:solidFill>
-                <a:latin typeface="Arial"/>
-                <a:ea typeface="Arial"/>
-                <a:cs typeface="Arial"/>
-              </a:defRPr>
-            </a:lvl2pPr>
-            <a:lvl3pPr>
-              <a:defRPr sz="1200" b="0">
-                <a:solidFill>
-                  <a:srgbClr val="5D555A"/>
-                </a:solidFill>
-                <a:latin typeface="Arial"/>
-                <a:ea typeface="Arial"/>
-                <a:cs typeface="Arial"/>
-              </a:defRPr>
-            </a:lvl3pPr>
-            <a:lvl4pPr>
-              <a:defRPr sz="1200" b="0">
-                <a:solidFill>
-                  <a:srgbClr val="5D555A"/>
-                </a:solidFill>
-                <a:latin typeface="Arial"/>
-                <a:ea typeface="Arial"/>
-                <a:cs typeface="Arial"/>
-              </a:defRPr>
-            </a:lvl4pPr>
-            <a:lvl5pPr>
-              <a:defRPr sz="1200" b="0">
-                <a:solidFill>
-                  <a:srgbClr val="5D555A"/>
-                </a:solidFill>
-                <a:latin typeface="Arial"/>
-                <a:ea typeface="Arial"/>
-                <a:cs typeface="Arial"/>
-              </a:defRPr>
-            </a:lvl5pPr>
-            <a:lvl6pPr>
-              <a:defRPr sz="1200" b="0">
-                <a:solidFill>
-                  <a:srgbClr val="5D555A"/>
-                </a:solidFill>
-                <a:latin typeface="Arial"/>
-                <a:ea typeface="Arial"/>
-                <a:cs typeface="Arial"/>
-              </a:defRPr>
-            </a:lvl6pPr>
-            <a:lvl7pPr>
-              <a:defRPr sz="1200" b="0">
-                <a:solidFill>
-                  <a:srgbClr val="5D555A"/>
-                </a:solidFill>
-                <a:latin typeface="Arial"/>
-                <a:ea typeface="Arial"/>
-                <a:cs typeface="Arial"/>
-              </a:defRPr>
-            </a:lvl7pPr>
-            <a:lvl8pPr>
-              <a:defRPr sz="1200" b="0">
-                <a:solidFill>
-                  <a:srgbClr val="5D555A"/>
-                </a:solidFill>
-                <a:latin typeface="Arial"/>
-                <a:ea typeface="Arial"/>
-                <a:cs typeface="Arial"/>
-              </a:defRPr>
-            </a:lvl8pPr>
-            <a:lvl9pPr>
-              <a:defRPr sz="1200" b="0">
-                <a:solidFill>
-                  <a:srgbClr val="5D555A"/>
-                </a:solidFill>
-                <a:latin typeface="Arial"/>
-                <a:ea typeface="Arial"/>
-                <a:cs typeface="Arial"/>
-              </a:defRPr>
-            </a:lvl9pPr>
-          </a:lstStyle>
-          <a:p xmlns:a="http://schemas.openxmlformats.org/drawingml/2006/main">
-            <a:pPr>
-              <a:defRPr sz="1200" b="0">
-                <a:solidFill>
-                  <a:srgbClr val="5D555A"/>
-                </a:solidFill>
-                <a:latin typeface="Arial"/>
-                <a:ea typeface="Arial"/>
-                <a:cs typeface="Arial"/>
-              </a:defRPr>
-            </a:pPr>
-            <a:r>
-              <a:rPr sz="1200" b="0">
-                <a:solidFill>
-                  <a:srgbClr val="5D555A"/>
-                </a:solidFill>
-                <a:latin typeface="Arial"/>
-                <a:ea typeface="Arial"/>
-                <a:cs typeface="Arial"/>
-              </a:rPr>
-              <a:t>average comments per post</a:t>
-            </a:r>
-          </a:p>
-        </p:txBody>
-      </p:sp>
-      <p:sp>
-        <p:nvSpPr>
-          <p:cNvPr id="16" name="rule-190">
-            <a:extLst xmlns:a="http://schemas.openxmlformats.org/drawingml/2006/main">
-              <a:ext uri="{FF2B5EF4-FFF2-40B4-BE49-F238E27FC236}">
-                <a16:creationId xmlns:a16="http://schemas.microsoft.com/office/drawing/2014/main" id="{E63F2785-14A9-41F4-BCFE-2EC9FAAA1677}"/>
+                <a16:creationId xmlns:a16="http://schemas.microsoft.com/office/drawing/2014/main" id="{917A10E3-9769-4FAE-A3F3-A0B00D0452F9}"/>
               </a:ext>
             </a:extLst>
           </p:cNvPr>
@@ -11002,10 +10626,10 @@
       </p:sp>
       <p:sp>
         <p:nvSpPr>
-          <p:cNvPr id="17" name="text-191">
+          <p:cNvPr id="15" name="text-185">
             <a:extLst xmlns:a="http://schemas.openxmlformats.org/drawingml/2006/main">
               <a:ext uri="{FF2B5EF4-FFF2-40B4-BE49-F238E27FC236}">
-                <a16:creationId xmlns:a16="http://schemas.microsoft.com/office/drawing/2014/main" id="{D2E0D46A-DF2A-4901-8F4C-987ACE430115}"/>
+                <a16:creationId xmlns:a16="http://schemas.microsoft.com/office/drawing/2014/main" id="{D174E328-5EC4-4475-AC8A-2C804BD25729}"/>
               </a:ext>
             </a:extLst>
           </p:cNvPr>
@@ -11016,8 +10640,8 @@
         </p:nvSpPr>
         <p:spPr>
           <a:xfrm xmlns:a="http://schemas.openxmlformats.org/drawingml/2006/main">
-            <a:off x="571500" y="3257550"/>
-            <a:ext cx="5381625" cy="666750"/>
+            <a:off x="571500" y="3209925"/>
+            <a:ext cx="3333750" cy="666750"/>
           </a:xfrm>
           <a:prstGeom xmlns:a="http://schemas.openxmlformats.org/drawingml/2006/main" prst="rect">
             <a:avLst/>
@@ -11033,7 +10657,7 @@
           </a:bodyPr>
           <a:lstStyle xmlns:a="http://schemas.openxmlformats.org/drawingml/2006/main">
             <a:defPPr>
-              <a:defRPr sz="3150" b="0">
+              <a:defRPr sz="3750" b="0">
                 <a:solidFill>
                   <a:srgbClr val="0D0B10"/>
                 </a:solidFill>
@@ -11043,7 +10667,7 @@
               </a:defRPr>
             </a:defPPr>
             <a:lvl1pPr>
-              <a:defRPr sz="3150" b="0">
+              <a:defRPr sz="3750" b="0">
                 <a:solidFill>
                   <a:srgbClr val="0D0B10"/>
                 </a:solidFill>
@@ -11053,7 +10677,7 @@
               </a:defRPr>
             </a:lvl1pPr>
             <a:lvl2pPr>
-              <a:defRPr sz="3150" b="0">
+              <a:defRPr sz="3750" b="0">
                 <a:solidFill>
                   <a:srgbClr val="0D0B10"/>
                 </a:solidFill>
@@ -11063,7 +10687,7 @@
               </a:defRPr>
             </a:lvl2pPr>
             <a:lvl3pPr>
-              <a:defRPr sz="3150" b="0">
+              <a:defRPr sz="3750" b="0">
                 <a:solidFill>
                   <a:srgbClr val="0D0B10"/>
                 </a:solidFill>
@@ -11073,7 +10697,7 @@
               </a:defRPr>
             </a:lvl3pPr>
             <a:lvl4pPr>
-              <a:defRPr sz="3150" b="0">
+              <a:defRPr sz="3750" b="0">
                 <a:solidFill>
                   <a:srgbClr val="0D0B10"/>
                 </a:solidFill>
@@ -11083,7 +10707,7 @@
               </a:defRPr>
             </a:lvl4pPr>
             <a:lvl5pPr>
-              <a:defRPr sz="3150" b="0">
+              <a:defRPr sz="3750" b="0">
                 <a:solidFill>
                   <a:srgbClr val="0D0B10"/>
                 </a:solidFill>
@@ -11093,7 +10717,7 @@
               </a:defRPr>
             </a:lvl5pPr>
             <a:lvl6pPr>
-              <a:defRPr sz="3150" b="0">
+              <a:defRPr sz="3750" b="0">
                 <a:solidFill>
                   <a:srgbClr val="0D0B10"/>
                 </a:solidFill>
@@ -11103,7 +10727,7 @@
               </a:defRPr>
             </a:lvl6pPr>
             <a:lvl7pPr>
-              <a:defRPr sz="3150" b="0">
+              <a:defRPr sz="3750" b="0">
                 <a:solidFill>
                   <a:srgbClr val="0D0B10"/>
                 </a:solidFill>
@@ -11113,7 +10737,7 @@
               </a:defRPr>
             </a:lvl7pPr>
             <a:lvl8pPr>
-              <a:defRPr sz="3150" b="0">
+              <a:defRPr sz="3750" b="0">
                 <a:solidFill>
                   <a:srgbClr val="0D0B10"/>
                 </a:solidFill>
@@ -11123,7 +10747,7 @@
               </a:defRPr>
             </a:lvl8pPr>
             <a:lvl9pPr>
-              <a:defRPr sz="3150" b="0">
+              <a:defRPr sz="3750" b="0">
                 <a:solidFill>
                   <a:srgbClr val="0D0B10"/>
                 </a:solidFill>
@@ -11135,7 +10759,7 @@
           </a:lstStyle>
           <a:p xmlns:a="http://schemas.openxmlformats.org/drawingml/2006/main">
             <a:pPr>
-              <a:defRPr sz="3150" b="0">
+              <a:defRPr sz="3750" b="0">
                 <a:solidFill>
                   <a:srgbClr val="0D0B10"/>
                 </a:solidFill>
@@ -11145,7 +10769,7 @@
               </a:defRPr>
             </a:pPr>
             <a:r>
-              <a:rPr sz="3150" b="0">
+              <a:rPr sz="3750" b="0">
                 <a:solidFill>
                   <a:srgbClr val="0D0B10"/>
                 </a:solidFill>
@@ -11153,17 +10777,17 @@
                 <a:ea typeface="Georgia"/>
                 <a:cs typeface="Georgia"/>
               </a:rPr>
-              <a:t>37.9K</a:t>
+              <a:t>31</a:t>
             </a:r>
           </a:p>
         </p:txBody>
       </p:sp>
       <p:sp>
         <p:nvSpPr>
-          <p:cNvPr id="18" name="text-192">
+          <p:cNvPr id="16" name="text-186">
             <a:extLst xmlns:a="http://schemas.openxmlformats.org/drawingml/2006/main">
               <a:ext uri="{FF2B5EF4-FFF2-40B4-BE49-F238E27FC236}">
-                <a16:creationId xmlns:a16="http://schemas.microsoft.com/office/drawing/2014/main" id="{7B3A10D6-0993-4C43-A7DE-C73EDC184691}"/>
+                <a16:creationId xmlns:a16="http://schemas.microsoft.com/office/drawing/2014/main" id="{F869FE47-4E4D-4E8E-A521-16BD822DD3EE}"/>
               </a:ext>
             </a:extLst>
           </p:cNvPr>
@@ -11174,8 +10798,8 @@
         </p:nvSpPr>
         <p:spPr>
           <a:xfrm xmlns:a="http://schemas.openxmlformats.org/drawingml/2006/main">
-            <a:off x="571500" y="4038600"/>
-            <a:ext cx="5381625" cy="323850"/>
+            <a:off x="571500" y="3990975"/>
+            <a:ext cx="3333750" cy="323850"/>
           </a:xfrm>
           <a:prstGeom xmlns:a="http://schemas.openxmlformats.org/drawingml/2006/main" prst="rect">
             <a:avLst/>
@@ -11311,17 +10935,17 @@
                 <a:ea typeface="Arial"/>
                 <a:cs typeface="Arial"/>
               </a:rPr>
-              <a:t>views in the last 30 days</a:t>
+              <a:t>average comments per post</a:t>
             </a:r>
           </a:p>
         </p:txBody>
       </p:sp>
       <p:sp>
         <p:nvSpPr>
-          <p:cNvPr id="19" name="text-193">
+          <p:cNvPr id="17" name="text-187">
             <a:extLst xmlns:a="http://schemas.openxmlformats.org/drawingml/2006/main">
               <a:ext uri="{FF2B5EF4-FFF2-40B4-BE49-F238E27FC236}">
-                <a16:creationId xmlns:a16="http://schemas.microsoft.com/office/drawing/2014/main" id="{65F4E24F-AF9C-4463-8FCB-CC03FCCFE23C}"/>
+                <a16:creationId xmlns:a16="http://schemas.microsoft.com/office/drawing/2014/main" id="{A89545F8-F46B-4879-A5F2-C7DD986D1EA9}"/>
               </a:ext>
             </a:extLst>
           </p:cNvPr>
@@ -11332,8 +10956,8 @@
         </p:nvSpPr>
         <p:spPr>
           <a:xfrm xmlns:a="http://schemas.openxmlformats.org/drawingml/2006/main">
-            <a:off x="6172200" y="3257550"/>
-            <a:ext cx="5381625" cy="666750"/>
+            <a:off x="4429125" y="3209925"/>
+            <a:ext cx="3333750" cy="666750"/>
           </a:xfrm>
           <a:prstGeom xmlns:a="http://schemas.openxmlformats.org/drawingml/2006/main" prst="rect">
             <a:avLst/>
@@ -11349,7 +10973,7 @@
           </a:bodyPr>
           <a:lstStyle xmlns:a="http://schemas.openxmlformats.org/drawingml/2006/main">
             <a:defPPr>
-              <a:defRPr sz="3150" b="0">
+              <a:defRPr sz="3750" b="0">
                 <a:solidFill>
                   <a:srgbClr val="0D0B10"/>
                 </a:solidFill>
@@ -11359,7 +10983,7 @@
               </a:defRPr>
             </a:defPPr>
             <a:lvl1pPr>
-              <a:defRPr sz="3150" b="0">
+              <a:defRPr sz="3750" b="0">
                 <a:solidFill>
                   <a:srgbClr val="0D0B10"/>
                 </a:solidFill>
@@ -11369,7 +10993,7 @@
               </a:defRPr>
             </a:lvl1pPr>
             <a:lvl2pPr>
-              <a:defRPr sz="3150" b="0">
+              <a:defRPr sz="3750" b="0">
                 <a:solidFill>
                   <a:srgbClr val="0D0B10"/>
                 </a:solidFill>
@@ -11379,7 +11003,7 @@
               </a:defRPr>
             </a:lvl2pPr>
             <a:lvl3pPr>
-              <a:defRPr sz="3150" b="0">
+              <a:defRPr sz="3750" b="0">
                 <a:solidFill>
                   <a:srgbClr val="0D0B10"/>
                 </a:solidFill>
@@ -11389,7 +11013,7 @@
               </a:defRPr>
             </a:lvl3pPr>
             <a:lvl4pPr>
-              <a:defRPr sz="3150" b="0">
+              <a:defRPr sz="3750" b="0">
                 <a:solidFill>
                   <a:srgbClr val="0D0B10"/>
                 </a:solidFill>
@@ -11399,7 +11023,7 @@
               </a:defRPr>
             </a:lvl4pPr>
             <a:lvl5pPr>
-              <a:defRPr sz="3150" b="0">
+              <a:defRPr sz="3750" b="0">
                 <a:solidFill>
                   <a:srgbClr val="0D0B10"/>
                 </a:solidFill>
@@ -11409,7 +11033,7 @@
               </a:defRPr>
             </a:lvl5pPr>
             <a:lvl6pPr>
-              <a:defRPr sz="3150" b="0">
+              <a:defRPr sz="3750" b="0">
                 <a:solidFill>
                   <a:srgbClr val="0D0B10"/>
                 </a:solidFill>
@@ -11419,7 +11043,7 @@
               </a:defRPr>
             </a:lvl6pPr>
             <a:lvl7pPr>
-              <a:defRPr sz="3150" b="0">
+              <a:defRPr sz="3750" b="0">
                 <a:solidFill>
                   <a:srgbClr val="0D0B10"/>
                 </a:solidFill>
@@ -11429,7 +11053,7 @@
               </a:defRPr>
             </a:lvl7pPr>
             <a:lvl8pPr>
-              <a:defRPr sz="3150" b="0">
+              <a:defRPr sz="3750" b="0">
                 <a:solidFill>
                   <a:srgbClr val="0D0B10"/>
                 </a:solidFill>
@@ -11439,7 +11063,7 @@
               </a:defRPr>
             </a:lvl8pPr>
             <a:lvl9pPr>
-              <a:defRPr sz="3150" b="0">
+              <a:defRPr sz="3750" b="0">
                 <a:solidFill>
                   <a:srgbClr val="0D0B10"/>
                 </a:solidFill>
@@ -11451,7 +11075,7 @@
           </a:lstStyle>
           <a:p xmlns:a="http://schemas.openxmlformats.org/drawingml/2006/main">
             <a:pPr>
-              <a:defRPr sz="3150" b="0">
+              <a:defRPr sz="3750" b="0">
                 <a:solidFill>
                   <a:srgbClr val="0D0B10"/>
                 </a:solidFill>
@@ -11461,7 +11085,7 @@
               </a:defRPr>
             </a:pPr>
             <a:r>
-              <a:rPr sz="3150" b="0">
+              <a:rPr sz="3750" b="0">
                 <a:solidFill>
                   <a:srgbClr val="0D0B10"/>
                 </a:solidFill>
@@ -11469,17 +11093,17 @@
                 <a:ea typeface="Georgia"/>
                 <a:cs typeface="Georgia"/>
               </a:rPr>
-              <a:t>9,090</a:t>
+              <a:t>37.9K</a:t>
             </a:r>
           </a:p>
         </p:txBody>
       </p:sp>
       <p:sp>
         <p:nvSpPr>
-          <p:cNvPr id="20" name="text-194">
+          <p:cNvPr id="18" name="text-188">
             <a:extLst xmlns:a="http://schemas.openxmlformats.org/drawingml/2006/main">
               <a:ext uri="{FF2B5EF4-FFF2-40B4-BE49-F238E27FC236}">
-                <a16:creationId xmlns:a16="http://schemas.microsoft.com/office/drawing/2014/main" id="{C647A612-A7F4-46FE-99B7-6CF41D9E96B2}"/>
+                <a16:creationId xmlns:a16="http://schemas.microsoft.com/office/drawing/2014/main" id="{7F105022-DA99-4FC3-9FA6-6357CE7879A4}"/>
               </a:ext>
             </a:extLst>
           </p:cNvPr>
@@ -11490,8 +11114,8 @@
         </p:nvSpPr>
         <p:spPr>
           <a:xfrm xmlns:a="http://schemas.openxmlformats.org/drawingml/2006/main">
-            <a:off x="6172200" y="4038600"/>
-            <a:ext cx="5381625" cy="323850"/>
+            <a:off x="4429125" y="3990975"/>
+            <a:ext cx="3333750" cy="323850"/>
           </a:xfrm>
           <a:prstGeom xmlns:a="http://schemas.openxmlformats.org/drawingml/2006/main" prst="rect">
             <a:avLst/>
@@ -11627,6 +11251,322 @@
                 <a:ea typeface="Arial"/>
                 <a:cs typeface="Arial"/>
               </a:rPr>
+              <a:t>views in the last 30 days</a:t>
+            </a:r>
+          </a:p>
+        </p:txBody>
+      </p:sp>
+      <p:sp>
+        <p:nvSpPr>
+          <p:cNvPr id="19" name="text-189">
+            <a:extLst xmlns:a="http://schemas.openxmlformats.org/drawingml/2006/main">
+              <a:ext uri="{FF2B5EF4-FFF2-40B4-BE49-F238E27FC236}">
+                <a16:creationId xmlns:a16="http://schemas.microsoft.com/office/drawing/2014/main" id="{8CF6DB55-7421-4A0C-8B94-B04AEDB79796}"/>
+              </a:ext>
+            </a:extLst>
+          </p:cNvPr>
+          <p:cNvSpPr>
+            <a:spLocks xmlns:a="http://schemas.openxmlformats.org/drawingml/2006/main" noGrp="1"/>
+          </p:cNvSpPr>
+          <p:nvPr/>
+        </p:nvSpPr>
+        <p:spPr>
+          <a:xfrm xmlns:a="http://schemas.openxmlformats.org/drawingml/2006/main">
+            <a:off x="8286750" y="3209925"/>
+            <a:ext cx="3333750" cy="666750"/>
+          </a:xfrm>
+          <a:prstGeom xmlns:a="http://schemas.openxmlformats.org/drawingml/2006/main" prst="rect">
+            <a:avLst/>
+          </a:prstGeom>
+          <a:noFill xmlns:a="http://schemas.openxmlformats.org/drawingml/2006/main"/>
+          <a:ln xmlns:a="http://schemas.openxmlformats.org/drawingml/2006/main" w="0">
+            <a:noFill/>
+          </a:ln>
+        </p:spPr>
+        <p:txBody>
+          <a:bodyPr xmlns:a="http://schemas.openxmlformats.org/drawingml/2006/main" lIns="0" tIns="0" rIns="0" bIns="0" anchor="t">
+            <a:noAutofit/>
+          </a:bodyPr>
+          <a:lstStyle xmlns:a="http://schemas.openxmlformats.org/drawingml/2006/main">
+            <a:defPPr>
+              <a:defRPr sz="3750" b="0">
+                <a:solidFill>
+                  <a:srgbClr val="0D0B10"/>
+                </a:solidFill>
+                <a:latin typeface="Georgia"/>
+                <a:ea typeface="Georgia"/>
+                <a:cs typeface="Georgia"/>
+              </a:defRPr>
+            </a:defPPr>
+            <a:lvl1pPr>
+              <a:defRPr sz="3750" b="0">
+                <a:solidFill>
+                  <a:srgbClr val="0D0B10"/>
+                </a:solidFill>
+                <a:latin typeface="Georgia"/>
+                <a:ea typeface="Georgia"/>
+                <a:cs typeface="Georgia"/>
+              </a:defRPr>
+            </a:lvl1pPr>
+            <a:lvl2pPr>
+              <a:defRPr sz="3750" b="0">
+                <a:solidFill>
+                  <a:srgbClr val="0D0B10"/>
+                </a:solidFill>
+                <a:latin typeface="Georgia"/>
+                <a:ea typeface="Georgia"/>
+                <a:cs typeface="Georgia"/>
+              </a:defRPr>
+            </a:lvl2pPr>
+            <a:lvl3pPr>
+              <a:defRPr sz="3750" b="0">
+                <a:solidFill>
+                  <a:srgbClr val="0D0B10"/>
+                </a:solidFill>
+                <a:latin typeface="Georgia"/>
+                <a:ea typeface="Georgia"/>
+                <a:cs typeface="Georgia"/>
+              </a:defRPr>
+            </a:lvl3pPr>
+            <a:lvl4pPr>
+              <a:defRPr sz="3750" b="0">
+                <a:solidFill>
+                  <a:srgbClr val="0D0B10"/>
+                </a:solidFill>
+                <a:latin typeface="Georgia"/>
+                <a:ea typeface="Georgia"/>
+                <a:cs typeface="Georgia"/>
+              </a:defRPr>
+            </a:lvl4pPr>
+            <a:lvl5pPr>
+              <a:defRPr sz="3750" b="0">
+                <a:solidFill>
+                  <a:srgbClr val="0D0B10"/>
+                </a:solidFill>
+                <a:latin typeface="Georgia"/>
+                <a:ea typeface="Georgia"/>
+                <a:cs typeface="Georgia"/>
+              </a:defRPr>
+            </a:lvl5pPr>
+            <a:lvl6pPr>
+              <a:defRPr sz="3750" b="0">
+                <a:solidFill>
+                  <a:srgbClr val="0D0B10"/>
+                </a:solidFill>
+                <a:latin typeface="Georgia"/>
+                <a:ea typeface="Georgia"/>
+                <a:cs typeface="Georgia"/>
+              </a:defRPr>
+            </a:lvl6pPr>
+            <a:lvl7pPr>
+              <a:defRPr sz="3750" b="0">
+                <a:solidFill>
+                  <a:srgbClr val="0D0B10"/>
+                </a:solidFill>
+                <a:latin typeface="Georgia"/>
+                <a:ea typeface="Georgia"/>
+                <a:cs typeface="Georgia"/>
+              </a:defRPr>
+            </a:lvl7pPr>
+            <a:lvl8pPr>
+              <a:defRPr sz="3750" b="0">
+                <a:solidFill>
+                  <a:srgbClr val="0D0B10"/>
+                </a:solidFill>
+                <a:latin typeface="Georgia"/>
+                <a:ea typeface="Georgia"/>
+                <a:cs typeface="Georgia"/>
+              </a:defRPr>
+            </a:lvl8pPr>
+            <a:lvl9pPr>
+              <a:defRPr sz="3750" b="0">
+                <a:solidFill>
+                  <a:srgbClr val="0D0B10"/>
+                </a:solidFill>
+                <a:latin typeface="Georgia"/>
+                <a:ea typeface="Georgia"/>
+                <a:cs typeface="Georgia"/>
+              </a:defRPr>
+            </a:lvl9pPr>
+          </a:lstStyle>
+          <a:p xmlns:a="http://schemas.openxmlformats.org/drawingml/2006/main">
+            <a:pPr>
+              <a:defRPr sz="3750" b="0">
+                <a:solidFill>
+                  <a:srgbClr val="0D0B10"/>
+                </a:solidFill>
+                <a:latin typeface="Georgia"/>
+                <a:ea typeface="Georgia"/>
+                <a:cs typeface="Georgia"/>
+              </a:defRPr>
+            </a:pPr>
+            <a:r>
+              <a:rPr sz="3750" b="0">
+                <a:solidFill>
+                  <a:srgbClr val="0D0B10"/>
+                </a:solidFill>
+                <a:latin typeface="Georgia"/>
+                <a:ea typeface="Georgia"/>
+                <a:cs typeface="Georgia"/>
+              </a:rPr>
+              <a:t>9,090</a:t>
+            </a:r>
+          </a:p>
+        </p:txBody>
+      </p:sp>
+      <p:sp>
+        <p:nvSpPr>
+          <p:cNvPr id="20" name="text-190">
+            <a:extLst xmlns:a="http://schemas.openxmlformats.org/drawingml/2006/main">
+              <a:ext uri="{FF2B5EF4-FFF2-40B4-BE49-F238E27FC236}">
+                <a16:creationId xmlns:a16="http://schemas.microsoft.com/office/drawing/2014/main" id="{518DCEE9-66DE-401F-B35F-4CD3BEADF792}"/>
+              </a:ext>
+            </a:extLst>
+          </p:cNvPr>
+          <p:cNvSpPr>
+            <a:spLocks xmlns:a="http://schemas.openxmlformats.org/drawingml/2006/main" noGrp="1"/>
+          </p:cNvSpPr>
+          <p:nvPr/>
+        </p:nvSpPr>
+        <p:spPr>
+          <a:xfrm xmlns:a="http://schemas.openxmlformats.org/drawingml/2006/main">
+            <a:off x="8286750" y="3990975"/>
+            <a:ext cx="3333750" cy="323850"/>
+          </a:xfrm>
+          <a:prstGeom xmlns:a="http://schemas.openxmlformats.org/drawingml/2006/main" prst="rect">
+            <a:avLst/>
+          </a:prstGeom>
+          <a:noFill xmlns:a="http://schemas.openxmlformats.org/drawingml/2006/main"/>
+          <a:ln xmlns:a="http://schemas.openxmlformats.org/drawingml/2006/main" w="0">
+            <a:noFill/>
+          </a:ln>
+        </p:spPr>
+        <p:txBody>
+          <a:bodyPr xmlns:a="http://schemas.openxmlformats.org/drawingml/2006/main" lIns="0" tIns="0" rIns="0" bIns="0" anchor="t">
+            <a:noAutofit/>
+          </a:bodyPr>
+          <a:lstStyle xmlns:a="http://schemas.openxmlformats.org/drawingml/2006/main">
+            <a:defPPr>
+              <a:defRPr sz="1200" b="0">
+                <a:solidFill>
+                  <a:srgbClr val="5D555A"/>
+                </a:solidFill>
+                <a:latin typeface="Arial"/>
+                <a:ea typeface="Arial"/>
+                <a:cs typeface="Arial"/>
+              </a:defRPr>
+            </a:defPPr>
+            <a:lvl1pPr>
+              <a:defRPr sz="1200" b="0">
+                <a:solidFill>
+                  <a:srgbClr val="5D555A"/>
+                </a:solidFill>
+                <a:latin typeface="Arial"/>
+                <a:ea typeface="Arial"/>
+                <a:cs typeface="Arial"/>
+              </a:defRPr>
+            </a:lvl1pPr>
+            <a:lvl2pPr>
+              <a:defRPr sz="1200" b="0">
+                <a:solidFill>
+                  <a:srgbClr val="5D555A"/>
+                </a:solidFill>
+                <a:latin typeface="Arial"/>
+                <a:ea typeface="Arial"/>
+                <a:cs typeface="Arial"/>
+              </a:defRPr>
+            </a:lvl2pPr>
+            <a:lvl3pPr>
+              <a:defRPr sz="1200" b="0">
+                <a:solidFill>
+                  <a:srgbClr val="5D555A"/>
+                </a:solidFill>
+                <a:latin typeface="Arial"/>
+                <a:ea typeface="Arial"/>
+                <a:cs typeface="Arial"/>
+              </a:defRPr>
+            </a:lvl3pPr>
+            <a:lvl4pPr>
+              <a:defRPr sz="1200" b="0">
+                <a:solidFill>
+                  <a:srgbClr val="5D555A"/>
+                </a:solidFill>
+                <a:latin typeface="Arial"/>
+                <a:ea typeface="Arial"/>
+                <a:cs typeface="Arial"/>
+              </a:defRPr>
+            </a:lvl4pPr>
+            <a:lvl5pPr>
+              <a:defRPr sz="1200" b="0">
+                <a:solidFill>
+                  <a:srgbClr val="5D555A"/>
+                </a:solidFill>
+                <a:latin typeface="Arial"/>
+                <a:ea typeface="Arial"/>
+                <a:cs typeface="Arial"/>
+              </a:defRPr>
+            </a:lvl5pPr>
+            <a:lvl6pPr>
+              <a:defRPr sz="1200" b="0">
+                <a:solidFill>
+                  <a:srgbClr val="5D555A"/>
+                </a:solidFill>
+                <a:latin typeface="Arial"/>
+                <a:ea typeface="Arial"/>
+                <a:cs typeface="Arial"/>
+              </a:defRPr>
+            </a:lvl6pPr>
+            <a:lvl7pPr>
+              <a:defRPr sz="1200" b="0">
+                <a:solidFill>
+                  <a:srgbClr val="5D555A"/>
+                </a:solidFill>
+                <a:latin typeface="Arial"/>
+                <a:ea typeface="Arial"/>
+                <a:cs typeface="Arial"/>
+              </a:defRPr>
+            </a:lvl7pPr>
+            <a:lvl8pPr>
+              <a:defRPr sz="1200" b="0">
+                <a:solidFill>
+                  <a:srgbClr val="5D555A"/>
+                </a:solidFill>
+                <a:latin typeface="Arial"/>
+                <a:ea typeface="Arial"/>
+                <a:cs typeface="Arial"/>
+              </a:defRPr>
+            </a:lvl8pPr>
+            <a:lvl9pPr>
+              <a:defRPr sz="1200" b="0">
+                <a:solidFill>
+                  <a:srgbClr val="5D555A"/>
+                </a:solidFill>
+                <a:latin typeface="Arial"/>
+                <a:ea typeface="Arial"/>
+                <a:cs typeface="Arial"/>
+              </a:defRPr>
+            </a:lvl9pPr>
+          </a:lstStyle>
+          <a:p xmlns:a="http://schemas.openxmlformats.org/drawingml/2006/main">
+            <a:pPr>
+              <a:defRPr sz="1200" b="0">
+                <a:solidFill>
+                  <a:srgbClr val="5D555A"/>
+                </a:solidFill>
+                <a:latin typeface="Arial"/>
+                <a:ea typeface="Arial"/>
+                <a:cs typeface="Arial"/>
+              </a:defRPr>
+            </a:pPr>
+            <a:r>
+              <a:rPr sz="1200" b="0">
+                <a:solidFill>
+                  <a:srgbClr val="5D555A"/>
+                </a:solidFill>
+                <a:latin typeface="Arial"/>
+                <a:ea typeface="Arial"/>
+                <a:cs typeface="Arial"/>
+              </a:rPr>
               <a:t>accounts that viewed the content</a:t>
             </a:r>
           </a:p>
@@ -11634,10 +11574,10 @@
       </p:sp>
       <p:sp>
         <p:nvSpPr>
-          <p:cNvPr id="21" name="rule-195">
+          <p:cNvPr id="21" name="rule-191">
             <a:extLst xmlns:a="http://schemas.openxmlformats.org/drawingml/2006/main">
               <a:ext uri="{FF2B5EF4-FFF2-40B4-BE49-F238E27FC236}">
-                <a16:creationId xmlns:a16="http://schemas.microsoft.com/office/drawing/2014/main" id="{5AB742E1-F7B3-428E-BF08-193673EEFFF9}"/>
+                <a16:creationId xmlns:a16="http://schemas.microsoft.com/office/drawing/2014/main" id="{0DBBE456-0029-4E34-9F0F-0E2BE66D39D3}"/>
               </a:ext>
             </a:extLst>
           </p:cNvPr>
@@ -11664,10 +11604,10 @@
       </p:sp>
       <p:sp>
         <p:nvSpPr>
-          <p:cNvPr id="22" name="text-196">
+          <p:cNvPr id="22" name="text-192">
             <a:extLst xmlns:a="http://schemas.openxmlformats.org/drawingml/2006/main">
               <a:ext uri="{FF2B5EF4-FFF2-40B4-BE49-F238E27FC236}">
-                <a16:creationId xmlns:a16="http://schemas.microsoft.com/office/drawing/2014/main" id="{9F03A6CB-C25D-4676-B92E-6968D59D40C1}"/>
+                <a16:creationId xmlns:a16="http://schemas.microsoft.com/office/drawing/2014/main" id="{50782F79-22A7-4AD5-B3BB-289B898C0385}"/>
               </a:ext>
             </a:extLst>
           </p:cNvPr>
@@ -11822,10 +11762,10 @@
       </p:sp>
       <p:sp>
         <p:nvSpPr>
-          <p:cNvPr id="23" name="text-197">
+          <p:cNvPr id="23" name="text-193">
             <a:extLst xmlns:a="http://schemas.openxmlformats.org/drawingml/2006/main">
               <a:ext uri="{FF2B5EF4-FFF2-40B4-BE49-F238E27FC236}">
-                <a16:creationId xmlns:a16="http://schemas.microsoft.com/office/drawing/2014/main" id="{5CB46FD6-1D2B-4A8A-BFE1-76267964400B}"/>
+                <a16:creationId xmlns:a16="http://schemas.microsoft.com/office/drawing/2014/main" id="{1BACA9DA-0DC7-4979-B100-A69EE986CCD0}"/>
               </a:ext>
             </a:extLst>
           </p:cNvPr>
@@ -11980,10 +11920,10 @@
       </p:sp>
       <p:sp>
         <p:nvSpPr>
-          <p:cNvPr id="24" name="box-198">
+          <p:cNvPr id="24" name="box-194">
             <a:extLst xmlns:a="http://schemas.openxmlformats.org/drawingml/2006/main">
               <a:ext uri="{FF2B5EF4-FFF2-40B4-BE49-F238E27FC236}">
-                <a16:creationId xmlns:a16="http://schemas.microsoft.com/office/drawing/2014/main" id="{1A9F1224-210D-4509-8568-FFF4F6E0EC15}"/>
+                <a16:creationId xmlns:a16="http://schemas.microsoft.com/office/drawing/2014/main" id="{3E430378-1BD7-4899-B69C-D41D39E367C8}"/>
               </a:ext>
             </a:extLst>
           </p:cNvPr>
@@ -12010,10 +11950,10 @@
       </p:sp>
       <p:sp>
         <p:nvSpPr>
-          <p:cNvPr id="25" name="box-199">
+          <p:cNvPr id="25" name="box-195">
             <a:extLst xmlns:a="http://schemas.openxmlformats.org/drawingml/2006/main">
               <a:ext uri="{FF2B5EF4-FFF2-40B4-BE49-F238E27FC236}">
-                <a16:creationId xmlns:a16="http://schemas.microsoft.com/office/drawing/2014/main" id="{BF4F4C3C-113D-488C-864F-063C6A4948D1}"/>
+                <a16:creationId xmlns:a16="http://schemas.microsoft.com/office/drawing/2014/main" id="{9ED08B45-79B7-42A0-B7B1-6379051CDADA}"/>
               </a:ext>
             </a:extLst>
           </p:cNvPr>
@@ -12040,10 +11980,10 @@
       </p:sp>
       <p:sp>
         <p:nvSpPr>
-          <p:cNvPr id="26" name="text-200">
+          <p:cNvPr id="26" name="text-196">
             <a:extLst xmlns:a="http://schemas.openxmlformats.org/drawingml/2006/main">
               <a:ext uri="{FF2B5EF4-FFF2-40B4-BE49-F238E27FC236}">
-                <a16:creationId xmlns:a16="http://schemas.microsoft.com/office/drawing/2014/main" id="{35927D30-14CE-4D8E-8E2E-1787CE1A215C}"/>
+                <a16:creationId xmlns:a16="http://schemas.microsoft.com/office/drawing/2014/main" id="{1EE2BDB9-DED6-474A-B883-48D58F52A42B}"/>
               </a:ext>
             </a:extLst>
           </p:cNvPr>
@@ -12198,10 +12138,10 @@
       </p:sp>
       <p:sp>
         <p:nvSpPr>
-          <p:cNvPr id="27" name="text-201">
+          <p:cNvPr id="27" name="text-197">
             <a:extLst xmlns:a="http://schemas.openxmlformats.org/drawingml/2006/main">
               <a:ext uri="{FF2B5EF4-FFF2-40B4-BE49-F238E27FC236}">
-                <a16:creationId xmlns:a16="http://schemas.microsoft.com/office/drawing/2014/main" id="{F34E24FF-24C7-4E79-A4F0-20C4D706D431}"/>
+                <a16:creationId xmlns:a16="http://schemas.microsoft.com/office/drawing/2014/main" id="{54832FC2-6704-461E-A077-0D88BB08A619}"/>
               </a:ext>
             </a:extLst>
           </p:cNvPr>
@@ -12356,10 +12296,10 @@
       </p:sp>
       <p:sp>
         <p:nvSpPr>
-          <p:cNvPr id="28" name="box-202">
+          <p:cNvPr id="28" name="box-198">
             <a:extLst xmlns:a="http://schemas.openxmlformats.org/drawingml/2006/main">
               <a:ext uri="{FF2B5EF4-FFF2-40B4-BE49-F238E27FC236}">
-                <a16:creationId xmlns:a16="http://schemas.microsoft.com/office/drawing/2014/main" id="{1C104623-C674-4E6C-B983-A266BB89717B}"/>
+                <a16:creationId xmlns:a16="http://schemas.microsoft.com/office/drawing/2014/main" id="{2E1E8361-3E79-4AA1-8BAF-6BBD3F8AE7D3}"/>
               </a:ext>
             </a:extLst>
           </p:cNvPr>
@@ -12386,10 +12326,10 @@
       </p:sp>
       <p:sp>
         <p:nvSpPr>
-          <p:cNvPr id="29" name="box-203">
+          <p:cNvPr id="29" name="box-199">
             <a:extLst xmlns:a="http://schemas.openxmlformats.org/drawingml/2006/main">
               <a:ext uri="{FF2B5EF4-FFF2-40B4-BE49-F238E27FC236}">
-                <a16:creationId xmlns:a16="http://schemas.microsoft.com/office/drawing/2014/main" id="{3961659A-49C7-4EE5-8CAA-274F12B1BD40}"/>
+                <a16:creationId xmlns:a16="http://schemas.microsoft.com/office/drawing/2014/main" id="{99272E93-FADE-4FEE-BB0C-C7946EBC46DA}"/>
               </a:ext>
             </a:extLst>
           </p:cNvPr>
@@ -12416,10 +12356,10 @@
       </p:sp>
       <p:sp>
         <p:nvSpPr>
-          <p:cNvPr id="30" name="text-204">
+          <p:cNvPr id="30" name="text-200">
             <a:extLst xmlns:a="http://schemas.openxmlformats.org/drawingml/2006/main">
               <a:ext uri="{FF2B5EF4-FFF2-40B4-BE49-F238E27FC236}">
-                <a16:creationId xmlns:a16="http://schemas.microsoft.com/office/drawing/2014/main" id="{8E1E98E4-B956-432D-8D28-B5012BCF5629}"/>
+                <a16:creationId xmlns:a16="http://schemas.microsoft.com/office/drawing/2014/main" id="{E5EED4E0-5C06-4CCA-B31E-41323C303233}"/>
               </a:ext>
             </a:extLst>
           </p:cNvPr>
@@ -12574,10 +12514,10 @@
       </p:sp>
       <p:sp>
         <p:nvSpPr>
-          <p:cNvPr id="31" name="text-205">
+          <p:cNvPr id="31" name="text-201">
             <a:extLst xmlns:a="http://schemas.openxmlformats.org/drawingml/2006/main">
               <a:ext uri="{FF2B5EF4-FFF2-40B4-BE49-F238E27FC236}">
-                <a16:creationId xmlns:a16="http://schemas.microsoft.com/office/drawing/2014/main" id="{6A1DF0BA-AAE7-4786-8A4B-B659AB061554}"/>
+                <a16:creationId xmlns:a16="http://schemas.microsoft.com/office/drawing/2014/main" id="{292C094A-16DF-43DD-9195-E7CFC20ADA0D}"/>
               </a:ext>
             </a:extLst>
           </p:cNvPr>
@@ -12732,10 +12672,10 @@
       </p:sp>
       <p:sp>
         <p:nvSpPr>
-          <p:cNvPr id="32" name="box-206">
+          <p:cNvPr id="32" name="box-202">
             <a:extLst xmlns:a="http://schemas.openxmlformats.org/drawingml/2006/main">
               <a:ext uri="{FF2B5EF4-FFF2-40B4-BE49-F238E27FC236}">
-                <a16:creationId xmlns:a16="http://schemas.microsoft.com/office/drawing/2014/main" id="{4C9FED9C-B92C-4C52-8A19-D98A014082D8}"/>
+                <a16:creationId xmlns:a16="http://schemas.microsoft.com/office/drawing/2014/main" id="{7DC936ED-5663-40EA-A339-06560AC9093C}"/>
               </a:ext>
             </a:extLst>
           </p:cNvPr>
@@ -12762,10 +12702,10 @@
       </p:sp>
       <p:sp>
         <p:nvSpPr>
-          <p:cNvPr id="33" name="box-207">
+          <p:cNvPr id="33" name="box-203">
             <a:extLst xmlns:a="http://schemas.openxmlformats.org/drawingml/2006/main">
               <a:ext uri="{FF2B5EF4-FFF2-40B4-BE49-F238E27FC236}">
-                <a16:creationId xmlns:a16="http://schemas.microsoft.com/office/drawing/2014/main" id="{DADFCCC7-D1CC-45EA-9512-24488D645644}"/>
+                <a16:creationId xmlns:a16="http://schemas.microsoft.com/office/drawing/2014/main" id="{8A3EEF09-4B0B-440B-91CF-92B99E29D029}"/>
               </a:ext>
             </a:extLst>
           </p:cNvPr>
@@ -12792,10 +12732,10 @@
       </p:sp>
       <p:sp>
         <p:nvSpPr>
-          <p:cNvPr id="34" name="text-208">
+          <p:cNvPr id="34" name="text-204">
             <a:extLst xmlns:a="http://schemas.openxmlformats.org/drawingml/2006/main">
               <a:ext uri="{FF2B5EF4-FFF2-40B4-BE49-F238E27FC236}">
-                <a16:creationId xmlns:a16="http://schemas.microsoft.com/office/drawing/2014/main" id="{FAD2E21A-4C95-4ADB-8565-B91DEF58B954}"/>
+                <a16:creationId xmlns:a16="http://schemas.microsoft.com/office/drawing/2014/main" id="{9DFC0CC3-5BB0-441E-A18D-92A190719E3E}"/>
               </a:ext>
             </a:extLst>
           </p:cNvPr>
@@ -12950,10 +12890,10 @@
       </p:sp>
       <p:sp>
         <p:nvSpPr>
-          <p:cNvPr id="35" name="text-209">
+          <p:cNvPr id="35" name="text-205">
             <a:extLst xmlns:a="http://schemas.openxmlformats.org/drawingml/2006/main">
               <a:ext uri="{FF2B5EF4-FFF2-40B4-BE49-F238E27FC236}">
-                <a16:creationId xmlns:a16="http://schemas.microsoft.com/office/drawing/2014/main" id="{029A6F06-BB52-4920-9286-5AB6BD0F778B}"/>
+                <a16:creationId xmlns:a16="http://schemas.microsoft.com/office/drawing/2014/main" id="{74EFCF7E-FB55-4F4C-A2FB-DE0E892FA219}"/>
               </a:ext>
             </a:extLst>
           </p:cNvPr>
@@ -13108,10 +13048,10 @@
       </p:sp>
       <p:sp>
         <p:nvSpPr>
-          <p:cNvPr id="36" name="box-210">
+          <p:cNvPr id="36" name="box-206">
             <a:extLst xmlns:a="http://schemas.openxmlformats.org/drawingml/2006/main">
               <a:ext uri="{FF2B5EF4-FFF2-40B4-BE49-F238E27FC236}">
-                <a16:creationId xmlns:a16="http://schemas.microsoft.com/office/drawing/2014/main" id="{C64B1C4F-7272-45F2-ACC3-F87A1001F97E}"/>
+                <a16:creationId xmlns:a16="http://schemas.microsoft.com/office/drawing/2014/main" id="{DB1B6CFE-4E42-4F80-BF12-0835A0126635}"/>
               </a:ext>
             </a:extLst>
           </p:cNvPr>
@@ -13138,10 +13078,10 @@
       </p:sp>
       <p:sp>
         <p:nvSpPr>
-          <p:cNvPr id="37" name="box-211">
+          <p:cNvPr id="37" name="box-207">
             <a:extLst xmlns:a="http://schemas.openxmlformats.org/drawingml/2006/main">
               <a:ext uri="{FF2B5EF4-FFF2-40B4-BE49-F238E27FC236}">
-                <a16:creationId xmlns:a16="http://schemas.microsoft.com/office/drawing/2014/main" id="{38F9EFD8-3F38-40E8-92A5-87C014C0B22D}"/>
+                <a16:creationId xmlns:a16="http://schemas.microsoft.com/office/drawing/2014/main" id="{577A4C7C-2232-4376-80CE-D5C8595838BC}"/>
               </a:ext>
             </a:extLst>
           </p:cNvPr>
@@ -13168,10 +13108,10 @@
       </p:sp>
       <p:sp>
         <p:nvSpPr>
-          <p:cNvPr id="38" name="text-212">
+          <p:cNvPr id="38" name="text-208">
             <a:extLst xmlns:a="http://schemas.openxmlformats.org/drawingml/2006/main">
               <a:ext uri="{FF2B5EF4-FFF2-40B4-BE49-F238E27FC236}">
-                <a16:creationId xmlns:a16="http://schemas.microsoft.com/office/drawing/2014/main" id="{F8752513-FEB6-47FD-BED0-22B41CA6E36B}"/>
+                <a16:creationId xmlns:a16="http://schemas.microsoft.com/office/drawing/2014/main" id="{DA651D34-D0DA-464F-94E7-37757A9C34D2}"/>
               </a:ext>
             </a:extLst>
           </p:cNvPr>
@@ -13326,10 +13266,10 @@
       </p:sp>
       <p:sp>
         <p:nvSpPr>
-          <p:cNvPr id="39" name="text-213">
+          <p:cNvPr id="39" name="text-209">
             <a:extLst xmlns:a="http://schemas.openxmlformats.org/drawingml/2006/main">
               <a:ext uri="{FF2B5EF4-FFF2-40B4-BE49-F238E27FC236}">
-                <a16:creationId xmlns:a16="http://schemas.microsoft.com/office/drawing/2014/main" id="{AFAC6EF3-E423-4E49-9E07-A45A18A7FBCC}"/>
+                <a16:creationId xmlns:a16="http://schemas.microsoft.com/office/drawing/2014/main" id="{FAFC8108-7EAA-4135-9479-1D1E8917A4DF}"/>
               </a:ext>
             </a:extLst>
           </p:cNvPr>
@@ -13484,10 +13424,10 @@
       </p:sp>
       <p:sp>
         <p:nvSpPr>
-          <p:cNvPr id="40" name="box-214">
+          <p:cNvPr id="40" name="box-210">
             <a:extLst xmlns:a="http://schemas.openxmlformats.org/drawingml/2006/main">
               <a:ext uri="{FF2B5EF4-FFF2-40B4-BE49-F238E27FC236}">
-                <a16:creationId xmlns:a16="http://schemas.microsoft.com/office/drawing/2014/main" id="{B36DE807-50B3-415D-B411-4BEB9A733060}"/>
+                <a16:creationId xmlns:a16="http://schemas.microsoft.com/office/drawing/2014/main" id="{E86CC012-0EE1-4639-9662-30F03CD24537}"/>
               </a:ext>
             </a:extLst>
           </p:cNvPr>
@@ -13514,10 +13454,10 @@
       </p:sp>
       <p:sp>
         <p:nvSpPr>
-          <p:cNvPr id="41" name="box-215">
+          <p:cNvPr id="41" name="box-211">
             <a:extLst xmlns:a="http://schemas.openxmlformats.org/drawingml/2006/main">
               <a:ext uri="{FF2B5EF4-FFF2-40B4-BE49-F238E27FC236}">
-                <a16:creationId xmlns:a16="http://schemas.microsoft.com/office/drawing/2014/main" id="{E0C15202-564B-4F07-90F4-BD6A113D5C3F}"/>
+                <a16:creationId xmlns:a16="http://schemas.microsoft.com/office/drawing/2014/main" id="{D2375A16-664B-486B-96A0-DBDC50FA2B72}"/>
               </a:ext>
             </a:extLst>
           </p:cNvPr>
@@ -13544,10 +13484,10 @@
       </p:sp>
       <p:sp>
         <p:nvSpPr>
-          <p:cNvPr id="42" name="text-216">
+          <p:cNvPr id="42" name="text-212">
             <a:extLst xmlns:a="http://schemas.openxmlformats.org/drawingml/2006/main">
               <a:ext uri="{FF2B5EF4-FFF2-40B4-BE49-F238E27FC236}">
-                <a16:creationId xmlns:a16="http://schemas.microsoft.com/office/drawing/2014/main" id="{C3B19F9D-B8A8-4087-B2C9-91E72101C9B7}"/>
+                <a16:creationId xmlns:a16="http://schemas.microsoft.com/office/drawing/2014/main" id="{4FA25430-7C57-4C7B-ACE8-DE91A1CE532B}"/>
               </a:ext>
             </a:extLst>
           </p:cNvPr>
@@ -13702,10 +13642,10 @@
       </p:sp>
       <p:sp>
         <p:nvSpPr>
-          <p:cNvPr id="43" name="text-217">
+          <p:cNvPr id="43" name="text-213">
             <a:extLst xmlns:a="http://schemas.openxmlformats.org/drawingml/2006/main">
               <a:ext uri="{FF2B5EF4-FFF2-40B4-BE49-F238E27FC236}">
-                <a16:creationId xmlns:a16="http://schemas.microsoft.com/office/drawing/2014/main" id="{0B0F8245-EF48-430D-93A1-11B5B2340651}"/>
+                <a16:creationId xmlns:a16="http://schemas.microsoft.com/office/drawing/2014/main" id="{E320BB19-4C54-4954-B3AA-3E7D06D417BC}"/>
               </a:ext>
             </a:extLst>
           </p:cNvPr>
@@ -13860,10 +13800,10 @@
       </p:sp>
       <p:sp>
         <p:nvSpPr>
-          <p:cNvPr id="44" name="box-218">
+          <p:cNvPr id="44" name="box-214">
             <a:extLst xmlns:a="http://schemas.openxmlformats.org/drawingml/2006/main">
               <a:ext uri="{FF2B5EF4-FFF2-40B4-BE49-F238E27FC236}">
-                <a16:creationId xmlns:a16="http://schemas.microsoft.com/office/drawing/2014/main" id="{D898F1BD-BF03-4365-A6E4-50135062F67F}"/>
+                <a16:creationId xmlns:a16="http://schemas.microsoft.com/office/drawing/2014/main" id="{81359F87-CDFB-43CA-80BD-277D2BA36D1F}"/>
               </a:ext>
             </a:extLst>
           </p:cNvPr>
@@ -13890,10 +13830,10 @@
       </p:sp>
       <p:sp>
         <p:nvSpPr>
-          <p:cNvPr id="45" name="box-219">
+          <p:cNvPr id="45" name="box-215">
             <a:extLst xmlns:a="http://schemas.openxmlformats.org/drawingml/2006/main">
               <a:ext uri="{FF2B5EF4-FFF2-40B4-BE49-F238E27FC236}">
-                <a16:creationId xmlns:a16="http://schemas.microsoft.com/office/drawing/2014/main" id="{E3F4EC9F-3EE5-41B1-93CC-AB985930E593}"/>
+                <a16:creationId xmlns:a16="http://schemas.microsoft.com/office/drawing/2014/main" id="{68A5F918-9825-45F1-A092-22233DE68F1F}"/>
               </a:ext>
             </a:extLst>
           </p:cNvPr>
@@ -13920,10 +13860,10 @@
       </p:sp>
       <p:sp>
         <p:nvSpPr>
-          <p:cNvPr id="46" name="text-220">
+          <p:cNvPr id="46" name="text-216">
             <a:extLst xmlns:a="http://schemas.openxmlformats.org/drawingml/2006/main">
               <a:ext uri="{FF2B5EF4-FFF2-40B4-BE49-F238E27FC236}">
-                <a16:creationId xmlns:a16="http://schemas.microsoft.com/office/drawing/2014/main" id="{FF78AA6A-54EC-483B-AC5F-630197B14DCE}"/>
+                <a16:creationId xmlns:a16="http://schemas.microsoft.com/office/drawing/2014/main" id="{84FCF441-AED5-4E71-BE56-8FB866046C35}"/>
               </a:ext>
             </a:extLst>
           </p:cNvPr>
@@ -14078,10 +14018,10 @@
       </p:sp>
       <p:sp>
         <p:nvSpPr>
-          <p:cNvPr id="47" name="text-221">
+          <p:cNvPr id="47" name="text-217">
             <a:extLst xmlns:a="http://schemas.openxmlformats.org/drawingml/2006/main">
               <a:ext uri="{FF2B5EF4-FFF2-40B4-BE49-F238E27FC236}">
-                <a16:creationId xmlns:a16="http://schemas.microsoft.com/office/drawing/2014/main" id="{A3DDD432-8052-46E4-B405-4A5BE92FD248}"/>
+                <a16:creationId xmlns:a16="http://schemas.microsoft.com/office/drawing/2014/main" id="{D5D9ADFC-C2A4-4002-B242-0256E746D551}"/>
               </a:ext>
             </a:extLst>
           </p:cNvPr>
@@ -14236,10 +14176,10 @@
       </p:sp>
       <p:sp>
         <p:nvSpPr>
-          <p:cNvPr id="48" name="text-222">
+          <p:cNvPr id="48" name="text-218">
             <a:extLst xmlns:a="http://schemas.openxmlformats.org/drawingml/2006/main">
               <a:ext uri="{FF2B5EF4-FFF2-40B4-BE49-F238E27FC236}">
-                <a16:creationId xmlns:a16="http://schemas.microsoft.com/office/drawing/2014/main" id="{98039B0C-14F5-4932-A726-073D88911C73}"/>
+                <a16:creationId xmlns:a16="http://schemas.microsoft.com/office/drawing/2014/main" id="{6CE37798-EA46-428B-A037-2E118608DD74}"/>
               </a:ext>
             </a:extLst>
           </p:cNvPr>
@@ -14394,10 +14334,10 @@
       </p:sp>
       <p:sp>
         <p:nvSpPr>
-          <p:cNvPr id="49" name="text-223">
+          <p:cNvPr id="49" name="text-219">
             <a:extLst xmlns:a="http://schemas.openxmlformats.org/drawingml/2006/main">
               <a:ext uri="{FF2B5EF4-FFF2-40B4-BE49-F238E27FC236}">
-                <a16:creationId xmlns:a16="http://schemas.microsoft.com/office/drawing/2014/main" id="{177B8C2A-D1F5-4274-9362-DAF4B3D69071}"/>
+                <a16:creationId xmlns:a16="http://schemas.microsoft.com/office/drawing/2014/main" id="{E4EB0586-AF1C-41F3-B368-EAB59393F6A2}"/>
               </a:ext>
             </a:extLst>
           </p:cNvPr>
@@ -14552,10 +14492,10 @@
       </p:sp>
       <p:sp>
         <p:nvSpPr>
-          <p:cNvPr id="50" name="text-224">
+          <p:cNvPr id="50" name="text-220">
             <a:extLst xmlns:a="http://schemas.openxmlformats.org/drawingml/2006/main">
               <a:ext uri="{FF2B5EF4-FFF2-40B4-BE49-F238E27FC236}">
-                <a16:creationId xmlns:a16="http://schemas.microsoft.com/office/drawing/2014/main" id="{6CCEAD19-A286-45A4-9F9E-F7DC28203F1C}"/>
+                <a16:creationId xmlns:a16="http://schemas.microsoft.com/office/drawing/2014/main" id="{AD539BC4-97E9-42DD-9934-FD800329F28A}"/>
               </a:ext>
             </a:extLst>
           </p:cNvPr>
@@ -14710,10 +14650,10 @@
       </p:sp>
       <p:sp>
         <p:nvSpPr>
-          <p:cNvPr id="51" name="text-225">
+          <p:cNvPr id="51" name="text-221">
             <a:extLst xmlns:a="http://schemas.openxmlformats.org/drawingml/2006/main">
               <a:ext uri="{FF2B5EF4-FFF2-40B4-BE49-F238E27FC236}">
-                <a16:creationId xmlns:a16="http://schemas.microsoft.com/office/drawing/2014/main" id="{7DF7D705-AD2B-489C-8CE5-FEFFE9DA1025}"/>
+                <a16:creationId xmlns:a16="http://schemas.microsoft.com/office/drawing/2014/main" id="{B4925C94-91C7-41B3-8E48-FE96CC3CFD82}"/>
               </a:ext>
             </a:extLst>
           </p:cNvPr>
@@ -14868,10 +14808,10 @@
       </p:sp>
       <p:sp>
         <p:nvSpPr>
-          <p:cNvPr id="52" name="text-226">
+          <p:cNvPr id="52" name="text-222">
             <a:extLst xmlns:a="http://schemas.openxmlformats.org/drawingml/2006/main">
               <a:ext uri="{FF2B5EF4-FFF2-40B4-BE49-F238E27FC236}">
-                <a16:creationId xmlns:a16="http://schemas.microsoft.com/office/drawing/2014/main" id="{BF07C2F8-C918-4540-878C-BCC4547D6431}"/>
+                <a16:creationId xmlns:a16="http://schemas.microsoft.com/office/drawing/2014/main" id="{5B6A60C5-50B0-4A20-82B3-0803A670D919}"/>
               </a:ext>
             </a:extLst>
           </p:cNvPr>
@@ -15027,7 +14967,7 @@
     </p:spTree>
     <p:extLst>
       <p:ext uri="{BB962C8B-B14F-4D97-AF65-F5344CB8AC3E}">
-        <p14:creationId xmlns:p14="http://schemas.microsoft.com/office/powerpoint/2010/main" val="1920042980"/>
+        <p14:creationId xmlns:p14="http://schemas.microsoft.com/office/powerpoint/2010/main" val="1085948654"/>
       </p:ext>
     </p:extLst>
   </p:cSld>
@@ -15055,10 +14995,10 @@
       </p:grpSpPr>
       <p:sp>
         <p:nvSpPr>
-          <p:cNvPr id="24" name="text-227">
+          <p:cNvPr id="24" name="text-223">
             <a:extLst xmlns:a="http://schemas.openxmlformats.org/drawingml/2006/main">
               <a:ext uri="{FF2B5EF4-FFF2-40B4-BE49-F238E27FC236}">
-                <a16:creationId xmlns:a16="http://schemas.microsoft.com/office/drawing/2014/main" id="{E0D06FEE-C82D-4F1E-9FDB-CF020278305F}"/>
+                <a16:creationId xmlns:a16="http://schemas.microsoft.com/office/drawing/2014/main" id="{2810E0A7-2F39-42A5-BE18-79AB13E1CC55}"/>
               </a:ext>
             </a:extLst>
           </p:cNvPr>
@@ -15213,10 +15153,10 @@
       </p:sp>
       <p:sp>
         <p:nvSpPr>
-          <p:cNvPr id="2" name="text-228">
+          <p:cNvPr id="2" name="text-224">
             <a:extLst xmlns:a="http://schemas.openxmlformats.org/drawingml/2006/main">
               <a:ext uri="{FF2B5EF4-FFF2-40B4-BE49-F238E27FC236}">
-                <a16:creationId xmlns:a16="http://schemas.microsoft.com/office/drawing/2014/main" id="{BC61F228-97E9-4388-8D60-9C66B985326F}"/>
+                <a16:creationId xmlns:a16="http://schemas.microsoft.com/office/drawing/2014/main" id="{ACAFDD64-30F3-4ED2-B5A6-E9FD94E8454E}"/>
               </a:ext>
             </a:extLst>
           </p:cNvPr>
@@ -15371,10 +15311,10 @@
       </p:sp>
       <p:sp>
         <p:nvSpPr>
-          <p:cNvPr id="3" name="rule-229">
+          <p:cNvPr id="3" name="rule-225">
             <a:extLst xmlns:a="http://schemas.openxmlformats.org/drawingml/2006/main">
               <a:ext uri="{FF2B5EF4-FFF2-40B4-BE49-F238E27FC236}">
-                <a16:creationId xmlns:a16="http://schemas.microsoft.com/office/drawing/2014/main" id="{BD3E0A52-9C1F-4CCC-B62E-E988C9EC0545}"/>
+                <a16:creationId xmlns:a16="http://schemas.microsoft.com/office/drawing/2014/main" id="{963E623E-F3F7-413B-A5C1-9B5679A449C5}"/>
               </a:ext>
             </a:extLst>
           </p:cNvPr>
@@ -15401,10 +15341,10 @@
       </p:sp>
       <p:sp>
         <p:nvSpPr>
-          <p:cNvPr id="4" name="text-230">
+          <p:cNvPr id="4" name="text-226">
             <a:extLst xmlns:a="http://schemas.openxmlformats.org/drawingml/2006/main">
               <a:ext uri="{FF2B5EF4-FFF2-40B4-BE49-F238E27FC236}">
-                <a16:creationId xmlns:a16="http://schemas.microsoft.com/office/drawing/2014/main" id="{486C9670-04B6-4FE4-BC13-7B049554F5B0}"/>
+                <a16:creationId xmlns:a16="http://schemas.microsoft.com/office/drawing/2014/main" id="{2D1350B4-821C-429B-8D36-2C162C9FD0AB}"/>
               </a:ext>
             </a:extLst>
           </p:cNvPr>
@@ -15559,10 +15499,10 @@
       </p:sp>
       <p:sp>
         <p:nvSpPr>
-          <p:cNvPr id="5" name="text-231">
+          <p:cNvPr id="5" name="text-227">
             <a:extLst xmlns:a="http://schemas.openxmlformats.org/drawingml/2006/main">
               <a:ext uri="{FF2B5EF4-FFF2-40B4-BE49-F238E27FC236}">
-                <a16:creationId xmlns:a16="http://schemas.microsoft.com/office/drawing/2014/main" id="{A96DFC19-5618-4D12-A1DB-EC47DC81C7A8}"/>
+                <a16:creationId xmlns:a16="http://schemas.microsoft.com/office/drawing/2014/main" id="{621D3A21-8868-435E-9BCC-119D1BFAB262}"/>
               </a:ext>
             </a:extLst>
           </p:cNvPr>
@@ -15717,10 +15657,10 @@
       </p:sp>
       <p:sp>
         <p:nvSpPr>
-          <p:cNvPr id="6" name="text-232">
+          <p:cNvPr id="6" name="text-228">
             <a:extLst xmlns:a="http://schemas.openxmlformats.org/drawingml/2006/main">
               <a:ext uri="{FF2B5EF4-FFF2-40B4-BE49-F238E27FC236}">
-                <a16:creationId xmlns:a16="http://schemas.microsoft.com/office/drawing/2014/main" id="{84D4EB3E-D4F0-477A-8F28-27AFC2ABEB17}"/>
+                <a16:creationId xmlns:a16="http://schemas.microsoft.com/office/drawing/2014/main" id="{DB0D0C1B-16B1-4FF6-8AFD-9CC8DDA006E6}"/>
               </a:ext>
             </a:extLst>
           </p:cNvPr>
@@ -15875,10 +15815,10 @@
       </p:sp>
       <p:sp>
         <p:nvSpPr>
-          <p:cNvPr id="7" name="text-233">
+          <p:cNvPr id="7" name="text-229">
             <a:extLst xmlns:a="http://schemas.openxmlformats.org/drawingml/2006/main">
               <a:ext uri="{FF2B5EF4-FFF2-40B4-BE49-F238E27FC236}">
-                <a16:creationId xmlns:a16="http://schemas.microsoft.com/office/drawing/2014/main" id="{7D4B8494-C714-4056-BC01-BB30E1CEED5A}"/>
+                <a16:creationId xmlns:a16="http://schemas.microsoft.com/office/drawing/2014/main" id="{42B4ABE6-55CC-4B94-8FF2-98D140304125}"/>
               </a:ext>
             </a:extLst>
           </p:cNvPr>
@@ -16036,7 +15976,7 @@
           <p:cNvPr id="8" name="">
             <a:extLst xmlns:a="http://schemas.openxmlformats.org/drawingml/2006/main">
               <a:ext uri="{FF2B5EF4-FFF2-40B4-BE49-F238E27FC236}">
-                <a16:creationId xmlns:a16="http://schemas.microsoft.com/office/drawing/2014/main" id="{8268CFC2-BD5F-4746-89FD-4C2423F38CBE}"/>
+                <a16:creationId xmlns:a16="http://schemas.microsoft.com/office/drawing/2014/main" id="{2EC44018-B7B0-4156-9B64-B198856F6AF0}"/>
               </a:ext>
             </a:extLst>
           </p:cNvPr>
@@ -16046,7 +15986,7 @@
           <p:nvPr/>
         </p:nvPicPr>
         <p:blipFill>
-          <a:blip xmlns:r="http://schemas.openxmlformats.org/officeDocument/2006/relationships" xmlns:a="http://schemas.openxmlformats.org/drawingml/2006/main" r:embed="Rd7a688e54bc944a6"/>
+          <a:blip xmlns:r="http://schemas.openxmlformats.org/officeDocument/2006/relationships" xmlns:a="http://schemas.openxmlformats.org/drawingml/2006/main" r:embed="R84575d3c667f4e10"/>
           <a:stretch xmlns:a="http://schemas.openxmlformats.org/drawingml/2006/main"/>
         </p:blipFill>
         <p:spPr>
@@ -16064,7 +16004,7 @@
           <p:cNvPr id="9" name="">
             <a:extLst xmlns:a="http://schemas.openxmlformats.org/drawingml/2006/main">
               <a:ext uri="{FF2B5EF4-FFF2-40B4-BE49-F238E27FC236}">
-                <a16:creationId xmlns:a16="http://schemas.microsoft.com/office/drawing/2014/main" id="{70E5FBB8-B95B-43AC-AF6C-4E3B962B8643}"/>
+                <a16:creationId xmlns:a16="http://schemas.microsoft.com/office/drawing/2014/main" id="{BA8D9241-13B2-43E7-B640-075BF4F1812A}"/>
               </a:ext>
             </a:extLst>
           </p:cNvPr>
@@ -16074,7 +16014,7 @@
           <p:nvPr/>
         </p:nvPicPr>
         <p:blipFill>
-          <a:blip xmlns:r="http://schemas.openxmlformats.org/officeDocument/2006/relationships" xmlns:a="http://schemas.openxmlformats.org/drawingml/2006/main" r:embed="R489e5069ed294b0c"/>
+          <a:blip xmlns:r="http://schemas.openxmlformats.org/officeDocument/2006/relationships" xmlns:a="http://schemas.openxmlformats.org/drawingml/2006/main" r:embed="Rfb8a5ce31877461f"/>
           <a:stretch xmlns:a="http://schemas.openxmlformats.org/drawingml/2006/main"/>
         </p:blipFill>
         <p:spPr>
@@ -16089,10 +16029,10 @@
       </p:pic>
       <p:sp>
         <p:nvSpPr>
-          <p:cNvPr id="10" name="text-234">
+          <p:cNvPr id="10" name="text-230">
             <a:extLst xmlns:a="http://schemas.openxmlformats.org/drawingml/2006/main">
               <a:ext uri="{FF2B5EF4-FFF2-40B4-BE49-F238E27FC236}">
-                <a16:creationId xmlns:a16="http://schemas.microsoft.com/office/drawing/2014/main" id="{A84BE554-EE5D-4361-808B-D32AD8D5102A}"/>
+                <a16:creationId xmlns:a16="http://schemas.microsoft.com/office/drawing/2014/main" id="{1F1F329F-1F74-4C54-BEE5-1D640180A0B9}"/>
               </a:ext>
             </a:extLst>
           </p:cNvPr>
@@ -16247,10 +16187,10 @@
       </p:sp>
       <p:sp>
         <p:nvSpPr>
-          <p:cNvPr id="11" name="text-235">
+          <p:cNvPr id="11" name="text-231">
             <a:extLst xmlns:a="http://schemas.openxmlformats.org/drawingml/2006/main">
               <a:ext uri="{FF2B5EF4-FFF2-40B4-BE49-F238E27FC236}">
-                <a16:creationId xmlns:a16="http://schemas.microsoft.com/office/drawing/2014/main" id="{190C22CA-1762-401F-A6A4-8834F844158A}"/>
+                <a16:creationId xmlns:a16="http://schemas.microsoft.com/office/drawing/2014/main" id="{31F7E6B1-CBCA-4B9F-80D1-D776073F31EE}"/>
               </a:ext>
             </a:extLst>
           </p:cNvPr>
@@ -16405,10 +16345,10 @@
       </p:sp>
       <p:sp>
         <p:nvSpPr>
-          <p:cNvPr id="12" name="text-236">
+          <p:cNvPr id="12" name="text-232">
             <a:extLst xmlns:a="http://schemas.openxmlformats.org/drawingml/2006/main">
               <a:ext uri="{FF2B5EF4-FFF2-40B4-BE49-F238E27FC236}">
-                <a16:creationId xmlns:a16="http://schemas.microsoft.com/office/drawing/2014/main" id="{38B88F9D-1B2A-45E0-B904-17C75E75129F}"/>
+                <a16:creationId xmlns:a16="http://schemas.microsoft.com/office/drawing/2014/main" id="{9A5598FE-CA53-4D27-AC2E-8B7CB460828D}"/>
               </a:ext>
             </a:extLst>
           </p:cNvPr>
@@ -16563,10 +16503,10 @@
       </p:sp>
       <p:sp>
         <p:nvSpPr>
-          <p:cNvPr id="13" name="text-237">
+          <p:cNvPr id="13" name="text-233">
             <a:extLst xmlns:a="http://schemas.openxmlformats.org/drawingml/2006/main">
               <a:ext uri="{FF2B5EF4-FFF2-40B4-BE49-F238E27FC236}">
-                <a16:creationId xmlns:a16="http://schemas.microsoft.com/office/drawing/2014/main" id="{B24B7ECB-EE61-4C3F-846C-8C3FE2374C12}"/>
+                <a16:creationId xmlns:a16="http://schemas.microsoft.com/office/drawing/2014/main" id="{BF084C92-9F1C-455C-9E53-F13CAA2E4066}"/>
               </a:ext>
             </a:extLst>
           </p:cNvPr>
@@ -16721,10 +16661,10 @@
       </p:sp>
       <p:sp>
         <p:nvSpPr>
-          <p:cNvPr id="14" name="text-238">
+          <p:cNvPr id="14" name="text-234">
             <a:extLst xmlns:a="http://schemas.openxmlformats.org/drawingml/2006/main">
               <a:ext uri="{FF2B5EF4-FFF2-40B4-BE49-F238E27FC236}">
-                <a16:creationId xmlns:a16="http://schemas.microsoft.com/office/drawing/2014/main" id="{54FE63C6-ED5B-4395-B423-D824952C7A6B}"/>
+                <a16:creationId xmlns:a16="http://schemas.microsoft.com/office/drawing/2014/main" id="{81057FBC-789B-48B2-9EBE-990C0A2CCB7B}"/>
               </a:ext>
             </a:extLst>
           </p:cNvPr>
@@ -16879,10 +16819,10 @@
       </p:sp>
       <p:sp>
         <p:nvSpPr>
-          <p:cNvPr id="15" name="text-239">
+          <p:cNvPr id="15" name="text-235">
             <a:extLst xmlns:a="http://schemas.openxmlformats.org/drawingml/2006/main">
               <a:ext uri="{FF2B5EF4-FFF2-40B4-BE49-F238E27FC236}">
-                <a16:creationId xmlns:a16="http://schemas.microsoft.com/office/drawing/2014/main" id="{036BCA56-1C3A-4B61-B385-C216B0EDA175}"/>
+                <a16:creationId xmlns:a16="http://schemas.microsoft.com/office/drawing/2014/main" id="{D6D05A65-3EDC-4D98-9394-2A1E4849DE30}"/>
               </a:ext>
             </a:extLst>
           </p:cNvPr>
@@ -17037,10 +16977,10 @@
       </p:sp>
       <p:sp>
         <p:nvSpPr>
-          <p:cNvPr id="16" name="text-240">
+          <p:cNvPr id="16" name="text-236">
             <a:extLst xmlns:a="http://schemas.openxmlformats.org/drawingml/2006/main">
               <a:ext uri="{FF2B5EF4-FFF2-40B4-BE49-F238E27FC236}">
-                <a16:creationId xmlns:a16="http://schemas.microsoft.com/office/drawing/2014/main" id="{BBEF3C53-2B6C-479D-8CC8-53444E4FB940}"/>
+                <a16:creationId xmlns:a16="http://schemas.microsoft.com/office/drawing/2014/main" id="{C4C8F71D-8D22-43EB-B417-FC4B171551A9}"/>
               </a:ext>
             </a:extLst>
           </p:cNvPr>
@@ -17195,10 +17135,10 @@
       </p:sp>
       <p:sp>
         <p:nvSpPr>
-          <p:cNvPr id="17" name="text-241">
+          <p:cNvPr id="17" name="text-237">
             <a:extLst xmlns:a="http://schemas.openxmlformats.org/drawingml/2006/main">
               <a:ext uri="{FF2B5EF4-FFF2-40B4-BE49-F238E27FC236}">
-                <a16:creationId xmlns:a16="http://schemas.microsoft.com/office/drawing/2014/main" id="{E42F6C60-2A9E-4C12-8591-321B26628499}"/>
+                <a16:creationId xmlns:a16="http://schemas.microsoft.com/office/drawing/2014/main" id="{817B3AAC-6D11-4FBC-8FB7-C442A3EA9042}"/>
               </a:ext>
             </a:extLst>
           </p:cNvPr>
@@ -17353,10 +17293,10 @@
       </p:sp>
       <p:sp>
         <p:nvSpPr>
-          <p:cNvPr id="18" name="text-242">
+          <p:cNvPr id="18" name="text-238">
             <a:extLst xmlns:a="http://schemas.openxmlformats.org/drawingml/2006/main">
               <a:ext uri="{FF2B5EF4-FFF2-40B4-BE49-F238E27FC236}">
-                <a16:creationId xmlns:a16="http://schemas.microsoft.com/office/drawing/2014/main" id="{E0EA9850-43C2-490B-91A4-18F7114ABBEB}"/>
+                <a16:creationId xmlns:a16="http://schemas.microsoft.com/office/drawing/2014/main" id="{7C683A43-A79A-4501-91CB-78AA16080D12}"/>
               </a:ext>
             </a:extLst>
           </p:cNvPr>
@@ -17511,10 +17451,10 @@
       </p:sp>
       <p:sp>
         <p:nvSpPr>
-          <p:cNvPr id="19" name="rule-243">
+          <p:cNvPr id="19" name="rule-239">
             <a:extLst xmlns:a="http://schemas.openxmlformats.org/drawingml/2006/main">
               <a:ext uri="{FF2B5EF4-FFF2-40B4-BE49-F238E27FC236}">
-                <a16:creationId xmlns:a16="http://schemas.microsoft.com/office/drawing/2014/main" id="{26DF393B-8F24-4DEB-BC59-C17C14C549C8}"/>
+                <a16:creationId xmlns:a16="http://schemas.microsoft.com/office/drawing/2014/main" id="{D76596E4-4C4A-4281-ADB4-DD0B6B86E355}"/>
               </a:ext>
             </a:extLst>
           </p:cNvPr>
@@ -17544,7 +17484,7 @@
           <p:cNvPr id="20" name="hotspot-1">
             <a:extLst xmlns:a="http://schemas.openxmlformats.org/drawingml/2006/main">
               <a:ext uri="{FF2B5EF4-FFF2-40B4-BE49-F238E27FC236}">
-                <a16:creationId xmlns:a16="http://schemas.microsoft.com/office/drawing/2014/main" id="{894A161D-1EFF-40DF-98BF-3D56DE88993A}"/>
+                <a16:creationId xmlns:a16="http://schemas.microsoft.com/office/drawing/2014/main" id="{B8CCA2DF-CAA3-4B93-9733-37C3BB4B1AEB}"/>
               </a:ext>
             </a:extLst>
             <ns0:hlinkClick xmlns:ns0="http://schemas.openxmlformats.org/drawingml/2006/main" xmlns:ns1="http://schemas.openxmlformats.org/officeDocument/2006/relationships" ns1:id="rIdClick1"/>
@@ -17574,10 +17514,10 @@
       </p:sp>
       <p:sp>
         <p:nvSpPr>
-          <p:cNvPr id="21" name="text-245">
+          <p:cNvPr id="21" name="text-241">
             <a:extLst xmlns:a="http://schemas.openxmlformats.org/drawingml/2006/main">
               <a:ext uri="{FF2B5EF4-FFF2-40B4-BE49-F238E27FC236}">
-                <a16:creationId xmlns:a16="http://schemas.microsoft.com/office/drawing/2014/main" id="{06B758A9-F8CC-4314-B564-7C3B6EFED09C}"/>
+                <a16:creationId xmlns:a16="http://schemas.microsoft.com/office/drawing/2014/main" id="{776C57C8-DB67-4B7E-905B-E8D69DE3D656}"/>
               </a:ext>
             </a:extLst>
           </p:cNvPr>
@@ -17732,10 +17672,10 @@
       </p:sp>
       <p:sp>
         <p:nvSpPr>
-          <p:cNvPr id="22" name="rule-246">
+          <p:cNvPr id="22" name="rule-242">
             <a:extLst xmlns:a="http://schemas.openxmlformats.org/drawingml/2006/main">
               <a:ext uri="{FF2B5EF4-FFF2-40B4-BE49-F238E27FC236}">
-                <a16:creationId xmlns:a16="http://schemas.microsoft.com/office/drawing/2014/main" id="{BE636E77-69F5-460B-BE7D-86BF55712839}"/>
+                <a16:creationId xmlns:a16="http://schemas.microsoft.com/office/drawing/2014/main" id="{39AAAE97-D24D-4372-81BD-68F9C5470472}"/>
               </a:ext>
             </a:extLst>
           </p:cNvPr>
@@ -17765,7 +17705,7 @@
           <p:cNvPr id="23" name="hotspot-2">
             <a:extLst xmlns:a="http://schemas.openxmlformats.org/drawingml/2006/main">
               <a:ext uri="{FF2B5EF4-FFF2-40B4-BE49-F238E27FC236}">
-                <a16:creationId xmlns:a16="http://schemas.microsoft.com/office/drawing/2014/main" id="{AE5AA133-DD4B-4405-BBAF-737E70151A26}"/>
+                <a16:creationId xmlns:a16="http://schemas.microsoft.com/office/drawing/2014/main" id="{35793A76-90EF-45BC-BFC5-896F987F812B}"/>
               </a:ext>
             </a:extLst>
             <ns2:hlinkClick xmlns:ns2="http://schemas.openxmlformats.org/drawingml/2006/main" xmlns:ns3="http://schemas.openxmlformats.org/officeDocument/2006/relationships" ns3:id="rIdClick2"/>
@@ -17796,7 +17736,7 @@
     </p:spTree>
     <p:extLst>
       <p:ext uri="{BB962C8B-B14F-4D97-AF65-F5344CB8AC3E}">
-        <p14:creationId xmlns:p14="http://schemas.microsoft.com/office/powerpoint/2010/main" val="95613203"/>
+        <p14:creationId xmlns:p14="http://schemas.microsoft.com/office/powerpoint/2010/main" val="1795761173"/>
       </p:ext>
     </p:extLst>
   </p:cSld>
@@ -17824,10 +17764,10 @@
       </p:grpSpPr>
       <p:sp>
         <p:nvSpPr>
-          <p:cNvPr id="20" name="text-248">
+          <p:cNvPr id="20" name="text-244">
             <a:extLst xmlns:a="http://schemas.openxmlformats.org/drawingml/2006/main">
               <a:ext uri="{FF2B5EF4-FFF2-40B4-BE49-F238E27FC236}">
-                <a16:creationId xmlns:a16="http://schemas.microsoft.com/office/drawing/2014/main" id="{3569F92E-A9DF-40CE-AC85-5DFCF6C57ABB}"/>
+                <a16:creationId xmlns:a16="http://schemas.microsoft.com/office/drawing/2014/main" id="{0F2ADDB5-2C53-42D7-BFC7-76B3FB236C3C}"/>
               </a:ext>
             </a:extLst>
           </p:cNvPr>
@@ -17982,10 +17922,10 @@
       </p:sp>
       <p:sp>
         <p:nvSpPr>
-          <p:cNvPr id="2" name="text-249">
+          <p:cNvPr id="2" name="text-245">
             <a:extLst xmlns:a="http://schemas.openxmlformats.org/drawingml/2006/main">
               <a:ext uri="{FF2B5EF4-FFF2-40B4-BE49-F238E27FC236}">
-                <a16:creationId xmlns:a16="http://schemas.microsoft.com/office/drawing/2014/main" id="{369C320B-D7F9-4ED4-B76D-2349D2DB22F2}"/>
+                <a16:creationId xmlns:a16="http://schemas.microsoft.com/office/drawing/2014/main" id="{394C6640-E0E9-464D-85A5-2E59DA8F0526}"/>
               </a:ext>
             </a:extLst>
           </p:cNvPr>
@@ -18140,10 +18080,10 @@
       </p:sp>
       <p:sp>
         <p:nvSpPr>
-          <p:cNvPr id="3" name="rule-250">
+          <p:cNvPr id="3" name="rule-246">
             <a:extLst xmlns:a="http://schemas.openxmlformats.org/drawingml/2006/main">
               <a:ext uri="{FF2B5EF4-FFF2-40B4-BE49-F238E27FC236}">
-                <a16:creationId xmlns:a16="http://schemas.microsoft.com/office/drawing/2014/main" id="{85BD1396-070C-4DEB-B307-1AAB6E99DCFC}"/>
+                <a16:creationId xmlns:a16="http://schemas.microsoft.com/office/drawing/2014/main" id="{2D4A7261-536F-4234-B6AA-0FE88F662B43}"/>
               </a:ext>
             </a:extLst>
           </p:cNvPr>
@@ -18170,10 +18110,10 @@
       </p:sp>
       <p:sp>
         <p:nvSpPr>
-          <p:cNvPr id="4" name="text-251">
+          <p:cNvPr id="4" name="text-247">
             <a:extLst xmlns:a="http://schemas.openxmlformats.org/drawingml/2006/main">
               <a:ext uri="{FF2B5EF4-FFF2-40B4-BE49-F238E27FC236}">
-                <a16:creationId xmlns:a16="http://schemas.microsoft.com/office/drawing/2014/main" id="{D82EBFC3-E505-4D5B-9A66-F35909C318BD}"/>
+                <a16:creationId xmlns:a16="http://schemas.microsoft.com/office/drawing/2014/main" id="{5F2516E6-EC62-4841-9AB6-C2B77301902F}"/>
               </a:ext>
             </a:extLst>
           </p:cNvPr>
@@ -18328,10 +18268,10 @@
       </p:sp>
       <p:sp>
         <p:nvSpPr>
-          <p:cNvPr id="5" name="text-252">
+          <p:cNvPr id="5" name="text-248">
             <a:extLst xmlns:a="http://schemas.openxmlformats.org/drawingml/2006/main">
               <a:ext uri="{FF2B5EF4-FFF2-40B4-BE49-F238E27FC236}">
-                <a16:creationId xmlns:a16="http://schemas.microsoft.com/office/drawing/2014/main" id="{EA0A9A7E-A96E-4000-9D60-FFDD2E115868}"/>
+                <a16:creationId xmlns:a16="http://schemas.microsoft.com/office/drawing/2014/main" id="{3C558729-A239-4DCB-8A26-2471411455C4}"/>
               </a:ext>
             </a:extLst>
           </p:cNvPr>
@@ -18486,10 +18426,10 @@
       </p:sp>
       <p:sp>
         <p:nvSpPr>
-          <p:cNvPr id="6" name="text-253">
+          <p:cNvPr id="6" name="text-249">
             <a:extLst xmlns:a="http://schemas.openxmlformats.org/drawingml/2006/main">
               <a:ext uri="{FF2B5EF4-FFF2-40B4-BE49-F238E27FC236}">
-                <a16:creationId xmlns:a16="http://schemas.microsoft.com/office/drawing/2014/main" id="{868E209E-DBE5-4493-9866-B33283010BCF}"/>
+                <a16:creationId xmlns:a16="http://schemas.microsoft.com/office/drawing/2014/main" id="{98A668F8-36F9-4297-B636-0805AE413CAD}"/>
               </a:ext>
             </a:extLst>
           </p:cNvPr>
@@ -18644,10 +18584,10 @@
       </p:sp>
       <p:sp>
         <p:nvSpPr>
-          <p:cNvPr id="7" name="text-254">
+          <p:cNvPr id="7" name="text-250">
             <a:extLst xmlns:a="http://schemas.openxmlformats.org/drawingml/2006/main">
               <a:ext uri="{FF2B5EF4-FFF2-40B4-BE49-F238E27FC236}">
-                <a16:creationId xmlns:a16="http://schemas.microsoft.com/office/drawing/2014/main" id="{B412E5BF-0EFD-44B7-84DD-316C59BDE89A}"/>
+                <a16:creationId xmlns:a16="http://schemas.microsoft.com/office/drawing/2014/main" id="{4785F46E-FDFE-405D-828F-6E109CF06477}"/>
               </a:ext>
             </a:extLst>
           </p:cNvPr>
@@ -18802,10 +18742,10 @@
       </p:sp>
       <p:sp>
         <p:nvSpPr>
-          <p:cNvPr id="8" name="rule-255">
+          <p:cNvPr id="8" name="rule-251">
             <a:extLst xmlns:a="http://schemas.openxmlformats.org/drawingml/2006/main">
               <a:ext uri="{FF2B5EF4-FFF2-40B4-BE49-F238E27FC236}">
-                <a16:creationId xmlns:a16="http://schemas.microsoft.com/office/drawing/2014/main" id="{C43C3293-F383-4CC0-9084-7B12E0DF0EA8}"/>
+                <a16:creationId xmlns:a16="http://schemas.microsoft.com/office/drawing/2014/main" id="{24530DED-EC96-4920-BAF7-4725506DBA07}"/>
               </a:ext>
             </a:extLst>
           </p:cNvPr>
@@ -18832,10 +18772,10 @@
       </p:sp>
       <p:sp>
         <p:nvSpPr>
-          <p:cNvPr id="9" name="text-256">
+          <p:cNvPr id="9" name="text-252">
             <a:extLst xmlns:a="http://schemas.openxmlformats.org/drawingml/2006/main">
               <a:ext uri="{FF2B5EF4-FFF2-40B4-BE49-F238E27FC236}">
-                <a16:creationId xmlns:a16="http://schemas.microsoft.com/office/drawing/2014/main" id="{9B96CBF6-3892-4493-BC35-79C55E8098DD}"/>
+                <a16:creationId xmlns:a16="http://schemas.microsoft.com/office/drawing/2014/main" id="{54C6EE70-FE8D-47BD-B5B6-9EC5D5C24E25}"/>
               </a:ext>
             </a:extLst>
           </p:cNvPr>
@@ -18990,10 +18930,10 @@
       </p:sp>
       <p:sp>
         <p:nvSpPr>
-          <p:cNvPr id="10" name="text-257">
+          <p:cNvPr id="10" name="text-253">
             <a:extLst xmlns:a="http://schemas.openxmlformats.org/drawingml/2006/main">
               <a:ext uri="{FF2B5EF4-FFF2-40B4-BE49-F238E27FC236}">
-                <a16:creationId xmlns:a16="http://schemas.microsoft.com/office/drawing/2014/main" id="{EC3A2579-42BF-453C-83AD-CA2DAA385F45}"/>
+                <a16:creationId xmlns:a16="http://schemas.microsoft.com/office/drawing/2014/main" id="{F2069705-4596-413E-8DA9-921BA60E25B4}"/>
               </a:ext>
             </a:extLst>
           </p:cNvPr>
@@ -19148,10 +19088,10 @@
       </p:sp>
       <p:sp>
         <p:nvSpPr>
-          <p:cNvPr id="11" name="rule-258">
+          <p:cNvPr id="11" name="rule-254">
             <a:extLst xmlns:a="http://schemas.openxmlformats.org/drawingml/2006/main">
               <a:ext uri="{FF2B5EF4-FFF2-40B4-BE49-F238E27FC236}">
-                <a16:creationId xmlns:a16="http://schemas.microsoft.com/office/drawing/2014/main" id="{0F4775DD-FAFA-414C-BD59-2CC535E1080F}"/>
+                <a16:creationId xmlns:a16="http://schemas.microsoft.com/office/drawing/2014/main" id="{D7963DD3-21E2-473C-8EE8-708072F6B2C2}"/>
               </a:ext>
             </a:extLst>
           </p:cNvPr>
@@ -19178,10 +19118,10 @@
       </p:sp>
       <p:sp>
         <p:nvSpPr>
-          <p:cNvPr id="12" name="text-259">
+          <p:cNvPr id="12" name="text-255">
             <a:extLst xmlns:a="http://schemas.openxmlformats.org/drawingml/2006/main">
               <a:ext uri="{FF2B5EF4-FFF2-40B4-BE49-F238E27FC236}">
-                <a16:creationId xmlns:a16="http://schemas.microsoft.com/office/drawing/2014/main" id="{5AB1F38E-79C3-4E45-87C9-A5BBCF6DA272}"/>
+                <a16:creationId xmlns:a16="http://schemas.microsoft.com/office/drawing/2014/main" id="{D47D285C-00AA-4A18-9E8F-56919CB9DD3C}"/>
               </a:ext>
             </a:extLst>
           </p:cNvPr>
@@ -19336,10 +19276,10 @@
       </p:sp>
       <p:sp>
         <p:nvSpPr>
-          <p:cNvPr id="13" name="text-260">
+          <p:cNvPr id="13" name="text-256">
             <a:extLst xmlns:a="http://schemas.openxmlformats.org/drawingml/2006/main">
               <a:ext uri="{FF2B5EF4-FFF2-40B4-BE49-F238E27FC236}">
-                <a16:creationId xmlns:a16="http://schemas.microsoft.com/office/drawing/2014/main" id="{23C24A90-F8E7-490E-B803-BC9BB5365277}"/>
+                <a16:creationId xmlns:a16="http://schemas.microsoft.com/office/drawing/2014/main" id="{C0E45EEE-4144-41F1-A27D-986783F17CA8}"/>
               </a:ext>
             </a:extLst>
           </p:cNvPr>
@@ -19494,10 +19434,10 @@
       </p:sp>
       <p:sp>
         <p:nvSpPr>
-          <p:cNvPr id="14" name="rule-261">
+          <p:cNvPr id="14" name="rule-257">
             <a:extLst xmlns:a="http://schemas.openxmlformats.org/drawingml/2006/main">
               <a:ext uri="{FF2B5EF4-FFF2-40B4-BE49-F238E27FC236}">
-                <a16:creationId xmlns:a16="http://schemas.microsoft.com/office/drawing/2014/main" id="{7B3C4B17-FF22-48E1-AA36-353C4C3BE5C0}"/>
+                <a16:creationId xmlns:a16="http://schemas.microsoft.com/office/drawing/2014/main" id="{4EF29326-4075-435F-8C38-329DCD39C70A}"/>
               </a:ext>
             </a:extLst>
           </p:cNvPr>
@@ -19524,10 +19464,10 @@
       </p:sp>
       <p:sp>
         <p:nvSpPr>
-          <p:cNvPr id="15" name="text-262">
+          <p:cNvPr id="15" name="text-258">
             <a:extLst xmlns:a="http://schemas.openxmlformats.org/drawingml/2006/main">
               <a:ext uri="{FF2B5EF4-FFF2-40B4-BE49-F238E27FC236}">
-                <a16:creationId xmlns:a16="http://schemas.microsoft.com/office/drawing/2014/main" id="{E66AC68B-C946-46FD-9D6E-3B73ABEA7EEE}"/>
+                <a16:creationId xmlns:a16="http://schemas.microsoft.com/office/drawing/2014/main" id="{F8B59644-CE5C-4CF7-B81F-F796F6AAE656}"/>
               </a:ext>
             </a:extLst>
           </p:cNvPr>
@@ -19682,10 +19622,10 @@
       </p:sp>
       <p:sp>
         <p:nvSpPr>
-          <p:cNvPr id="16" name="text-263">
+          <p:cNvPr id="16" name="text-259">
             <a:extLst xmlns:a="http://schemas.openxmlformats.org/drawingml/2006/main">
               <a:ext uri="{FF2B5EF4-FFF2-40B4-BE49-F238E27FC236}">
-                <a16:creationId xmlns:a16="http://schemas.microsoft.com/office/drawing/2014/main" id="{62278B63-2B18-46B8-A557-564E8D39444C}"/>
+                <a16:creationId xmlns:a16="http://schemas.microsoft.com/office/drawing/2014/main" id="{33B389FD-1837-4A08-9F8C-C12687B6C1BB}"/>
               </a:ext>
             </a:extLst>
           </p:cNvPr>
@@ -19840,10 +19780,10 @@
       </p:sp>
       <p:sp>
         <p:nvSpPr>
-          <p:cNvPr id="17" name="rule-264">
+          <p:cNvPr id="17" name="rule-260">
             <a:extLst xmlns:a="http://schemas.openxmlformats.org/drawingml/2006/main">
               <a:ext uri="{FF2B5EF4-FFF2-40B4-BE49-F238E27FC236}">
-                <a16:creationId xmlns:a16="http://schemas.microsoft.com/office/drawing/2014/main" id="{08EF4E58-3179-4AD8-B8F2-D6A24297BDCD}"/>
+                <a16:creationId xmlns:a16="http://schemas.microsoft.com/office/drawing/2014/main" id="{79BAF2DD-D31B-4AE6-BAB2-30535C6E46DE}"/>
               </a:ext>
             </a:extLst>
           </p:cNvPr>
@@ -19873,7 +19813,7 @@
           <p:cNvPr id="18" name="hotspot-1">
             <a:extLst xmlns:a="http://schemas.openxmlformats.org/drawingml/2006/main">
               <a:ext uri="{FF2B5EF4-FFF2-40B4-BE49-F238E27FC236}">
-                <a16:creationId xmlns:a16="http://schemas.microsoft.com/office/drawing/2014/main" id="{5E826CD3-50EF-4B27-B7C8-0FBFDE452B88}"/>
+                <a16:creationId xmlns:a16="http://schemas.microsoft.com/office/drawing/2014/main" id="{04EAD2A0-C54D-4544-8DF5-1BD4F5EFFDFB}"/>
               </a:ext>
             </a:extLst>
             <ns0:hlinkClick xmlns:ns0="http://schemas.openxmlformats.org/drawingml/2006/main" xmlns:ns1="http://schemas.openxmlformats.org/officeDocument/2006/relationships" ns1:id="rIdClick1"/>
@@ -19903,10 +19843,10 @@
       </p:sp>
       <p:sp>
         <p:nvSpPr>
-          <p:cNvPr id="19" name="rule-266">
+          <p:cNvPr id="19" name="rule-262">
             <a:extLst xmlns:a="http://schemas.openxmlformats.org/drawingml/2006/main">
               <a:ext uri="{FF2B5EF4-FFF2-40B4-BE49-F238E27FC236}">
-                <a16:creationId xmlns:a16="http://schemas.microsoft.com/office/drawing/2014/main" id="{BF354788-3C49-4A20-9889-6A7A296D15F7}"/>
+                <a16:creationId xmlns:a16="http://schemas.microsoft.com/office/drawing/2014/main" id="{736F0C76-9D05-40C0-92DB-0E884C00E82F}"/>
               </a:ext>
             </a:extLst>
           </p:cNvPr>
@@ -19934,7 +19874,7 @@
     </p:spTree>
     <p:extLst>
       <p:ext uri="{BB962C8B-B14F-4D97-AF65-F5344CB8AC3E}">
-        <p14:creationId xmlns:p14="http://schemas.microsoft.com/office/powerpoint/2010/main" val="1044253843"/>
+        <p14:creationId xmlns:p14="http://schemas.microsoft.com/office/powerpoint/2010/main" val="233129292"/>
       </p:ext>
     </p:extLst>
   </p:cSld>

</xml_diff>